<commit_message>
release: IFSC-calibrated case, maker-checker sign-off, defense answers, recorded demo video
</commit_message>
<xml_diff>
--- a/deck/KRISEVA_ATTEST_GIFT_2026.pptx
+++ b/deck/KRISEVA_ATTEST_GIFT_2026.pptx
@@ -2,22 +2,22 @@
 <file path=ppt/presentation.xml><?xml version="1.0" encoding="utf-8"?>
 <p:presentation xmlns:p="http://schemas.openxmlformats.org/presentationml/2006/main">
   <p:sldMasterIdLst>
-    <p:sldMasterId xmlns:r="http://schemas.openxmlformats.org/officeDocument/2006/relationships" id="2147483648" r:id="Ra809e1d20b194c56"/>
+    <p:sldMasterId xmlns:r="http://schemas.openxmlformats.org/officeDocument/2006/relationships" id="2147483648" r:id="Rf40dc96fb1974dca"/>
   </p:sldMasterIdLst>
   <p:notesMasterIdLst>
-    <p:notesMasterId xmlns:r="http://schemas.openxmlformats.org/officeDocument/2006/relationships" r:id="R846df654af634e6f"/>
+    <p:notesMasterId xmlns:r="http://schemas.openxmlformats.org/officeDocument/2006/relationships" r:id="R63d7dc1d31234603"/>
   </p:notesMasterIdLst>
   <p:sldIdLst>
-    <p:sldId xmlns:r="http://schemas.openxmlformats.org/officeDocument/2006/relationships" id="256" r:id="R80a048628069405e"/>
-    <p:sldId xmlns:r="http://schemas.openxmlformats.org/officeDocument/2006/relationships" id="257" r:id="Rfb0e85268d034b25"/>
-    <p:sldId xmlns:r="http://schemas.openxmlformats.org/officeDocument/2006/relationships" id="258" r:id="R88a5d41dec034a99"/>
-    <p:sldId xmlns:r="http://schemas.openxmlformats.org/officeDocument/2006/relationships" id="259" r:id="R0924083f86e647a5"/>
-    <p:sldId xmlns:r="http://schemas.openxmlformats.org/officeDocument/2006/relationships" id="260" r:id="R40cffa6786ce4440"/>
-    <p:sldId xmlns:r="http://schemas.openxmlformats.org/officeDocument/2006/relationships" id="261" r:id="R9f3514a27d88417f"/>
-    <p:sldId xmlns:r="http://schemas.openxmlformats.org/officeDocument/2006/relationships" id="262" r:id="R9c843acc5c834b37"/>
-    <p:sldId xmlns:r="http://schemas.openxmlformats.org/officeDocument/2006/relationships" id="263" r:id="Raa8532414f464108"/>
-    <p:sldId xmlns:r="http://schemas.openxmlformats.org/officeDocument/2006/relationships" id="264" r:id="R9b8ca4af81a64eb2"/>
-    <p:sldId xmlns:r="http://schemas.openxmlformats.org/officeDocument/2006/relationships" id="265" r:id="Reab87bc750884295"/>
+    <p:sldId xmlns:r="http://schemas.openxmlformats.org/officeDocument/2006/relationships" id="256" r:id="Rb7046164e1314215"/>
+    <p:sldId xmlns:r="http://schemas.openxmlformats.org/officeDocument/2006/relationships" id="257" r:id="R9af5731eb2fa45ae"/>
+    <p:sldId xmlns:r="http://schemas.openxmlformats.org/officeDocument/2006/relationships" id="258" r:id="R3c44464c7ad44e10"/>
+    <p:sldId xmlns:r="http://schemas.openxmlformats.org/officeDocument/2006/relationships" id="259" r:id="R7d2cede707694b53"/>
+    <p:sldId xmlns:r="http://schemas.openxmlformats.org/officeDocument/2006/relationships" id="260" r:id="R06f661682921437c"/>
+    <p:sldId xmlns:r="http://schemas.openxmlformats.org/officeDocument/2006/relationships" id="261" r:id="R3862e6feb7d24ef6"/>
+    <p:sldId xmlns:r="http://schemas.openxmlformats.org/officeDocument/2006/relationships" id="262" r:id="R3fda92ac727a4ad8"/>
+    <p:sldId xmlns:r="http://schemas.openxmlformats.org/officeDocument/2006/relationships" id="263" r:id="Rf2eef61a22394ab3"/>
+    <p:sldId xmlns:r="http://schemas.openxmlformats.org/officeDocument/2006/relationships" id="264" r:id="R91033edbf0f449f4"/>
+    <p:sldId xmlns:r="http://schemas.openxmlformats.org/officeDocument/2006/relationships" id="265" r:id="Rf5a73399916f4069"/>
   </p:sldIdLst>
   <p:sldSz cx="12192000" cy="6858000"/>
   <p:notesSz cx="6858000" cy="9144000"/>
@@ -451,6 +451,16 @@
           <a:lstStyle xmlns:a="http://schemas.openxmlformats.org/drawingml/2006/main"/>
           <a:p xmlns:a="http://schemas.openxmlformats.org/drawingml/2006/main">
             <a:r>
+              <a:t>Superseded cover framing, retained for audit only (replaced 2026-08-13):</a:t>
+            </a:r>
+          </a:p>
+          <a:p xmlns:a="http://schemas.openxmlformats.org/drawingml/2006/main">
+            <a:r>
+              <a:t>"Application product lock. Company wedge not locked."</a:t>
+            </a:r>
+          </a:p>
+          <a:p xmlns:a="http://schemas.openxmlformats.org/drawingml/2006/main">
+            <a:r>
               <a:t>[Sources]</a:t>
             </a:r>
           </a:p>
@@ -1329,7 +1339,7 @@
   </p:cSld>
   <p:clrMap bg1="lt1" tx1="dk1" bg2="lt2" tx2="dk2" accent1="accent1" accent2="accent2" accent3="accent3" accent4="accent4" accent5="accent5" accent6="accent6" hlink="hlink" folHlink="folHlink"/>
   <p:sldLayoutIdLst>
-    <p:sldLayoutId xmlns:r="http://schemas.openxmlformats.org/officeDocument/2006/relationships" id="2147483649" r:id="R222c168b9a7041a7"/>
+    <p:sldLayoutId xmlns:r="http://schemas.openxmlformats.org/officeDocument/2006/relationships" id="2147483649" r:id="R630a6026818646a8"/>
   </p:sldLayoutIdLst>
   <p:txStyles>
     <p:titleStyle>
@@ -1877,10 +1887,10 @@
       </p:grpSpPr>
       <p:sp>
         <p:nvSpPr>
-          <p:cNvPr id="12" name="cover-navy-field">
-            <a:extLst xmlns:a="http://schemas.openxmlformats.org/drawingml/2006/main">
-              <a:ext uri="{FF2B5EF4-FFF2-40B4-BE49-F238E27FC236}">
-                <a16:creationId xmlns:a16="http://schemas.microsoft.com/office/drawing/2014/main" id="{C807557B-157D-4287-A474-05D490A56C26}"/>
+          <p:cNvPr id="13" name="cover-navy-field">
+            <a:extLst xmlns:a="http://schemas.openxmlformats.org/drawingml/2006/main">
+              <a:ext uri="{FF2B5EF4-FFF2-40B4-BE49-F238E27FC236}">
+                <a16:creationId xmlns:a16="http://schemas.microsoft.com/office/drawing/2014/main" id="{3DFFFE68-60BB-41B9-BE64-960898E67BF7}"/>
               </a:ext>
             </a:extLst>
           </p:cNvPr>
@@ -1913,7 +1923,7 @@
           <p:cNvPr id="2" name="cover-brass-spine">
             <a:extLst xmlns:a="http://schemas.openxmlformats.org/drawingml/2006/main">
               <a:ext uri="{FF2B5EF4-FFF2-40B4-BE49-F238E27FC236}">
-                <a16:creationId xmlns:a16="http://schemas.microsoft.com/office/drawing/2014/main" id="{71947AC0-BFEB-461C-9715-45FBF7D074B9}"/>
+                <a16:creationId xmlns:a16="http://schemas.microsoft.com/office/drawing/2014/main" id="{E55130A6-3BB6-4D46-84FB-30861AF90CF3}"/>
               </a:ext>
             </a:extLst>
           </p:cNvPr>
@@ -1944,7 +1954,7 @@
           <p:cNvPr id="3" name="brand-1">
             <a:extLst xmlns:a="http://schemas.openxmlformats.org/drawingml/2006/main">
               <a:ext uri="{FF2B5EF4-FFF2-40B4-BE49-F238E27FC236}">
-                <a16:creationId xmlns:a16="http://schemas.microsoft.com/office/drawing/2014/main" id="{AAA681BA-E01E-499E-8A98-691EB5C180F2}"/>
+                <a16:creationId xmlns:a16="http://schemas.microsoft.com/office/drawing/2014/main" id="{96B3175D-F454-4824-9823-C95B4857A619}"/>
               </a:ext>
             </a:extLst>
           </p:cNvPr>
@@ -2002,7 +2012,7 @@
           <p:cNvPr id="4" name="cover-title">
             <a:extLst xmlns:a="http://schemas.openxmlformats.org/drawingml/2006/main">
               <a:ext uri="{FF2B5EF4-FFF2-40B4-BE49-F238E27FC236}">
-                <a16:creationId xmlns:a16="http://schemas.microsoft.com/office/drawing/2014/main" id="{C9C59B38-0BC9-4659-BC49-7F2A6A643AF4}"/>
+                <a16:creationId xmlns:a16="http://schemas.microsoft.com/office/drawing/2014/main" id="{629F1F21-57FE-4C4B-BFFC-90607D40BD2D}"/>
               </a:ext>
             </a:extLst>
           </p:cNvPr>
@@ -2060,7 +2070,7 @@
           <p:cNvPr id="5" name="cover-subtitle">
             <a:extLst xmlns:a="http://schemas.openxmlformats.org/drawingml/2006/main">
               <a:ext uri="{FF2B5EF4-FFF2-40B4-BE49-F238E27FC236}">
-                <a16:creationId xmlns:a16="http://schemas.microsoft.com/office/drawing/2014/main" id="{A474E3C8-B297-4DCF-BED5-BC72A70B82C9}"/>
+                <a16:creationId xmlns:a16="http://schemas.microsoft.com/office/drawing/2014/main" id="{B75C82B7-83E0-4006-9ABB-6B7CF9BB6535}"/>
               </a:ext>
             </a:extLst>
           </p:cNvPr>
@@ -2118,7 +2128,7 @@
           <p:cNvPr id="6" name="cover-rule">
             <a:extLst xmlns:a="http://schemas.openxmlformats.org/drawingml/2006/main">
               <a:ext uri="{FF2B5EF4-FFF2-40B4-BE49-F238E27FC236}">
-                <a16:creationId xmlns:a16="http://schemas.microsoft.com/office/drawing/2014/main" id="{45CE11AF-709C-47C5-85DD-4C8815948158}"/>
+                <a16:creationId xmlns:a16="http://schemas.microsoft.com/office/drawing/2014/main" id="{C5A9E9F7-4908-4691-964B-DB1166ED0F9F}"/>
               </a:ext>
             </a:extLst>
           </p:cNvPr>
@@ -2149,7 +2159,7 @@
           <p:cNvPr id="7" name="cover-lock">
             <a:extLst xmlns:a="http://schemas.openxmlformats.org/drawingml/2006/main">
               <a:ext uri="{FF2B5EF4-FFF2-40B4-BE49-F238E27FC236}">
-                <a16:creationId xmlns:a16="http://schemas.microsoft.com/office/drawing/2014/main" id="{8063A444-96FE-4000-9260-7D82B6E4C85F}"/>
+                <a16:creationId xmlns:a16="http://schemas.microsoft.com/office/drawing/2014/main" id="{D5003CB8-9377-4033-86B7-AEDBE42E2C19}"/>
               </a:ext>
             </a:extLst>
           </p:cNvPr>
@@ -2161,7 +2171,7 @@
         <p:spPr>
           <a:xfrm xmlns:a="http://schemas.openxmlformats.org/drawingml/2006/main">
             <a:off x="647700" y="4171950"/>
-            <a:ext cx="6191250" cy="361950"/>
+            <a:ext cx="6191250" cy="914400"/>
           </a:xfrm>
           <a:prstGeom xmlns:a="http://schemas.openxmlformats.org/drawingml/2006/main" prst="rect">
             <a:avLst/>
@@ -2197,7 +2207,7 @@
                 <a:ea typeface="Arial"/>
                 <a:cs typeface="Arial"/>
               </a:rPr>
-              <a:t>Application product lock. Company wedge not locked.</a:t>
+              <a:t>This prototype is final for this application. Whether it becomes the company's product is deliberately still open.</a:t>
             </a:r>
           </a:p>
         </p:txBody>
@@ -2207,18 +2217,18 @@
           <p:cNvPr id="8" name="cover-boundary">
             <a:extLst xmlns:a="http://schemas.openxmlformats.org/drawingml/2006/main">
               <a:ext uri="{FF2B5EF4-FFF2-40B4-BE49-F238E27FC236}">
-                <a16:creationId xmlns:a16="http://schemas.microsoft.com/office/drawing/2014/main" id="{1ECE79E3-0A5B-4FC2-ADF1-FA32866A843D}"/>
-              </a:ext>
-            </a:extLst>
-          </p:cNvPr>
-          <p:cNvSpPr>
-            <a:spLocks xmlns:a="http://schemas.openxmlformats.org/drawingml/2006/main" noGrp="1"/>
-          </p:cNvSpPr>
-          <p:nvPr/>
-        </p:nvSpPr>
-        <p:spPr>
-          <a:xfrm xmlns:a="http://schemas.openxmlformats.org/drawingml/2006/main">
-            <a:off x="647700" y="4857750"/>
+                <a16:creationId xmlns:a16="http://schemas.microsoft.com/office/drawing/2014/main" id="{2FCC3A0E-8F1E-46D5-8CE1-53E4ED040CB2}"/>
+              </a:ext>
+            </a:extLst>
+          </p:cNvPr>
+          <p:cNvSpPr>
+            <a:spLocks xmlns:a="http://schemas.openxmlformats.org/drawingml/2006/main" noGrp="1"/>
+          </p:cNvSpPr>
+          <p:nvPr/>
+        </p:nvSpPr>
+        <p:spPr>
+          <a:xfrm xmlns:a="http://schemas.openxmlformats.org/drawingml/2006/main">
+            <a:off x="647700" y="5200650"/>
             <a:ext cx="7810500" cy="514350"/>
           </a:xfrm>
           <a:prstGeom xmlns:a="http://schemas.openxmlformats.org/drawingml/2006/main" prst="rect">
@@ -2265,7 +2275,7 @@
           <p:cNvPr id="9" name="cover-number">
             <a:extLst xmlns:a="http://schemas.openxmlformats.org/drawingml/2006/main">
               <a:ext uri="{FF2B5EF4-FFF2-40B4-BE49-F238E27FC236}">
-                <a16:creationId xmlns:a16="http://schemas.microsoft.com/office/drawing/2014/main" id="{56FC8AC2-0016-4D8B-AE5E-59CAAE3E4BBF}"/>
+                <a16:creationId xmlns:a16="http://schemas.microsoft.com/office/drawing/2014/main" id="{A408687B-7836-4BCE-90BF-19981DCBFDAD}"/>
               </a:ext>
             </a:extLst>
           </p:cNvPr>
@@ -2323,7 +2333,7 @@
           <p:cNvPr id="10" name="cover-classification">
             <a:extLst xmlns:a="http://schemas.openxmlformats.org/drawingml/2006/main">
               <a:ext uri="{FF2B5EF4-FFF2-40B4-BE49-F238E27FC236}">
-                <a16:creationId xmlns:a16="http://schemas.microsoft.com/office/drawing/2014/main" id="{BD51F7DF-49F6-49C7-BA56-B04DC31875A0}"/>
+                <a16:creationId xmlns:a16="http://schemas.microsoft.com/office/drawing/2014/main" id="{26A6CB2C-7CDD-4FDF-A736-B0F5F457144D}"/>
               </a:ext>
             </a:extLst>
           </p:cNvPr>
@@ -2427,7 +2437,7 @@
           <p:cNvPr id="11" name="cover-page">
             <a:extLst xmlns:a="http://schemas.openxmlformats.org/drawingml/2006/main">
               <a:ext uri="{FF2B5EF4-FFF2-40B4-BE49-F238E27FC236}">
-                <a16:creationId xmlns:a16="http://schemas.microsoft.com/office/drawing/2014/main" id="{467E91C8-0250-4560-B31E-7094F896E201}"/>
+                <a16:creationId xmlns:a16="http://schemas.microsoft.com/office/drawing/2014/main" id="{B28B17C7-8F83-4DB6-93EC-DF0BD38D0049}"/>
               </a:ext>
             </a:extLst>
           </p:cNvPr>
@@ -2476,6 +2486,87 @@
                 <a:cs typeface="Courier New"/>
               </a:rPr>
               <a:t>APPLICATION EVIDENCE</a:t>
+            </a:r>
+          </a:p>
+        </p:txBody>
+      </p:sp>
+      <p:sp>
+        <p:nvSpPr>
+          <p:cNvPr id="12" name="footer-cover-url">
+            <a:extLst xmlns:a="http://schemas.openxmlformats.org/drawingml/2006/main">
+              <a:ext uri="{FF2B5EF4-FFF2-40B4-BE49-F238E27FC236}">
+                <a16:creationId xmlns:a16="http://schemas.microsoft.com/office/drawing/2014/main" id="{32BA6995-55CA-4794-B654-19B0035C0632}"/>
+              </a:ext>
+            </a:extLst>
+          </p:cNvPr>
+          <p:cNvSpPr>
+            <a:spLocks xmlns:a="http://schemas.openxmlformats.org/drawingml/2006/main" noGrp="1"/>
+          </p:cNvSpPr>
+          <p:nvPr/>
+        </p:nvSpPr>
+        <p:spPr>
+          <a:xfrm xmlns:a="http://schemas.openxmlformats.org/drawingml/2006/main">
+            <a:off x="9886950" y="6286500"/>
+            <a:ext cx="1905000" cy="381000"/>
+          </a:xfrm>
+          <a:prstGeom xmlns:a="http://schemas.openxmlformats.org/drawingml/2006/main" prst="rect">
+            <a:avLst/>
+          </a:prstGeom>
+          <a:noFill xmlns:a="http://schemas.openxmlformats.org/drawingml/2006/main"/>
+          <a:ln xmlns:a="http://schemas.openxmlformats.org/drawingml/2006/main" w="0">
+            <a:noFill/>
+            <a:prstDash val="solid"/>
+          </a:ln>
+        </p:spPr>
+        <p:txBody>
+          <a:bodyPr xmlns:a="http://schemas.openxmlformats.org/drawingml/2006/main" wrap="square" lIns="0" tIns="0" rIns="0" bIns="0" anchor="t">
+            <a:noAutofit/>
+          </a:bodyPr>
+          <a:lstStyle xmlns:a="http://schemas.openxmlformats.org/drawingml/2006/main"/>
+          <a:p xmlns:a="http://schemas.openxmlformats.org/drawingml/2006/main">
+            <a:pPr algn="l">
+              <a:defRPr sz="900" b="0" i="0">
+                <a:solidFill>
+                  <a:srgbClr val="F3EDE0"/>
+                </a:solidFill>
+                <a:latin typeface="Courier New"/>
+                <a:ea typeface="Courier New"/>
+                <a:cs typeface="Courier New"/>
+              </a:defRPr>
+            </a:pPr>
+            <a:r>
+              <a:rPr sz="900" b="0" i="0">
+                <a:solidFill>
+                  <a:srgbClr val="F3EDE0"/>
+                </a:solidFill>
+                <a:latin typeface="Courier New"/>
+                <a:ea typeface="Courier New"/>
+                <a:cs typeface="Courier New"/>
+              </a:rPr>
+              <a:t>ayushtiwary-ops.github.io</a:t>
+            </a:r>
+          </a:p>
+          <a:p xmlns:a="http://schemas.openxmlformats.org/drawingml/2006/main">
+            <a:pPr algn="l">
+              <a:defRPr sz="900" b="0" i="0">
+                <a:solidFill>
+                  <a:srgbClr val="F3EDE0"/>
+                </a:solidFill>
+                <a:latin typeface="Courier New"/>
+                <a:ea typeface="Courier New"/>
+                <a:cs typeface="Courier New"/>
+              </a:defRPr>
+            </a:pPr>
+            <a:r>
+              <a:rPr sz="900" b="0" i="0">
+                <a:solidFill>
+                  <a:srgbClr val="F3EDE0"/>
+                </a:solidFill>
+                <a:latin typeface="Courier New"/>
+                <a:ea typeface="Courier New"/>
+                <a:cs typeface="Courier New"/>
+              </a:rPr>
+              <a:t>/kriseva-attest</a:t>
             </a:r>
           </a:p>
         </p:txBody>
@@ -2483,7 +2574,7 @@
     </p:spTree>
     <p:extLst>
       <p:ext uri="{BB962C8B-B14F-4D97-AF65-F5344CB8AC3E}">
-        <p14:creationId xmlns:p14="http://schemas.microsoft.com/office/powerpoint/2010/main" val="2006560895"/>
+        <p14:creationId xmlns:p14="http://schemas.microsoft.com/office/powerpoint/2010/main" val="1053460075"/>
       </p:ext>
     </p:extLst>
   </p:cSld>
@@ -2511,10 +2602,10 @@
       </p:grpSpPr>
       <p:sp>
         <p:nvSpPr>
-          <p:cNvPr id="16" name="brand-10">
-            <a:extLst xmlns:a="http://schemas.openxmlformats.org/drawingml/2006/main">
-              <a:ext uri="{FF2B5EF4-FFF2-40B4-BE49-F238E27FC236}">
-                <a16:creationId xmlns:a16="http://schemas.microsoft.com/office/drawing/2014/main" id="{BAE05195-1FF2-484D-845D-A8266270ACF8}"/>
+          <p:cNvPr id="17" name="brand-10">
+            <a:extLst xmlns:a="http://schemas.openxmlformats.org/drawingml/2006/main">
+              <a:ext uri="{FF2B5EF4-FFF2-40B4-BE49-F238E27FC236}">
+                <a16:creationId xmlns:a16="http://schemas.microsoft.com/office/drawing/2014/main" id="{AAD1F7C2-91D6-4475-986C-841A8EE20AC2}"/>
               </a:ext>
             </a:extLst>
           </p:cNvPr>
@@ -2572,7 +2663,7 @@
           <p:cNvPr id="2" name="title-10">
             <a:extLst xmlns:a="http://schemas.openxmlformats.org/drawingml/2006/main">
               <a:ext uri="{FF2B5EF4-FFF2-40B4-BE49-F238E27FC236}">
-                <a16:creationId xmlns:a16="http://schemas.microsoft.com/office/drawing/2014/main" id="{8A4F8C37-0A3D-4610-A4E0-98D581A371D8}"/>
+                <a16:creationId xmlns:a16="http://schemas.microsoft.com/office/drawing/2014/main" id="{CE2F133C-3CF2-41C9-B537-C0A49A0A87C2}"/>
               </a:ext>
             </a:extLst>
           </p:cNvPr>
@@ -2630,7 +2721,7 @@
           <p:cNvPr id="3" name="footer-rule-10">
             <a:extLst xmlns:a="http://schemas.openxmlformats.org/drawingml/2006/main">
               <a:ext uri="{FF2B5EF4-FFF2-40B4-BE49-F238E27FC236}">
-                <a16:creationId xmlns:a16="http://schemas.microsoft.com/office/drawing/2014/main" id="{743ED46B-7E11-4D3F-9734-035366EB939B}"/>
+                <a16:creationId xmlns:a16="http://schemas.microsoft.com/office/drawing/2014/main" id="{7EE465FC-C262-4BD9-90DE-8F9F299D0EDD}"/>
               </a:ext>
             </a:extLst>
           </p:cNvPr>
@@ -2661,7 +2752,7 @@
           <p:cNvPr id="4" name="footer-source-10">
             <a:extLst xmlns:a="http://schemas.openxmlformats.org/drawingml/2006/main">
               <a:ext uri="{FF2B5EF4-FFF2-40B4-BE49-F238E27FC236}">
-                <a16:creationId xmlns:a16="http://schemas.microsoft.com/office/drawing/2014/main" id="{B3EA98DF-D96D-4284-A5E0-2C49C78556B1}"/>
+                <a16:creationId xmlns:a16="http://schemas.microsoft.com/office/drawing/2014/main" id="{6262026B-BB35-4D94-B17E-C8718B0A26C8}"/>
               </a:ext>
             </a:extLst>
           </p:cNvPr>
@@ -2719,7 +2810,7 @@
           <p:cNvPr id="5" name="footer-page-10">
             <a:extLst xmlns:a="http://schemas.openxmlformats.org/drawingml/2006/main">
               <a:ext uri="{FF2B5EF4-FFF2-40B4-BE49-F238E27FC236}">
-                <a16:creationId xmlns:a16="http://schemas.microsoft.com/office/drawing/2014/main" id="{BB4F5FAA-9F11-4242-92EB-949311CEB049}"/>
+                <a16:creationId xmlns:a16="http://schemas.microsoft.com/office/drawing/2014/main" id="{56E8F212-47E3-4F9B-9AD8-B9BD1628956B}"/>
               </a:ext>
             </a:extLst>
           </p:cNvPr>
@@ -2777,7 +2868,7 @@
           <p:cNvPr id="6" name="ask-spine">
             <a:extLst xmlns:a="http://schemas.openxmlformats.org/drawingml/2006/main">
               <a:ext uri="{FF2B5EF4-FFF2-40B4-BE49-F238E27FC236}">
-                <a16:creationId xmlns:a16="http://schemas.microsoft.com/office/drawing/2014/main" id="{0C19BF06-EEB4-480A-8B8A-9AEF4E2A82CD}"/>
+                <a16:creationId xmlns:a16="http://schemas.microsoft.com/office/drawing/2014/main" id="{8F13CC76-23C7-42A9-B699-B2273FC3318D}"/>
               </a:ext>
             </a:extLst>
           </p:cNvPr>
@@ -2808,7 +2899,7 @@
           <p:cNvPr id="7" name="ask-access-label">
             <a:extLst xmlns:a="http://schemas.openxmlformats.org/drawingml/2006/main">
               <a:ext uri="{FF2B5EF4-FFF2-40B4-BE49-F238E27FC236}">
-                <a16:creationId xmlns:a16="http://schemas.microsoft.com/office/drawing/2014/main" id="{5371E774-986F-4EF1-8834-34902E0B4633}"/>
+                <a16:creationId xmlns:a16="http://schemas.microsoft.com/office/drawing/2014/main" id="{E51CF449-4ED9-40F4-871D-CCAE09E45642}"/>
               </a:ext>
             </a:extLst>
           </p:cNvPr>
@@ -2866,7 +2957,7 @@
           <p:cNvPr id="8" name="ask-access-copy">
             <a:extLst xmlns:a="http://schemas.openxmlformats.org/drawingml/2006/main">
               <a:ext uri="{FF2B5EF4-FFF2-40B4-BE49-F238E27FC236}">
-                <a16:creationId xmlns:a16="http://schemas.microsoft.com/office/drawing/2014/main" id="{B3E819DF-0928-4049-B48A-5AE8D6B7B264}"/>
+                <a16:creationId xmlns:a16="http://schemas.microsoft.com/office/drawing/2014/main" id="{BE7CBC18-9AD5-4105-A379-C8F44114B7AB}"/>
               </a:ext>
             </a:extLst>
           </p:cNvPr>
@@ -2878,7 +2969,7 @@
         <p:spPr>
           <a:xfrm xmlns:a="http://schemas.openxmlformats.org/drawingml/2006/main">
             <a:off x="590550" y="2152650"/>
-            <a:ext cx="4000500" cy="1447800"/>
+            <a:ext cx="4000500" cy="2095500"/>
           </a:xfrm>
           <a:prstGeom xmlns:a="http://schemas.openxmlformats.org/drawingml/2006/main" prst="rect">
             <a:avLst/>
@@ -2896,7 +2987,7 @@
           <a:lstStyle xmlns:a="http://schemas.openxmlformats.org/drawingml/2006/main"/>
           <a:p xmlns:a="http://schemas.openxmlformats.org/drawingml/2006/main">
             <a:pPr algn="l">
-              <a:defRPr sz="2400" b="0" i="0">
+              <a:defRPr sz="2250" b="0" i="0">
                 <a:solidFill>
                   <a:srgbClr val="F3EDE0"/>
                 </a:solidFill>
@@ -2906,7 +2997,7 @@
               </a:defRPr>
             </a:pPr>
             <a:r>
-              <a:rPr sz="2400" b="0" i="0">
+              <a:rPr sz="2250" b="0" i="0">
                 <a:solidFill>
                   <a:srgbClr val="F3EDE0"/>
                 </a:solidFill>
@@ -2914,7 +3005,7 @@
                 <a:ea typeface="Georgia"/>
                 <a:cs typeface="Georgia"/>
               </a:rPr>
-              <a:t>2 FME officers + 2 administrators + 1 independent compliance provider</a:t>
+              <a:t>2 FME (fund management entity) officers + 2 administrators + 1 independent compliance provider</a:t>
             </a:r>
           </a:p>
         </p:txBody>
@@ -2924,7 +3015,7 @@
           <p:cNvPr id="9" name="ask-falsify">
             <a:extLst xmlns:a="http://schemas.openxmlformats.org/drawingml/2006/main">
               <a:ext uri="{FF2B5EF4-FFF2-40B4-BE49-F238E27FC236}">
-                <a16:creationId xmlns:a16="http://schemas.microsoft.com/office/drawing/2014/main" id="{9ABFAB83-C815-4CA9-8636-DCD17FD39996}"/>
+                <a16:creationId xmlns:a16="http://schemas.microsoft.com/office/drawing/2014/main" id="{E7F9FCD9-25AD-451E-B375-71BE85564BB2}"/>
               </a:ext>
             </a:extLst>
           </p:cNvPr>
@@ -2982,7 +3073,7 @@
           <p:cNvPr id="10" name="ask-challenge-label">
             <a:extLst xmlns:a="http://schemas.openxmlformats.org/drawingml/2006/main">
               <a:ext uri="{FF2B5EF4-FFF2-40B4-BE49-F238E27FC236}">
-                <a16:creationId xmlns:a16="http://schemas.microsoft.com/office/drawing/2014/main" id="{EBF7626E-8D2E-4783-B58D-D9858C1876E5}"/>
+                <a16:creationId xmlns:a16="http://schemas.microsoft.com/office/drawing/2014/main" id="{25B5AEFB-2E7C-4112-903B-09728E70B281}"/>
               </a:ext>
             </a:extLst>
           </p:cNvPr>
@@ -3040,7 +3131,7 @@
           <p:cNvPr id="11" name="ask-challenge-copy">
             <a:extLst xmlns:a="http://schemas.openxmlformats.org/drawingml/2006/main">
               <a:ext uri="{FF2B5EF4-FFF2-40B4-BE49-F238E27FC236}">
-                <a16:creationId xmlns:a16="http://schemas.microsoft.com/office/drawing/2014/main" id="{D66DA43E-63C6-4567-B472-000AF340CE15}"/>
+                <a16:creationId xmlns:a16="http://schemas.microsoft.com/office/drawing/2014/main" id="{4E7E9FD8-06E9-4024-BD71-B38A03F19387}"/>
               </a:ext>
             </a:extLst>
           </p:cNvPr>
@@ -3088,7 +3179,7 @@
                 <a:ea typeface="Georgia"/>
                 <a:cs typeface="Georgia"/>
               </a:rPr>
-              <a:t>Is upstream evidence work outside DRR or bundled services?</a:t>
+              <a:t>Is upstream evidence outside DRR/bundled services?</a:t>
             </a:r>
           </a:p>
         </p:txBody>
@@ -3098,7 +3189,7 @@
           <p:cNvPr id="12" name="ask-test-label">
             <a:extLst xmlns:a="http://schemas.openxmlformats.org/drawingml/2006/main">
               <a:ext uri="{FF2B5EF4-FFF2-40B4-BE49-F238E27FC236}">
-                <a16:creationId xmlns:a16="http://schemas.microsoft.com/office/drawing/2014/main" id="{D8C15BE1-C25D-4DA8-A40E-E0750B6D3F32}"/>
+                <a16:creationId xmlns:a16="http://schemas.microsoft.com/office/drawing/2014/main" id="{D872DA96-4469-4F8C-BB48-90BD9C147977}"/>
               </a:ext>
             </a:extLst>
           </p:cNvPr>
@@ -3156,7 +3247,7 @@
           <p:cNvPr id="13" name="ask-test-copy">
             <a:extLst xmlns:a="http://schemas.openxmlformats.org/drawingml/2006/main">
               <a:ext uri="{FF2B5EF4-FFF2-40B4-BE49-F238E27FC236}">
-                <a16:creationId xmlns:a16="http://schemas.microsoft.com/office/drawing/2014/main" id="{11BDFBA6-217D-4362-BAA4-55C98D0255CE}"/>
+                <a16:creationId xmlns:a16="http://schemas.microsoft.com/office/drawing/2014/main" id="{89F0F8DF-70D7-402E-9F9C-E52074D49268}"/>
               </a:ext>
             </a:extLst>
           </p:cNvPr>
@@ -3214,7 +3305,7 @@
           <p:cNvPr id="14" name="ask-decide-label">
             <a:extLst xmlns:a="http://schemas.openxmlformats.org/drawingml/2006/main">
               <a:ext uri="{FF2B5EF4-FFF2-40B4-BE49-F238E27FC236}">
-                <a16:creationId xmlns:a16="http://schemas.microsoft.com/office/drawing/2014/main" id="{00A62B7D-CF16-4B44-92DF-8A53887F2925}"/>
+                <a16:creationId xmlns:a16="http://schemas.microsoft.com/office/drawing/2014/main" id="{01B19575-A25D-4820-9636-3CC1C03AAF4C}"/>
               </a:ext>
             </a:extLst>
           </p:cNvPr>
@@ -3272,7 +3363,7 @@
           <p:cNvPr id="15" name="ask-decide-copy">
             <a:extLst xmlns:a="http://schemas.openxmlformats.org/drawingml/2006/main">
               <a:ext uri="{FF2B5EF4-FFF2-40B4-BE49-F238E27FC236}">
-                <a16:creationId xmlns:a16="http://schemas.microsoft.com/office/drawing/2014/main" id="{C5892CDA-A4FD-4CB7-812A-BACE8F1D7F93}"/>
+                <a16:creationId xmlns:a16="http://schemas.microsoft.com/office/drawing/2014/main" id="{5B74DB67-B010-4430-8D37-72D7CC2D6E0D}"/>
               </a:ext>
             </a:extLst>
           </p:cNvPr>
@@ -3325,10 +3416,68 @@
           </a:p>
         </p:txBody>
       </p:sp>
+      <p:sp>
+        <p:nvSpPr>
+          <p:cNvPr id="16" name="footer-ask-links">
+            <a:extLst xmlns:a="http://schemas.openxmlformats.org/drawingml/2006/main">
+              <a:ext uri="{FF2B5EF4-FFF2-40B4-BE49-F238E27FC236}">
+                <a16:creationId xmlns:a16="http://schemas.microsoft.com/office/drawing/2014/main" id="{DA4CABDD-ABBD-4FA7-A03A-A51A99268C5F}"/>
+              </a:ext>
+            </a:extLst>
+          </p:cNvPr>
+          <p:cNvSpPr>
+            <a:spLocks xmlns:a="http://schemas.openxmlformats.org/drawingml/2006/main" noGrp="1"/>
+          </p:cNvSpPr>
+          <p:nvPr/>
+        </p:nvSpPr>
+        <p:spPr>
+          <a:xfrm xmlns:a="http://schemas.openxmlformats.org/drawingml/2006/main">
+            <a:off x="590550" y="5981700"/>
+            <a:ext cx="10668000" cy="228600"/>
+          </a:xfrm>
+          <a:prstGeom xmlns:a="http://schemas.openxmlformats.org/drawingml/2006/main" prst="rect">
+            <a:avLst/>
+          </a:prstGeom>
+          <a:noFill xmlns:a="http://schemas.openxmlformats.org/drawingml/2006/main"/>
+          <a:ln xmlns:a="http://schemas.openxmlformats.org/drawingml/2006/main" w="0">
+            <a:noFill/>
+            <a:prstDash val="solid"/>
+          </a:ln>
+        </p:spPr>
+        <p:txBody>
+          <a:bodyPr xmlns:a="http://schemas.openxmlformats.org/drawingml/2006/main" wrap="square" lIns="0" tIns="0" rIns="0" bIns="0" anchor="t">
+            <a:noAutofit/>
+          </a:bodyPr>
+          <a:lstStyle xmlns:a="http://schemas.openxmlformats.org/drawingml/2006/main"/>
+          <a:p xmlns:a="http://schemas.openxmlformats.org/drawingml/2006/main">
+            <a:pPr algn="l">
+              <a:defRPr sz="975" b="0" i="0">
+                <a:solidFill>
+                  <a:srgbClr val="F3EDE0"/>
+                </a:solidFill>
+                <a:latin typeface="Courier New"/>
+                <a:ea typeface="Courier New"/>
+                <a:cs typeface="Courier New"/>
+              </a:defRPr>
+            </a:pPr>
+            <a:r>
+              <a:rPr sz="975" b="0" i="0">
+                <a:solidFill>
+                  <a:srgbClr val="F3EDE0"/>
+                </a:solidFill>
+                <a:latin typeface="Courier New"/>
+                <a:ea typeface="Courier New"/>
+                <a:cs typeface="Courier New"/>
+              </a:rPr>
+              <a:t>Live: ayushtiwary-ops.github.io/kriseva-attest  ·  Code: github.com/ayushtiwary-ops/kriseva-attest</a:t>
+            </a:r>
+          </a:p>
+        </p:txBody>
+      </p:sp>
     </p:spTree>
     <p:extLst>
       <p:ext uri="{BB962C8B-B14F-4D97-AF65-F5344CB8AC3E}">
-        <p14:creationId xmlns:p14="http://schemas.microsoft.com/office/powerpoint/2010/main" val="1309001528"/>
+        <p14:creationId xmlns:p14="http://schemas.microsoft.com/office/powerpoint/2010/main" val="150700677"/>
       </p:ext>
     </p:extLst>
   </p:cSld>
@@ -3356,10 +3505,10 @@
       </p:grpSpPr>
       <p:sp>
         <p:nvSpPr>
-          <p:cNvPr id="15" name="brand-2">
-            <a:extLst xmlns:a="http://schemas.openxmlformats.org/drawingml/2006/main">
-              <a:ext uri="{FF2B5EF4-FFF2-40B4-BE49-F238E27FC236}">
-                <a16:creationId xmlns:a16="http://schemas.microsoft.com/office/drawing/2014/main" id="{C1AC0916-AE49-4370-93EA-DEDA0B7EA452}"/>
+          <p:cNvPr id="18" name="brand-2">
+            <a:extLst xmlns:a="http://schemas.openxmlformats.org/drawingml/2006/main">
+              <a:ext uri="{FF2B5EF4-FFF2-40B4-BE49-F238E27FC236}">
+                <a16:creationId xmlns:a16="http://schemas.microsoft.com/office/drawing/2014/main" id="{C6759A71-4779-43EF-AB43-6356C191AC2C}"/>
               </a:ext>
             </a:extLst>
           </p:cNvPr>
@@ -3417,7 +3566,7 @@
           <p:cNvPr id="2" name="title-2">
             <a:extLst xmlns:a="http://schemas.openxmlformats.org/drawingml/2006/main">
               <a:ext uri="{FF2B5EF4-FFF2-40B4-BE49-F238E27FC236}">
-                <a16:creationId xmlns:a16="http://schemas.microsoft.com/office/drawing/2014/main" id="{03379C18-1565-4561-BBE1-EBB014CAEA9D}"/>
+                <a16:creationId xmlns:a16="http://schemas.microsoft.com/office/drawing/2014/main" id="{53DF900D-A260-4F54-83D0-527893B8B23E}"/>
               </a:ext>
             </a:extLst>
           </p:cNvPr>
@@ -3475,7 +3624,7 @@
           <p:cNvPr id="3" name="footer-rule-2">
             <a:extLst xmlns:a="http://schemas.openxmlformats.org/drawingml/2006/main">
               <a:ext uri="{FF2B5EF4-FFF2-40B4-BE49-F238E27FC236}">
-                <a16:creationId xmlns:a16="http://schemas.microsoft.com/office/drawing/2014/main" id="{A925C9C0-5EB4-43EC-9AA1-5944FB01D4E9}"/>
+                <a16:creationId xmlns:a16="http://schemas.microsoft.com/office/drawing/2014/main" id="{1BB957D9-EDB4-41FC-8269-00E902FB96E0}"/>
               </a:ext>
             </a:extLst>
           </p:cNvPr>
@@ -3506,7 +3655,7 @@
           <p:cNvPr id="4" name="footer-source-2">
             <a:extLst xmlns:a="http://schemas.openxmlformats.org/drawingml/2006/main">
               <a:ext uri="{FF2B5EF4-FFF2-40B4-BE49-F238E27FC236}">
-                <a16:creationId xmlns:a16="http://schemas.microsoft.com/office/drawing/2014/main" id="{57466D05-2A50-4D40-A008-5852D4DBBD63}"/>
+                <a16:creationId xmlns:a16="http://schemas.microsoft.com/office/drawing/2014/main" id="{19DF77C4-0EA4-44AE-90F8-9784F234162B}"/>
               </a:ext>
             </a:extLst>
           </p:cNvPr>
@@ -3564,7 +3713,7 @@
           <p:cNvPr id="5" name="footer-page-2">
             <a:extLst xmlns:a="http://schemas.openxmlformats.org/drawingml/2006/main">
               <a:ext uri="{FF2B5EF4-FFF2-40B4-BE49-F238E27FC236}">
-                <a16:creationId xmlns:a16="http://schemas.microsoft.com/office/drawing/2014/main" id="{BD53F46E-07A8-4E99-B637-BE7D817BA151}"/>
+                <a16:creationId xmlns:a16="http://schemas.microsoft.com/office/drawing/2014/main" id="{EB8E1AF8-94DD-45D9-8FCF-D90C2CFE5FBA}"/>
               </a:ext>
             </a:extLst>
           </p:cNvPr>
@@ -3622,7 +3771,7 @@
           <p:cNvPr id="6" name="accountability-divider">
             <a:extLst xmlns:a="http://schemas.openxmlformats.org/drawingml/2006/main">
               <a:ext uri="{FF2B5EF4-FFF2-40B4-BE49-F238E27FC236}">
-                <a16:creationId xmlns:a16="http://schemas.microsoft.com/office/drawing/2014/main" id="{68563A27-504A-4C28-83D2-90A1313F5643}"/>
+                <a16:creationId xmlns:a16="http://schemas.microsoft.com/office/drawing/2014/main" id="{0254F7FF-A64F-45EF-917D-1334E810FF83}"/>
               </a:ext>
             </a:extLst>
           </p:cNvPr>
@@ -3653,7 +3802,7 @@
           <p:cNvPr id="7" name="accountability-label">
             <a:extLst xmlns:a="http://schemas.openxmlformats.org/drawingml/2006/main">
               <a:ext uri="{FF2B5EF4-FFF2-40B4-BE49-F238E27FC236}">
-                <a16:creationId xmlns:a16="http://schemas.microsoft.com/office/drawing/2014/main" id="{7CACD1AE-EF69-4683-8AA3-91B9192AFF35}"/>
+                <a16:creationId xmlns:a16="http://schemas.microsoft.com/office/drawing/2014/main" id="{F2F65F0D-5D35-417B-AA5A-4C5C59B40577}"/>
               </a:ext>
             </a:extLst>
           </p:cNvPr>
@@ -3711,7 +3860,7 @@
           <p:cNvPr id="8" name="accountability-structured">
             <a:extLst xmlns:a="http://schemas.openxmlformats.org/drawingml/2006/main">
               <a:ext uri="{FF2B5EF4-FFF2-40B4-BE49-F238E27FC236}">
-                <a16:creationId xmlns:a16="http://schemas.microsoft.com/office/drawing/2014/main" id="{50051031-FA0E-41C9-AF1A-24A3F5CA7242}"/>
+                <a16:creationId xmlns:a16="http://schemas.microsoft.com/office/drawing/2014/main" id="{CAA74730-000E-45E9-9A38-9231F2854EE1}"/>
               </a:ext>
             </a:extLst>
           </p:cNvPr>
@@ -3769,7 +3918,7 @@
           <p:cNvPr id="9" name="accountability-question">
             <a:extLst xmlns:a="http://schemas.openxmlformats.org/drawingml/2006/main">
               <a:ext uri="{FF2B5EF4-FFF2-40B4-BE49-F238E27FC236}">
-                <a16:creationId xmlns:a16="http://schemas.microsoft.com/office/drawing/2014/main" id="{EC140DA9-51BF-414D-AEA3-3EE3819620A5}"/>
+                <a16:creationId xmlns:a16="http://schemas.microsoft.com/office/drawing/2014/main" id="{B20340B7-9E79-4277-95F2-D8EE3284C963}"/>
               </a:ext>
             </a:extLst>
           </p:cNvPr>
@@ -3824,10 +3973,68 @@
       </p:sp>
       <p:sp>
         <p:nvSpPr>
-          <p:cNvPr id="10" name="accountability-source-rule-1">
-            <a:extLst xmlns:a="http://schemas.openxmlformats.org/drawingml/2006/main">
-              <a:ext uri="{FF2B5EF4-FFF2-40B4-BE49-F238E27FC236}">
-                <a16:creationId xmlns:a16="http://schemas.microsoft.com/office/drawing/2014/main" id="{43E98316-E7A7-4EFC-9BAB-40CAAA0B7F71}"/>
+          <p:cNvPr id="10" name="footer-accountability-caption-1">
+            <a:extLst xmlns:a="http://schemas.openxmlformats.org/drawingml/2006/main">
+              <a:ext uri="{FF2B5EF4-FFF2-40B4-BE49-F238E27FC236}">
+                <a16:creationId xmlns:a16="http://schemas.microsoft.com/office/drawing/2014/main" id="{9B51D584-0C98-4F3D-A2AD-270B10F84BEF}"/>
+              </a:ext>
+            </a:extLst>
+          </p:cNvPr>
+          <p:cNvSpPr>
+            <a:spLocks xmlns:a="http://schemas.openxmlformats.org/drawingml/2006/main" noGrp="1"/>
+          </p:cNvSpPr>
+          <p:nvPr/>
+        </p:nvSpPr>
+        <p:spPr>
+          <a:xfrm xmlns:a="http://schemas.openxmlformats.org/drawingml/2006/main">
+            <a:off x="7239000" y="1638300"/>
+            <a:ext cx="1905000" cy="171450"/>
+          </a:xfrm>
+          <a:prstGeom xmlns:a="http://schemas.openxmlformats.org/drawingml/2006/main" prst="rect">
+            <a:avLst/>
+          </a:prstGeom>
+          <a:noFill xmlns:a="http://schemas.openxmlformats.org/drawingml/2006/main"/>
+          <a:ln xmlns:a="http://schemas.openxmlformats.org/drawingml/2006/main" w="0">
+            <a:noFill/>
+            <a:prstDash val="solid"/>
+          </a:ln>
+        </p:spPr>
+        <p:txBody>
+          <a:bodyPr xmlns:a="http://schemas.openxmlformats.org/drawingml/2006/main" wrap="square" lIns="0" tIns="0" rIns="0" bIns="0" anchor="t">
+            <a:noAutofit/>
+          </a:bodyPr>
+          <a:lstStyle xmlns:a="http://schemas.openxmlformats.org/drawingml/2006/main"/>
+          <a:p xmlns:a="http://schemas.openxmlformats.org/drawingml/2006/main">
+            <a:pPr algn="l">
+              <a:defRPr sz="975" b="1" i="0">
+                <a:solidFill>
+                  <a:srgbClr val="A87229"/>
+                </a:solidFill>
+                <a:latin typeface="Courier New"/>
+                <a:ea typeface="Courier New"/>
+                <a:cs typeface="Courier New"/>
+              </a:defRPr>
+            </a:pPr>
+            <a:r>
+              <a:rPr sz="975" b="1" i="0">
+                <a:solidFill>
+                  <a:srgbClr val="A87229"/>
+                </a:solidFill>
+                <a:latin typeface="Courier New"/>
+                <a:ea typeface="Courier New"/>
+                <a:cs typeface="Courier New"/>
+              </a:rPr>
+              <a:t>STATEMENT</a:t>
+            </a:r>
+          </a:p>
+        </p:txBody>
+      </p:sp>
+      <p:sp>
+        <p:nvSpPr>
+          <p:cNvPr id="11" name="accountability-source-rule-1">
+            <a:extLst xmlns:a="http://schemas.openxmlformats.org/drawingml/2006/main">
+              <a:ext uri="{FF2B5EF4-FFF2-40B4-BE49-F238E27FC236}">
+                <a16:creationId xmlns:a16="http://schemas.microsoft.com/office/drawing/2014/main" id="{3A227878-5620-4FD7-B819-A10D4F9D09D3}"/>
               </a:ext>
             </a:extLst>
           </p:cNvPr>
@@ -3855,10 +4062,68 @@
       </p:sp>
       <p:sp>
         <p:nvSpPr>
-          <p:cNvPr id="11" name="accountability-source-rule-2">
-            <a:extLst xmlns:a="http://schemas.openxmlformats.org/drawingml/2006/main">
-              <a:ext uri="{FF2B5EF4-FFF2-40B4-BE49-F238E27FC236}">
-                <a16:creationId xmlns:a16="http://schemas.microsoft.com/office/drawing/2014/main" id="{9BECA429-CEFF-4CDE-BEE0-2294436639AE}"/>
+          <p:cNvPr id="12" name="footer-accountability-caption-2">
+            <a:extLst xmlns:a="http://schemas.openxmlformats.org/drawingml/2006/main">
+              <a:ext uri="{FF2B5EF4-FFF2-40B4-BE49-F238E27FC236}">
+                <a16:creationId xmlns:a16="http://schemas.microsoft.com/office/drawing/2014/main" id="{E7E8C79D-2824-4574-85C7-F02020BC9DA4}"/>
+              </a:ext>
+            </a:extLst>
+          </p:cNvPr>
+          <p:cNvSpPr>
+            <a:spLocks xmlns:a="http://schemas.openxmlformats.org/drawingml/2006/main" noGrp="1"/>
+          </p:cNvSpPr>
+          <p:nvPr/>
+        </p:nvSpPr>
+        <p:spPr>
+          <a:xfrm xmlns:a="http://schemas.openxmlformats.org/drawingml/2006/main">
+            <a:off x="7239000" y="2266950"/>
+            <a:ext cx="1905000" cy="171450"/>
+          </a:xfrm>
+          <a:prstGeom xmlns:a="http://schemas.openxmlformats.org/drawingml/2006/main" prst="rect">
+            <a:avLst/>
+          </a:prstGeom>
+          <a:noFill xmlns:a="http://schemas.openxmlformats.org/drawingml/2006/main"/>
+          <a:ln xmlns:a="http://schemas.openxmlformats.org/drawingml/2006/main" w="0">
+            <a:noFill/>
+            <a:prstDash val="solid"/>
+          </a:ln>
+        </p:spPr>
+        <p:txBody>
+          <a:bodyPr xmlns:a="http://schemas.openxmlformats.org/drawingml/2006/main" wrap="square" lIns="0" tIns="0" rIns="0" bIns="0" anchor="t">
+            <a:noAutofit/>
+          </a:bodyPr>
+          <a:lstStyle xmlns:a="http://schemas.openxmlformats.org/drawingml/2006/main"/>
+          <a:p xmlns:a="http://schemas.openxmlformats.org/drawingml/2006/main">
+            <a:pPr algn="l">
+              <a:defRPr sz="975" b="1" i="0">
+                <a:solidFill>
+                  <a:srgbClr val="A87229"/>
+                </a:solidFill>
+                <a:latin typeface="Courier New"/>
+                <a:ea typeface="Courier New"/>
+                <a:cs typeface="Courier New"/>
+              </a:defRPr>
+            </a:pPr>
+            <a:r>
+              <a:rPr sz="975" b="1" i="0">
+                <a:solidFill>
+                  <a:srgbClr val="A87229"/>
+                </a:solidFill>
+                <a:latin typeface="Courier New"/>
+                <a:ea typeface="Courier New"/>
+                <a:cs typeface="Courier New"/>
+              </a:rPr>
+              <a:t>LEDGER</a:t>
+            </a:r>
+          </a:p>
+        </p:txBody>
+      </p:sp>
+      <p:sp>
+        <p:nvSpPr>
+          <p:cNvPr id="13" name="accountability-source-rule-2">
+            <a:extLst xmlns:a="http://schemas.openxmlformats.org/drawingml/2006/main">
+              <a:ext uri="{FF2B5EF4-FFF2-40B4-BE49-F238E27FC236}">
+                <a16:creationId xmlns:a16="http://schemas.microsoft.com/office/drawing/2014/main" id="{661F3BF3-F55D-4A6A-BFCB-2A01D845F8FA}"/>
               </a:ext>
             </a:extLst>
           </p:cNvPr>
@@ -3886,10 +4151,68 @@
       </p:sp>
       <p:sp>
         <p:nvSpPr>
-          <p:cNvPr id="12" name="accountability-source-rule-3">
-            <a:extLst xmlns:a="http://schemas.openxmlformats.org/drawingml/2006/main">
-              <a:ext uri="{FF2B5EF4-FFF2-40B4-BE49-F238E27FC236}">
-                <a16:creationId xmlns:a16="http://schemas.microsoft.com/office/drawing/2014/main" id="{A5528252-06F1-470F-BF9A-7F2954F677BC}"/>
+          <p:cNvPr id="14" name="footer-accountability-caption-3">
+            <a:extLst xmlns:a="http://schemas.openxmlformats.org/drawingml/2006/main">
+              <a:ext uri="{FF2B5EF4-FFF2-40B4-BE49-F238E27FC236}">
+                <a16:creationId xmlns:a16="http://schemas.microsoft.com/office/drawing/2014/main" id="{F21C67DB-C8B4-447F-B1F1-CC95C2D723F7}"/>
+              </a:ext>
+            </a:extLst>
+          </p:cNvPr>
+          <p:cNvSpPr>
+            <a:spLocks xmlns:a="http://schemas.openxmlformats.org/drawingml/2006/main" noGrp="1"/>
+          </p:cNvSpPr>
+          <p:nvPr/>
+        </p:nvSpPr>
+        <p:spPr>
+          <a:xfrm xmlns:a="http://schemas.openxmlformats.org/drawingml/2006/main">
+            <a:off x="7239000" y="2895600"/>
+            <a:ext cx="1905000" cy="171450"/>
+          </a:xfrm>
+          <a:prstGeom xmlns:a="http://schemas.openxmlformats.org/drawingml/2006/main" prst="rect">
+            <a:avLst/>
+          </a:prstGeom>
+          <a:noFill xmlns:a="http://schemas.openxmlformats.org/drawingml/2006/main"/>
+          <a:ln xmlns:a="http://schemas.openxmlformats.org/drawingml/2006/main" w="0">
+            <a:noFill/>
+            <a:prstDash val="solid"/>
+          </a:ln>
+        </p:spPr>
+        <p:txBody>
+          <a:bodyPr xmlns:a="http://schemas.openxmlformats.org/drawingml/2006/main" wrap="square" lIns="0" tIns="0" rIns="0" bIns="0" anchor="t">
+            <a:noAutofit/>
+          </a:bodyPr>
+          <a:lstStyle xmlns:a="http://schemas.openxmlformats.org/drawingml/2006/main"/>
+          <a:p xmlns:a="http://schemas.openxmlformats.org/drawingml/2006/main">
+            <a:pPr algn="l">
+              <a:defRPr sz="975" b="1" i="0">
+                <a:solidFill>
+                  <a:srgbClr val="A87229"/>
+                </a:solidFill>
+                <a:latin typeface="Courier New"/>
+                <a:ea typeface="Courier New"/>
+                <a:cs typeface="Courier New"/>
+              </a:defRPr>
+            </a:pPr>
+            <a:r>
+              <a:rPr sz="975" b="1" i="0">
+                <a:solidFill>
+                  <a:srgbClr val="A87229"/>
+                </a:solidFill>
+                <a:latin typeface="Courier New"/>
+                <a:ea typeface="Courier New"/>
+                <a:cs typeface="Courier New"/>
+              </a:rPr>
+              <a:t>SCHEDULE</a:t>
+            </a:r>
+          </a:p>
+        </p:txBody>
+      </p:sp>
+      <p:sp>
+        <p:nvSpPr>
+          <p:cNvPr id="15" name="accountability-source-rule-3">
+            <a:extLst xmlns:a="http://schemas.openxmlformats.org/drawingml/2006/main">
+              <a:ext uri="{FF2B5EF4-FFF2-40B4-BE49-F238E27FC236}">
+                <a16:creationId xmlns:a16="http://schemas.microsoft.com/office/drawing/2014/main" id="{B18DEAAC-8315-4C48-B77B-6315F75A8569}"/>
               </a:ext>
             </a:extLst>
           </p:cNvPr>
@@ -3917,10 +4240,10 @@
       </p:sp>
       <p:sp>
         <p:nvSpPr>
-          <p:cNvPr id="13" name="accountability-evidence">
-            <a:extLst xmlns:a="http://schemas.openxmlformats.org/drawingml/2006/main">
-              <a:ext uri="{FF2B5EF4-FFF2-40B4-BE49-F238E27FC236}">
-                <a16:creationId xmlns:a16="http://schemas.microsoft.com/office/drawing/2014/main" id="{D071A803-EFD0-428D-AAC9-C702C5246ECC}"/>
+          <p:cNvPr id="16" name="accountability-evidence">
+            <a:extLst xmlns:a="http://schemas.openxmlformats.org/drawingml/2006/main">
+              <a:ext uri="{FF2B5EF4-FFF2-40B4-BE49-F238E27FC236}">
+                <a16:creationId xmlns:a16="http://schemas.microsoft.com/office/drawing/2014/main" id="{D8956D23-9DAC-4E9C-AF16-61CEC653FB2A}"/>
               </a:ext>
             </a:extLst>
           </p:cNvPr>
@@ -3975,10 +4298,10 @@
       </p:sp>
       <p:sp>
         <p:nvSpPr>
-          <p:cNvPr id="14" name="accountability-unknowns">
-            <a:extLst xmlns:a="http://schemas.openxmlformats.org/drawingml/2006/main">
-              <a:ext uri="{FF2B5EF4-FFF2-40B4-BE49-F238E27FC236}">
-                <a16:creationId xmlns:a16="http://schemas.microsoft.com/office/drawing/2014/main" id="{C8AB2840-5B2F-4DC0-BDE8-75FC2FF53E81}"/>
+          <p:cNvPr id="17" name="accountability-unknowns">
+            <a:extLst xmlns:a="http://schemas.openxmlformats.org/drawingml/2006/main">
+              <a:ext uri="{FF2B5EF4-FFF2-40B4-BE49-F238E27FC236}">
+                <a16:creationId xmlns:a16="http://schemas.microsoft.com/office/drawing/2014/main" id="{37BAE2C6-2B73-4647-963E-B7C14111BD72}"/>
               </a:ext>
             </a:extLst>
           </p:cNvPr>
@@ -4034,7 +4357,7 @@
     </p:spTree>
     <p:extLst>
       <p:ext uri="{BB962C8B-B14F-4D97-AF65-F5344CB8AC3E}">
-        <p14:creationId xmlns:p14="http://schemas.microsoft.com/office/powerpoint/2010/main" val="641124769"/>
+        <p14:creationId xmlns:p14="http://schemas.microsoft.com/office/powerpoint/2010/main" val="169805241"/>
       </p:ext>
     </p:extLst>
   </p:cSld>
@@ -4065,7 +4388,7 @@
           <p:cNvPr id="14" name="brand-3">
             <a:extLst xmlns:a="http://schemas.openxmlformats.org/drawingml/2006/main">
               <a:ext uri="{FF2B5EF4-FFF2-40B4-BE49-F238E27FC236}">
-                <a16:creationId xmlns:a16="http://schemas.microsoft.com/office/drawing/2014/main" id="{8EA70884-61C6-4C23-AA01-D35ADBFA81F0}"/>
+                <a16:creationId xmlns:a16="http://schemas.microsoft.com/office/drawing/2014/main" id="{315A9DFE-570F-495C-8304-9F1D353D383B}"/>
               </a:ext>
             </a:extLst>
           </p:cNvPr>
@@ -4123,7 +4446,7 @@
           <p:cNvPr id="2" name="title-3">
             <a:extLst xmlns:a="http://schemas.openxmlformats.org/drawingml/2006/main">
               <a:ext uri="{FF2B5EF4-FFF2-40B4-BE49-F238E27FC236}">
-                <a16:creationId xmlns:a16="http://schemas.microsoft.com/office/drawing/2014/main" id="{A608939E-511B-4799-BFAD-D5DA851CE620}"/>
+                <a16:creationId xmlns:a16="http://schemas.microsoft.com/office/drawing/2014/main" id="{F85C880B-E823-4196-9B1D-0C965DF2BCB3}"/>
               </a:ext>
             </a:extLst>
           </p:cNvPr>
@@ -4181,7 +4504,7 @@
           <p:cNvPr id="3" name="footer-rule-3">
             <a:extLst xmlns:a="http://schemas.openxmlformats.org/drawingml/2006/main">
               <a:ext uri="{FF2B5EF4-FFF2-40B4-BE49-F238E27FC236}">
-                <a16:creationId xmlns:a16="http://schemas.microsoft.com/office/drawing/2014/main" id="{7A08A3B3-07F5-4003-9FF1-895784932C4E}"/>
+                <a16:creationId xmlns:a16="http://schemas.microsoft.com/office/drawing/2014/main" id="{2364EBD3-0D3A-4361-953A-8FBF425069E9}"/>
               </a:ext>
             </a:extLst>
           </p:cNvPr>
@@ -4212,7 +4535,7 @@
           <p:cNvPr id="4" name="footer-source-3">
             <a:extLst xmlns:a="http://schemas.openxmlformats.org/drawingml/2006/main">
               <a:ext uri="{FF2B5EF4-FFF2-40B4-BE49-F238E27FC236}">
-                <a16:creationId xmlns:a16="http://schemas.microsoft.com/office/drawing/2014/main" id="{8C767D59-2D18-47A6-82B1-EF31B55530D9}"/>
+                <a16:creationId xmlns:a16="http://schemas.microsoft.com/office/drawing/2014/main" id="{A4A0BC92-D01E-469A-8BA2-EAA3B9A9F14F}"/>
               </a:ext>
             </a:extLst>
           </p:cNvPr>
@@ -4270,7 +4593,7 @@
           <p:cNvPr id="5" name="footer-page-3">
             <a:extLst xmlns:a="http://schemas.openxmlformats.org/drawingml/2006/main">
               <a:ext uri="{FF2B5EF4-FFF2-40B4-BE49-F238E27FC236}">
-                <a16:creationId xmlns:a16="http://schemas.microsoft.com/office/drawing/2014/main" id="{9B6806C7-1467-49A3-B5C8-6CEE4CEC1605}"/>
+                <a16:creationId xmlns:a16="http://schemas.microsoft.com/office/drawing/2014/main" id="{B5DCF227-A2D3-4094-B763-7509640310DE}"/>
               </a:ext>
             </a:extLst>
           </p:cNvPr>
@@ -4328,7 +4651,7 @@
           <p:cNvPr id="6" name="boundary-left">
             <a:extLst xmlns:a="http://schemas.openxmlformats.org/drawingml/2006/main">
               <a:ext uri="{FF2B5EF4-FFF2-40B4-BE49-F238E27FC236}">
-                <a16:creationId xmlns:a16="http://schemas.microsoft.com/office/drawing/2014/main" id="{F1D8E93C-F99F-47E2-81BA-B9F8248C497C}"/>
+                <a16:creationId xmlns:a16="http://schemas.microsoft.com/office/drawing/2014/main" id="{DF605CF2-CF2A-4348-B531-64999BDFFCF5}"/>
               </a:ext>
             </a:extLst>
           </p:cNvPr>
@@ -4361,7 +4684,7 @@
           <p:cNvPr id="7" name="boundary-spine">
             <a:extLst xmlns:a="http://schemas.openxmlformats.org/drawingml/2006/main">
               <a:ext uri="{FF2B5EF4-FFF2-40B4-BE49-F238E27FC236}">
-                <a16:creationId xmlns:a16="http://schemas.microsoft.com/office/drawing/2014/main" id="{E203CEF2-F987-4325-985A-62C4B3A7714B}"/>
+                <a16:creationId xmlns:a16="http://schemas.microsoft.com/office/drawing/2014/main" id="{4F72DE0C-80EB-461B-ACA2-174F9583980A}"/>
               </a:ext>
             </a:extLst>
           </p:cNvPr>
@@ -4392,7 +4715,7 @@
           <p:cNvPr id="8" name="boundary-drr">
             <a:extLst xmlns:a="http://schemas.openxmlformats.org/drawingml/2006/main">
               <a:ext uri="{FF2B5EF4-FFF2-40B4-BE49-F238E27FC236}">
-                <a16:creationId xmlns:a16="http://schemas.microsoft.com/office/drawing/2014/main" id="{9F7133F5-B971-4695-B284-B2765B80149C}"/>
+                <a16:creationId xmlns:a16="http://schemas.microsoft.com/office/drawing/2014/main" id="{978AD53D-2E70-4954-9787-20651EAB5B48}"/>
               </a:ext>
             </a:extLst>
           </p:cNvPr>
@@ -4450,7 +4773,7 @@
           <p:cNvPr id="9" name="boundary-drr-copy">
             <a:extLst xmlns:a="http://schemas.openxmlformats.org/drawingml/2006/main">
               <a:ext uri="{FF2B5EF4-FFF2-40B4-BE49-F238E27FC236}">
-                <a16:creationId xmlns:a16="http://schemas.microsoft.com/office/drawing/2014/main" id="{991B1174-F4A5-4B48-9260-90F1C0C99398}"/>
+                <a16:creationId xmlns:a16="http://schemas.microsoft.com/office/drawing/2014/main" id="{00A783FF-8049-49F6-8ED7-1A78708D056E}"/>
               </a:ext>
             </a:extLst>
           </p:cNvPr>
@@ -4462,7 +4785,7 @@
         <p:spPr>
           <a:xfrm xmlns:a="http://schemas.openxmlformats.org/drawingml/2006/main">
             <a:off x="628650" y="2781300"/>
-            <a:ext cx="4762500" cy="1143000"/>
+            <a:ext cx="4762500" cy="2190750"/>
           </a:xfrm>
           <a:prstGeom xmlns:a="http://schemas.openxmlformats.org/drawingml/2006/main" prst="rect">
             <a:avLst/>
@@ -4480,7 +4803,7 @@
           <a:lstStyle xmlns:a="http://schemas.openxmlformats.org/drawingml/2006/main"/>
           <a:p xmlns:a="http://schemas.openxmlformats.org/drawingml/2006/main">
             <a:pPr algn="l">
-              <a:defRPr sz="2025" b="0" i="0">
+              <a:defRPr sz="1800" b="0" i="0">
                 <a:solidFill>
                   <a:srgbClr val="F3EDE0"/>
                 </a:solidFill>
@@ -4490,7 +4813,7 @@
               </a:defRPr>
             </a:pPr>
             <a:r>
-              <a:rPr sz="2025" b="0" i="0">
+              <a:rPr sz="1800" b="0" i="0">
                 <a:solidFill>
                   <a:srgbClr val="F3EDE0"/>
                 </a:solidFill>
@@ -4498,29 +4821,145 @@
                 <a:ea typeface="Georgia"/>
                 <a:cs typeface="Georgia"/>
               </a:rPr>
-              <a:t>Structured reporting channels, validation and submission infrastructure</a:t>
-            </a:r>
-          </a:p>
-        </p:txBody>
-      </p:sp>
-      <p:sp>
-        <p:nvSpPr>
-          <p:cNvPr id="10" name="boundary-absence">
-            <a:extLst xmlns:a="http://schemas.openxmlformats.org/drawingml/2006/main">
-              <a:ext uri="{FF2B5EF4-FFF2-40B4-BE49-F238E27FC236}">
-                <a16:creationId xmlns:a16="http://schemas.microsoft.com/office/drawing/2014/main" id="{4099177F-47A9-4899-A40D-E760B252BFB3}"/>
-              </a:ext>
-            </a:extLst>
-          </p:cNvPr>
-          <p:cNvSpPr>
-            <a:spLocks xmlns:a="http://schemas.openxmlformats.org/drawingml/2006/main" noGrp="1"/>
-          </p:cNvSpPr>
-          <p:nvPr/>
-        </p:nvSpPr>
-        <p:spPr>
-          <a:xfrm xmlns:a="http://schemas.openxmlformats.org/drawingml/2006/main">
-            <a:off x="628650" y="4953000"/>
-            <a:ext cx="4762500" cy="457200"/>
+              <a:t>DRR (IFSCA's Digital Regulatory Reporting platform, procured 2026): structured reporting channels, validation and submission infrastructure.</a:t>
+            </a:r>
+          </a:p>
+        </p:txBody>
+      </p:sp>
+      <p:sp>
+        <p:nvSpPr>
+          <p:cNvPr id="10" name="boundary-attest">
+            <a:extLst xmlns:a="http://schemas.openxmlformats.org/drawingml/2006/main">
+              <a:ext uri="{FF2B5EF4-FFF2-40B4-BE49-F238E27FC236}">
+                <a16:creationId xmlns:a16="http://schemas.microsoft.com/office/drawing/2014/main" id="{59074284-2903-4475-932D-ACB6120EB4BC}"/>
+              </a:ext>
+            </a:extLst>
+          </p:cNvPr>
+          <p:cNvSpPr>
+            <a:spLocks xmlns:a="http://schemas.openxmlformats.org/drawingml/2006/main" noGrp="1"/>
+          </p:cNvSpPr>
+          <p:nvPr/>
+        </p:nvSpPr>
+        <p:spPr>
+          <a:xfrm xmlns:a="http://schemas.openxmlformats.org/drawingml/2006/main">
+            <a:off x="6705600" y="1752600"/>
+            <a:ext cx="4762500" cy="800100"/>
+          </a:xfrm>
+          <a:prstGeom xmlns:a="http://schemas.openxmlformats.org/drawingml/2006/main" prst="rect">
+            <a:avLst/>
+          </a:prstGeom>
+          <a:noFill xmlns:a="http://schemas.openxmlformats.org/drawingml/2006/main"/>
+          <a:ln xmlns:a="http://schemas.openxmlformats.org/drawingml/2006/main" w="0">
+            <a:noFill/>
+            <a:prstDash val="solid"/>
+          </a:ln>
+        </p:spPr>
+        <p:txBody>
+          <a:bodyPr xmlns:a="http://schemas.openxmlformats.org/drawingml/2006/main" wrap="square" lIns="0" tIns="0" rIns="0" bIns="0" anchor="t">
+            <a:noAutofit/>
+          </a:bodyPr>
+          <a:lstStyle xmlns:a="http://schemas.openxmlformats.org/drawingml/2006/main"/>
+          <a:p xmlns:a="http://schemas.openxmlformats.org/drawingml/2006/main">
+            <a:pPr algn="l">
+              <a:defRPr sz="4800" b="0" i="0">
+                <a:solidFill>
+                  <a:srgbClr val="0A1F44"/>
+                </a:solidFill>
+                <a:latin typeface="Georgia"/>
+                <a:ea typeface="Georgia"/>
+                <a:cs typeface="Georgia"/>
+              </a:defRPr>
+            </a:pPr>
+            <a:r>
+              <a:rPr sz="4800" b="0" i="0">
+                <a:solidFill>
+                  <a:srgbClr val="0A1F44"/>
+                </a:solidFill>
+                <a:latin typeface="Georgia"/>
+                <a:ea typeface="Georgia"/>
+                <a:cs typeface="Georgia"/>
+              </a:rPr>
+              <a:t>ATTEST</a:t>
+            </a:r>
+          </a:p>
+        </p:txBody>
+      </p:sp>
+      <p:sp>
+        <p:nvSpPr>
+          <p:cNvPr id="11" name="boundary-attest-copy">
+            <a:extLst xmlns:a="http://schemas.openxmlformats.org/drawingml/2006/main">
+              <a:ext uri="{FF2B5EF4-FFF2-40B4-BE49-F238E27FC236}">
+                <a16:creationId xmlns:a16="http://schemas.microsoft.com/office/drawing/2014/main" id="{4B8E2AAC-A096-4E0F-93DF-53800515DBD1}"/>
+              </a:ext>
+            </a:extLst>
+          </p:cNvPr>
+          <p:cNvSpPr>
+            <a:spLocks xmlns:a="http://schemas.openxmlformats.org/drawingml/2006/main" noGrp="1"/>
+          </p:cNvSpPr>
+          <p:nvPr/>
+        </p:nvSpPr>
+        <p:spPr>
+          <a:xfrm xmlns:a="http://schemas.openxmlformats.org/drawingml/2006/main">
+            <a:off x="6743700" y="2781300"/>
+            <a:ext cx="4762500" cy="1143000"/>
+          </a:xfrm>
+          <a:prstGeom xmlns:a="http://schemas.openxmlformats.org/drawingml/2006/main" prst="rect">
+            <a:avLst/>
+          </a:prstGeom>
+          <a:noFill xmlns:a="http://schemas.openxmlformats.org/drawingml/2006/main"/>
+          <a:ln xmlns:a="http://schemas.openxmlformats.org/drawingml/2006/main" w="0">
+            <a:noFill/>
+            <a:prstDash val="solid"/>
+          </a:ln>
+        </p:spPr>
+        <p:txBody>
+          <a:bodyPr xmlns:a="http://schemas.openxmlformats.org/drawingml/2006/main" wrap="square" lIns="0" tIns="0" rIns="0" bIns="0" anchor="t">
+            <a:noAutofit/>
+          </a:bodyPr>
+          <a:lstStyle xmlns:a="http://schemas.openxmlformats.org/drawingml/2006/main"/>
+          <a:p xmlns:a="http://schemas.openxmlformats.org/drawingml/2006/main">
+            <a:pPr algn="l">
+              <a:defRPr sz="2025" b="0" i="0">
+                <a:solidFill>
+                  <a:srgbClr val="0F0E0B"/>
+                </a:solidFill>
+                <a:latin typeface="Georgia"/>
+                <a:ea typeface="Georgia"/>
+                <a:cs typeface="Georgia"/>
+              </a:defRPr>
+            </a:pPr>
+            <a:r>
+              <a:rPr sz="2025" b="0" i="0">
+                <a:solidFill>
+                  <a:srgbClr val="0F0E0B"/>
+                </a:solidFill>
+                <a:latin typeface="Georgia"/>
+                <a:ea typeface="Georgia"/>
+                <a:cs typeface="Georgia"/>
+              </a:rPr>
+              <a:t>Provider-neutral source references, disagreement and human review</a:t>
+            </a:r>
+          </a:p>
+        </p:txBody>
+      </p:sp>
+      <p:sp>
+        <p:nvSpPr>
+          <p:cNvPr id="12" name="boundary-limit">
+            <a:extLst xmlns:a="http://schemas.openxmlformats.org/drawingml/2006/main">
+              <a:ext uri="{FF2B5EF4-FFF2-40B4-BE49-F238E27FC236}">
+                <a16:creationId xmlns:a16="http://schemas.microsoft.com/office/drawing/2014/main" id="{234374A7-2FD8-45C4-96FB-9845AFD1A6B9}"/>
+              </a:ext>
+            </a:extLst>
+          </p:cNvPr>
+          <p:cNvSpPr>
+            <a:spLocks xmlns:a="http://schemas.openxmlformats.org/drawingml/2006/main" noGrp="1"/>
+          </p:cNvSpPr>
+          <p:nvPr/>
+        </p:nvSpPr>
+        <p:spPr>
+          <a:xfrm xmlns:a="http://schemas.openxmlformats.org/drawingml/2006/main">
+            <a:off x="6743700" y="4552950"/>
+            <a:ext cx="4762500" cy="742950"/>
           </a:xfrm>
           <a:prstGeom xmlns:a="http://schemas.openxmlformats.org/drawingml/2006/main" prst="rect">
             <a:avLst/>
@@ -4540,7 +4979,7 @@
             <a:pPr algn="l">
               <a:defRPr sz="1650" b="1" i="0">
                 <a:solidFill>
-                  <a:srgbClr val="A87229"/>
+                  <a:srgbClr val="96491A"/>
                 </a:solidFill>
                 <a:latin typeface="Arial"/>
                 <a:ea typeface="Arial"/>
@@ -4550,151 +4989,35 @@
             <a:r>
               <a:rPr sz="1650" b="1" i="0">
                 <a:solidFill>
-                  <a:srgbClr val="A87229"/>
+                  <a:srgbClr val="96491A"/>
                 </a:solidFill>
                 <a:latin typeface="Arial"/>
                 <a:ea typeface="Arial"/>
                 <a:cs typeface="Arial"/>
               </a:rPr>
-              <a:t>Public absence is not proof.</a:t>
-            </a:r>
-          </a:p>
-        </p:txBody>
-      </p:sp>
-      <p:sp>
-        <p:nvSpPr>
-          <p:cNvPr id="11" name="boundary-attest">
-            <a:extLst xmlns:a="http://schemas.openxmlformats.org/drawingml/2006/main">
-              <a:ext uri="{FF2B5EF4-FFF2-40B4-BE49-F238E27FC236}">
-                <a16:creationId xmlns:a16="http://schemas.microsoft.com/office/drawing/2014/main" id="{CF1FB065-252C-4AE3-AF4C-701F880EC8BF}"/>
-              </a:ext>
-            </a:extLst>
-          </p:cNvPr>
-          <p:cNvSpPr>
-            <a:spLocks xmlns:a="http://schemas.openxmlformats.org/drawingml/2006/main" noGrp="1"/>
-          </p:cNvSpPr>
-          <p:nvPr/>
-        </p:nvSpPr>
-        <p:spPr>
-          <a:xfrm xmlns:a="http://schemas.openxmlformats.org/drawingml/2006/main">
-            <a:off x="6705600" y="1752600"/>
-            <a:ext cx="4762500" cy="800100"/>
-          </a:xfrm>
-          <a:prstGeom xmlns:a="http://schemas.openxmlformats.org/drawingml/2006/main" prst="rect">
-            <a:avLst/>
-          </a:prstGeom>
-          <a:noFill xmlns:a="http://schemas.openxmlformats.org/drawingml/2006/main"/>
-          <a:ln xmlns:a="http://schemas.openxmlformats.org/drawingml/2006/main" w="0">
-            <a:noFill/>
-            <a:prstDash val="solid"/>
-          </a:ln>
-        </p:spPr>
-        <p:txBody>
-          <a:bodyPr xmlns:a="http://schemas.openxmlformats.org/drawingml/2006/main" wrap="square" lIns="0" tIns="0" rIns="0" bIns="0" anchor="t">
-            <a:noAutofit/>
-          </a:bodyPr>
-          <a:lstStyle xmlns:a="http://schemas.openxmlformats.org/drawingml/2006/main"/>
-          <a:p xmlns:a="http://schemas.openxmlformats.org/drawingml/2006/main">
-            <a:pPr algn="l">
-              <a:defRPr sz="4800" b="0" i="0">
-                <a:solidFill>
-                  <a:srgbClr val="0A1F44"/>
-                </a:solidFill>
-                <a:latin typeface="Georgia"/>
-                <a:ea typeface="Georgia"/>
-                <a:cs typeface="Georgia"/>
-              </a:defRPr>
-            </a:pPr>
-            <a:r>
-              <a:rPr sz="4800" b="0" i="0">
-                <a:solidFill>
-                  <a:srgbClr val="0A1F44"/>
-                </a:solidFill>
-                <a:latin typeface="Georgia"/>
-                <a:ea typeface="Georgia"/>
-                <a:cs typeface="Georgia"/>
-              </a:rPr>
-              <a:t>ATTEST</a:t>
-            </a:r>
-          </a:p>
-        </p:txBody>
-      </p:sp>
-      <p:sp>
-        <p:nvSpPr>
-          <p:cNvPr id="12" name="boundary-attest-copy">
-            <a:extLst xmlns:a="http://schemas.openxmlformats.org/drawingml/2006/main">
-              <a:ext uri="{FF2B5EF4-FFF2-40B4-BE49-F238E27FC236}">
-                <a16:creationId xmlns:a16="http://schemas.microsoft.com/office/drawing/2014/main" id="{448285A7-F369-45D7-B373-6523076AA937}"/>
-              </a:ext>
-            </a:extLst>
-          </p:cNvPr>
-          <p:cNvSpPr>
-            <a:spLocks xmlns:a="http://schemas.openxmlformats.org/drawingml/2006/main" noGrp="1"/>
-          </p:cNvSpPr>
-          <p:nvPr/>
-        </p:nvSpPr>
-        <p:spPr>
-          <a:xfrm xmlns:a="http://schemas.openxmlformats.org/drawingml/2006/main">
-            <a:off x="6743700" y="2781300"/>
-            <a:ext cx="4762500" cy="1143000"/>
-          </a:xfrm>
-          <a:prstGeom xmlns:a="http://schemas.openxmlformats.org/drawingml/2006/main" prst="rect">
-            <a:avLst/>
-          </a:prstGeom>
-          <a:noFill xmlns:a="http://schemas.openxmlformats.org/drawingml/2006/main"/>
-          <a:ln xmlns:a="http://schemas.openxmlformats.org/drawingml/2006/main" w="0">
-            <a:noFill/>
-            <a:prstDash val="solid"/>
-          </a:ln>
-        </p:spPr>
-        <p:txBody>
-          <a:bodyPr xmlns:a="http://schemas.openxmlformats.org/drawingml/2006/main" wrap="square" lIns="0" tIns="0" rIns="0" bIns="0" anchor="t">
-            <a:noAutofit/>
-          </a:bodyPr>
-          <a:lstStyle xmlns:a="http://schemas.openxmlformats.org/drawingml/2006/main"/>
-          <a:p xmlns:a="http://schemas.openxmlformats.org/drawingml/2006/main">
-            <a:pPr algn="l">
-              <a:defRPr sz="2025" b="0" i="0">
-                <a:solidFill>
-                  <a:srgbClr val="0F0E0B"/>
-                </a:solidFill>
-                <a:latin typeface="Georgia"/>
-                <a:ea typeface="Georgia"/>
-                <a:cs typeface="Georgia"/>
-              </a:defRPr>
-            </a:pPr>
-            <a:r>
-              <a:rPr sz="2025" b="0" i="0">
-                <a:solidFill>
-                  <a:srgbClr val="0F0E0B"/>
-                </a:solidFill>
-                <a:latin typeface="Georgia"/>
-                <a:ea typeface="Georgia"/>
-                <a:cs typeface="Georgia"/>
-              </a:rPr>
-              <a:t>Provider-neutral source references, disagreement and human review</a:t>
-            </a:r>
-          </a:p>
-        </p:txBody>
-      </p:sp>
-      <p:sp>
-        <p:nvSpPr>
-          <p:cNvPr id="13" name="boundary-limit">
-            <a:extLst xmlns:a="http://schemas.openxmlformats.org/drawingml/2006/main">
-              <a:ext uri="{FF2B5EF4-FFF2-40B4-BE49-F238E27FC236}">
-                <a16:creationId xmlns:a16="http://schemas.microsoft.com/office/drawing/2014/main" id="{14B0ED83-7165-4C86-B04D-D290CD137A9E}"/>
-              </a:ext>
-            </a:extLst>
-          </p:cNvPr>
-          <p:cNvSpPr>
-            <a:spLocks xmlns:a="http://schemas.openxmlformats.org/drawingml/2006/main" noGrp="1"/>
-          </p:cNvSpPr>
-          <p:nvPr/>
-        </p:nvSpPr>
-        <p:spPr>
-          <a:xfrm xmlns:a="http://schemas.openxmlformats.org/drawingml/2006/main">
-            <a:off x="6743700" y="4552950"/>
-            <a:ext cx="4762500" cy="742950"/>
+              <a:t>No filing. No DRR connection. No claimed gap.</a:t>
+            </a:r>
+          </a:p>
+        </p:txBody>
+      </p:sp>
+      <p:sp>
+        <p:nvSpPr>
+          <p:cNvPr id="13" name="boundary-absence">
+            <a:extLst xmlns:a="http://schemas.openxmlformats.org/drawingml/2006/main">
+              <a:ext uri="{FF2B5EF4-FFF2-40B4-BE49-F238E27FC236}">
+                <a16:creationId xmlns:a16="http://schemas.microsoft.com/office/drawing/2014/main" id="{379097CC-AE1E-41F7-8C18-717FF8F2E401}"/>
+              </a:ext>
+            </a:extLst>
+          </p:cNvPr>
+          <p:cNvSpPr>
+            <a:spLocks xmlns:a="http://schemas.openxmlformats.org/drawingml/2006/main" noGrp="1"/>
+          </p:cNvSpPr>
+          <p:nvPr/>
+        </p:nvSpPr>
+        <p:spPr>
+          <a:xfrm xmlns:a="http://schemas.openxmlformats.org/drawingml/2006/main">
+            <a:off x="6743700" y="5391150"/>
+            <a:ext cx="4762500" cy="457200"/>
           </a:xfrm>
           <a:prstGeom xmlns:a="http://schemas.openxmlformats.org/drawingml/2006/main" prst="rect">
             <a:avLst/>
@@ -4714,7 +5037,7 @@
             <a:pPr algn="l">
               <a:defRPr sz="1650" b="1" i="0">
                 <a:solidFill>
-                  <a:srgbClr val="96491A"/>
+                  <a:srgbClr val="A87229"/>
                 </a:solidFill>
                 <a:latin typeface="Arial"/>
                 <a:ea typeface="Arial"/>
@@ -4724,13 +5047,13 @@
             <a:r>
               <a:rPr sz="1650" b="1" i="0">
                 <a:solidFill>
-                  <a:srgbClr val="96491A"/>
+                  <a:srgbClr val="A87229"/>
                 </a:solidFill>
                 <a:latin typeface="Arial"/>
                 <a:ea typeface="Arial"/>
                 <a:cs typeface="Arial"/>
               </a:rPr>
-              <a:t>No filing. No DRR connection. No claimed gap.</a:t>
+              <a:t>Public absence is not proof.</a:t>
             </a:r>
           </a:p>
         </p:txBody>
@@ -4738,7 +5061,7 @@
     </p:spTree>
     <p:extLst>
       <p:ext uri="{BB962C8B-B14F-4D97-AF65-F5344CB8AC3E}">
-        <p14:creationId xmlns:p14="http://schemas.microsoft.com/office/powerpoint/2010/main" val="1696460392"/>
+        <p14:creationId xmlns:p14="http://schemas.microsoft.com/office/powerpoint/2010/main" val="572006445"/>
       </p:ext>
     </p:extLst>
   </p:cSld>
@@ -4769,7 +5092,7 @@
           <p:cNvPr id="22" name="brand-4">
             <a:extLst xmlns:a="http://schemas.openxmlformats.org/drawingml/2006/main">
               <a:ext uri="{FF2B5EF4-FFF2-40B4-BE49-F238E27FC236}">
-                <a16:creationId xmlns:a16="http://schemas.microsoft.com/office/drawing/2014/main" id="{9EACA11F-5AF8-496E-87A3-9A11C6A9FF92}"/>
+                <a16:creationId xmlns:a16="http://schemas.microsoft.com/office/drawing/2014/main" id="{82F689D1-9B94-4090-8E37-4DC0A48FF1F6}"/>
               </a:ext>
             </a:extLst>
           </p:cNvPr>
@@ -4827,7 +5150,7 @@
           <p:cNvPr id="2" name="title-4">
             <a:extLst xmlns:a="http://schemas.openxmlformats.org/drawingml/2006/main">
               <a:ext uri="{FF2B5EF4-FFF2-40B4-BE49-F238E27FC236}">
-                <a16:creationId xmlns:a16="http://schemas.microsoft.com/office/drawing/2014/main" id="{BC177A44-66E5-4EF4-A12F-B1805D113D1D}"/>
+                <a16:creationId xmlns:a16="http://schemas.microsoft.com/office/drawing/2014/main" id="{ED1F2187-3750-4E75-A298-52D0C6869B11}"/>
               </a:ext>
             </a:extLst>
           </p:cNvPr>
@@ -4885,7 +5208,7 @@
           <p:cNvPr id="3" name="footer-rule-4">
             <a:extLst xmlns:a="http://schemas.openxmlformats.org/drawingml/2006/main">
               <a:ext uri="{FF2B5EF4-FFF2-40B4-BE49-F238E27FC236}">
-                <a16:creationId xmlns:a16="http://schemas.microsoft.com/office/drawing/2014/main" id="{DF3F1BEC-AF74-41FB-A959-DBE93E2909C9}"/>
+                <a16:creationId xmlns:a16="http://schemas.microsoft.com/office/drawing/2014/main" id="{4F6F0EC0-8B5D-46AC-BBF1-42671086265B}"/>
               </a:ext>
             </a:extLst>
           </p:cNvPr>
@@ -4916,7 +5239,7 @@
           <p:cNvPr id="4" name="footer-source-4">
             <a:extLst xmlns:a="http://schemas.openxmlformats.org/drawingml/2006/main">
               <a:ext uri="{FF2B5EF4-FFF2-40B4-BE49-F238E27FC236}">
-                <a16:creationId xmlns:a16="http://schemas.microsoft.com/office/drawing/2014/main" id="{F646AC12-0065-4783-8F02-4EFFADFAD937}"/>
+                <a16:creationId xmlns:a16="http://schemas.microsoft.com/office/drawing/2014/main" id="{E94416CF-78AD-423D-94DC-5414569CBD62}"/>
               </a:ext>
             </a:extLst>
           </p:cNvPr>
@@ -4974,7 +5297,7 @@
           <p:cNvPr id="5" name="footer-page-4">
             <a:extLst xmlns:a="http://schemas.openxmlformats.org/drawingml/2006/main">
               <a:ext uri="{FF2B5EF4-FFF2-40B4-BE49-F238E27FC236}">
-                <a16:creationId xmlns:a16="http://schemas.microsoft.com/office/drawing/2014/main" id="{96B11D31-E3EC-450E-8F60-ADF4F8B90402}"/>
+                <a16:creationId xmlns:a16="http://schemas.microsoft.com/office/drawing/2014/main" id="{4EA6A1F7-1C0F-4180-A03A-B3E1DE1BF2CF}"/>
               </a:ext>
             </a:extLst>
           </p:cNvPr>
@@ -5032,7 +5355,7 @@
           <p:cNvPr id="6" name="case-entity">
             <a:extLst xmlns:a="http://schemas.openxmlformats.org/drawingml/2006/main">
               <a:ext uri="{FF2B5EF4-FFF2-40B4-BE49-F238E27FC236}">
-                <a16:creationId xmlns:a16="http://schemas.microsoft.com/office/drawing/2014/main" id="{E9021288-E6BC-4E0C-ACD7-46D0CD019344}"/>
+                <a16:creationId xmlns:a16="http://schemas.microsoft.com/office/drawing/2014/main" id="{BF48C93F-B661-43F3-9EA0-300AFC1794F5}"/>
               </a:ext>
             </a:extLst>
           </p:cNvPr>
@@ -5080,7 +5403,7 @@
                 <a:ea typeface="Georgia"/>
                 <a:cs typeface="Georgia"/>
               </a:rPr>
-              <a:t>Meridian Horizon Fund Management IFSC Pvt Ltd</a:t>
+              <a:t>Meridian Horizon Fund I (Meridian Horizon Fund Management IFSC Pvt Ltd)</a:t>
             </a:r>
           </a:p>
         </p:txBody>
@@ -5090,7 +5413,7 @@
           <p:cNvPr id="7" name="case-period">
             <a:extLst xmlns:a="http://schemas.openxmlformats.org/drawingml/2006/main">
               <a:ext uri="{FF2B5EF4-FFF2-40B4-BE49-F238E27FC236}">
-                <a16:creationId xmlns:a16="http://schemas.microsoft.com/office/drawing/2014/main" id="{84359CA0-86A0-40B7-BCF9-1BF7516E1CE9}"/>
+                <a16:creationId xmlns:a16="http://schemas.microsoft.com/office/drawing/2014/main" id="{E1722C7D-7E30-44EA-829E-2887433B1562}"/>
               </a:ext>
             </a:extLst>
           </p:cNvPr>
@@ -5138,7 +5461,7 @@
                 <a:ea typeface="Courier New"/>
                 <a:cs typeface="Courier New"/>
               </a:rPr>
-              <a:t>Q2 2026</a:t>
+              <a:t>QE 30 Jun 2026</a:t>
             </a:r>
           </a:p>
         </p:txBody>
@@ -5148,7 +5471,7 @@
           <p:cNvPr id="8" name="case-marker">
             <a:extLst xmlns:a="http://schemas.openxmlformats.org/drawingml/2006/main">
               <a:ext uri="{FF2B5EF4-FFF2-40B4-BE49-F238E27FC236}">
-                <a16:creationId xmlns:a16="http://schemas.microsoft.com/office/drawing/2014/main" id="{14781BCF-4022-454B-B3B6-F2B11CD9A46A}"/>
+                <a16:creationId xmlns:a16="http://schemas.microsoft.com/office/drawing/2014/main" id="{36113BCA-3098-456C-8D4A-15CCA0018592}"/>
               </a:ext>
             </a:extLst>
           </p:cNvPr>
@@ -5206,7 +5529,7 @@
           <p:cNvPr id="9" name="case-divider">
             <a:extLst xmlns:a="http://schemas.openxmlformats.org/drawingml/2006/main">
               <a:ext uri="{FF2B5EF4-FFF2-40B4-BE49-F238E27FC236}">
-                <a16:creationId xmlns:a16="http://schemas.microsoft.com/office/drawing/2014/main" id="{DC95BE49-FE25-4A66-892E-6A581B24A692}"/>
+                <a16:creationId xmlns:a16="http://schemas.microsoft.com/office/drawing/2014/main" id="{A4362507-65BC-4EAD-8234-B885A50524BF}"/>
               </a:ext>
             </a:extLst>
           </p:cNvPr>
@@ -5237,7 +5560,7 @@
           <p:cNvPr id="10" name="case-row-rule-1">
             <a:extLst xmlns:a="http://schemas.openxmlformats.org/drawingml/2006/main">
               <a:ext uri="{FF2B5EF4-FFF2-40B4-BE49-F238E27FC236}">
-                <a16:creationId xmlns:a16="http://schemas.microsoft.com/office/drawing/2014/main" id="{434A48D7-43FF-4DC9-9B45-A5FCFC735ABC}"/>
+                <a16:creationId xmlns:a16="http://schemas.microsoft.com/office/drawing/2014/main" id="{0EE2FD0E-11EC-43F1-8B59-A2B95DBD780C}"/>
               </a:ext>
             </a:extLst>
           </p:cNvPr>
@@ -5268,7 +5591,7 @@
           <p:cNvPr id="11" name="case-row-status-1">
             <a:extLst xmlns:a="http://schemas.openxmlformats.org/drawingml/2006/main">
               <a:ext uri="{FF2B5EF4-FFF2-40B4-BE49-F238E27FC236}">
-                <a16:creationId xmlns:a16="http://schemas.microsoft.com/office/drawing/2014/main" id="{B90BBFE8-0C11-4E25-9F70-50B80E419425}"/>
+                <a16:creationId xmlns:a16="http://schemas.microsoft.com/office/drawing/2014/main" id="{B8909839-33A9-4CEA-853D-FEE062EEEF41}"/>
               </a:ext>
             </a:extLst>
           </p:cNvPr>
@@ -5326,7 +5649,7 @@
           <p:cNvPr id="12" name="case-row-label-1">
             <a:extLst xmlns:a="http://schemas.openxmlformats.org/drawingml/2006/main">
               <a:ext uri="{FF2B5EF4-FFF2-40B4-BE49-F238E27FC236}">
-                <a16:creationId xmlns:a16="http://schemas.microsoft.com/office/drawing/2014/main" id="{22A4A2F0-282F-4B80-A866-28E8DD1C5DFF}"/>
+                <a16:creationId xmlns:a16="http://schemas.microsoft.com/office/drawing/2014/main" id="{67225747-565F-4E1F-B5BB-78389B793346}"/>
               </a:ext>
             </a:extLst>
           </p:cNvPr>
@@ -5384,7 +5707,7 @@
           <p:cNvPr id="13" name="case-row-copy-1">
             <a:extLst xmlns:a="http://schemas.openxmlformats.org/drawingml/2006/main">
               <a:ext uri="{FF2B5EF4-FFF2-40B4-BE49-F238E27FC236}">
-                <a16:creationId xmlns:a16="http://schemas.microsoft.com/office/drawing/2014/main" id="{284ECC96-2C6B-4E14-85EB-A90B1861FC55}"/>
+                <a16:creationId xmlns:a16="http://schemas.microsoft.com/office/drawing/2014/main" id="{1A646FDB-67F5-4C92-ACF6-53D58101F542}"/>
               </a:ext>
             </a:extLst>
           </p:cNvPr>
@@ -5432,7 +5755,7 @@
                 <a:ea typeface="Arial"/>
                 <a:cs typeface="Arial"/>
               </a:rPr>
-              <a:t>INR 12.5M agrees across two sources</a:t>
+              <a:t>USD 12.4M agrees across two sources</a:t>
             </a:r>
           </a:p>
         </p:txBody>
@@ -5442,7 +5765,7 @@
           <p:cNvPr id="14" name="case-row-rule-2">
             <a:extLst xmlns:a="http://schemas.openxmlformats.org/drawingml/2006/main">
               <a:ext uri="{FF2B5EF4-FFF2-40B4-BE49-F238E27FC236}">
-                <a16:creationId xmlns:a16="http://schemas.microsoft.com/office/drawing/2014/main" id="{9DAD1C09-8F3F-44BE-92E2-B751B268D1D1}"/>
+                <a16:creationId xmlns:a16="http://schemas.microsoft.com/office/drawing/2014/main" id="{990C6465-C66E-4022-B0D1-CBBC8C800D15}"/>
               </a:ext>
             </a:extLst>
           </p:cNvPr>
@@ -5473,7 +5796,7 @@
           <p:cNvPr id="15" name="case-row-status-2">
             <a:extLst xmlns:a="http://schemas.openxmlformats.org/drawingml/2006/main">
               <a:ext uri="{FF2B5EF4-FFF2-40B4-BE49-F238E27FC236}">
-                <a16:creationId xmlns:a16="http://schemas.microsoft.com/office/drawing/2014/main" id="{9CE8E6B4-BE6C-400B-9EF4-45EB0BD6833B}"/>
+                <a16:creationId xmlns:a16="http://schemas.microsoft.com/office/drawing/2014/main" id="{8D34D2E6-40D8-4DA3-B4BC-D9A717F4318F}"/>
               </a:ext>
             </a:extLst>
           </p:cNvPr>
@@ -5531,7 +5854,7 @@
           <p:cNvPr id="16" name="case-row-label-2">
             <a:extLst xmlns:a="http://schemas.openxmlformats.org/drawingml/2006/main">
               <a:ext uri="{FF2B5EF4-FFF2-40B4-BE49-F238E27FC236}">
-                <a16:creationId xmlns:a16="http://schemas.microsoft.com/office/drawing/2014/main" id="{374FB416-C364-4457-9E0A-3ED961E326CD}"/>
+                <a16:creationId xmlns:a16="http://schemas.microsoft.com/office/drawing/2014/main" id="{E0FC6972-51D3-41BA-8DAC-1315AF133C43}"/>
               </a:ext>
             </a:extLst>
           </p:cNvPr>
@@ -5589,7 +5912,7 @@
           <p:cNvPr id="17" name="case-row-copy-2">
             <a:extLst xmlns:a="http://schemas.openxmlformats.org/drawingml/2006/main">
               <a:ext uri="{FF2B5EF4-FFF2-40B4-BE49-F238E27FC236}">
-                <a16:creationId xmlns:a16="http://schemas.microsoft.com/office/drawing/2014/main" id="{24103339-8004-453C-8F84-E1A3EE8446D8}"/>
+                <a16:creationId xmlns:a16="http://schemas.microsoft.com/office/drawing/2014/main" id="{54621B36-6F05-4DD8-878F-D96D3BDA754B}"/>
               </a:ext>
             </a:extLst>
           </p:cNvPr>
@@ -5637,7 +5960,7 @@
                 <a:ea typeface="Arial"/>
                 <a:cs typeface="Arial"/>
               </a:rPr>
-              <a:t>INR 50M vs INR 48M</a:t>
+              <a:t>USD 25M vs USD 24M</a:t>
             </a:r>
           </a:p>
         </p:txBody>
@@ -5647,7 +5970,7 @@
           <p:cNvPr id="18" name="case-row-rule-3">
             <a:extLst xmlns:a="http://schemas.openxmlformats.org/drawingml/2006/main">
               <a:ext uri="{FF2B5EF4-FFF2-40B4-BE49-F238E27FC236}">
-                <a16:creationId xmlns:a16="http://schemas.microsoft.com/office/drawing/2014/main" id="{2155E03D-37F5-46A4-8F3E-B0F72D067221}"/>
+                <a16:creationId xmlns:a16="http://schemas.microsoft.com/office/drawing/2014/main" id="{06B33CE9-13FD-4FBC-BA01-94AC7EB23803}"/>
               </a:ext>
             </a:extLst>
           </p:cNvPr>
@@ -5678,7 +6001,7 @@
           <p:cNvPr id="19" name="case-row-status-3">
             <a:extLst xmlns:a="http://schemas.openxmlformats.org/drawingml/2006/main">
               <a:ext uri="{FF2B5EF4-FFF2-40B4-BE49-F238E27FC236}">
-                <a16:creationId xmlns:a16="http://schemas.microsoft.com/office/drawing/2014/main" id="{5E1BE532-48EC-4026-9065-312ED6EFCCA5}"/>
+                <a16:creationId xmlns:a16="http://schemas.microsoft.com/office/drawing/2014/main" id="{F63CC6FB-8E19-48ED-837D-46855753A4AE}"/>
               </a:ext>
             </a:extLst>
           </p:cNvPr>
@@ -5736,7 +6059,7 @@
           <p:cNvPr id="20" name="case-row-label-3">
             <a:extLst xmlns:a="http://schemas.openxmlformats.org/drawingml/2006/main">
               <a:ext uri="{FF2B5EF4-FFF2-40B4-BE49-F238E27FC236}">
-                <a16:creationId xmlns:a16="http://schemas.microsoft.com/office/drawing/2014/main" id="{883E22AE-72AD-464B-9EA3-E38A582D53EF}"/>
+                <a16:creationId xmlns:a16="http://schemas.microsoft.com/office/drawing/2014/main" id="{BA93B6AC-CC25-4DC9-B65F-2C8DEAFD0EE0}"/>
               </a:ext>
             </a:extLst>
           </p:cNvPr>
@@ -5784,7 +6107,7 @@
                 <a:ea typeface="Georgia"/>
                 <a:cs typeface="Georgia"/>
               </a:rPr>
-              <a:t>Investor complaints closed</a:t>
+              <a:t>Complaints closed</a:t>
             </a:r>
           </a:p>
         </p:txBody>
@@ -5794,7 +6117,7 @@
           <p:cNvPr id="21" name="case-row-copy-3">
             <a:extLst xmlns:a="http://schemas.openxmlformats.org/drawingml/2006/main">
               <a:ext uri="{FF2B5EF4-FFF2-40B4-BE49-F238E27FC236}">
-                <a16:creationId xmlns:a16="http://schemas.microsoft.com/office/drawing/2014/main" id="{9305DCBA-4C6F-460C-9064-9BA348C943CD}"/>
+                <a16:creationId xmlns:a16="http://schemas.microsoft.com/office/drawing/2014/main" id="{11D2D166-3798-4C9F-8652-64D6EFF09267}"/>
               </a:ext>
             </a:extLst>
           </p:cNvPr>
@@ -5850,7 +6173,7 @@
     </p:spTree>
     <p:extLst>
       <p:ext uri="{BB962C8B-B14F-4D97-AF65-F5344CB8AC3E}">
-        <p14:creationId xmlns:p14="http://schemas.microsoft.com/office/powerpoint/2010/main" val="1305077789"/>
+        <p14:creationId xmlns:p14="http://schemas.microsoft.com/office/powerpoint/2010/main" val="942550303"/>
       </p:ext>
     </p:extLst>
   </p:cSld>
@@ -5881,7 +6204,7 @@
           <p:cNvPr id="17" name="brand-5">
             <a:extLst xmlns:a="http://schemas.openxmlformats.org/drawingml/2006/main">
               <a:ext uri="{FF2B5EF4-FFF2-40B4-BE49-F238E27FC236}">
-                <a16:creationId xmlns:a16="http://schemas.microsoft.com/office/drawing/2014/main" id="{D619050C-0B1D-4BF4-B5FD-5A966A58570A}"/>
+                <a16:creationId xmlns:a16="http://schemas.microsoft.com/office/drawing/2014/main" id="{E4DA99D2-E7EC-4A2A-90C0-D8C1507892F9}"/>
               </a:ext>
             </a:extLst>
           </p:cNvPr>
@@ -5939,7 +6262,7 @@
           <p:cNvPr id="2" name="title-5">
             <a:extLst xmlns:a="http://schemas.openxmlformats.org/drawingml/2006/main">
               <a:ext uri="{FF2B5EF4-FFF2-40B4-BE49-F238E27FC236}">
-                <a16:creationId xmlns:a16="http://schemas.microsoft.com/office/drawing/2014/main" id="{02C25FEF-E911-42BC-9F88-943479526841}"/>
+                <a16:creationId xmlns:a16="http://schemas.microsoft.com/office/drawing/2014/main" id="{33DBB377-EA0E-4432-8EA2-8C4E88BE2117}"/>
               </a:ext>
             </a:extLst>
           </p:cNvPr>
@@ -5997,7 +6320,7 @@
           <p:cNvPr id="3" name="footer-rule-5">
             <a:extLst xmlns:a="http://schemas.openxmlformats.org/drawingml/2006/main">
               <a:ext uri="{FF2B5EF4-FFF2-40B4-BE49-F238E27FC236}">
-                <a16:creationId xmlns:a16="http://schemas.microsoft.com/office/drawing/2014/main" id="{64B2123A-B36E-4EAC-B2DD-19248B9BF306}"/>
+                <a16:creationId xmlns:a16="http://schemas.microsoft.com/office/drawing/2014/main" id="{06A4BCD4-C699-4DA0-8605-C40212B9F75E}"/>
               </a:ext>
             </a:extLst>
           </p:cNvPr>
@@ -6028,7 +6351,7 @@
           <p:cNvPr id="4" name="footer-source-5">
             <a:extLst xmlns:a="http://schemas.openxmlformats.org/drawingml/2006/main">
               <a:ext uri="{FF2B5EF4-FFF2-40B4-BE49-F238E27FC236}">
-                <a16:creationId xmlns:a16="http://schemas.microsoft.com/office/drawing/2014/main" id="{AC84C5A4-35A2-4587-8FC8-794EFBC65624}"/>
+                <a16:creationId xmlns:a16="http://schemas.microsoft.com/office/drawing/2014/main" id="{46AC43F5-614A-47A8-95B4-F0B928B5DDA3}"/>
               </a:ext>
             </a:extLst>
           </p:cNvPr>
@@ -6086,7 +6409,7 @@
           <p:cNvPr id="5" name="footer-page-5">
             <a:extLst xmlns:a="http://schemas.openxmlformats.org/drawingml/2006/main">
               <a:ext uri="{FF2B5EF4-FFF2-40B4-BE49-F238E27FC236}">
-                <a16:creationId xmlns:a16="http://schemas.microsoft.com/office/drawing/2014/main" id="{270C9786-60F4-4E71-85C5-60ED7FE9D217}"/>
+                <a16:creationId xmlns:a16="http://schemas.microsoft.com/office/drawing/2014/main" id="{64065D31-69F8-4184-A6D8-154B11793855}"/>
               </a:ext>
             </a:extLst>
           </p:cNvPr>
@@ -6144,7 +6467,7 @@
           <p:cNvPr id="6" name="workflow-rail">
             <a:extLst xmlns:a="http://schemas.openxmlformats.org/drawingml/2006/main">
               <a:ext uri="{FF2B5EF4-FFF2-40B4-BE49-F238E27FC236}">
-                <a16:creationId xmlns:a16="http://schemas.microsoft.com/office/drawing/2014/main" id="{B3FBC08A-F5AC-42C1-B1E1-A9654F64BACC}"/>
+                <a16:creationId xmlns:a16="http://schemas.microsoft.com/office/drawing/2014/main" id="{F86146BE-127A-4989-8A2E-66959D0C5C56}"/>
               </a:ext>
             </a:extLst>
           </p:cNvPr>
@@ -6175,7 +6498,7 @@
           <p:cNvPr id="7" name="workflow-tick-1">
             <a:extLst xmlns:a="http://schemas.openxmlformats.org/drawingml/2006/main">
               <a:ext uri="{FF2B5EF4-FFF2-40B4-BE49-F238E27FC236}">
-                <a16:creationId xmlns:a16="http://schemas.microsoft.com/office/drawing/2014/main" id="{12212C50-CBD6-4898-A450-D10C631227BF}"/>
+                <a16:creationId xmlns:a16="http://schemas.microsoft.com/office/drawing/2014/main" id="{BF19BCFF-FE17-4289-A3D4-E371678F4D00}"/>
               </a:ext>
             </a:extLst>
           </p:cNvPr>
@@ -6206,7 +6529,7 @@
           <p:cNvPr id="8" name="workflow-step-1">
             <a:extLst xmlns:a="http://schemas.openxmlformats.org/drawingml/2006/main">
               <a:ext uri="{FF2B5EF4-FFF2-40B4-BE49-F238E27FC236}">
-                <a16:creationId xmlns:a16="http://schemas.microsoft.com/office/drawing/2014/main" id="{2BAC3978-9C10-4FB4-B1B5-5993610F97BB}"/>
+                <a16:creationId xmlns:a16="http://schemas.microsoft.com/office/drawing/2014/main" id="{089C8012-5D72-45D0-BF69-1035C409D4B4}"/>
               </a:ext>
             </a:extLst>
           </p:cNvPr>
@@ -6264,7 +6587,7 @@
           <p:cNvPr id="9" name="workflow-tick-2">
             <a:extLst xmlns:a="http://schemas.openxmlformats.org/drawingml/2006/main">
               <a:ext uri="{FF2B5EF4-FFF2-40B4-BE49-F238E27FC236}">
-                <a16:creationId xmlns:a16="http://schemas.microsoft.com/office/drawing/2014/main" id="{F7556C63-1FB8-4DAA-80EA-BF4EAA70DDE9}"/>
+                <a16:creationId xmlns:a16="http://schemas.microsoft.com/office/drawing/2014/main" id="{37F7DF3E-A4AB-473E-B2DF-63C4F912EA7E}"/>
               </a:ext>
             </a:extLst>
           </p:cNvPr>
@@ -6295,7 +6618,7 @@
           <p:cNvPr id="10" name="workflow-step-2">
             <a:extLst xmlns:a="http://schemas.openxmlformats.org/drawingml/2006/main">
               <a:ext uri="{FF2B5EF4-FFF2-40B4-BE49-F238E27FC236}">
-                <a16:creationId xmlns:a16="http://schemas.microsoft.com/office/drawing/2014/main" id="{76A23314-1A3C-4E2E-BA59-099504103B4C}"/>
+                <a16:creationId xmlns:a16="http://schemas.microsoft.com/office/drawing/2014/main" id="{8B058FEB-02B4-4144-AEB8-20DF070AC7F5}"/>
               </a:ext>
             </a:extLst>
           </p:cNvPr>
@@ -6353,7 +6676,7 @@
           <p:cNvPr id="11" name="workflow-tick-3">
             <a:extLst xmlns:a="http://schemas.openxmlformats.org/drawingml/2006/main">
               <a:ext uri="{FF2B5EF4-FFF2-40B4-BE49-F238E27FC236}">
-                <a16:creationId xmlns:a16="http://schemas.microsoft.com/office/drawing/2014/main" id="{A1E40888-ECF4-4106-A1AA-5088EF5B6D37}"/>
+                <a16:creationId xmlns:a16="http://schemas.microsoft.com/office/drawing/2014/main" id="{21BF1CDF-9A58-48FA-9160-DA1BC380C20B}"/>
               </a:ext>
             </a:extLst>
           </p:cNvPr>
@@ -6384,7 +6707,7 @@
           <p:cNvPr id="12" name="workflow-step-3">
             <a:extLst xmlns:a="http://schemas.openxmlformats.org/drawingml/2006/main">
               <a:ext uri="{FF2B5EF4-FFF2-40B4-BE49-F238E27FC236}">
-                <a16:creationId xmlns:a16="http://schemas.microsoft.com/office/drawing/2014/main" id="{ABBB14CF-53DD-41A5-8EBB-C0BBDC4FCB64}"/>
+                <a16:creationId xmlns:a16="http://schemas.microsoft.com/office/drawing/2014/main" id="{210512FE-A174-4D29-B197-1293D5D6A50E}"/>
               </a:ext>
             </a:extLst>
           </p:cNvPr>
@@ -6442,7 +6765,7 @@
           <p:cNvPr id="13" name="workflow-tick-4">
             <a:extLst xmlns:a="http://schemas.openxmlformats.org/drawingml/2006/main">
               <a:ext uri="{FF2B5EF4-FFF2-40B4-BE49-F238E27FC236}">
-                <a16:creationId xmlns:a16="http://schemas.microsoft.com/office/drawing/2014/main" id="{B1C2EB70-2A82-4ACF-B377-7DF76584CB15}"/>
+                <a16:creationId xmlns:a16="http://schemas.microsoft.com/office/drawing/2014/main" id="{64103D35-84C6-48ED-BA33-F22E33FEEEBC}"/>
               </a:ext>
             </a:extLst>
           </p:cNvPr>
@@ -6473,7 +6796,7 @@
           <p:cNvPr id="14" name="workflow-step-4">
             <a:extLst xmlns:a="http://schemas.openxmlformats.org/drawingml/2006/main">
               <a:ext uri="{FF2B5EF4-FFF2-40B4-BE49-F238E27FC236}">
-                <a16:creationId xmlns:a16="http://schemas.microsoft.com/office/drawing/2014/main" id="{B435699C-4E66-4C06-82E4-A738432BE478}"/>
+                <a16:creationId xmlns:a16="http://schemas.microsoft.com/office/drawing/2014/main" id="{50D2B3DE-AFAF-4EDF-8690-1248E53BD8ED}"/>
               </a:ext>
             </a:extLst>
           </p:cNvPr>
@@ -6531,7 +6854,7 @@
           <p:cNvPr id="15" name="workflow-tick-5">
             <a:extLst xmlns:a="http://schemas.openxmlformats.org/drawingml/2006/main">
               <a:ext uri="{FF2B5EF4-FFF2-40B4-BE49-F238E27FC236}">
-                <a16:creationId xmlns:a16="http://schemas.microsoft.com/office/drawing/2014/main" id="{84DF3910-C6DF-472C-BA2A-FC1F3FCEFD71}"/>
+                <a16:creationId xmlns:a16="http://schemas.microsoft.com/office/drawing/2014/main" id="{64FCDFCD-0645-4D0B-8461-A1F66F01A6BA}"/>
               </a:ext>
             </a:extLst>
           </p:cNvPr>
@@ -6562,7 +6885,7 @@
           <p:cNvPr id="16" name="workflow-step-5">
             <a:extLst xmlns:a="http://schemas.openxmlformats.org/drawingml/2006/main">
               <a:ext uri="{FF2B5EF4-FFF2-40B4-BE49-F238E27FC236}">
-                <a16:creationId xmlns:a16="http://schemas.microsoft.com/office/drawing/2014/main" id="{6186ED49-EDE3-4D0B-A506-D5B8B741B0C6}"/>
+                <a16:creationId xmlns:a16="http://schemas.microsoft.com/office/drawing/2014/main" id="{688CD65B-C2D6-4FAF-8F43-ACCE26A1AF67}"/>
               </a:ext>
             </a:extLst>
           </p:cNvPr>
@@ -6592,7 +6915,7 @@
           <a:lstStyle xmlns:a="http://schemas.openxmlformats.org/drawingml/2006/main"/>
           <a:p xmlns:a="http://schemas.openxmlformats.org/drawingml/2006/main">
             <a:pPr algn="l">
-              <a:defRPr sz="1650" b="1" i="0">
+              <a:defRPr sz="1650" b="0" i="0">
                 <a:solidFill>
                   <a:srgbClr val="0A1F44"/>
                 </a:solidFill>
@@ -6602,7 +6925,7 @@
               </a:defRPr>
             </a:pPr>
             <a:r>
-              <a:rPr sz="1650" b="1" i="0">
+              <a:rPr sz="1650" b="0" i="0">
                 <a:solidFill>
                   <a:srgbClr val="0A1F44"/>
                 </a:solidFill>
@@ -6618,7 +6941,7 @@
     </p:spTree>
     <p:extLst>
       <p:ext uri="{BB962C8B-B14F-4D97-AF65-F5344CB8AC3E}">
-        <p14:creationId xmlns:p14="http://schemas.microsoft.com/office/powerpoint/2010/main" val="1935498678"/>
+        <p14:creationId xmlns:p14="http://schemas.microsoft.com/office/powerpoint/2010/main" val="1214121636"/>
       </p:ext>
     </p:extLst>
   </p:cSld>
@@ -6649,7 +6972,7 @@
           <p:cNvPr id="16" name="brand-6">
             <a:extLst xmlns:a="http://schemas.openxmlformats.org/drawingml/2006/main">
               <a:ext uri="{FF2B5EF4-FFF2-40B4-BE49-F238E27FC236}">
-                <a16:creationId xmlns:a16="http://schemas.microsoft.com/office/drawing/2014/main" id="{2BBD370F-CFE4-4558-A154-AB97C2B7AC91}"/>
+                <a16:creationId xmlns:a16="http://schemas.microsoft.com/office/drawing/2014/main" id="{BDE91300-AEEA-4819-A1E1-01ECB09A4B49}"/>
               </a:ext>
             </a:extLst>
           </p:cNvPr>
@@ -6707,7 +7030,7 @@
           <p:cNvPr id="2" name="title-6">
             <a:extLst xmlns:a="http://schemas.openxmlformats.org/drawingml/2006/main">
               <a:ext uri="{FF2B5EF4-FFF2-40B4-BE49-F238E27FC236}">
-                <a16:creationId xmlns:a16="http://schemas.microsoft.com/office/drawing/2014/main" id="{17FBF569-A58D-41C9-A3F5-59479FE658FA}"/>
+                <a16:creationId xmlns:a16="http://schemas.microsoft.com/office/drawing/2014/main" id="{2A86D89A-2ABF-4E12-91AE-CEEBEC7214D2}"/>
               </a:ext>
             </a:extLst>
           </p:cNvPr>
@@ -6765,7 +7088,7 @@
           <p:cNvPr id="3" name="footer-rule-6">
             <a:extLst xmlns:a="http://schemas.openxmlformats.org/drawingml/2006/main">
               <a:ext uri="{FF2B5EF4-FFF2-40B4-BE49-F238E27FC236}">
-                <a16:creationId xmlns:a16="http://schemas.microsoft.com/office/drawing/2014/main" id="{9C3E1B6E-55DF-4584-9705-39123404A6B3}"/>
+                <a16:creationId xmlns:a16="http://schemas.microsoft.com/office/drawing/2014/main" id="{5C4E2F7D-1C6C-4FB9-B0AF-EB1182A3A770}"/>
               </a:ext>
             </a:extLst>
           </p:cNvPr>
@@ -6796,7 +7119,7 @@
           <p:cNvPr id="4" name="footer-source-6">
             <a:extLst xmlns:a="http://schemas.openxmlformats.org/drawingml/2006/main">
               <a:ext uri="{FF2B5EF4-FFF2-40B4-BE49-F238E27FC236}">
-                <a16:creationId xmlns:a16="http://schemas.microsoft.com/office/drawing/2014/main" id="{A479AC38-08F9-420E-BC91-153268DD3D0F}"/>
+                <a16:creationId xmlns:a16="http://schemas.microsoft.com/office/drawing/2014/main" id="{85388F93-08BE-4DEA-B350-BC9B52A5FBDC}"/>
               </a:ext>
             </a:extLst>
           </p:cNvPr>
@@ -6854,7 +7177,7 @@
           <p:cNvPr id="5" name="footer-page-6">
             <a:extLst xmlns:a="http://schemas.openxmlformats.org/drawingml/2006/main">
               <a:ext uri="{FF2B5EF4-FFF2-40B4-BE49-F238E27FC236}">
-                <a16:creationId xmlns:a16="http://schemas.microsoft.com/office/drawing/2014/main" id="{9E721275-B35E-4740-B102-0E0604F61C9A}"/>
+                <a16:creationId xmlns:a16="http://schemas.microsoft.com/office/drawing/2014/main" id="{0CCC41E0-1FA3-40DC-8FDB-1EA36E5219E4}"/>
               </a:ext>
             </a:extLst>
           </p:cNvPr>
@@ -6912,7 +7235,7 @@
           <p:cNvPr id="6" name="agent-trace-label">
             <a:extLst xmlns:a="http://schemas.openxmlformats.org/drawingml/2006/main">
               <a:ext uri="{FF2B5EF4-FFF2-40B4-BE49-F238E27FC236}">
-                <a16:creationId xmlns:a16="http://schemas.microsoft.com/office/drawing/2014/main" id="{7FB5B9F8-C1AB-4DC6-AAB7-4D5BC4F79449}"/>
+                <a16:creationId xmlns:a16="http://schemas.microsoft.com/office/drawing/2014/main" id="{1F43A5A6-5DF6-41DB-B800-95EFAC0349C1}"/>
               </a:ext>
             </a:extLst>
           </p:cNvPr>
@@ -6960,7 +7283,7 @@
                 <a:ea typeface="Courier New"/>
                 <a:cs typeface="Courier New"/>
               </a:rPr>
-              <a:t>RECORDED DETERMINISTIC PROTOTYPE TRACE</a:t>
+              <a:t>DETERMINISTIC TRACE</a:t>
             </a:r>
           </a:p>
         </p:txBody>
@@ -6970,7 +7293,7 @@
           <p:cNvPr id="7" name="agent-trace-spine">
             <a:extLst xmlns:a="http://schemas.openxmlformats.org/drawingml/2006/main">
               <a:ext uri="{FF2B5EF4-FFF2-40B4-BE49-F238E27FC236}">
-                <a16:creationId xmlns:a16="http://schemas.microsoft.com/office/drawing/2014/main" id="{03018589-7532-4FE5-ABC9-CBAA95098A0D}"/>
+                <a16:creationId xmlns:a16="http://schemas.microsoft.com/office/drawing/2014/main" id="{AED06A9F-E31C-4DE2-A32E-85CC35DAE098}"/>
               </a:ext>
             </a:extLst>
           </p:cNvPr>
@@ -7001,7 +7324,7 @@
           <p:cNvPr id="8" name="agent-propose">
             <a:extLst xmlns:a="http://schemas.openxmlformats.org/drawingml/2006/main">
               <a:ext uri="{FF2B5EF4-FFF2-40B4-BE49-F238E27FC236}">
-                <a16:creationId xmlns:a16="http://schemas.microsoft.com/office/drawing/2014/main" id="{7F42106F-D67B-4B5F-9136-9CEF1894490C}"/>
+                <a16:creationId xmlns:a16="http://schemas.microsoft.com/office/drawing/2014/main" id="{14A01665-BAC3-4BCC-ADFE-F10DF98A726A}"/>
               </a:ext>
             </a:extLst>
           </p:cNvPr>
@@ -7059,7 +7382,7 @@
           <p:cNvPr id="9" name="agent-propose-copy">
             <a:extLst xmlns:a="http://schemas.openxmlformats.org/drawingml/2006/main">
               <a:ext uri="{FF2B5EF4-FFF2-40B4-BE49-F238E27FC236}">
-                <a16:creationId xmlns:a16="http://schemas.microsoft.com/office/drawing/2014/main" id="{BC4A89FD-F1D6-4B15-A6C8-67A53C76DAC8}"/>
+                <a16:creationId xmlns:a16="http://schemas.microsoft.com/office/drawing/2014/main" id="{5FD3012E-4E40-46A1-A6B8-C9008D9CBE8F}"/>
               </a:ext>
             </a:extLst>
           </p:cNvPr>
@@ -7117,7 +7440,7 @@
           <p:cNvPr id="10" name="agent-abstain">
             <a:extLst xmlns:a="http://schemas.openxmlformats.org/drawingml/2006/main">
               <a:ext uri="{FF2B5EF4-FFF2-40B4-BE49-F238E27FC236}">
-                <a16:creationId xmlns:a16="http://schemas.microsoft.com/office/drawing/2014/main" id="{E1C1C406-A1C8-4EA9-8329-01EC84D6ADA4}"/>
+                <a16:creationId xmlns:a16="http://schemas.microsoft.com/office/drawing/2014/main" id="{5FA0D4DE-5B6A-4455-AAC6-EA3FEAADCCDC}"/>
               </a:ext>
             </a:extLst>
           </p:cNvPr>
@@ -7175,7 +7498,7 @@
           <p:cNvPr id="11" name="agent-abstain-copy">
             <a:extLst xmlns:a="http://schemas.openxmlformats.org/drawingml/2006/main">
               <a:ext uri="{FF2B5EF4-FFF2-40B4-BE49-F238E27FC236}">
-                <a16:creationId xmlns:a16="http://schemas.microsoft.com/office/drawing/2014/main" id="{4752B695-EF0D-40B3-A17B-B8836E4CF0EE}"/>
+                <a16:creationId xmlns:a16="http://schemas.microsoft.com/office/drawing/2014/main" id="{519E0572-D19A-4E03-BDA7-A24960D35313}"/>
               </a:ext>
             </a:extLst>
           </p:cNvPr>
@@ -7233,7 +7556,7 @@
           <p:cNvPr id="12" name="agent-decide">
             <a:extLst xmlns:a="http://schemas.openxmlformats.org/drawingml/2006/main">
               <a:ext uri="{FF2B5EF4-FFF2-40B4-BE49-F238E27FC236}">
-                <a16:creationId xmlns:a16="http://schemas.microsoft.com/office/drawing/2014/main" id="{484E9631-3B25-41FE-ADD8-03B9C79168D4}"/>
+                <a16:creationId xmlns:a16="http://schemas.microsoft.com/office/drawing/2014/main" id="{E3D9A3BC-0571-42C9-AB0E-99FA250684FE}"/>
               </a:ext>
             </a:extLst>
           </p:cNvPr>
@@ -7291,7 +7614,7 @@
           <p:cNvPr id="13" name="agent-decide-copy">
             <a:extLst xmlns:a="http://schemas.openxmlformats.org/drawingml/2006/main">
               <a:ext uri="{FF2B5EF4-FFF2-40B4-BE49-F238E27FC236}">
-                <a16:creationId xmlns:a16="http://schemas.microsoft.com/office/drawing/2014/main" id="{8CC6F521-6117-44C2-871E-AB0DF152DF07}"/>
+                <a16:creationId xmlns:a16="http://schemas.microsoft.com/office/drawing/2014/main" id="{B759E6ED-5C98-4252-89B9-86412A2D4471}"/>
               </a:ext>
             </a:extLst>
           </p:cNvPr>
@@ -7349,7 +7672,7 @@
           <p:cNvPr id="14" name="agent-boundary-rule">
             <a:extLst xmlns:a="http://schemas.openxmlformats.org/drawingml/2006/main">
               <a:ext uri="{FF2B5EF4-FFF2-40B4-BE49-F238E27FC236}">
-                <a16:creationId xmlns:a16="http://schemas.microsoft.com/office/drawing/2014/main" id="{9E75963C-1A7B-4D3B-9DE6-F9B2E2357AF2}"/>
+                <a16:creationId xmlns:a16="http://schemas.microsoft.com/office/drawing/2014/main" id="{D63EE846-C5FA-4CDA-95A2-99DA34316BDD}"/>
               </a:ext>
             </a:extLst>
           </p:cNvPr>
@@ -7380,7 +7703,7 @@
           <p:cNvPr id="15" name="agent-boundary-copy">
             <a:extLst xmlns:a="http://schemas.openxmlformats.org/drawingml/2006/main">
               <a:ext uri="{FF2B5EF4-FFF2-40B4-BE49-F238E27FC236}">
-                <a16:creationId xmlns:a16="http://schemas.microsoft.com/office/drawing/2014/main" id="{66C97652-DEA3-4E71-BEE6-B080A2F26E8E}"/>
+                <a16:creationId xmlns:a16="http://schemas.microsoft.com/office/drawing/2014/main" id="{F3FDF385-66C3-49C9-B47C-608665C7DF54}"/>
               </a:ext>
             </a:extLst>
           </p:cNvPr>
@@ -7392,7 +7715,7 @@
         <p:spPr>
           <a:xfrm xmlns:a="http://schemas.openxmlformats.org/drawingml/2006/main">
             <a:off x="8153400" y="2438400"/>
-            <a:ext cx="2857500" cy="1428750"/>
+            <a:ext cx="2857500" cy="2476500"/>
           </a:xfrm>
           <a:prstGeom xmlns:a="http://schemas.openxmlformats.org/drawingml/2006/main" prst="rect">
             <a:avLst/>
@@ -7410,7 +7733,7 @@
           <a:lstStyle xmlns:a="http://schemas.openxmlformats.org/drawingml/2006/main"/>
           <a:p xmlns:a="http://schemas.openxmlformats.org/drawingml/2006/main">
             <a:pPr algn="l">
-              <a:defRPr sz="2250" b="0" i="0">
+              <a:defRPr sz="1950" b="0" i="0">
                 <a:solidFill>
                   <a:srgbClr val="A87229"/>
                 </a:solidFill>
@@ -7420,7 +7743,7 @@
               </a:defRPr>
             </a:pPr>
             <a:r>
-              <a:rPr sz="2250" b="0" i="0">
+              <a:rPr sz="1950" b="0" i="0">
                 <a:solidFill>
                   <a:srgbClr val="A87229"/>
                 </a:solidFill>
@@ -7428,7 +7751,7 @@
                 <a:ea typeface="Georgia"/>
                 <a:cs typeface="Georgia"/>
               </a:rPr>
-              <a:t>No live model. No compliance conclusion.</a:t>
+              <a:t>No live model. No compliance conclusion. Harness built and tested before any model enters.</a:t>
             </a:r>
           </a:p>
         </p:txBody>
@@ -7436,7 +7759,7 @@
     </p:spTree>
     <p:extLst>
       <p:ext uri="{BB962C8B-B14F-4D97-AF65-F5344CB8AC3E}">
-        <p14:creationId xmlns:p14="http://schemas.microsoft.com/office/powerpoint/2010/main" val="1623457723"/>
+        <p14:creationId xmlns:p14="http://schemas.microsoft.com/office/powerpoint/2010/main" val="526058206"/>
       </p:ext>
     </p:extLst>
   </p:cSld>
@@ -7467,7 +7790,7 @@
           <p:cNvPr id="15" name="brand-7">
             <a:extLst xmlns:a="http://schemas.openxmlformats.org/drawingml/2006/main">
               <a:ext uri="{FF2B5EF4-FFF2-40B4-BE49-F238E27FC236}">
-                <a16:creationId xmlns:a16="http://schemas.microsoft.com/office/drawing/2014/main" id="{0B210DAB-E4B7-4FA6-911D-D11638B306F8}"/>
+                <a16:creationId xmlns:a16="http://schemas.microsoft.com/office/drawing/2014/main" id="{A1E1C9B6-E67E-497B-B849-66B524D6FC1E}"/>
               </a:ext>
             </a:extLst>
           </p:cNvPr>
@@ -7525,7 +7848,7 @@
           <p:cNvPr id="2" name="title-7">
             <a:extLst xmlns:a="http://schemas.openxmlformats.org/drawingml/2006/main">
               <a:ext uri="{FF2B5EF4-FFF2-40B4-BE49-F238E27FC236}">
-                <a16:creationId xmlns:a16="http://schemas.microsoft.com/office/drawing/2014/main" id="{B9C5ED59-5380-4614-83FD-FEB6F5D82029}"/>
+                <a16:creationId xmlns:a16="http://schemas.microsoft.com/office/drawing/2014/main" id="{B596BE8A-2B11-4F32-B428-D38E85F0924F}"/>
               </a:ext>
             </a:extLst>
           </p:cNvPr>
@@ -7583,7 +7906,7 @@
           <p:cNvPr id="3" name="footer-rule-7">
             <a:extLst xmlns:a="http://schemas.openxmlformats.org/drawingml/2006/main">
               <a:ext uri="{FF2B5EF4-FFF2-40B4-BE49-F238E27FC236}">
-                <a16:creationId xmlns:a16="http://schemas.microsoft.com/office/drawing/2014/main" id="{70332EFB-5145-4B9B-BF3F-F7971939A6A7}"/>
+                <a16:creationId xmlns:a16="http://schemas.microsoft.com/office/drawing/2014/main" id="{0A0C0DC9-6964-4FFE-AFE9-B026C695D0A4}"/>
               </a:ext>
             </a:extLst>
           </p:cNvPr>
@@ -7614,7 +7937,7 @@
           <p:cNvPr id="4" name="footer-source-7">
             <a:extLst xmlns:a="http://schemas.openxmlformats.org/drawingml/2006/main">
               <a:ext uri="{FF2B5EF4-FFF2-40B4-BE49-F238E27FC236}">
-                <a16:creationId xmlns:a16="http://schemas.microsoft.com/office/drawing/2014/main" id="{ABBD2B29-2203-4C64-A35A-6A605D2AF60A}"/>
+                <a16:creationId xmlns:a16="http://schemas.microsoft.com/office/drawing/2014/main" id="{D5DCDDFB-D422-412E-A449-4E2574436912}"/>
               </a:ext>
             </a:extLst>
           </p:cNvPr>
@@ -7672,7 +7995,7 @@
           <p:cNvPr id="5" name="footer-page-7">
             <a:extLst xmlns:a="http://schemas.openxmlformats.org/drawingml/2006/main">
               <a:ext uri="{FF2B5EF4-FFF2-40B4-BE49-F238E27FC236}">
-                <a16:creationId xmlns:a16="http://schemas.microsoft.com/office/drawing/2014/main" id="{05DE4952-6190-446F-B2C2-4A130CC16866}"/>
+                <a16:creationId xmlns:a16="http://schemas.microsoft.com/office/drawing/2014/main" id="{DEB05FFE-BA6B-4D7B-A621-A89D3FE89FFE}"/>
               </a:ext>
             </a:extLst>
           </p:cNvPr>
@@ -7730,7 +8053,7 @@
           <p:cNvPr id="6" name="prototype-proof-label">
             <a:extLst xmlns:a="http://schemas.openxmlformats.org/drawingml/2006/main">
               <a:ext uri="{FF2B5EF4-FFF2-40B4-BE49-F238E27FC236}">
-                <a16:creationId xmlns:a16="http://schemas.microsoft.com/office/drawing/2014/main" id="{AEC4F2E6-1645-485E-B811-80191CDEBEF8}"/>
+                <a16:creationId xmlns:a16="http://schemas.microsoft.com/office/drawing/2014/main" id="{1D0311B3-51FB-4109-BC17-786AC209684C}"/>
               </a:ext>
             </a:extLst>
           </p:cNvPr>
@@ -7792,16 +8115,16 @@
           <p:nvPr/>
         </p:nvPicPr>
         <p:blipFill>
-          <a:blip xmlns:r="http://schemas.openxmlformats.org/officeDocument/2006/relationships" xmlns:a="http://schemas.openxmlformats.org/drawingml/2006/main" r:embed="R73d4db7fea484020"/>
-          <a:srcRect xmlns:a="http://schemas.openxmlformats.org/drawingml/2006/main" l="0" t="27730" r="0" b="27730"/>
+          <a:blip xmlns:r="http://schemas.openxmlformats.org/officeDocument/2006/relationships" xmlns:a="http://schemas.openxmlformats.org/drawingml/2006/main" r:embed="R686740e650fc4f7c"/>
+          <a:srcRect xmlns:a="http://schemas.openxmlformats.org/drawingml/2006/main" l="0" t="9" r="0" b="9"/>
           <a:stretch xmlns:a="http://schemas.openxmlformats.org/drawingml/2006/main">
             <a:fillRect l="0" t="0" r="0" b="0"/>
           </a:stretch>
         </p:blipFill>
         <p:spPr>
           <a:xfrm xmlns:a="http://schemas.openxmlformats.org/drawingml/2006/main">
-            <a:off x="571500" y="1619250"/>
-            <a:ext cx="7067550" cy="3600450"/>
+            <a:off x="981075" y="1619250"/>
+            <a:ext cx="3600450" cy="3667125"/>
           </a:xfrm>
           <a:prstGeom xmlns:a="http://schemas.openxmlformats.org/drawingml/2006/main" prst="rect">
             <a:avLst/>
@@ -7813,19 +8136,19 @@
           <p:cNvPr id="8" name="prototype-conflict-border">
             <a:extLst xmlns:a="http://schemas.openxmlformats.org/drawingml/2006/main">
               <a:ext uri="{FF2B5EF4-FFF2-40B4-BE49-F238E27FC236}">
-                <a16:creationId xmlns:a16="http://schemas.microsoft.com/office/drawing/2014/main" id="{CCA56627-F6F5-4C3C-8BDD-7850A46C823E}"/>
-              </a:ext>
-            </a:extLst>
-          </p:cNvPr>
-          <p:cNvSpPr>
-            <a:spLocks xmlns:a="http://schemas.openxmlformats.org/drawingml/2006/main" noGrp="1"/>
-          </p:cNvSpPr>
-          <p:nvPr/>
-        </p:nvSpPr>
-        <p:spPr>
-          <a:xfrm xmlns:a="http://schemas.openxmlformats.org/drawingml/2006/main">
-            <a:off x="571500" y="1619250"/>
-            <a:ext cx="7067550" cy="3600450"/>
+                <a16:creationId xmlns:a16="http://schemas.microsoft.com/office/drawing/2014/main" id="{0FE1E28A-A021-428D-8A48-17C20CE682C6}"/>
+              </a:ext>
+            </a:extLst>
+          </p:cNvPr>
+          <p:cNvSpPr>
+            <a:spLocks xmlns:a="http://schemas.openxmlformats.org/drawingml/2006/main" noGrp="1"/>
+          </p:cNvSpPr>
+          <p:nvPr/>
+        </p:nvSpPr>
+        <p:spPr>
+          <a:xfrm xmlns:a="http://schemas.openxmlformats.org/drawingml/2006/main">
+            <a:off x="981075" y="1619250"/>
+            <a:ext cx="3600450" cy="3667125"/>
           </a:xfrm>
           <a:prstGeom xmlns:a="http://schemas.openxmlformats.org/drawingml/2006/main" prst="rect">
             <a:avLst/>
@@ -7848,16 +8171,16 @@
           <p:nvPr/>
         </p:nvPicPr>
         <p:blipFill>
-          <a:blip xmlns:r="http://schemas.openxmlformats.org/officeDocument/2006/relationships" xmlns:a="http://schemas.openxmlformats.org/drawingml/2006/main" r:embed="R92ec378d7c2e4be3"/>
-          <a:srcRect xmlns:a="http://schemas.openxmlformats.org/drawingml/2006/main" l="0" t="23676" r="0" b="23676"/>
+          <a:blip xmlns:r="http://schemas.openxmlformats.org/officeDocument/2006/relationships" xmlns:a="http://schemas.openxmlformats.org/drawingml/2006/main" r:embed="R717042d5d0204ad4"/>
+          <a:srcRect xmlns:a="http://schemas.openxmlformats.org/drawingml/2006/main" l="19" t="0" r="19" b="0"/>
           <a:stretch xmlns:a="http://schemas.openxmlformats.org/drawingml/2006/main">
             <a:fillRect l="0" t="0" r="0" b="0"/>
           </a:stretch>
         </p:blipFill>
         <p:spPr>
           <a:xfrm xmlns:a="http://schemas.openxmlformats.org/drawingml/2006/main">
-            <a:off x="7905750" y="1619250"/>
-            <a:ext cx="3714750" cy="3600450"/>
+            <a:off x="4962525" y="1619250"/>
+            <a:ext cx="6248400" cy="3667125"/>
           </a:xfrm>
           <a:prstGeom xmlns:a="http://schemas.openxmlformats.org/drawingml/2006/main" prst="rect">
             <a:avLst/>
@@ -7869,19 +8192,19 @@
           <p:cNvPr id="10" name="prototype-receipt-border">
             <a:extLst xmlns:a="http://schemas.openxmlformats.org/drawingml/2006/main">
               <a:ext uri="{FF2B5EF4-FFF2-40B4-BE49-F238E27FC236}">
-                <a16:creationId xmlns:a16="http://schemas.microsoft.com/office/drawing/2014/main" id="{4C907B09-436A-4BF3-904E-CD16AA84F580}"/>
-              </a:ext>
-            </a:extLst>
-          </p:cNvPr>
-          <p:cNvSpPr>
-            <a:spLocks xmlns:a="http://schemas.openxmlformats.org/drawingml/2006/main" noGrp="1"/>
-          </p:cNvSpPr>
-          <p:nvPr/>
-        </p:nvSpPr>
-        <p:spPr>
-          <a:xfrm xmlns:a="http://schemas.openxmlformats.org/drawingml/2006/main">
-            <a:off x="7905750" y="1619250"/>
-            <a:ext cx="3714750" cy="3600450"/>
+                <a16:creationId xmlns:a16="http://schemas.microsoft.com/office/drawing/2014/main" id="{33298CAB-3FEB-478A-94E2-A64F1154DCCA}"/>
+              </a:ext>
+            </a:extLst>
+          </p:cNvPr>
+          <p:cNvSpPr>
+            <a:spLocks xmlns:a="http://schemas.openxmlformats.org/drawingml/2006/main" noGrp="1"/>
+          </p:cNvSpPr>
+          <p:nvPr/>
+        </p:nvSpPr>
+        <p:spPr>
+          <a:xfrm xmlns:a="http://schemas.openxmlformats.org/drawingml/2006/main">
+            <a:off x="4962525" y="1619250"/>
+            <a:ext cx="6248400" cy="3667125"/>
           </a:xfrm>
           <a:prstGeom xmlns:a="http://schemas.openxmlformats.org/drawingml/2006/main" prst="rect">
             <a:avLst/>
@@ -7900,7 +8223,7 @@
           <p:cNvPr id="11" name="prototype-callout-1">
             <a:extLst xmlns:a="http://schemas.openxmlformats.org/drawingml/2006/main">
               <a:ext uri="{FF2B5EF4-FFF2-40B4-BE49-F238E27FC236}">
-                <a16:creationId xmlns:a16="http://schemas.microsoft.com/office/drawing/2014/main" id="{A767CAF5-9B81-488C-A186-0DD9F868C8F7}"/>
+                <a16:creationId xmlns:a16="http://schemas.microsoft.com/office/drawing/2014/main" id="{54382E01-7EF3-417C-88E3-07C6A6447234}"/>
               </a:ext>
             </a:extLst>
           </p:cNvPr>
@@ -7958,7 +8281,7 @@
           <p:cNvPr id="12" name="prototype-callout-2">
             <a:extLst xmlns:a="http://schemas.openxmlformats.org/drawingml/2006/main">
               <a:ext uri="{FF2B5EF4-FFF2-40B4-BE49-F238E27FC236}">
-                <a16:creationId xmlns:a16="http://schemas.microsoft.com/office/drawing/2014/main" id="{C3DE5BCE-785A-4622-9C22-276CA81AD273}"/>
+                <a16:creationId xmlns:a16="http://schemas.microsoft.com/office/drawing/2014/main" id="{453974C6-54A9-4A12-876A-0A50B7B28EDE}"/>
               </a:ext>
             </a:extLst>
           </p:cNvPr>
@@ -8016,7 +8339,7 @@
           <p:cNvPr id="13" name="prototype-callout-3">
             <a:extLst xmlns:a="http://schemas.openxmlformats.org/drawingml/2006/main">
               <a:ext uri="{FF2B5EF4-FFF2-40B4-BE49-F238E27FC236}">
-                <a16:creationId xmlns:a16="http://schemas.microsoft.com/office/drawing/2014/main" id="{C6D9D781-F20B-4F25-BCCB-E10958B26D0F}"/>
+                <a16:creationId xmlns:a16="http://schemas.microsoft.com/office/drawing/2014/main" id="{7B6FE59D-CB03-4AF9-B46A-62F1E2196FE2}"/>
               </a:ext>
             </a:extLst>
           </p:cNvPr>
@@ -8074,7 +8397,7 @@
           <p:cNvPr id="14" name="prototype-callout-4">
             <a:extLst xmlns:a="http://schemas.openxmlformats.org/drawingml/2006/main">
               <a:ext uri="{FF2B5EF4-FFF2-40B4-BE49-F238E27FC236}">
-                <a16:creationId xmlns:a16="http://schemas.microsoft.com/office/drawing/2014/main" id="{2519A459-5776-4511-802D-B63289BCE2B0}"/>
+                <a16:creationId xmlns:a16="http://schemas.microsoft.com/office/drawing/2014/main" id="{626D0704-1EEB-410D-B33A-D62912B8FB20}"/>
               </a:ext>
             </a:extLst>
           </p:cNvPr>
@@ -8130,7 +8453,7 @@
     </p:spTree>
     <p:extLst>
       <p:ext uri="{BB962C8B-B14F-4D97-AF65-F5344CB8AC3E}">
-        <p14:creationId xmlns:p14="http://schemas.microsoft.com/office/powerpoint/2010/main" val="1610947046"/>
+        <p14:creationId xmlns:p14="http://schemas.microsoft.com/office/powerpoint/2010/main" val="462260120"/>
       </p:ext>
     </p:extLst>
   </p:cSld>
@@ -8158,10 +8481,10 @@
       </p:grpSpPr>
       <p:sp>
         <p:nvSpPr>
-          <p:cNvPr id="30" name="brand-8">
-            <a:extLst xmlns:a="http://schemas.openxmlformats.org/drawingml/2006/main">
-              <a:ext uri="{FF2B5EF4-FFF2-40B4-BE49-F238E27FC236}">
-                <a16:creationId xmlns:a16="http://schemas.microsoft.com/office/drawing/2014/main" id="{064BF53F-C008-4A80-BCBD-5B5AFEA8EDDB}"/>
+          <p:cNvPr id="24" name="brand-8">
+            <a:extLst xmlns:a="http://schemas.openxmlformats.org/drawingml/2006/main">
+              <a:ext uri="{FF2B5EF4-FFF2-40B4-BE49-F238E27FC236}">
+                <a16:creationId xmlns:a16="http://schemas.microsoft.com/office/drawing/2014/main" id="{9385E0F0-4B50-4105-930F-9AEE835B3AEE}"/>
               </a:ext>
             </a:extLst>
           </p:cNvPr>
@@ -8219,7 +8542,7 @@
           <p:cNvPr id="2" name="title-8">
             <a:extLst xmlns:a="http://schemas.openxmlformats.org/drawingml/2006/main">
               <a:ext uri="{FF2B5EF4-FFF2-40B4-BE49-F238E27FC236}">
-                <a16:creationId xmlns:a16="http://schemas.microsoft.com/office/drawing/2014/main" id="{CC15BCDF-0187-47F0-942C-42F24206C6F9}"/>
+                <a16:creationId xmlns:a16="http://schemas.microsoft.com/office/drawing/2014/main" id="{C0CE5AC8-B109-40AE-9DE6-A737D1CDDCA5}"/>
               </a:ext>
             </a:extLst>
           </p:cNvPr>
@@ -8277,7 +8600,7 @@
           <p:cNvPr id="3" name="footer-rule-8">
             <a:extLst xmlns:a="http://schemas.openxmlformats.org/drawingml/2006/main">
               <a:ext uri="{FF2B5EF4-FFF2-40B4-BE49-F238E27FC236}">
-                <a16:creationId xmlns:a16="http://schemas.microsoft.com/office/drawing/2014/main" id="{2B817319-7FAA-411E-B9A4-7ED963F2B262}"/>
+                <a16:creationId xmlns:a16="http://schemas.microsoft.com/office/drawing/2014/main" id="{8302B38E-0060-46B6-8C29-31D366B65F8E}"/>
               </a:ext>
             </a:extLst>
           </p:cNvPr>
@@ -8308,7 +8631,7 @@
           <p:cNvPr id="4" name="footer-source-8">
             <a:extLst xmlns:a="http://schemas.openxmlformats.org/drawingml/2006/main">
               <a:ext uri="{FF2B5EF4-FFF2-40B4-BE49-F238E27FC236}">
-                <a16:creationId xmlns:a16="http://schemas.microsoft.com/office/drawing/2014/main" id="{09115BE8-D063-4D17-9DD1-D4DDA3BC0121}"/>
+                <a16:creationId xmlns:a16="http://schemas.microsoft.com/office/drawing/2014/main" id="{108D24D8-7860-4680-8650-9D85655EF7AB}"/>
               </a:ext>
             </a:extLst>
           </p:cNvPr>
@@ -8366,7 +8689,7 @@
           <p:cNvPr id="5" name="footer-page-8">
             <a:extLst xmlns:a="http://schemas.openxmlformats.org/drawingml/2006/main">
               <a:ext uri="{FF2B5EF4-FFF2-40B4-BE49-F238E27FC236}">
-                <a16:creationId xmlns:a16="http://schemas.microsoft.com/office/drawing/2014/main" id="{67A5656E-DAF2-461F-BCEA-309ED60FAB8B}"/>
+                <a16:creationId xmlns:a16="http://schemas.microsoft.com/office/drawing/2014/main" id="{2B52EFE2-B1ED-400E-86E4-48CBC7573BDC}"/>
               </a:ext>
             </a:extLst>
           </p:cNvPr>
@@ -8424,7 +8747,7 @@
           <p:cNvPr id="6" name="sensitivity-label">
             <a:extLst xmlns:a="http://schemas.openxmlformats.org/drawingml/2006/main">
               <a:ext uri="{FF2B5EF4-FFF2-40B4-BE49-F238E27FC236}">
-                <a16:creationId xmlns:a16="http://schemas.microsoft.com/office/drawing/2014/main" id="{331BBAC2-E41F-4550-B012-C4959CEC7CB2}"/>
+                <a16:creationId xmlns:a16="http://schemas.microsoft.com/office/drawing/2014/main" id="{BAD60377-63F2-4D41-97EE-40FB18E1D69B}"/>
               </a:ext>
             </a:extLst>
           </p:cNvPr>
@@ -8482,19 +8805,19 @@
           <p:cNvPr id="7" name="sensitivity-row-0">
             <a:extLst xmlns:a="http://schemas.openxmlformats.org/drawingml/2006/main">
               <a:ext uri="{FF2B5EF4-FFF2-40B4-BE49-F238E27FC236}">
-                <a16:creationId xmlns:a16="http://schemas.microsoft.com/office/drawing/2014/main" id="{368ED05B-DBD7-411A-9EA4-8E22DF0BFDBF}"/>
-              </a:ext>
-            </a:extLst>
-          </p:cNvPr>
-          <p:cNvSpPr>
-            <a:spLocks xmlns:a="http://schemas.openxmlformats.org/drawingml/2006/main" noGrp="1"/>
-          </p:cNvSpPr>
-          <p:nvPr/>
-        </p:nvSpPr>
-        <p:spPr>
-          <a:xfrm xmlns:a="http://schemas.openxmlformats.org/drawingml/2006/main">
-            <a:off x="571500" y="2438400"/>
-            <a:ext cx="5715000" cy="0"/>
+                <a16:creationId xmlns:a16="http://schemas.microsoft.com/office/drawing/2014/main" id="{60064A4B-802C-41F3-85C9-F5CEE8422411}"/>
+              </a:ext>
+            </a:extLst>
+          </p:cNvPr>
+          <p:cNvSpPr>
+            <a:spLocks xmlns:a="http://schemas.openxmlformats.org/drawingml/2006/main" noGrp="1"/>
+          </p:cNvSpPr>
+          <p:nvPr/>
+        </p:nvSpPr>
+        <p:spPr>
+          <a:xfrm xmlns:a="http://schemas.openxmlformats.org/drawingml/2006/main">
+            <a:off x="571500" y="2552700"/>
+            <a:ext cx="5238750" cy="0"/>
           </a:xfrm>
           <a:prstGeom xmlns:a="http://schemas.openxmlformats.org/drawingml/2006/main" prst="line">
             <a:avLst/>
@@ -8513,7 +8836,7 @@
           <p:cNvPr id="8" name="sensitivity-0-0">
             <a:extLst xmlns:a="http://schemas.openxmlformats.org/drawingml/2006/main">
               <a:ext uri="{FF2B5EF4-FFF2-40B4-BE49-F238E27FC236}">
-                <a16:creationId xmlns:a16="http://schemas.microsoft.com/office/drawing/2014/main" id="{11C8AA8A-4924-41A1-866A-5375E5BC7C4A}"/>
+                <a16:creationId xmlns:a16="http://schemas.microsoft.com/office/drawing/2014/main" id="{522A3949-CFD1-4058-9763-5FFD88C3E31C}"/>
               </a:ext>
             </a:extLst>
           </p:cNvPr>
@@ -8525,7 +8848,7 @@
         <p:spPr>
           <a:xfrm xmlns:a="http://schemas.openxmlformats.org/drawingml/2006/main">
             <a:off x="571500" y="1752600"/>
-            <a:ext cx="1428750" cy="685800"/>
+            <a:ext cx="1428750" cy="800100"/>
           </a:xfrm>
           <a:prstGeom xmlns:a="http://schemas.openxmlformats.org/drawingml/2006/main" prst="rect">
             <a:avLst/>
@@ -8561,7 +8884,7 @@
                 <a:ea typeface="Courier New"/>
                 <a:cs typeface="Courier New"/>
               </a:rPr>
-              <a:t>Entities</a:t>
+              <a:t>ENTITIES</a:t>
             </a:r>
           </a:p>
         </p:txBody>
@@ -8571,7 +8894,7 @@
           <p:cNvPr id="9" name="sensitivity-0-1">
             <a:extLst xmlns:a="http://schemas.openxmlformats.org/drawingml/2006/main">
               <a:ext uri="{FF2B5EF4-FFF2-40B4-BE49-F238E27FC236}">
-                <a16:creationId xmlns:a16="http://schemas.microsoft.com/office/drawing/2014/main" id="{6902BAEA-CE9E-41E5-A0E5-9BFB4F20E8ED}"/>
+                <a16:creationId xmlns:a16="http://schemas.microsoft.com/office/drawing/2014/main" id="{2ABAF12D-30DC-43DE-8A83-4C1E1A19F2A3}"/>
               </a:ext>
             </a:extLst>
           </p:cNvPr>
@@ -8583,7 +8906,7 @@
         <p:spPr>
           <a:xfrm xmlns:a="http://schemas.openxmlformats.org/drawingml/2006/main">
             <a:off x="2000250" y="1752600"/>
-            <a:ext cx="1428750" cy="685800"/>
+            <a:ext cx="1905000" cy="800100"/>
           </a:xfrm>
           <a:prstGeom xmlns:a="http://schemas.openxmlformats.org/drawingml/2006/main" prst="rect">
             <a:avLst/>
@@ -8629,19 +8952,19 @@
           <p:cNvPr id="10" name="sensitivity-0-2">
             <a:extLst xmlns:a="http://schemas.openxmlformats.org/drawingml/2006/main">
               <a:ext uri="{FF2B5EF4-FFF2-40B4-BE49-F238E27FC236}">
-                <a16:creationId xmlns:a16="http://schemas.microsoft.com/office/drawing/2014/main" id="{84E74C66-7BB5-44F9-BB1A-BE21F0BF1781}"/>
-              </a:ext>
-            </a:extLst>
-          </p:cNvPr>
-          <p:cNvSpPr>
-            <a:spLocks xmlns:a="http://schemas.openxmlformats.org/drawingml/2006/main" noGrp="1"/>
-          </p:cNvSpPr>
-          <p:nvPr/>
-        </p:nvSpPr>
-        <p:spPr>
-          <a:xfrm xmlns:a="http://schemas.openxmlformats.org/drawingml/2006/main">
-            <a:off x="3429000" y="1752600"/>
-            <a:ext cx="1428750" cy="685800"/>
+                <a16:creationId xmlns:a16="http://schemas.microsoft.com/office/drawing/2014/main" id="{9E8F5172-E2B0-4F9F-BB1D-DA373BB8258A}"/>
+              </a:ext>
+            </a:extLst>
+          </p:cNvPr>
+          <p:cNvSpPr>
+            <a:spLocks xmlns:a="http://schemas.openxmlformats.org/drawingml/2006/main" noGrp="1"/>
+          </p:cNvSpPr>
+          <p:nvPr/>
+        </p:nvSpPr>
+        <p:spPr>
+          <a:xfrm xmlns:a="http://schemas.openxmlformats.org/drawingml/2006/main">
+            <a:off x="3905250" y="1752600"/>
+            <a:ext cx="1905000" cy="800100"/>
           </a:xfrm>
           <a:prstGeom xmlns:a="http://schemas.openxmlformats.org/drawingml/2006/main" prst="rect">
             <a:avLst/>
@@ -8677,64 +9000,6 @@
                 <a:ea typeface="Courier New"/>
                 <a:cs typeface="Courier New"/>
               </a:rPr>
-              <a:t>₹6L</a:t>
-            </a:r>
-          </a:p>
-        </p:txBody>
-      </p:sp>
-      <p:sp>
-        <p:nvSpPr>
-          <p:cNvPr id="11" name="sensitivity-0-3">
-            <a:extLst xmlns:a="http://schemas.openxmlformats.org/drawingml/2006/main">
-              <a:ext uri="{FF2B5EF4-FFF2-40B4-BE49-F238E27FC236}">
-                <a16:creationId xmlns:a16="http://schemas.microsoft.com/office/drawing/2014/main" id="{1BA851F6-6A55-402E-A46D-F909B525DDB3}"/>
-              </a:ext>
-            </a:extLst>
-          </p:cNvPr>
-          <p:cNvSpPr>
-            <a:spLocks xmlns:a="http://schemas.openxmlformats.org/drawingml/2006/main" noGrp="1"/>
-          </p:cNvSpPr>
-          <p:nvPr/>
-        </p:nvSpPr>
-        <p:spPr>
-          <a:xfrm xmlns:a="http://schemas.openxmlformats.org/drawingml/2006/main">
-            <a:off x="4857750" y="1752600"/>
-            <a:ext cx="1428750" cy="685800"/>
-          </a:xfrm>
-          <a:prstGeom xmlns:a="http://schemas.openxmlformats.org/drawingml/2006/main" prst="rect">
-            <a:avLst/>
-          </a:prstGeom>
-          <a:noFill xmlns:a="http://schemas.openxmlformats.org/drawingml/2006/main"/>
-          <a:ln xmlns:a="http://schemas.openxmlformats.org/drawingml/2006/main" w="0">
-            <a:noFill/>
-            <a:prstDash val="solid"/>
-          </a:ln>
-        </p:spPr>
-        <p:txBody>
-          <a:bodyPr xmlns:a="http://schemas.openxmlformats.org/drawingml/2006/main" wrap="square" lIns="95250" tIns="0" rIns="95250" bIns="0" anchor="ctr">
-            <a:noAutofit/>
-          </a:bodyPr>
-          <a:lstStyle xmlns:a="http://schemas.openxmlformats.org/drawingml/2006/main"/>
-          <a:p xmlns:a="http://schemas.openxmlformats.org/drawingml/2006/main">
-            <a:pPr algn="r">
-              <a:defRPr sz="1650" b="1" i="0">
-                <a:solidFill>
-                  <a:srgbClr val="625B53"/>
-                </a:solidFill>
-                <a:latin typeface="Courier New"/>
-                <a:ea typeface="Courier New"/>
-                <a:cs typeface="Courier New"/>
-              </a:defRPr>
-            </a:pPr>
-            <a:r>
-              <a:rPr sz="1650" b="1" i="0">
-                <a:solidFill>
-                  <a:srgbClr val="625B53"/>
-                </a:solidFill>
-                <a:latin typeface="Courier New"/>
-                <a:ea typeface="Courier New"/>
-                <a:cs typeface="Courier New"/>
-              </a:rPr>
               <a:t>₹12L</a:t>
             </a:r>
           </a:p>
@@ -8742,22 +9007,22 @@
       </p:sp>
       <p:sp>
         <p:nvSpPr>
-          <p:cNvPr id="12" name="sensitivity-row-1">
-            <a:extLst xmlns:a="http://schemas.openxmlformats.org/drawingml/2006/main">
-              <a:ext uri="{FF2B5EF4-FFF2-40B4-BE49-F238E27FC236}">
-                <a16:creationId xmlns:a16="http://schemas.microsoft.com/office/drawing/2014/main" id="{DDE95BC0-2AF7-4E5A-9F2A-4A1F41C23681}"/>
-              </a:ext>
-            </a:extLst>
-          </p:cNvPr>
-          <p:cNvSpPr>
-            <a:spLocks xmlns:a="http://schemas.openxmlformats.org/drawingml/2006/main" noGrp="1"/>
-          </p:cNvSpPr>
-          <p:nvPr/>
-        </p:nvSpPr>
-        <p:spPr>
-          <a:xfrm xmlns:a="http://schemas.openxmlformats.org/drawingml/2006/main">
-            <a:off x="571500" y="3124200"/>
-            <a:ext cx="5715000" cy="0"/>
+          <p:cNvPr id="11" name="sensitivity-row-1">
+            <a:extLst xmlns:a="http://schemas.openxmlformats.org/drawingml/2006/main">
+              <a:ext uri="{FF2B5EF4-FFF2-40B4-BE49-F238E27FC236}">
+                <a16:creationId xmlns:a16="http://schemas.microsoft.com/office/drawing/2014/main" id="{9EB82347-1098-4413-B242-D27E25A6B844}"/>
+              </a:ext>
+            </a:extLst>
+          </p:cNvPr>
+          <p:cNvSpPr>
+            <a:spLocks xmlns:a="http://schemas.openxmlformats.org/drawingml/2006/main" noGrp="1"/>
+          </p:cNvSpPr>
+          <p:nvPr/>
+        </p:nvSpPr>
+        <p:spPr>
+          <a:xfrm xmlns:a="http://schemas.openxmlformats.org/drawingml/2006/main">
+            <a:off x="571500" y="3352800"/>
+            <a:ext cx="5238750" cy="0"/>
           </a:xfrm>
           <a:prstGeom xmlns:a="http://schemas.openxmlformats.org/drawingml/2006/main" prst="line">
             <a:avLst/>
@@ -8773,22 +9038,22 @@
       </p:sp>
       <p:sp>
         <p:nvSpPr>
-          <p:cNvPr id="13" name="sensitivity-1-0">
-            <a:extLst xmlns:a="http://schemas.openxmlformats.org/drawingml/2006/main">
-              <a:ext uri="{FF2B5EF4-FFF2-40B4-BE49-F238E27FC236}">
-                <a16:creationId xmlns:a16="http://schemas.microsoft.com/office/drawing/2014/main" id="{A127E383-AF52-46BD-9DC9-BA2AC5BC997B}"/>
-              </a:ext>
-            </a:extLst>
-          </p:cNvPr>
-          <p:cNvSpPr>
-            <a:spLocks xmlns:a="http://schemas.openxmlformats.org/drawingml/2006/main" noGrp="1"/>
-          </p:cNvSpPr>
-          <p:nvPr/>
-        </p:nvSpPr>
-        <p:spPr>
-          <a:xfrm xmlns:a="http://schemas.openxmlformats.org/drawingml/2006/main">
-            <a:off x="571500" y="2438400"/>
-            <a:ext cx="1428750" cy="685800"/>
+          <p:cNvPr id="12" name="sensitivity-1-0">
+            <a:extLst xmlns:a="http://schemas.openxmlformats.org/drawingml/2006/main">
+              <a:ext uri="{FF2B5EF4-FFF2-40B4-BE49-F238E27FC236}">
+                <a16:creationId xmlns:a16="http://schemas.microsoft.com/office/drawing/2014/main" id="{546FD19B-8F5B-4D1D-BFB5-77D5E6723ADC}"/>
+              </a:ext>
+            </a:extLst>
+          </p:cNvPr>
+          <p:cNvSpPr>
+            <a:spLocks xmlns:a="http://schemas.openxmlformats.org/drawingml/2006/main" noGrp="1"/>
+          </p:cNvSpPr>
+          <p:nvPr/>
+        </p:nvSpPr>
+        <p:spPr>
+          <a:xfrm xmlns:a="http://schemas.openxmlformats.org/drawingml/2006/main">
+            <a:off x="571500" y="2552700"/>
+            <a:ext cx="1428750" cy="800100"/>
           </a:xfrm>
           <a:prstGeom xmlns:a="http://schemas.openxmlformats.org/drawingml/2006/main" prst="rect">
             <a:avLst/>
@@ -8806,7 +9071,7 @@
           <a:lstStyle xmlns:a="http://schemas.openxmlformats.org/drawingml/2006/main"/>
           <a:p xmlns:a="http://schemas.openxmlformats.org/drawingml/2006/main">
             <a:pPr algn="l">
-              <a:defRPr sz="1875" b="1" i="0">
+              <a:defRPr sz="2250" b="1" i="0">
                 <a:solidFill>
                   <a:srgbClr val="0A1F44"/>
                 </a:solidFill>
@@ -8816,7 +9081,7 @@
               </a:defRPr>
             </a:pPr>
             <a:r>
-              <a:rPr sz="1875" b="1" i="0">
+              <a:rPr sz="2250" b="1" i="0">
                 <a:solidFill>
                   <a:srgbClr val="0A1F44"/>
                 </a:solidFill>
@@ -8831,22 +9096,22 @@
       </p:sp>
       <p:sp>
         <p:nvSpPr>
-          <p:cNvPr id="14" name="sensitivity-1-1">
-            <a:extLst xmlns:a="http://schemas.openxmlformats.org/drawingml/2006/main">
-              <a:ext uri="{FF2B5EF4-FFF2-40B4-BE49-F238E27FC236}">
-                <a16:creationId xmlns:a16="http://schemas.microsoft.com/office/drawing/2014/main" id="{9E80764D-C1A0-415A-A7ED-1393DE1DFE9E}"/>
-              </a:ext>
-            </a:extLst>
-          </p:cNvPr>
-          <p:cNvSpPr>
-            <a:spLocks xmlns:a="http://schemas.openxmlformats.org/drawingml/2006/main" noGrp="1"/>
-          </p:cNvSpPr>
-          <p:nvPr/>
-        </p:nvSpPr>
-        <p:spPr>
-          <a:xfrm xmlns:a="http://schemas.openxmlformats.org/drawingml/2006/main">
-            <a:off x="2000250" y="2438400"/>
-            <a:ext cx="1428750" cy="685800"/>
+          <p:cNvPr id="13" name="sensitivity-1-1">
+            <a:extLst xmlns:a="http://schemas.openxmlformats.org/drawingml/2006/main">
+              <a:ext uri="{FF2B5EF4-FFF2-40B4-BE49-F238E27FC236}">
+                <a16:creationId xmlns:a16="http://schemas.microsoft.com/office/drawing/2014/main" id="{BF273F9B-9008-45B7-BD11-2750779286E3}"/>
+              </a:ext>
+            </a:extLst>
+          </p:cNvPr>
+          <p:cNvSpPr>
+            <a:spLocks xmlns:a="http://schemas.openxmlformats.org/drawingml/2006/main" noGrp="1"/>
+          </p:cNvSpPr>
+          <p:nvPr/>
+        </p:nvSpPr>
+        <p:spPr>
+          <a:xfrm xmlns:a="http://schemas.openxmlformats.org/drawingml/2006/main">
+            <a:off x="2000250" y="2552700"/>
+            <a:ext cx="1905000" cy="800100"/>
           </a:xfrm>
           <a:prstGeom xmlns:a="http://schemas.openxmlformats.org/drawingml/2006/main" prst="rect">
             <a:avLst/>
@@ -8864,7 +9129,7 @@
           <a:lstStyle xmlns:a="http://schemas.openxmlformats.org/drawingml/2006/main"/>
           <a:p xmlns:a="http://schemas.openxmlformats.org/drawingml/2006/main">
             <a:pPr algn="r">
-              <a:defRPr sz="1875" b="0" i="0">
+              <a:defRPr sz="2250" b="0" i="0">
                 <a:solidFill>
                   <a:srgbClr val="0A1F44"/>
                 </a:solidFill>
@@ -8874,7 +9139,7 @@
               </a:defRPr>
             </a:pPr>
             <a:r>
-              <a:rPr sz="1875" b="0" i="0">
+              <a:rPr sz="2250" b="0" i="0">
                 <a:solidFill>
                   <a:srgbClr val="0A1F44"/>
                 </a:solidFill>
@@ -8889,22 +9154,22 @@
       </p:sp>
       <p:sp>
         <p:nvSpPr>
-          <p:cNvPr id="15" name="sensitivity-1-2">
-            <a:extLst xmlns:a="http://schemas.openxmlformats.org/drawingml/2006/main">
-              <a:ext uri="{FF2B5EF4-FFF2-40B4-BE49-F238E27FC236}">
-                <a16:creationId xmlns:a16="http://schemas.microsoft.com/office/drawing/2014/main" id="{1E3F0772-5314-4617-BF64-0768979DD6D0}"/>
-              </a:ext>
-            </a:extLst>
-          </p:cNvPr>
-          <p:cNvSpPr>
-            <a:spLocks xmlns:a="http://schemas.openxmlformats.org/drawingml/2006/main" noGrp="1"/>
-          </p:cNvSpPr>
-          <p:nvPr/>
-        </p:nvSpPr>
-        <p:spPr>
-          <a:xfrm xmlns:a="http://schemas.openxmlformats.org/drawingml/2006/main">
-            <a:off x="3429000" y="2438400"/>
-            <a:ext cx="1428750" cy="685800"/>
+          <p:cNvPr id="14" name="sensitivity-1-2">
+            <a:extLst xmlns:a="http://schemas.openxmlformats.org/drawingml/2006/main">
+              <a:ext uri="{FF2B5EF4-FFF2-40B4-BE49-F238E27FC236}">
+                <a16:creationId xmlns:a16="http://schemas.microsoft.com/office/drawing/2014/main" id="{6780FE40-5BB0-4856-9C2A-74CF7F69E26F}"/>
+              </a:ext>
+            </a:extLst>
+          </p:cNvPr>
+          <p:cNvSpPr>
+            <a:spLocks xmlns:a="http://schemas.openxmlformats.org/drawingml/2006/main" noGrp="1"/>
+          </p:cNvSpPr>
+          <p:nvPr/>
+        </p:nvSpPr>
+        <p:spPr>
+          <a:xfrm xmlns:a="http://schemas.openxmlformats.org/drawingml/2006/main">
+            <a:off x="3905250" y="2552700"/>
+            <a:ext cx="1905000" cy="800100"/>
           </a:xfrm>
           <a:prstGeom xmlns:a="http://schemas.openxmlformats.org/drawingml/2006/main" prst="rect">
             <a:avLst/>
@@ -8922,7 +9187,7 @@
           <a:lstStyle xmlns:a="http://schemas.openxmlformats.org/drawingml/2006/main"/>
           <a:p xmlns:a="http://schemas.openxmlformats.org/drawingml/2006/main">
             <a:pPr algn="r">
-              <a:defRPr sz="1875" b="0" i="0">
+              <a:defRPr sz="2250" b="0" i="0">
                 <a:solidFill>
                   <a:srgbClr val="0A1F44"/>
                 </a:solidFill>
@@ -8932,7 +9197,7 @@
               </a:defRPr>
             </a:pPr>
             <a:r>
-              <a:rPr sz="1875" b="0" i="0">
+              <a:rPr sz="2250" b="0" i="0">
                 <a:solidFill>
                   <a:srgbClr val="0A1F44"/>
                 </a:solidFill>
@@ -8940,64 +9205,6 @@
                 <a:ea typeface="Georgia"/>
                 <a:cs typeface="Georgia"/>
               </a:rPr>
-              <a:t>₹30L</a:t>
-            </a:r>
-          </a:p>
-        </p:txBody>
-      </p:sp>
-      <p:sp>
-        <p:nvSpPr>
-          <p:cNvPr id="16" name="sensitivity-1-3">
-            <a:extLst xmlns:a="http://schemas.openxmlformats.org/drawingml/2006/main">
-              <a:ext uri="{FF2B5EF4-FFF2-40B4-BE49-F238E27FC236}">
-                <a16:creationId xmlns:a16="http://schemas.microsoft.com/office/drawing/2014/main" id="{29F8E30E-2378-4606-9628-3D1693FE4485}"/>
-              </a:ext>
-            </a:extLst>
-          </p:cNvPr>
-          <p:cNvSpPr>
-            <a:spLocks xmlns:a="http://schemas.openxmlformats.org/drawingml/2006/main" noGrp="1"/>
-          </p:cNvSpPr>
-          <p:nvPr/>
-        </p:nvSpPr>
-        <p:spPr>
-          <a:xfrm xmlns:a="http://schemas.openxmlformats.org/drawingml/2006/main">
-            <a:off x="4857750" y="2438400"/>
-            <a:ext cx="1428750" cy="685800"/>
-          </a:xfrm>
-          <a:prstGeom xmlns:a="http://schemas.openxmlformats.org/drawingml/2006/main" prst="rect">
-            <a:avLst/>
-          </a:prstGeom>
-          <a:noFill xmlns:a="http://schemas.openxmlformats.org/drawingml/2006/main"/>
-          <a:ln xmlns:a="http://schemas.openxmlformats.org/drawingml/2006/main" w="0">
-            <a:noFill/>
-            <a:prstDash val="solid"/>
-          </a:ln>
-        </p:spPr>
-        <p:txBody>
-          <a:bodyPr xmlns:a="http://schemas.openxmlformats.org/drawingml/2006/main" wrap="square" lIns="95250" tIns="0" rIns="95250" bIns="0" anchor="ctr">
-            <a:noAutofit/>
-          </a:bodyPr>
-          <a:lstStyle xmlns:a="http://schemas.openxmlformats.org/drawingml/2006/main"/>
-          <a:p xmlns:a="http://schemas.openxmlformats.org/drawingml/2006/main">
-            <a:pPr algn="r">
-              <a:defRPr sz="1875" b="0" i="0">
-                <a:solidFill>
-                  <a:srgbClr val="0A1F44"/>
-                </a:solidFill>
-                <a:latin typeface="Georgia"/>
-                <a:ea typeface="Georgia"/>
-                <a:cs typeface="Georgia"/>
-              </a:defRPr>
-            </a:pPr>
-            <a:r>
-              <a:rPr sz="1875" b="0" i="0">
-                <a:solidFill>
-                  <a:srgbClr val="0A1F44"/>
-                </a:solidFill>
-                <a:latin typeface="Georgia"/>
-                <a:ea typeface="Georgia"/>
-                <a:cs typeface="Georgia"/>
-              </a:rPr>
               <a:t>₹60L</a:t>
             </a:r>
           </a:p>
@@ -9005,22 +9212,22 @@
       </p:sp>
       <p:sp>
         <p:nvSpPr>
-          <p:cNvPr id="17" name="sensitivity-row-2">
-            <a:extLst xmlns:a="http://schemas.openxmlformats.org/drawingml/2006/main">
-              <a:ext uri="{FF2B5EF4-FFF2-40B4-BE49-F238E27FC236}">
-                <a16:creationId xmlns:a16="http://schemas.microsoft.com/office/drawing/2014/main" id="{52B0E903-762D-427F-BA79-B7769D23F1C4}"/>
-              </a:ext>
-            </a:extLst>
-          </p:cNvPr>
-          <p:cNvSpPr>
-            <a:spLocks xmlns:a="http://schemas.openxmlformats.org/drawingml/2006/main" noGrp="1"/>
-          </p:cNvSpPr>
-          <p:nvPr/>
-        </p:nvSpPr>
-        <p:spPr>
-          <a:xfrm xmlns:a="http://schemas.openxmlformats.org/drawingml/2006/main">
-            <a:off x="571500" y="3810000"/>
-            <a:ext cx="5715000" cy="0"/>
+          <p:cNvPr id="15" name="sensitivity-row-2">
+            <a:extLst xmlns:a="http://schemas.openxmlformats.org/drawingml/2006/main">
+              <a:ext uri="{FF2B5EF4-FFF2-40B4-BE49-F238E27FC236}">
+                <a16:creationId xmlns:a16="http://schemas.microsoft.com/office/drawing/2014/main" id="{11FF56B9-06ED-45E6-A025-73B34AAAFBA2}"/>
+              </a:ext>
+            </a:extLst>
+          </p:cNvPr>
+          <p:cNvSpPr>
+            <a:spLocks xmlns:a="http://schemas.openxmlformats.org/drawingml/2006/main" noGrp="1"/>
+          </p:cNvSpPr>
+          <p:nvPr/>
+        </p:nvSpPr>
+        <p:spPr>
+          <a:xfrm xmlns:a="http://schemas.openxmlformats.org/drawingml/2006/main">
+            <a:off x="571500" y="4152900"/>
+            <a:ext cx="5238750" cy="0"/>
           </a:xfrm>
           <a:prstGeom xmlns:a="http://schemas.openxmlformats.org/drawingml/2006/main" prst="line">
             <a:avLst/>
@@ -9036,22 +9243,22 @@
       </p:sp>
       <p:sp>
         <p:nvSpPr>
-          <p:cNvPr id="18" name="sensitivity-2-0">
-            <a:extLst xmlns:a="http://schemas.openxmlformats.org/drawingml/2006/main">
-              <a:ext uri="{FF2B5EF4-FFF2-40B4-BE49-F238E27FC236}">
-                <a16:creationId xmlns:a16="http://schemas.microsoft.com/office/drawing/2014/main" id="{33652A3C-B727-4E6C-AA81-1EF3F9F19489}"/>
-              </a:ext>
-            </a:extLst>
-          </p:cNvPr>
-          <p:cNvSpPr>
-            <a:spLocks xmlns:a="http://schemas.openxmlformats.org/drawingml/2006/main" noGrp="1"/>
-          </p:cNvSpPr>
-          <p:nvPr/>
-        </p:nvSpPr>
-        <p:spPr>
-          <a:xfrm xmlns:a="http://schemas.openxmlformats.org/drawingml/2006/main">
-            <a:off x="571500" y="3124200"/>
-            <a:ext cx="1428750" cy="685800"/>
+          <p:cNvPr id="16" name="sensitivity-2-0">
+            <a:extLst xmlns:a="http://schemas.openxmlformats.org/drawingml/2006/main">
+              <a:ext uri="{FF2B5EF4-FFF2-40B4-BE49-F238E27FC236}">
+                <a16:creationId xmlns:a16="http://schemas.microsoft.com/office/drawing/2014/main" id="{72CC6D68-390A-4715-9EBA-CD5D31B038F5}"/>
+              </a:ext>
+            </a:extLst>
+          </p:cNvPr>
+          <p:cNvSpPr>
+            <a:spLocks xmlns:a="http://schemas.openxmlformats.org/drawingml/2006/main" noGrp="1"/>
+          </p:cNvSpPr>
+          <p:nvPr/>
+        </p:nvSpPr>
+        <p:spPr>
+          <a:xfrm xmlns:a="http://schemas.openxmlformats.org/drawingml/2006/main">
+            <a:off x="571500" y="3352800"/>
+            <a:ext cx="1428750" cy="800100"/>
           </a:xfrm>
           <a:prstGeom xmlns:a="http://schemas.openxmlformats.org/drawingml/2006/main" prst="rect">
             <a:avLst/>
@@ -9069,7 +9276,7 @@
           <a:lstStyle xmlns:a="http://schemas.openxmlformats.org/drawingml/2006/main"/>
           <a:p xmlns:a="http://schemas.openxmlformats.org/drawingml/2006/main">
             <a:pPr algn="l">
-              <a:defRPr sz="1875" b="1" i="0">
+              <a:defRPr sz="2250" b="1" i="0">
                 <a:solidFill>
                   <a:srgbClr val="0A1F44"/>
                 </a:solidFill>
@@ -9079,7 +9286,7 @@
               </a:defRPr>
             </a:pPr>
             <a:r>
-              <a:rPr sz="1875" b="1" i="0">
+              <a:rPr sz="2250" b="1" i="0">
                 <a:solidFill>
                   <a:srgbClr val="0A1F44"/>
                 </a:solidFill>
@@ -9087,29 +9294,29 @@
                 <a:ea typeface="Georgia"/>
                 <a:cs typeface="Georgia"/>
               </a:rPr>
-              <a:t>20</a:t>
-            </a:r>
-          </a:p>
-        </p:txBody>
-      </p:sp>
-      <p:sp>
-        <p:nvSpPr>
-          <p:cNvPr id="19" name="sensitivity-2-1">
-            <a:extLst xmlns:a="http://schemas.openxmlformats.org/drawingml/2006/main">
-              <a:ext uri="{FF2B5EF4-FFF2-40B4-BE49-F238E27FC236}">
-                <a16:creationId xmlns:a16="http://schemas.microsoft.com/office/drawing/2014/main" id="{CB307BDF-B986-47FC-85A8-232C7F9A97C5}"/>
-              </a:ext>
-            </a:extLst>
-          </p:cNvPr>
-          <p:cNvSpPr>
-            <a:spLocks xmlns:a="http://schemas.openxmlformats.org/drawingml/2006/main" noGrp="1"/>
-          </p:cNvSpPr>
-          <p:nvPr/>
-        </p:nvSpPr>
-        <p:spPr>
-          <a:xfrm xmlns:a="http://schemas.openxmlformats.org/drawingml/2006/main">
-            <a:off x="2000250" y="3124200"/>
-            <a:ext cx="1428750" cy="685800"/>
+              <a:t>50</a:t>
+            </a:r>
+          </a:p>
+        </p:txBody>
+      </p:sp>
+      <p:sp>
+        <p:nvSpPr>
+          <p:cNvPr id="17" name="sensitivity-2-1">
+            <a:extLst xmlns:a="http://schemas.openxmlformats.org/drawingml/2006/main">
+              <a:ext uri="{FF2B5EF4-FFF2-40B4-BE49-F238E27FC236}">
+                <a16:creationId xmlns:a16="http://schemas.microsoft.com/office/drawing/2014/main" id="{B63764D2-A1A1-408F-8030-CDC3ED1A8B00}"/>
+              </a:ext>
+            </a:extLst>
+          </p:cNvPr>
+          <p:cNvSpPr>
+            <a:spLocks xmlns:a="http://schemas.openxmlformats.org/drawingml/2006/main" noGrp="1"/>
+          </p:cNvSpPr>
+          <p:nvPr/>
+        </p:nvSpPr>
+        <p:spPr>
+          <a:xfrm xmlns:a="http://schemas.openxmlformats.org/drawingml/2006/main">
+            <a:off x="2000250" y="3352800"/>
+            <a:ext cx="1905000" cy="800100"/>
           </a:xfrm>
           <a:prstGeom xmlns:a="http://schemas.openxmlformats.org/drawingml/2006/main" prst="rect">
             <a:avLst/>
@@ -9127,7 +9334,7 @@
           <a:lstStyle xmlns:a="http://schemas.openxmlformats.org/drawingml/2006/main"/>
           <a:p xmlns:a="http://schemas.openxmlformats.org/drawingml/2006/main">
             <a:pPr algn="r">
-              <a:defRPr sz="1875" b="0" i="0">
+              <a:defRPr sz="2250" b="0" i="0">
                 <a:solidFill>
                   <a:srgbClr val="0A1F44"/>
                 </a:solidFill>
@@ -9137,7 +9344,7 @@
               </a:defRPr>
             </a:pPr>
             <a:r>
-              <a:rPr sz="1875" b="0" i="0">
+              <a:rPr sz="2250" b="0" i="0">
                 <a:solidFill>
                   <a:srgbClr val="0A1F44"/>
                 </a:solidFill>
@@ -9145,29 +9352,29 @@
                 <a:ea typeface="Georgia"/>
                 <a:cs typeface="Georgia"/>
               </a:rPr>
-              <a:t>₹60L</a:t>
-            </a:r>
-          </a:p>
-        </p:txBody>
-      </p:sp>
-      <p:sp>
-        <p:nvSpPr>
-          <p:cNvPr id="20" name="sensitivity-2-2">
-            <a:extLst xmlns:a="http://schemas.openxmlformats.org/drawingml/2006/main">
-              <a:ext uri="{FF2B5EF4-FFF2-40B4-BE49-F238E27FC236}">
-                <a16:creationId xmlns:a16="http://schemas.microsoft.com/office/drawing/2014/main" id="{1096D7D1-51EB-4A8B-A492-D4A4AC23E8EA}"/>
-              </a:ext>
-            </a:extLst>
-          </p:cNvPr>
-          <p:cNvSpPr>
-            <a:spLocks xmlns:a="http://schemas.openxmlformats.org/drawingml/2006/main" noGrp="1"/>
-          </p:cNvSpPr>
-          <p:nvPr/>
-        </p:nvSpPr>
-        <p:spPr>
-          <a:xfrm xmlns:a="http://schemas.openxmlformats.org/drawingml/2006/main">
-            <a:off x="3429000" y="3124200"/>
-            <a:ext cx="1428750" cy="685800"/>
+              <a:t>₹1.5Cr</a:t>
+            </a:r>
+          </a:p>
+        </p:txBody>
+      </p:sp>
+      <p:sp>
+        <p:nvSpPr>
+          <p:cNvPr id="18" name="sensitivity-2-2">
+            <a:extLst xmlns:a="http://schemas.openxmlformats.org/drawingml/2006/main">
+              <a:ext uri="{FF2B5EF4-FFF2-40B4-BE49-F238E27FC236}">
+                <a16:creationId xmlns:a16="http://schemas.microsoft.com/office/drawing/2014/main" id="{D25E0BB6-210C-47B8-82B6-659453809C2B}"/>
+              </a:ext>
+            </a:extLst>
+          </p:cNvPr>
+          <p:cNvSpPr>
+            <a:spLocks xmlns:a="http://schemas.openxmlformats.org/drawingml/2006/main" noGrp="1"/>
+          </p:cNvSpPr>
+          <p:nvPr/>
+        </p:nvSpPr>
+        <p:spPr>
+          <a:xfrm xmlns:a="http://schemas.openxmlformats.org/drawingml/2006/main">
+            <a:off x="3905250" y="3352800"/>
+            <a:ext cx="1905000" cy="800100"/>
           </a:xfrm>
           <a:prstGeom xmlns:a="http://schemas.openxmlformats.org/drawingml/2006/main" prst="rect">
             <a:avLst/>
@@ -9185,7 +9392,7 @@
           <a:lstStyle xmlns:a="http://schemas.openxmlformats.org/drawingml/2006/main"/>
           <a:p xmlns:a="http://schemas.openxmlformats.org/drawingml/2006/main">
             <a:pPr algn="r">
-              <a:defRPr sz="1875" b="0" i="0">
+              <a:defRPr sz="2250" b="0" i="0">
                 <a:solidFill>
                   <a:srgbClr val="0A1F44"/>
                 </a:solidFill>
@@ -9195,7 +9402,7 @@
               </a:defRPr>
             </a:pPr>
             <a:r>
-              <a:rPr sz="1875" b="0" i="0">
+              <a:rPr sz="2250" b="0" i="0">
                 <a:solidFill>
                   <a:srgbClr val="0A1F44"/>
                 </a:solidFill>
@@ -9203,327 +9410,6 @@
                 <a:ea typeface="Georgia"/>
                 <a:cs typeface="Georgia"/>
               </a:rPr>
-              <a:t>₹1.2Cr</a:t>
-            </a:r>
-          </a:p>
-        </p:txBody>
-      </p:sp>
-      <p:sp>
-        <p:nvSpPr>
-          <p:cNvPr id="21" name="sensitivity-2-3">
-            <a:extLst xmlns:a="http://schemas.openxmlformats.org/drawingml/2006/main">
-              <a:ext uri="{FF2B5EF4-FFF2-40B4-BE49-F238E27FC236}">
-                <a16:creationId xmlns:a16="http://schemas.microsoft.com/office/drawing/2014/main" id="{888812AB-0273-4FF3-BC15-63CF438E7245}"/>
-              </a:ext>
-            </a:extLst>
-          </p:cNvPr>
-          <p:cNvSpPr>
-            <a:spLocks xmlns:a="http://schemas.openxmlformats.org/drawingml/2006/main" noGrp="1"/>
-          </p:cNvSpPr>
-          <p:nvPr/>
-        </p:nvSpPr>
-        <p:spPr>
-          <a:xfrm xmlns:a="http://schemas.openxmlformats.org/drawingml/2006/main">
-            <a:off x="4857750" y="3124200"/>
-            <a:ext cx="1428750" cy="685800"/>
-          </a:xfrm>
-          <a:prstGeom xmlns:a="http://schemas.openxmlformats.org/drawingml/2006/main" prst="rect">
-            <a:avLst/>
-          </a:prstGeom>
-          <a:noFill xmlns:a="http://schemas.openxmlformats.org/drawingml/2006/main"/>
-          <a:ln xmlns:a="http://schemas.openxmlformats.org/drawingml/2006/main" w="0">
-            <a:noFill/>
-            <a:prstDash val="solid"/>
-          </a:ln>
-        </p:spPr>
-        <p:txBody>
-          <a:bodyPr xmlns:a="http://schemas.openxmlformats.org/drawingml/2006/main" wrap="square" lIns="95250" tIns="0" rIns="95250" bIns="0" anchor="ctr">
-            <a:noAutofit/>
-          </a:bodyPr>
-          <a:lstStyle xmlns:a="http://schemas.openxmlformats.org/drawingml/2006/main"/>
-          <a:p xmlns:a="http://schemas.openxmlformats.org/drawingml/2006/main">
-            <a:pPr algn="r">
-              <a:defRPr sz="1875" b="0" i="0">
-                <a:solidFill>
-                  <a:srgbClr val="0A1F44"/>
-                </a:solidFill>
-                <a:latin typeface="Georgia"/>
-                <a:ea typeface="Georgia"/>
-                <a:cs typeface="Georgia"/>
-              </a:defRPr>
-            </a:pPr>
-            <a:r>
-              <a:rPr sz="1875" b="0" i="0">
-                <a:solidFill>
-                  <a:srgbClr val="0A1F44"/>
-                </a:solidFill>
-                <a:latin typeface="Georgia"/>
-                <a:ea typeface="Georgia"/>
-                <a:cs typeface="Georgia"/>
-              </a:rPr>
-              <a:t>₹2.4Cr</a:t>
-            </a:r>
-          </a:p>
-        </p:txBody>
-      </p:sp>
-      <p:sp>
-        <p:nvSpPr>
-          <p:cNvPr id="22" name="sensitivity-row-3">
-            <a:extLst xmlns:a="http://schemas.openxmlformats.org/drawingml/2006/main">
-              <a:ext uri="{FF2B5EF4-FFF2-40B4-BE49-F238E27FC236}">
-                <a16:creationId xmlns:a16="http://schemas.microsoft.com/office/drawing/2014/main" id="{92FB5B76-FFF2-4827-A303-6E4E7FE00FC0}"/>
-              </a:ext>
-            </a:extLst>
-          </p:cNvPr>
-          <p:cNvSpPr>
-            <a:spLocks xmlns:a="http://schemas.openxmlformats.org/drawingml/2006/main" noGrp="1"/>
-          </p:cNvSpPr>
-          <p:nvPr/>
-        </p:nvSpPr>
-        <p:spPr>
-          <a:xfrm xmlns:a="http://schemas.openxmlformats.org/drawingml/2006/main">
-            <a:off x="571500" y="4495800"/>
-            <a:ext cx="5715000" cy="0"/>
-          </a:xfrm>
-          <a:prstGeom xmlns:a="http://schemas.openxmlformats.org/drawingml/2006/main" prst="line">
-            <a:avLst/>
-          </a:prstGeom>
-          <a:noFill xmlns:a="http://schemas.openxmlformats.org/drawingml/2006/main"/>
-          <a:ln xmlns:a="http://schemas.openxmlformats.org/drawingml/2006/main" w="9525">
-            <a:solidFill>
-              <a:srgbClr val="7E786E"/>
-            </a:solidFill>
-            <a:prstDash val="solid"/>
-          </a:ln>
-        </p:spPr>
-      </p:sp>
-      <p:sp>
-        <p:nvSpPr>
-          <p:cNvPr id="23" name="sensitivity-3-0">
-            <a:extLst xmlns:a="http://schemas.openxmlformats.org/drawingml/2006/main">
-              <a:ext uri="{FF2B5EF4-FFF2-40B4-BE49-F238E27FC236}">
-                <a16:creationId xmlns:a16="http://schemas.microsoft.com/office/drawing/2014/main" id="{A601994A-7844-4CE8-B4D0-EE4238CC1D73}"/>
-              </a:ext>
-            </a:extLst>
-          </p:cNvPr>
-          <p:cNvSpPr>
-            <a:spLocks xmlns:a="http://schemas.openxmlformats.org/drawingml/2006/main" noGrp="1"/>
-          </p:cNvSpPr>
-          <p:nvPr/>
-        </p:nvSpPr>
-        <p:spPr>
-          <a:xfrm xmlns:a="http://schemas.openxmlformats.org/drawingml/2006/main">
-            <a:off x="571500" y="3810000"/>
-            <a:ext cx="1428750" cy="685800"/>
-          </a:xfrm>
-          <a:prstGeom xmlns:a="http://schemas.openxmlformats.org/drawingml/2006/main" prst="rect">
-            <a:avLst/>
-          </a:prstGeom>
-          <a:noFill xmlns:a="http://schemas.openxmlformats.org/drawingml/2006/main"/>
-          <a:ln xmlns:a="http://schemas.openxmlformats.org/drawingml/2006/main" w="0">
-            <a:noFill/>
-            <a:prstDash val="solid"/>
-          </a:ln>
-        </p:spPr>
-        <p:txBody>
-          <a:bodyPr xmlns:a="http://schemas.openxmlformats.org/drawingml/2006/main" wrap="square" lIns="95250" tIns="0" rIns="95250" bIns="0" anchor="ctr">
-            <a:noAutofit/>
-          </a:bodyPr>
-          <a:lstStyle xmlns:a="http://schemas.openxmlformats.org/drawingml/2006/main"/>
-          <a:p xmlns:a="http://schemas.openxmlformats.org/drawingml/2006/main">
-            <a:pPr algn="l">
-              <a:defRPr sz="1875" b="1" i="0">
-                <a:solidFill>
-                  <a:srgbClr val="0A1F44"/>
-                </a:solidFill>
-                <a:latin typeface="Georgia"/>
-                <a:ea typeface="Georgia"/>
-                <a:cs typeface="Georgia"/>
-              </a:defRPr>
-            </a:pPr>
-            <a:r>
-              <a:rPr sz="1875" b="1" i="0">
-                <a:solidFill>
-                  <a:srgbClr val="0A1F44"/>
-                </a:solidFill>
-                <a:latin typeface="Georgia"/>
-                <a:ea typeface="Georgia"/>
-                <a:cs typeface="Georgia"/>
-              </a:rPr>
-              <a:t>50</a:t>
-            </a:r>
-          </a:p>
-        </p:txBody>
-      </p:sp>
-      <p:sp>
-        <p:nvSpPr>
-          <p:cNvPr id="24" name="sensitivity-3-1">
-            <a:extLst xmlns:a="http://schemas.openxmlformats.org/drawingml/2006/main">
-              <a:ext uri="{FF2B5EF4-FFF2-40B4-BE49-F238E27FC236}">
-                <a16:creationId xmlns:a16="http://schemas.microsoft.com/office/drawing/2014/main" id="{0DF2A57C-753F-492E-8680-F43509541AE8}"/>
-              </a:ext>
-            </a:extLst>
-          </p:cNvPr>
-          <p:cNvSpPr>
-            <a:spLocks xmlns:a="http://schemas.openxmlformats.org/drawingml/2006/main" noGrp="1"/>
-          </p:cNvSpPr>
-          <p:nvPr/>
-        </p:nvSpPr>
-        <p:spPr>
-          <a:xfrm xmlns:a="http://schemas.openxmlformats.org/drawingml/2006/main">
-            <a:off x="2000250" y="3810000"/>
-            <a:ext cx="1428750" cy="685800"/>
-          </a:xfrm>
-          <a:prstGeom xmlns:a="http://schemas.openxmlformats.org/drawingml/2006/main" prst="rect">
-            <a:avLst/>
-          </a:prstGeom>
-          <a:noFill xmlns:a="http://schemas.openxmlformats.org/drawingml/2006/main"/>
-          <a:ln xmlns:a="http://schemas.openxmlformats.org/drawingml/2006/main" w="0">
-            <a:noFill/>
-            <a:prstDash val="solid"/>
-          </a:ln>
-        </p:spPr>
-        <p:txBody>
-          <a:bodyPr xmlns:a="http://schemas.openxmlformats.org/drawingml/2006/main" wrap="square" lIns="95250" tIns="0" rIns="95250" bIns="0" anchor="ctr">
-            <a:noAutofit/>
-          </a:bodyPr>
-          <a:lstStyle xmlns:a="http://schemas.openxmlformats.org/drawingml/2006/main"/>
-          <a:p xmlns:a="http://schemas.openxmlformats.org/drawingml/2006/main">
-            <a:pPr algn="r">
-              <a:defRPr sz="1875" b="0" i="0">
-                <a:solidFill>
-                  <a:srgbClr val="0A1F44"/>
-                </a:solidFill>
-                <a:latin typeface="Georgia"/>
-                <a:ea typeface="Georgia"/>
-                <a:cs typeface="Georgia"/>
-              </a:defRPr>
-            </a:pPr>
-            <a:r>
-              <a:rPr sz="1875" b="0" i="0">
-                <a:solidFill>
-                  <a:srgbClr val="0A1F44"/>
-                </a:solidFill>
-                <a:latin typeface="Georgia"/>
-                <a:ea typeface="Georgia"/>
-                <a:cs typeface="Georgia"/>
-              </a:rPr>
-              <a:t>₹1.5Cr</a:t>
-            </a:r>
-          </a:p>
-        </p:txBody>
-      </p:sp>
-      <p:sp>
-        <p:nvSpPr>
-          <p:cNvPr id="25" name="sensitivity-3-2">
-            <a:extLst xmlns:a="http://schemas.openxmlformats.org/drawingml/2006/main">
-              <a:ext uri="{FF2B5EF4-FFF2-40B4-BE49-F238E27FC236}">
-                <a16:creationId xmlns:a16="http://schemas.microsoft.com/office/drawing/2014/main" id="{B1AD8284-5A39-45D2-AED4-5E26E5BD16D8}"/>
-              </a:ext>
-            </a:extLst>
-          </p:cNvPr>
-          <p:cNvSpPr>
-            <a:spLocks xmlns:a="http://schemas.openxmlformats.org/drawingml/2006/main" noGrp="1"/>
-          </p:cNvSpPr>
-          <p:nvPr/>
-        </p:nvSpPr>
-        <p:spPr>
-          <a:xfrm xmlns:a="http://schemas.openxmlformats.org/drawingml/2006/main">
-            <a:off x="3429000" y="3810000"/>
-            <a:ext cx="1428750" cy="685800"/>
-          </a:xfrm>
-          <a:prstGeom xmlns:a="http://schemas.openxmlformats.org/drawingml/2006/main" prst="rect">
-            <a:avLst/>
-          </a:prstGeom>
-          <a:noFill xmlns:a="http://schemas.openxmlformats.org/drawingml/2006/main"/>
-          <a:ln xmlns:a="http://schemas.openxmlformats.org/drawingml/2006/main" w="0">
-            <a:noFill/>
-            <a:prstDash val="solid"/>
-          </a:ln>
-        </p:spPr>
-        <p:txBody>
-          <a:bodyPr xmlns:a="http://schemas.openxmlformats.org/drawingml/2006/main" wrap="square" lIns="95250" tIns="0" rIns="95250" bIns="0" anchor="ctr">
-            <a:noAutofit/>
-          </a:bodyPr>
-          <a:lstStyle xmlns:a="http://schemas.openxmlformats.org/drawingml/2006/main"/>
-          <a:p xmlns:a="http://schemas.openxmlformats.org/drawingml/2006/main">
-            <a:pPr algn="r">
-              <a:defRPr sz="1875" b="0" i="0">
-                <a:solidFill>
-                  <a:srgbClr val="0A1F44"/>
-                </a:solidFill>
-                <a:latin typeface="Georgia"/>
-                <a:ea typeface="Georgia"/>
-                <a:cs typeface="Georgia"/>
-              </a:defRPr>
-            </a:pPr>
-            <a:r>
-              <a:rPr sz="1875" b="0" i="0">
-                <a:solidFill>
-                  <a:srgbClr val="0A1F44"/>
-                </a:solidFill>
-                <a:latin typeface="Georgia"/>
-                <a:ea typeface="Georgia"/>
-                <a:cs typeface="Georgia"/>
-              </a:rPr>
-              <a:t>₹3Cr</a:t>
-            </a:r>
-          </a:p>
-        </p:txBody>
-      </p:sp>
-      <p:sp>
-        <p:nvSpPr>
-          <p:cNvPr id="26" name="sensitivity-3-3">
-            <a:extLst xmlns:a="http://schemas.openxmlformats.org/drawingml/2006/main">
-              <a:ext uri="{FF2B5EF4-FFF2-40B4-BE49-F238E27FC236}">
-                <a16:creationId xmlns:a16="http://schemas.microsoft.com/office/drawing/2014/main" id="{55C495F4-57BD-4FC0-99BB-110C3C6BF1F3}"/>
-              </a:ext>
-            </a:extLst>
-          </p:cNvPr>
-          <p:cNvSpPr>
-            <a:spLocks xmlns:a="http://schemas.openxmlformats.org/drawingml/2006/main" noGrp="1"/>
-          </p:cNvSpPr>
-          <p:nvPr/>
-        </p:nvSpPr>
-        <p:spPr>
-          <a:xfrm xmlns:a="http://schemas.openxmlformats.org/drawingml/2006/main">
-            <a:off x="4857750" y="3810000"/>
-            <a:ext cx="1428750" cy="685800"/>
-          </a:xfrm>
-          <a:prstGeom xmlns:a="http://schemas.openxmlformats.org/drawingml/2006/main" prst="rect">
-            <a:avLst/>
-          </a:prstGeom>
-          <a:noFill xmlns:a="http://schemas.openxmlformats.org/drawingml/2006/main"/>
-          <a:ln xmlns:a="http://schemas.openxmlformats.org/drawingml/2006/main" w="0">
-            <a:noFill/>
-            <a:prstDash val="solid"/>
-          </a:ln>
-        </p:spPr>
-        <p:txBody>
-          <a:bodyPr xmlns:a="http://schemas.openxmlformats.org/drawingml/2006/main" wrap="square" lIns="95250" tIns="0" rIns="95250" bIns="0" anchor="ctr">
-            <a:noAutofit/>
-          </a:bodyPr>
-          <a:lstStyle xmlns:a="http://schemas.openxmlformats.org/drawingml/2006/main"/>
-          <a:p xmlns:a="http://schemas.openxmlformats.org/drawingml/2006/main">
-            <a:pPr algn="r">
-              <a:defRPr sz="1875" b="0" i="0">
-                <a:solidFill>
-                  <a:srgbClr val="0A1F44"/>
-                </a:solidFill>
-                <a:latin typeface="Georgia"/>
-                <a:ea typeface="Georgia"/>
-                <a:cs typeface="Georgia"/>
-              </a:defRPr>
-            </a:pPr>
-            <a:r>
-              <a:rPr sz="1875" b="0" i="0">
-                <a:solidFill>
-                  <a:srgbClr val="0A1F44"/>
-                </a:solidFill>
-                <a:latin typeface="Georgia"/>
-                <a:ea typeface="Georgia"/>
-                <a:cs typeface="Georgia"/>
-              </a:rPr>
               <a:t>₹6Cr</a:t>
             </a:r>
           </a:p>
@@ -9531,10 +9417,10 @@
       </p:sp>
       <p:sp>
         <p:nvSpPr>
-          <p:cNvPr id="27" name="sensitivity-divider">
-            <a:extLst xmlns:a="http://schemas.openxmlformats.org/drawingml/2006/main">
-              <a:ext uri="{FF2B5EF4-FFF2-40B4-BE49-F238E27FC236}">
-                <a16:creationId xmlns:a16="http://schemas.microsoft.com/office/drawing/2014/main" id="{10AADC35-C4AF-4875-A978-F402207878A0}"/>
+          <p:cNvPr id="19" name="sensitivity-divider">
+            <a:extLst xmlns:a="http://schemas.openxmlformats.org/drawingml/2006/main">
+              <a:ext uri="{FF2B5EF4-FFF2-40B4-BE49-F238E27FC236}">
+                <a16:creationId xmlns:a16="http://schemas.microsoft.com/office/drawing/2014/main" id="{CF4DAC7F-0BC4-466D-BAC8-A1CD15E353EF}"/>
               </a:ext>
             </a:extLst>
           </p:cNvPr>
@@ -9562,10 +9448,10 @@
       </p:sp>
       <p:sp>
         <p:nvSpPr>
-          <p:cNvPr id="28" name="sensitivity-gates">
-            <a:extLst xmlns:a="http://schemas.openxmlformats.org/drawingml/2006/main">
-              <a:ext uri="{FF2B5EF4-FFF2-40B4-BE49-F238E27FC236}">
-                <a16:creationId xmlns:a16="http://schemas.microsoft.com/office/drawing/2014/main" id="{63EBEF9A-9F73-4A05-8A82-B1653B43C239}"/>
+          <p:cNvPr id="20" name="sensitivity-gates">
+            <a:extLst xmlns:a="http://schemas.openxmlformats.org/drawingml/2006/main">
+              <a:ext uri="{FF2B5EF4-FFF2-40B4-BE49-F238E27FC236}">
+                <a16:creationId xmlns:a16="http://schemas.microsoft.com/office/drawing/2014/main" id="{3BB6BCF6-A353-43FC-A910-133DC9FE0CB9}"/>
               </a:ext>
             </a:extLst>
           </p:cNvPr>
@@ -9577,7 +9463,7 @@
         <p:spPr>
           <a:xfrm xmlns:a="http://schemas.openxmlformats.org/drawingml/2006/main">
             <a:off x="7296150" y="1809750"/>
-            <a:ext cx="4000500" cy="1676400"/>
+            <a:ext cx="4000500" cy="1333500"/>
           </a:xfrm>
           <a:prstGeom xmlns:a="http://schemas.openxmlformats.org/drawingml/2006/main" prst="rect">
             <a:avLst/>
@@ -9595,7 +9481,7 @@
           <a:lstStyle xmlns:a="http://schemas.openxmlformats.org/drawingml/2006/main"/>
           <a:p xmlns:a="http://schemas.openxmlformats.org/drawingml/2006/main">
             <a:pPr algn="l">
-              <a:defRPr sz="2100" b="0" i="0">
+              <a:defRPr sz="1800" b="0" i="0">
                 <a:solidFill>
                   <a:srgbClr val="0A1F44"/>
                 </a:solidFill>
@@ -9605,7 +9491,7 @@
               </a:defRPr>
             </a:pPr>
             <a:r>
-              <a:rPr sz="2100" b="0" i="0">
+              <a:rPr sz="1800" b="0" i="0">
                 <a:solidFill>
                   <a:srgbClr val="0A1F44"/>
                 </a:solidFill>
@@ -9613,29 +9499,29 @@
                 <a:ea typeface="Georgia"/>
                 <a:cs typeface="Georgia"/>
               </a:rPr>
-              <a:t>Gates · buyer · bundling · legal · paid test · support economics</a:t>
-            </a:r>
-          </a:p>
-        </p:txBody>
-      </p:sp>
-      <p:sp>
-        <p:nvSpPr>
-          <p:cNvPr id="29" name="sensitivity-disclaimer">
-            <a:extLst xmlns:a="http://schemas.openxmlformats.org/drawingml/2006/main">
-              <a:ext uri="{FF2B5EF4-FFF2-40B4-BE49-F238E27FC236}">
-                <a16:creationId xmlns:a16="http://schemas.microsoft.com/office/drawing/2014/main" id="{9934691C-A3F8-4788-B71B-73ED728764F3}"/>
-              </a:ext>
-            </a:extLst>
-          </p:cNvPr>
-          <p:cNvSpPr>
-            <a:spLocks xmlns:a="http://schemas.openxmlformats.org/drawingml/2006/main" noGrp="1"/>
-          </p:cNvSpPr>
-          <p:nvPr/>
-        </p:nvSpPr>
-        <p:spPr>
-          <a:xfrm xmlns:a="http://schemas.openxmlformats.org/drawingml/2006/main">
-            <a:off x="7296150" y="4000500"/>
-            <a:ext cx="4000500" cy="990600"/>
+              <a:t>Unproven gates: buyer, bundling risk, legal perimeter, paid test, support economics</a:t>
+            </a:r>
+          </a:p>
+        </p:txBody>
+      </p:sp>
+      <p:sp>
+        <p:nvSpPr>
+          <p:cNvPr id="21" name="footer-sensitivity-hypothesis-label">
+            <a:extLst xmlns:a="http://schemas.openxmlformats.org/drawingml/2006/main">
+              <a:ext uri="{FF2B5EF4-FFF2-40B4-BE49-F238E27FC236}">
+                <a16:creationId xmlns:a16="http://schemas.microsoft.com/office/drawing/2014/main" id="{9865058F-1B48-40F9-A362-F1D0E119FFD4}"/>
+              </a:ext>
+            </a:extLst>
+          </p:cNvPr>
+          <p:cNvSpPr>
+            <a:spLocks xmlns:a="http://schemas.openxmlformats.org/drawingml/2006/main" noGrp="1"/>
+          </p:cNvSpPr>
+          <p:nvPr/>
+        </p:nvSpPr>
+        <p:spPr>
+          <a:xfrm xmlns:a="http://schemas.openxmlformats.org/drawingml/2006/main">
+            <a:off x="7296150" y="3276600"/>
+            <a:ext cx="4000500" cy="190500"/>
           </a:xfrm>
           <a:prstGeom xmlns:a="http://schemas.openxmlformats.org/drawingml/2006/main" prst="rect">
             <a:avLst/>
@@ -9653,9 +9539,125 @@
           <a:lstStyle xmlns:a="http://schemas.openxmlformats.org/drawingml/2006/main"/>
           <a:p xmlns:a="http://schemas.openxmlformats.org/drawingml/2006/main">
             <a:pPr algn="l">
-              <a:defRPr sz="1725" b="0" i="0">
+              <a:defRPr sz="1050" b="1" i="0">
                 <a:solidFill>
                   <a:srgbClr val="96491A"/>
+                </a:solidFill>
+                <a:latin typeface="Courier New"/>
+                <a:ea typeface="Courier New"/>
+                <a:cs typeface="Courier New"/>
+              </a:defRPr>
+            </a:pPr>
+            <a:r>
+              <a:rPr sz="1050" b="1" i="0">
+                <a:solidFill>
+                  <a:srgbClr val="96491A"/>
+                </a:solidFill>
+                <a:latin typeface="Courier New"/>
+                <a:ea typeface="Courier New"/>
+                <a:cs typeface="Courier New"/>
+              </a:rPr>
+              <a:t>HYPOTHESIS</a:t>
+            </a:r>
+          </a:p>
+        </p:txBody>
+      </p:sp>
+      <p:sp>
+        <p:nvSpPr>
+          <p:cNvPr id="22" name="sensitivity-hypothesis">
+            <a:extLst xmlns:a="http://schemas.openxmlformats.org/drawingml/2006/main">
+              <a:ext uri="{FF2B5EF4-FFF2-40B4-BE49-F238E27FC236}">
+                <a16:creationId xmlns:a16="http://schemas.microsoft.com/office/drawing/2014/main" id="{1EB80EAB-4895-4B18-B75B-182E6F8F1A1E}"/>
+              </a:ext>
+            </a:extLst>
+          </p:cNvPr>
+          <p:cNvSpPr>
+            <a:spLocks xmlns:a="http://schemas.openxmlformats.org/drawingml/2006/main" noGrp="1"/>
+          </p:cNvSpPr>
+          <p:nvPr/>
+        </p:nvSpPr>
+        <p:spPr>
+          <a:xfrm xmlns:a="http://schemas.openxmlformats.org/drawingml/2006/main">
+            <a:off x="7296150" y="3505200"/>
+            <a:ext cx="4000500" cy="1047750"/>
+          </a:xfrm>
+          <a:prstGeom xmlns:a="http://schemas.openxmlformats.org/drawingml/2006/main" prst="rect">
+            <a:avLst/>
+          </a:prstGeom>
+          <a:noFill xmlns:a="http://schemas.openxmlformats.org/drawingml/2006/main"/>
+          <a:ln xmlns:a="http://schemas.openxmlformats.org/drawingml/2006/main" w="0">
+            <a:noFill/>
+            <a:prstDash val="solid"/>
+          </a:ln>
+        </p:spPr>
+        <p:txBody>
+          <a:bodyPr xmlns:a="http://schemas.openxmlformats.org/drawingml/2006/main" wrap="square" lIns="0" tIns="0" rIns="0" bIns="0" anchor="t">
+            <a:noAutofit/>
+          </a:bodyPr>
+          <a:lstStyle xmlns:a="http://schemas.openxmlformats.org/drawingml/2006/main"/>
+          <a:p xmlns:a="http://schemas.openxmlformats.org/drawingml/2006/main">
+            <a:pPr algn="l">
+              <a:defRPr sz="1650" b="0" i="1">
+                <a:solidFill>
+                  <a:srgbClr val="96491A"/>
+                </a:solidFill>
+                <a:latin typeface="Arial"/>
+                <a:ea typeface="Arial"/>
+                <a:cs typeface="Arial"/>
+              </a:defRPr>
+            </a:pPr>
+            <a:r>
+              <a:rPr sz="1650" b="0" i="1">
+                <a:solidFill>
+                  <a:srgbClr val="96491A"/>
+                </a:solidFill>
+                <a:latin typeface="Arial"/>
+                <a:ea typeface="Arial"/>
+                <a:cs typeface="Arial"/>
+              </a:rPr>
+              <a:t>If the wedge locks: the same evidence substrate extends to adjacent regulated-reporting workflows (hypothesis)</a:t>
+            </a:r>
+          </a:p>
+        </p:txBody>
+      </p:sp>
+      <p:sp>
+        <p:nvSpPr>
+          <p:cNvPr id="23" name="sensitivity-disclaimer">
+            <a:extLst xmlns:a="http://schemas.openxmlformats.org/drawingml/2006/main">
+              <a:ext uri="{FF2B5EF4-FFF2-40B4-BE49-F238E27FC236}">
+                <a16:creationId xmlns:a16="http://schemas.microsoft.com/office/drawing/2014/main" id="{D55F80FB-01D6-439B-BF1B-4D7F8396674B}"/>
+              </a:ext>
+            </a:extLst>
+          </p:cNvPr>
+          <p:cNvSpPr>
+            <a:spLocks xmlns:a="http://schemas.openxmlformats.org/drawingml/2006/main" noGrp="1"/>
+          </p:cNvSpPr>
+          <p:nvPr/>
+        </p:nvSpPr>
+        <p:spPr>
+          <a:xfrm xmlns:a="http://schemas.openxmlformats.org/drawingml/2006/main">
+            <a:off x="7296150" y="4705350"/>
+            <a:ext cx="4000500" cy="419100"/>
+          </a:xfrm>
+          <a:prstGeom xmlns:a="http://schemas.openxmlformats.org/drawingml/2006/main" prst="rect">
+            <a:avLst/>
+          </a:prstGeom>
+          <a:noFill xmlns:a="http://schemas.openxmlformats.org/drawingml/2006/main"/>
+          <a:ln xmlns:a="http://schemas.openxmlformats.org/drawingml/2006/main" w="0">
+            <a:noFill/>
+            <a:prstDash val="solid"/>
+          </a:ln>
+        </p:spPr>
+        <p:txBody>
+          <a:bodyPr xmlns:a="http://schemas.openxmlformats.org/drawingml/2006/main" wrap="square" lIns="0" tIns="0" rIns="0" bIns="0" anchor="t">
+            <a:noAutofit/>
+          </a:bodyPr>
+          <a:lstStyle xmlns:a="http://schemas.openxmlformats.org/drawingml/2006/main"/>
+          <a:p xmlns:a="http://schemas.openxmlformats.org/drawingml/2006/main">
+            <a:pPr algn="l">
+              <a:defRPr sz="1650" b="0" i="0">
+                <a:solidFill>
+                  <a:srgbClr val="625B53"/>
                 </a:solidFill>
                 <a:latin typeface="Georgia"/>
                 <a:ea typeface="Georgia"/>
@@ -9663,15 +9665,15 @@
               </a:defRPr>
             </a:pPr>
             <a:r>
-              <a:rPr sz="1725" b="0" i="0">
-                <a:solidFill>
-                  <a:srgbClr val="96491A"/>
+              <a:rPr sz="1650" b="0" i="0">
+                <a:solidFill>
+                  <a:srgbClr val="625B53"/>
                 </a:solidFill>
                 <a:latin typeface="Georgia"/>
                 <a:ea typeface="Georgia"/>
                 <a:cs typeface="Georgia"/>
               </a:rPr>
-              <a:t>Not TAM, forecast or willingness-to-pay evidence.</a:t>
+              <a:t>Not TAM/WTP.</a:t>
             </a:r>
           </a:p>
         </p:txBody>
@@ -9679,7 +9681,7 @@
     </p:spTree>
     <p:extLst>
       <p:ext uri="{BB962C8B-B14F-4D97-AF65-F5344CB8AC3E}">
-        <p14:creationId xmlns:p14="http://schemas.microsoft.com/office/powerpoint/2010/main" val="775522909"/>
+        <p14:creationId xmlns:p14="http://schemas.microsoft.com/office/powerpoint/2010/main" val="1070236789"/>
       </p:ext>
     </p:extLst>
   </p:cSld>
@@ -9710,7 +9712,7 @@
           <p:cNvPr id="13" name="brand-9">
             <a:extLst xmlns:a="http://schemas.openxmlformats.org/drawingml/2006/main">
               <a:ext uri="{FF2B5EF4-FFF2-40B4-BE49-F238E27FC236}">
-                <a16:creationId xmlns:a16="http://schemas.microsoft.com/office/drawing/2014/main" id="{E36B6259-0D2B-4604-B5B4-FDD8C8C1B6B3}"/>
+                <a16:creationId xmlns:a16="http://schemas.microsoft.com/office/drawing/2014/main" id="{683148D7-0C21-4C22-BC7B-B168DFB1C4CE}"/>
               </a:ext>
             </a:extLst>
           </p:cNvPr>
@@ -9768,7 +9770,7 @@
           <p:cNvPr id="2" name="title-9">
             <a:extLst xmlns:a="http://schemas.openxmlformats.org/drawingml/2006/main">
               <a:ext uri="{FF2B5EF4-FFF2-40B4-BE49-F238E27FC236}">
-                <a16:creationId xmlns:a16="http://schemas.microsoft.com/office/drawing/2014/main" id="{BE7F8EE8-3B3B-49C6-8E57-5A00DF895D66}"/>
+                <a16:creationId xmlns:a16="http://schemas.microsoft.com/office/drawing/2014/main" id="{DEA4D588-C8F5-47B8-ACFA-9FA428E2E715}"/>
               </a:ext>
             </a:extLst>
           </p:cNvPr>
@@ -9816,7 +9818,7 @@
                 <a:ea typeface="Georgia"/>
                 <a:cs typeface="Georgia"/>
               </a:rPr>
-              <a:t>Equal contribution means equal accountability</a:t>
+              <a:t>One accountable founder. One defined finance lane.</a:t>
             </a:r>
           </a:p>
         </p:txBody>
@@ -9826,7 +9828,7 @@
           <p:cNvPr id="3" name="footer-rule-9">
             <a:extLst xmlns:a="http://schemas.openxmlformats.org/drawingml/2006/main">
               <a:ext uri="{FF2B5EF4-FFF2-40B4-BE49-F238E27FC236}">
-                <a16:creationId xmlns:a16="http://schemas.microsoft.com/office/drawing/2014/main" id="{47F58E57-CF83-424F-8067-6EB0F8F0A0C8}"/>
+                <a16:creationId xmlns:a16="http://schemas.microsoft.com/office/drawing/2014/main" id="{1EE0E0F8-544A-4C51-B83B-C82DD670D29E}"/>
               </a:ext>
             </a:extLst>
           </p:cNvPr>
@@ -9857,7 +9859,7 @@
           <p:cNvPr id="4" name="footer-source-9">
             <a:extLst xmlns:a="http://schemas.openxmlformats.org/drawingml/2006/main">
               <a:ext uri="{FF2B5EF4-FFF2-40B4-BE49-F238E27FC236}">
-                <a16:creationId xmlns:a16="http://schemas.microsoft.com/office/drawing/2014/main" id="{087D95ED-2961-462C-A688-70CB3C201A78}"/>
+                <a16:creationId xmlns:a16="http://schemas.microsoft.com/office/drawing/2014/main" id="{D68F26DC-D339-4410-BE96-D2DC9D66B696}"/>
               </a:ext>
             </a:extLst>
           </p:cNvPr>
@@ -9915,7 +9917,7 @@
           <p:cNvPr id="5" name="footer-page-9">
             <a:extLst xmlns:a="http://schemas.openxmlformats.org/drawingml/2006/main">
               <a:ext uri="{FF2B5EF4-FFF2-40B4-BE49-F238E27FC236}">
-                <a16:creationId xmlns:a16="http://schemas.microsoft.com/office/drawing/2014/main" id="{3AEC50CD-493D-4746-B7CB-80877A6FEA06}"/>
+                <a16:creationId xmlns:a16="http://schemas.microsoft.com/office/drawing/2014/main" id="{2628C3C1-6982-49CE-91EE-31867104A662}"/>
               </a:ext>
             </a:extLst>
           </p:cNvPr>
@@ -9973,7 +9975,7 @@
           <p:cNvPr id="6" name="ownership-divider">
             <a:extLst xmlns:a="http://schemas.openxmlformats.org/drawingml/2006/main">
               <a:ext uri="{FF2B5EF4-FFF2-40B4-BE49-F238E27FC236}">
-                <a16:creationId xmlns:a16="http://schemas.microsoft.com/office/drawing/2014/main" id="{CB821A66-D7EA-4842-8EE5-2A7429FE266A}"/>
+                <a16:creationId xmlns:a16="http://schemas.microsoft.com/office/drawing/2014/main" id="{77EA703D-79F4-4508-91EF-377D1B44E413}"/>
               </a:ext>
             </a:extLst>
           </p:cNvPr>
@@ -10004,7 +10006,7 @@
           <p:cNvPr id="7" name="ownership-ayush-label">
             <a:extLst xmlns:a="http://schemas.openxmlformats.org/drawingml/2006/main">
               <a:ext uri="{FF2B5EF4-FFF2-40B4-BE49-F238E27FC236}">
-                <a16:creationId xmlns:a16="http://schemas.microsoft.com/office/drawing/2014/main" id="{06BCE376-6265-4762-BF39-79C19EC2285C}"/>
+                <a16:creationId xmlns:a16="http://schemas.microsoft.com/office/drawing/2014/main" id="{ED27CB52-DD02-44B4-85D6-5BF2FFF251B1}"/>
               </a:ext>
             </a:extLst>
           </p:cNvPr>
@@ -10062,7 +10064,7 @@
           <p:cNvPr id="8" name="ownership-ayush-copy">
             <a:extLst xmlns:a="http://schemas.openxmlformats.org/drawingml/2006/main">
               <a:ext uri="{FF2B5EF4-FFF2-40B4-BE49-F238E27FC236}">
-                <a16:creationId xmlns:a16="http://schemas.microsoft.com/office/drawing/2014/main" id="{77ABF51A-3FFA-4505-B0A8-9EE9A7365A85}"/>
+                <a16:creationId xmlns:a16="http://schemas.microsoft.com/office/drawing/2014/main" id="{1C51E47D-D686-4AEE-8955-BBE4457FC4C9}"/>
               </a:ext>
             </a:extLst>
           </p:cNvPr>
@@ -10074,7 +10076,7 @@
         <p:spPr>
           <a:xfrm xmlns:a="http://schemas.openxmlformats.org/drawingml/2006/main">
             <a:off x="628650" y="2324100"/>
-            <a:ext cx="4762500" cy="1238250"/>
+            <a:ext cx="4762500" cy="2571750"/>
           </a:xfrm>
           <a:prstGeom xmlns:a="http://schemas.openxmlformats.org/drawingml/2006/main" prst="rect">
             <a:avLst/>
@@ -10092,7 +10094,7 @@
           <a:lstStyle xmlns:a="http://schemas.openxmlformats.org/drawingml/2006/main"/>
           <a:p xmlns:a="http://schemas.openxmlformats.org/drawingml/2006/main">
             <a:pPr algn="l">
-              <a:defRPr sz="2400" b="0" i="0">
+              <a:defRPr sz="2100" b="0" i="0">
                 <a:solidFill>
                   <a:srgbClr val="0A1F44"/>
                 </a:solidFill>
@@ -10102,7 +10104,7 @@
               </a:defRPr>
             </a:pPr>
             <a:r>
-              <a:rPr sz="2400" b="0" i="0">
+              <a:rPr sz="2100" b="0" i="0">
                 <a:solidFill>
                   <a:srgbClr val="0A1F44"/>
                 </a:solidFill>
@@ -10110,7 +10112,7 @@
                 <a:ea typeface="Georgia"/>
                 <a:cs typeface="Georgia"/>
               </a:rPr>
-              <a:t>Engineering, integration, test evidence and packaging.</a:t>
+              <a:t>Engineering, integration, test evidence, packaging. KRISEVA ships evidence-first, human-review procurement software in Indian defense today.</a:t>
             </a:r>
           </a:p>
         </p:txBody>
@@ -10120,7 +10122,7 @@
           <p:cNvPr id="9" name="ownership-finance-label">
             <a:extLst xmlns:a="http://schemas.openxmlformats.org/drawingml/2006/main">
               <a:ext uri="{FF2B5EF4-FFF2-40B4-BE49-F238E27FC236}">
-                <a16:creationId xmlns:a16="http://schemas.microsoft.com/office/drawing/2014/main" id="{900712E5-0DA4-4437-A9C7-523A551FAFB5}"/>
+                <a16:creationId xmlns:a16="http://schemas.microsoft.com/office/drawing/2014/main" id="{017232C9-F113-4C92-BACE-07D46F0CC57F}"/>
               </a:ext>
             </a:extLst>
           </p:cNvPr>
@@ -10168,7 +10170,7 @@
                 <a:ea typeface="Courier New"/>
                 <a:cs typeface="Courier New"/>
               </a:rPr>
-              <a:t>FINANCE &amp; BUSINESS ANALYSIS OWNER</a:t>
+              <a:t>FINANCE &amp; BUSINESS ANALYSIS LANE</a:t>
             </a:r>
           </a:p>
         </p:txBody>
@@ -10178,7 +10180,7 @@
           <p:cNvPr id="10" name="ownership-finance-copy">
             <a:extLst xmlns:a="http://schemas.openxmlformats.org/drawingml/2006/main">
               <a:ext uri="{FF2B5EF4-FFF2-40B4-BE49-F238E27FC236}">
-                <a16:creationId xmlns:a16="http://schemas.microsoft.com/office/drawing/2014/main" id="{296793A2-3B4E-48DB-9057-2A781B6B0346}"/>
+                <a16:creationId xmlns:a16="http://schemas.microsoft.com/office/drawing/2014/main" id="{BEB8A2E8-F9EF-4366-8542-09072E5A4891}"/>
               </a:ext>
             </a:extLst>
           </p:cNvPr>
@@ -10226,7 +10228,7 @@
                 <a:ea typeface="Georgia"/>
                 <a:cs typeface="Georgia"/>
               </a:rPr>
-              <a:t>Case consistency, buyer hypotheses, pricing research, workflow QA, pitch and demo contribution.</a:t>
+              <a:t>Case consistency, buyer hypotheses, pricing research, workflow QA.</a:t>
             </a:r>
           </a:p>
         </p:txBody>
@@ -10236,7 +10238,7 @@
           <p:cNvPr id="11" name="ownership-gate-band">
             <a:extLst xmlns:a="http://schemas.openxmlformats.org/drawingml/2006/main">
               <a:ext uri="{FF2B5EF4-FFF2-40B4-BE49-F238E27FC236}">
-                <a16:creationId xmlns:a16="http://schemas.microsoft.com/office/drawing/2014/main" id="{F8AE210E-05F8-4445-B8FA-8165B1A97E92}"/>
+                <a16:creationId xmlns:a16="http://schemas.microsoft.com/office/drawing/2014/main" id="{186EDFBF-F074-409C-AB02-41C48300E403}"/>
               </a:ext>
             </a:extLst>
           </p:cNvPr>
@@ -10269,7 +10271,7 @@
           <p:cNvPr id="12" name="ownership-gate">
             <a:extLst xmlns:a="http://schemas.openxmlformats.org/drawingml/2006/main">
               <a:ext uri="{FF2B5EF4-FFF2-40B4-BE49-F238E27FC236}">
-                <a16:creationId xmlns:a16="http://schemas.microsoft.com/office/drawing/2014/main" id="{A703625D-93BF-4763-B9AF-2E2E7002AF1A}"/>
+                <a16:creationId xmlns:a16="http://schemas.microsoft.com/office/drawing/2014/main" id="{CF523057-8482-422A-8536-EA34C4245B74}"/>
               </a:ext>
             </a:extLst>
           </p:cNvPr>
@@ -10325,7 +10327,7 @@
     </p:spTree>
     <p:extLst>
       <p:ext uri="{BB962C8B-B14F-4D97-AF65-F5344CB8AC3E}">
-        <p14:creationId xmlns:p14="http://schemas.microsoft.com/office/powerpoint/2010/main" val="2090938468"/>
+        <p14:creationId xmlns:p14="http://schemas.microsoft.com/office/powerpoint/2010/main" val="1978350242"/>
       </p:ext>
     </p:extLst>
   </p:cSld>

</xml_diff>

<commit_message>
release: seven-screen prototype with risk board, recorded live model run, eval harness, and repositioned narrative
</commit_message>
<xml_diff>
--- a/deck/KRISEVA_ATTEST_GIFT_2026.pptx
+++ b/deck/KRISEVA_ATTEST_GIFT_2026.pptx
@@ -2,22 +2,22 @@
 <file path=ppt/presentation.xml><?xml version="1.0" encoding="utf-8"?>
 <p:presentation xmlns:p="http://schemas.openxmlformats.org/presentationml/2006/main">
   <p:sldMasterIdLst>
-    <p:sldMasterId xmlns:r="http://schemas.openxmlformats.org/officeDocument/2006/relationships" id="2147483648" r:id="Rf40dc96fb1974dca"/>
+    <p:sldMasterId xmlns:r="http://schemas.openxmlformats.org/officeDocument/2006/relationships" id="2147483648" r:id="Rf3227bbac48c4fc8"/>
   </p:sldMasterIdLst>
   <p:notesMasterIdLst>
-    <p:notesMasterId xmlns:r="http://schemas.openxmlformats.org/officeDocument/2006/relationships" r:id="R63d7dc1d31234603"/>
+    <p:notesMasterId xmlns:r="http://schemas.openxmlformats.org/officeDocument/2006/relationships" r:id="Rb6fbf07064cb4d22"/>
   </p:notesMasterIdLst>
   <p:sldIdLst>
-    <p:sldId xmlns:r="http://schemas.openxmlformats.org/officeDocument/2006/relationships" id="256" r:id="Rb7046164e1314215"/>
-    <p:sldId xmlns:r="http://schemas.openxmlformats.org/officeDocument/2006/relationships" id="257" r:id="R9af5731eb2fa45ae"/>
-    <p:sldId xmlns:r="http://schemas.openxmlformats.org/officeDocument/2006/relationships" id="258" r:id="R3c44464c7ad44e10"/>
-    <p:sldId xmlns:r="http://schemas.openxmlformats.org/officeDocument/2006/relationships" id="259" r:id="R7d2cede707694b53"/>
-    <p:sldId xmlns:r="http://schemas.openxmlformats.org/officeDocument/2006/relationships" id="260" r:id="R06f661682921437c"/>
-    <p:sldId xmlns:r="http://schemas.openxmlformats.org/officeDocument/2006/relationships" id="261" r:id="R3862e6feb7d24ef6"/>
-    <p:sldId xmlns:r="http://schemas.openxmlformats.org/officeDocument/2006/relationships" id="262" r:id="R3fda92ac727a4ad8"/>
-    <p:sldId xmlns:r="http://schemas.openxmlformats.org/officeDocument/2006/relationships" id="263" r:id="Rf2eef61a22394ab3"/>
-    <p:sldId xmlns:r="http://schemas.openxmlformats.org/officeDocument/2006/relationships" id="264" r:id="R91033edbf0f449f4"/>
-    <p:sldId xmlns:r="http://schemas.openxmlformats.org/officeDocument/2006/relationships" id="265" r:id="Rf5a73399916f4069"/>
+    <p:sldId xmlns:r="http://schemas.openxmlformats.org/officeDocument/2006/relationships" id="256" r:id="R96266747072f41e6"/>
+    <p:sldId xmlns:r="http://schemas.openxmlformats.org/officeDocument/2006/relationships" id="257" r:id="R158506ae99c8497e"/>
+    <p:sldId xmlns:r="http://schemas.openxmlformats.org/officeDocument/2006/relationships" id="258" r:id="Re9a0b82851bf4788"/>
+    <p:sldId xmlns:r="http://schemas.openxmlformats.org/officeDocument/2006/relationships" id="259" r:id="Rcf72f3a179fb49a5"/>
+    <p:sldId xmlns:r="http://schemas.openxmlformats.org/officeDocument/2006/relationships" id="260" r:id="R4dde3d9cfa5d4745"/>
+    <p:sldId xmlns:r="http://schemas.openxmlformats.org/officeDocument/2006/relationships" id="261" r:id="Rb7963c4aed304f86"/>
+    <p:sldId xmlns:r="http://schemas.openxmlformats.org/officeDocument/2006/relationships" id="262" r:id="R5338240f51d04577"/>
+    <p:sldId xmlns:r="http://schemas.openxmlformats.org/officeDocument/2006/relationships" id="263" r:id="R98aec4958a1e4252"/>
+    <p:sldId xmlns:r="http://schemas.openxmlformats.org/officeDocument/2006/relationships" id="264" r:id="R302ad8efb92540ab"/>
+    <p:sldId xmlns:r="http://schemas.openxmlformats.org/officeDocument/2006/relationships" id="265" r:id="Rb83628f4ef794bb2"/>
   </p:sldIdLst>
   <p:sldSz cx="12192000" cy="6858000"/>
   <p:notesSz cx="6858000" cy="9144000"/>
@@ -1339,7 +1339,7 @@
   </p:cSld>
   <p:clrMap bg1="lt1" tx1="dk1" bg2="lt2" tx2="dk2" accent1="accent1" accent2="accent2" accent3="accent3" accent4="accent4" accent5="accent5" accent6="accent6" hlink="hlink" folHlink="folHlink"/>
   <p:sldLayoutIdLst>
-    <p:sldLayoutId xmlns:r="http://schemas.openxmlformats.org/officeDocument/2006/relationships" id="2147483649" r:id="R630a6026818646a8"/>
+    <p:sldLayoutId xmlns:r="http://schemas.openxmlformats.org/officeDocument/2006/relationships" id="2147483649" r:id="Rc2fa58d1cd0a409a"/>
   </p:sldLayoutIdLst>
   <p:txStyles>
     <p:titleStyle>
@@ -1890,7 +1890,7 @@
           <p:cNvPr id="13" name="cover-navy-field">
             <a:extLst xmlns:a="http://schemas.openxmlformats.org/drawingml/2006/main">
               <a:ext uri="{FF2B5EF4-FFF2-40B4-BE49-F238E27FC236}">
-                <a16:creationId xmlns:a16="http://schemas.microsoft.com/office/drawing/2014/main" id="{3DFFFE68-60BB-41B9-BE64-960898E67BF7}"/>
+                <a16:creationId xmlns:a16="http://schemas.microsoft.com/office/drawing/2014/main" id="{ECAE0C58-9A95-4EB7-B6E3-A66CC1B9153C}"/>
               </a:ext>
             </a:extLst>
           </p:cNvPr>
@@ -1923,7 +1923,7 @@
           <p:cNvPr id="2" name="cover-brass-spine">
             <a:extLst xmlns:a="http://schemas.openxmlformats.org/drawingml/2006/main">
               <a:ext uri="{FF2B5EF4-FFF2-40B4-BE49-F238E27FC236}">
-                <a16:creationId xmlns:a16="http://schemas.microsoft.com/office/drawing/2014/main" id="{E55130A6-3BB6-4D46-84FB-30861AF90CF3}"/>
+                <a16:creationId xmlns:a16="http://schemas.microsoft.com/office/drawing/2014/main" id="{E66CE90F-0747-4694-9429-06737F47138D}"/>
               </a:ext>
             </a:extLst>
           </p:cNvPr>
@@ -1954,7 +1954,7 @@
           <p:cNvPr id="3" name="brand-1">
             <a:extLst xmlns:a="http://schemas.openxmlformats.org/drawingml/2006/main">
               <a:ext uri="{FF2B5EF4-FFF2-40B4-BE49-F238E27FC236}">
-                <a16:creationId xmlns:a16="http://schemas.microsoft.com/office/drawing/2014/main" id="{96B3175D-F454-4824-9823-C95B4857A619}"/>
+                <a16:creationId xmlns:a16="http://schemas.microsoft.com/office/drawing/2014/main" id="{9A15F9E1-8C37-42B8-9728-A7784F51484C}"/>
               </a:ext>
             </a:extLst>
           </p:cNvPr>
@@ -2012,7 +2012,7 @@
           <p:cNvPr id="4" name="cover-title">
             <a:extLst xmlns:a="http://schemas.openxmlformats.org/drawingml/2006/main">
               <a:ext uri="{FF2B5EF4-FFF2-40B4-BE49-F238E27FC236}">
-                <a16:creationId xmlns:a16="http://schemas.microsoft.com/office/drawing/2014/main" id="{629F1F21-57FE-4C4B-BFFC-90607D40BD2D}"/>
+                <a16:creationId xmlns:a16="http://schemas.microsoft.com/office/drawing/2014/main" id="{77EEC7EA-4F5C-4813-988B-9D497B229813}"/>
               </a:ext>
             </a:extLst>
           </p:cNvPr>
@@ -2070,7 +2070,7 @@
           <p:cNvPr id="5" name="cover-subtitle">
             <a:extLst xmlns:a="http://schemas.openxmlformats.org/drawingml/2006/main">
               <a:ext uri="{FF2B5EF4-FFF2-40B4-BE49-F238E27FC236}">
-                <a16:creationId xmlns:a16="http://schemas.microsoft.com/office/drawing/2014/main" id="{B75C82B7-83E0-4006-9ABB-6B7CF9BB6535}"/>
+                <a16:creationId xmlns:a16="http://schemas.microsoft.com/office/drawing/2014/main" id="{840A6919-D0B0-484A-BADA-2FE33436A328}"/>
               </a:ext>
             </a:extLst>
           </p:cNvPr>
@@ -2118,7 +2118,7 @@
                 <a:ea typeface="Georgia"/>
                 <a:cs typeface="Georgia"/>
               </a:rPr>
-              <a:t>A bounded source-to-field evidence workbench for human review.</a:t>
+              <a:t>An entity-side evidence-integrity and human-accountability layer for AI-assisted regulatory reporting in GIFT IFSC.</a:t>
             </a:r>
           </a:p>
         </p:txBody>
@@ -2128,7 +2128,7 @@
           <p:cNvPr id="6" name="cover-rule">
             <a:extLst xmlns:a="http://schemas.openxmlformats.org/drawingml/2006/main">
               <a:ext uri="{FF2B5EF4-FFF2-40B4-BE49-F238E27FC236}">
-                <a16:creationId xmlns:a16="http://schemas.microsoft.com/office/drawing/2014/main" id="{C5A9E9F7-4908-4691-964B-DB1166ED0F9F}"/>
+                <a16:creationId xmlns:a16="http://schemas.microsoft.com/office/drawing/2014/main" id="{FE1C2740-C63A-4AE6-9BFD-61A97DF35145}"/>
               </a:ext>
             </a:extLst>
           </p:cNvPr>
@@ -2159,7 +2159,7 @@
           <p:cNvPr id="7" name="cover-lock">
             <a:extLst xmlns:a="http://schemas.openxmlformats.org/drawingml/2006/main">
               <a:ext uri="{FF2B5EF4-FFF2-40B4-BE49-F238E27FC236}">
-                <a16:creationId xmlns:a16="http://schemas.microsoft.com/office/drawing/2014/main" id="{D5003CB8-9377-4033-86B7-AEDBE42E2C19}"/>
+                <a16:creationId xmlns:a16="http://schemas.microsoft.com/office/drawing/2014/main" id="{851A4A76-B55D-4814-86B6-007D7D791674}"/>
               </a:ext>
             </a:extLst>
           </p:cNvPr>
@@ -2217,7 +2217,7 @@
           <p:cNvPr id="8" name="cover-boundary">
             <a:extLst xmlns:a="http://schemas.openxmlformats.org/drawingml/2006/main">
               <a:ext uri="{FF2B5EF4-FFF2-40B4-BE49-F238E27FC236}">
-                <a16:creationId xmlns:a16="http://schemas.microsoft.com/office/drawing/2014/main" id="{2FCC3A0E-8F1E-46D5-8CE1-53E4ED040CB2}"/>
+                <a16:creationId xmlns:a16="http://schemas.microsoft.com/office/drawing/2014/main" id="{D7C227E2-EFCF-4EC6-A9D0-99445C32A1F0}"/>
               </a:ext>
             </a:extLst>
           </p:cNvPr>
@@ -2275,7 +2275,7 @@
           <p:cNvPr id="9" name="cover-number">
             <a:extLst xmlns:a="http://schemas.openxmlformats.org/drawingml/2006/main">
               <a:ext uri="{FF2B5EF4-FFF2-40B4-BE49-F238E27FC236}">
-                <a16:creationId xmlns:a16="http://schemas.microsoft.com/office/drawing/2014/main" id="{A408687B-7836-4BCE-90BF-19981DCBFDAD}"/>
+                <a16:creationId xmlns:a16="http://schemas.microsoft.com/office/drawing/2014/main" id="{F86FF196-F22A-414C-8671-1DA18B5DFF04}"/>
               </a:ext>
             </a:extLst>
           </p:cNvPr>
@@ -2333,7 +2333,7 @@
           <p:cNvPr id="10" name="cover-classification">
             <a:extLst xmlns:a="http://schemas.openxmlformats.org/drawingml/2006/main">
               <a:ext uri="{FF2B5EF4-FFF2-40B4-BE49-F238E27FC236}">
-                <a16:creationId xmlns:a16="http://schemas.microsoft.com/office/drawing/2014/main" id="{26A6CB2C-7CDD-4FDF-A736-B0F5F457144D}"/>
+                <a16:creationId xmlns:a16="http://schemas.microsoft.com/office/drawing/2014/main" id="{2B4B381D-AD8B-42FD-89E0-0C619081768B}"/>
               </a:ext>
             </a:extLst>
           </p:cNvPr>
@@ -2437,7 +2437,7 @@
           <p:cNvPr id="11" name="cover-page">
             <a:extLst xmlns:a="http://schemas.openxmlformats.org/drawingml/2006/main">
               <a:ext uri="{FF2B5EF4-FFF2-40B4-BE49-F238E27FC236}">
-                <a16:creationId xmlns:a16="http://schemas.microsoft.com/office/drawing/2014/main" id="{B28B17C7-8F83-4DB6-93EC-DF0BD38D0049}"/>
+                <a16:creationId xmlns:a16="http://schemas.microsoft.com/office/drawing/2014/main" id="{EFE5A2BA-C557-46E1-847A-D15A205E46AE}"/>
               </a:ext>
             </a:extLst>
           </p:cNvPr>
@@ -2495,7 +2495,7 @@
           <p:cNvPr id="12" name="footer-cover-url">
             <a:extLst xmlns:a="http://schemas.openxmlformats.org/drawingml/2006/main">
               <a:ext uri="{FF2B5EF4-FFF2-40B4-BE49-F238E27FC236}">
-                <a16:creationId xmlns:a16="http://schemas.microsoft.com/office/drawing/2014/main" id="{32BA6995-55CA-4794-B654-19B0035C0632}"/>
+                <a16:creationId xmlns:a16="http://schemas.microsoft.com/office/drawing/2014/main" id="{80AD3597-C50B-43DA-9319-82D2338566D9}"/>
               </a:ext>
             </a:extLst>
           </p:cNvPr>
@@ -2574,7 +2574,7 @@
     </p:spTree>
     <p:extLst>
       <p:ext uri="{BB962C8B-B14F-4D97-AF65-F5344CB8AC3E}">
-        <p14:creationId xmlns:p14="http://schemas.microsoft.com/office/powerpoint/2010/main" val="1053460075"/>
+        <p14:creationId xmlns:p14="http://schemas.microsoft.com/office/powerpoint/2010/main" val="1820702860"/>
       </p:ext>
     </p:extLst>
   </p:cSld>
@@ -2605,7 +2605,7 @@
           <p:cNvPr id="17" name="brand-10">
             <a:extLst xmlns:a="http://schemas.openxmlformats.org/drawingml/2006/main">
               <a:ext uri="{FF2B5EF4-FFF2-40B4-BE49-F238E27FC236}">
-                <a16:creationId xmlns:a16="http://schemas.microsoft.com/office/drawing/2014/main" id="{AAD1F7C2-91D6-4475-986C-841A8EE20AC2}"/>
+                <a16:creationId xmlns:a16="http://schemas.microsoft.com/office/drawing/2014/main" id="{75C87787-6BFC-4044-AEF7-911F4561689B}"/>
               </a:ext>
             </a:extLst>
           </p:cNvPr>
@@ -2663,7 +2663,7 @@
           <p:cNvPr id="2" name="title-10">
             <a:extLst xmlns:a="http://schemas.openxmlformats.org/drawingml/2006/main">
               <a:ext uri="{FF2B5EF4-FFF2-40B4-BE49-F238E27FC236}">
-                <a16:creationId xmlns:a16="http://schemas.microsoft.com/office/drawing/2014/main" id="{CE2F133C-3CF2-41C9-B537-C0A49A0A87C2}"/>
+                <a16:creationId xmlns:a16="http://schemas.microsoft.com/office/drawing/2014/main" id="{7FE1D891-C371-4152-BCFF-D57FD026A902}"/>
               </a:ext>
             </a:extLst>
           </p:cNvPr>
@@ -2721,7 +2721,7 @@
           <p:cNvPr id="3" name="footer-rule-10">
             <a:extLst xmlns:a="http://schemas.openxmlformats.org/drawingml/2006/main">
               <a:ext uri="{FF2B5EF4-FFF2-40B4-BE49-F238E27FC236}">
-                <a16:creationId xmlns:a16="http://schemas.microsoft.com/office/drawing/2014/main" id="{7EE465FC-C262-4BD9-90DE-8F9F299D0EDD}"/>
+                <a16:creationId xmlns:a16="http://schemas.microsoft.com/office/drawing/2014/main" id="{B4F6C2AC-13D9-4B82-B744-8ED03548A611}"/>
               </a:ext>
             </a:extLst>
           </p:cNvPr>
@@ -2752,7 +2752,7 @@
           <p:cNvPr id="4" name="footer-source-10">
             <a:extLst xmlns:a="http://schemas.openxmlformats.org/drawingml/2006/main">
               <a:ext uri="{FF2B5EF4-FFF2-40B4-BE49-F238E27FC236}">
-                <a16:creationId xmlns:a16="http://schemas.microsoft.com/office/drawing/2014/main" id="{6262026B-BB35-4D94-B17E-C8718B0A26C8}"/>
+                <a16:creationId xmlns:a16="http://schemas.microsoft.com/office/drawing/2014/main" id="{918458B9-CFC0-4AE2-AD85-E15AC8E67EA0}"/>
               </a:ext>
             </a:extLst>
           </p:cNvPr>
@@ -2810,7 +2810,7 @@
           <p:cNvPr id="5" name="footer-page-10">
             <a:extLst xmlns:a="http://schemas.openxmlformats.org/drawingml/2006/main">
               <a:ext uri="{FF2B5EF4-FFF2-40B4-BE49-F238E27FC236}">
-                <a16:creationId xmlns:a16="http://schemas.microsoft.com/office/drawing/2014/main" id="{56E8F212-47E3-4F9B-9AD8-B9BD1628956B}"/>
+                <a16:creationId xmlns:a16="http://schemas.microsoft.com/office/drawing/2014/main" id="{6EC571A5-91C1-4FE8-B18D-CDD64C076D2B}"/>
               </a:ext>
             </a:extLst>
           </p:cNvPr>
@@ -2868,7 +2868,7 @@
           <p:cNvPr id="6" name="ask-spine">
             <a:extLst xmlns:a="http://schemas.openxmlformats.org/drawingml/2006/main">
               <a:ext uri="{FF2B5EF4-FFF2-40B4-BE49-F238E27FC236}">
-                <a16:creationId xmlns:a16="http://schemas.microsoft.com/office/drawing/2014/main" id="{8F13CC76-23C7-42A9-B699-B2273FC3318D}"/>
+                <a16:creationId xmlns:a16="http://schemas.microsoft.com/office/drawing/2014/main" id="{37791D56-050D-4A78-B0C1-EFBCDFD432A9}"/>
               </a:ext>
             </a:extLst>
           </p:cNvPr>
@@ -2899,7 +2899,7 @@
           <p:cNvPr id="7" name="ask-access-label">
             <a:extLst xmlns:a="http://schemas.openxmlformats.org/drawingml/2006/main">
               <a:ext uri="{FF2B5EF4-FFF2-40B4-BE49-F238E27FC236}">
-                <a16:creationId xmlns:a16="http://schemas.microsoft.com/office/drawing/2014/main" id="{E51CF449-4ED9-40F4-871D-CCAE09E45642}"/>
+                <a16:creationId xmlns:a16="http://schemas.microsoft.com/office/drawing/2014/main" id="{D86F18A2-56E1-47A2-9E5C-B26DD524414B}"/>
               </a:ext>
             </a:extLst>
           </p:cNvPr>
@@ -2957,7 +2957,7 @@
           <p:cNvPr id="8" name="ask-access-copy">
             <a:extLst xmlns:a="http://schemas.openxmlformats.org/drawingml/2006/main">
               <a:ext uri="{FF2B5EF4-FFF2-40B4-BE49-F238E27FC236}">
-                <a16:creationId xmlns:a16="http://schemas.microsoft.com/office/drawing/2014/main" id="{BE7CBC18-9AD5-4105-A379-C8F44114B7AB}"/>
+                <a16:creationId xmlns:a16="http://schemas.microsoft.com/office/drawing/2014/main" id="{AAC6FC8B-75A6-454A-AF69-068FA62D9F1D}"/>
               </a:ext>
             </a:extLst>
           </p:cNvPr>
@@ -3015,7 +3015,7 @@
           <p:cNvPr id="9" name="ask-falsify">
             <a:extLst xmlns:a="http://schemas.openxmlformats.org/drawingml/2006/main">
               <a:ext uri="{FF2B5EF4-FFF2-40B4-BE49-F238E27FC236}">
-                <a16:creationId xmlns:a16="http://schemas.microsoft.com/office/drawing/2014/main" id="{E7F9FCD9-25AD-451E-B375-71BE85564BB2}"/>
+                <a16:creationId xmlns:a16="http://schemas.microsoft.com/office/drawing/2014/main" id="{53A0BCF6-E748-41C6-9A8D-EF52053B4FF5}"/>
               </a:ext>
             </a:extLst>
           </p:cNvPr>
@@ -3073,7 +3073,7 @@
           <p:cNvPr id="10" name="ask-challenge-label">
             <a:extLst xmlns:a="http://schemas.openxmlformats.org/drawingml/2006/main">
               <a:ext uri="{FF2B5EF4-FFF2-40B4-BE49-F238E27FC236}">
-                <a16:creationId xmlns:a16="http://schemas.microsoft.com/office/drawing/2014/main" id="{25B5AEFB-2E7C-4112-903B-09728E70B281}"/>
+                <a16:creationId xmlns:a16="http://schemas.microsoft.com/office/drawing/2014/main" id="{180F8B98-31AC-4E21-BA99-E41878A1CB8E}"/>
               </a:ext>
             </a:extLst>
           </p:cNvPr>
@@ -3131,7 +3131,7 @@
           <p:cNvPr id="11" name="ask-challenge-copy">
             <a:extLst xmlns:a="http://schemas.openxmlformats.org/drawingml/2006/main">
               <a:ext uri="{FF2B5EF4-FFF2-40B4-BE49-F238E27FC236}">
-                <a16:creationId xmlns:a16="http://schemas.microsoft.com/office/drawing/2014/main" id="{4E7E9FD8-06E9-4024-BD71-B38A03F19387}"/>
+                <a16:creationId xmlns:a16="http://schemas.microsoft.com/office/drawing/2014/main" id="{C49BA21A-ADD4-4C45-8B3A-C6629D3418B1}"/>
               </a:ext>
             </a:extLst>
           </p:cNvPr>
@@ -3189,7 +3189,7 @@
           <p:cNvPr id="12" name="ask-test-label">
             <a:extLst xmlns:a="http://schemas.openxmlformats.org/drawingml/2006/main">
               <a:ext uri="{FF2B5EF4-FFF2-40B4-BE49-F238E27FC236}">
-                <a16:creationId xmlns:a16="http://schemas.microsoft.com/office/drawing/2014/main" id="{D872DA96-4469-4F8C-BB48-90BD9C147977}"/>
+                <a16:creationId xmlns:a16="http://schemas.microsoft.com/office/drawing/2014/main" id="{280C98E4-6110-483B-AE43-33278D92AC55}"/>
               </a:ext>
             </a:extLst>
           </p:cNvPr>
@@ -3247,7 +3247,7 @@
           <p:cNvPr id="13" name="ask-test-copy">
             <a:extLst xmlns:a="http://schemas.openxmlformats.org/drawingml/2006/main">
               <a:ext uri="{FF2B5EF4-FFF2-40B4-BE49-F238E27FC236}">
-                <a16:creationId xmlns:a16="http://schemas.microsoft.com/office/drawing/2014/main" id="{89F0F8DF-70D7-402E-9F9C-E52074D49268}"/>
+                <a16:creationId xmlns:a16="http://schemas.microsoft.com/office/drawing/2014/main" id="{781EAB79-6BB6-4172-B1EA-6762125423C0}"/>
               </a:ext>
             </a:extLst>
           </p:cNvPr>
@@ -3305,7 +3305,7 @@
           <p:cNvPr id="14" name="ask-decide-label">
             <a:extLst xmlns:a="http://schemas.openxmlformats.org/drawingml/2006/main">
               <a:ext uri="{FF2B5EF4-FFF2-40B4-BE49-F238E27FC236}">
-                <a16:creationId xmlns:a16="http://schemas.microsoft.com/office/drawing/2014/main" id="{01B19575-A25D-4820-9636-3CC1C03AAF4C}"/>
+                <a16:creationId xmlns:a16="http://schemas.microsoft.com/office/drawing/2014/main" id="{7BFC0B19-6C69-4F0C-B80B-531A1037399A}"/>
               </a:ext>
             </a:extLst>
           </p:cNvPr>
@@ -3363,7 +3363,7 @@
           <p:cNvPr id="15" name="ask-decide-copy">
             <a:extLst xmlns:a="http://schemas.openxmlformats.org/drawingml/2006/main">
               <a:ext uri="{FF2B5EF4-FFF2-40B4-BE49-F238E27FC236}">
-                <a16:creationId xmlns:a16="http://schemas.microsoft.com/office/drawing/2014/main" id="{5B74DB67-B010-4430-8D37-72D7CC2D6E0D}"/>
+                <a16:creationId xmlns:a16="http://schemas.microsoft.com/office/drawing/2014/main" id="{D6584F64-58E5-492B-B147-BE42E04C1F5E}"/>
               </a:ext>
             </a:extLst>
           </p:cNvPr>
@@ -3421,7 +3421,7 @@
           <p:cNvPr id="16" name="footer-ask-links">
             <a:extLst xmlns:a="http://schemas.openxmlformats.org/drawingml/2006/main">
               <a:ext uri="{FF2B5EF4-FFF2-40B4-BE49-F238E27FC236}">
-                <a16:creationId xmlns:a16="http://schemas.microsoft.com/office/drawing/2014/main" id="{DA4CABDD-ABBD-4FA7-A03A-A51A99268C5F}"/>
+                <a16:creationId xmlns:a16="http://schemas.microsoft.com/office/drawing/2014/main" id="{1B15656D-B57F-49E5-8E19-3381C09B14DB}"/>
               </a:ext>
             </a:extLst>
           </p:cNvPr>
@@ -3477,7 +3477,7 @@
     </p:spTree>
     <p:extLst>
       <p:ext uri="{BB962C8B-B14F-4D97-AF65-F5344CB8AC3E}">
-        <p14:creationId xmlns:p14="http://schemas.microsoft.com/office/powerpoint/2010/main" val="150700677"/>
+        <p14:creationId xmlns:p14="http://schemas.microsoft.com/office/powerpoint/2010/main" val="338198850"/>
       </p:ext>
     </p:extLst>
   </p:cSld>
@@ -3508,7 +3508,7 @@
           <p:cNvPr id="18" name="brand-2">
             <a:extLst xmlns:a="http://schemas.openxmlformats.org/drawingml/2006/main">
               <a:ext uri="{FF2B5EF4-FFF2-40B4-BE49-F238E27FC236}">
-                <a16:creationId xmlns:a16="http://schemas.microsoft.com/office/drawing/2014/main" id="{C6759A71-4779-43EF-AB43-6356C191AC2C}"/>
+                <a16:creationId xmlns:a16="http://schemas.microsoft.com/office/drawing/2014/main" id="{483AD6F6-7ABF-4DAE-9973-FE574A3C7BE0}"/>
               </a:ext>
             </a:extLst>
           </p:cNvPr>
@@ -3566,7 +3566,7 @@
           <p:cNvPr id="2" name="title-2">
             <a:extLst xmlns:a="http://schemas.openxmlformats.org/drawingml/2006/main">
               <a:ext uri="{FF2B5EF4-FFF2-40B4-BE49-F238E27FC236}">
-                <a16:creationId xmlns:a16="http://schemas.microsoft.com/office/drawing/2014/main" id="{53DF900D-A260-4F54-83D0-527893B8B23E}"/>
+                <a16:creationId xmlns:a16="http://schemas.microsoft.com/office/drawing/2014/main" id="{F9D8DE36-8DA2-409E-A218-65AAD20C8CCD}"/>
               </a:ext>
             </a:extLst>
           </p:cNvPr>
@@ -3624,7 +3624,7 @@
           <p:cNvPr id="3" name="footer-rule-2">
             <a:extLst xmlns:a="http://schemas.openxmlformats.org/drawingml/2006/main">
               <a:ext uri="{FF2B5EF4-FFF2-40B4-BE49-F238E27FC236}">
-                <a16:creationId xmlns:a16="http://schemas.microsoft.com/office/drawing/2014/main" id="{1BB957D9-EDB4-41FC-8269-00E902FB96E0}"/>
+                <a16:creationId xmlns:a16="http://schemas.microsoft.com/office/drawing/2014/main" id="{2535721F-A868-449C-9649-290DE64C61E4}"/>
               </a:ext>
             </a:extLst>
           </p:cNvPr>
@@ -3655,7 +3655,7 @@
           <p:cNvPr id="4" name="footer-source-2">
             <a:extLst xmlns:a="http://schemas.openxmlformats.org/drawingml/2006/main">
               <a:ext uri="{FF2B5EF4-FFF2-40B4-BE49-F238E27FC236}">
-                <a16:creationId xmlns:a16="http://schemas.microsoft.com/office/drawing/2014/main" id="{19DF77C4-0EA4-44AE-90F8-9784F234162B}"/>
+                <a16:creationId xmlns:a16="http://schemas.microsoft.com/office/drawing/2014/main" id="{731B2884-1F18-484B-B508-BB6CE2708FF9}"/>
               </a:ext>
             </a:extLst>
           </p:cNvPr>
@@ -3713,7 +3713,7 @@
           <p:cNvPr id="5" name="footer-page-2">
             <a:extLst xmlns:a="http://schemas.openxmlformats.org/drawingml/2006/main">
               <a:ext uri="{FF2B5EF4-FFF2-40B4-BE49-F238E27FC236}">
-                <a16:creationId xmlns:a16="http://schemas.microsoft.com/office/drawing/2014/main" id="{EB8E1AF8-94DD-45D9-8FCF-D90C2CFE5FBA}"/>
+                <a16:creationId xmlns:a16="http://schemas.microsoft.com/office/drawing/2014/main" id="{FD982E19-D6DB-49B8-851B-620A4E58C8B1}"/>
               </a:ext>
             </a:extLst>
           </p:cNvPr>
@@ -3771,7 +3771,7 @@
           <p:cNvPr id="6" name="accountability-divider">
             <a:extLst xmlns:a="http://schemas.openxmlformats.org/drawingml/2006/main">
               <a:ext uri="{FF2B5EF4-FFF2-40B4-BE49-F238E27FC236}">
-                <a16:creationId xmlns:a16="http://schemas.microsoft.com/office/drawing/2014/main" id="{0254F7FF-A64F-45EF-917D-1334E810FF83}"/>
+                <a16:creationId xmlns:a16="http://schemas.microsoft.com/office/drawing/2014/main" id="{DB296407-80E9-4F9E-A0E0-FE1E032F39D8}"/>
               </a:ext>
             </a:extLst>
           </p:cNvPr>
@@ -3802,7 +3802,7 @@
           <p:cNvPr id="7" name="accountability-label">
             <a:extLst xmlns:a="http://schemas.openxmlformats.org/drawingml/2006/main">
               <a:ext uri="{FF2B5EF4-FFF2-40B4-BE49-F238E27FC236}">
-                <a16:creationId xmlns:a16="http://schemas.microsoft.com/office/drawing/2014/main" id="{F2F65F0D-5D35-417B-AA5A-4C5C59B40577}"/>
+                <a16:creationId xmlns:a16="http://schemas.microsoft.com/office/drawing/2014/main" id="{5567905A-60F0-402A-99F6-807456B9F337}"/>
               </a:ext>
             </a:extLst>
           </p:cNvPr>
@@ -3860,7 +3860,7 @@
           <p:cNvPr id="8" name="accountability-structured">
             <a:extLst xmlns:a="http://schemas.openxmlformats.org/drawingml/2006/main">
               <a:ext uri="{FF2B5EF4-FFF2-40B4-BE49-F238E27FC236}">
-                <a16:creationId xmlns:a16="http://schemas.microsoft.com/office/drawing/2014/main" id="{CAA74730-000E-45E9-9A38-9231F2854EE1}"/>
+                <a16:creationId xmlns:a16="http://schemas.microsoft.com/office/drawing/2014/main" id="{854AD8B5-DDFE-4CD5-8097-ABAFD96CD7E4}"/>
               </a:ext>
             </a:extLst>
           </p:cNvPr>
@@ -3918,7 +3918,7 @@
           <p:cNvPr id="9" name="accountability-question">
             <a:extLst xmlns:a="http://schemas.openxmlformats.org/drawingml/2006/main">
               <a:ext uri="{FF2B5EF4-FFF2-40B4-BE49-F238E27FC236}">
-                <a16:creationId xmlns:a16="http://schemas.microsoft.com/office/drawing/2014/main" id="{B20340B7-9E79-4277-95F2-D8EE3284C963}"/>
+                <a16:creationId xmlns:a16="http://schemas.microsoft.com/office/drawing/2014/main" id="{7FD5189C-0482-47C9-900A-52171AB645DD}"/>
               </a:ext>
             </a:extLst>
           </p:cNvPr>
@@ -3976,7 +3976,7 @@
           <p:cNvPr id="10" name="footer-accountability-caption-1">
             <a:extLst xmlns:a="http://schemas.openxmlformats.org/drawingml/2006/main">
               <a:ext uri="{FF2B5EF4-FFF2-40B4-BE49-F238E27FC236}">
-                <a16:creationId xmlns:a16="http://schemas.microsoft.com/office/drawing/2014/main" id="{9B51D584-0C98-4F3D-A2AD-270B10F84BEF}"/>
+                <a16:creationId xmlns:a16="http://schemas.microsoft.com/office/drawing/2014/main" id="{0A73404A-3F72-4D4E-938B-77DB654293BC}"/>
               </a:ext>
             </a:extLst>
           </p:cNvPr>
@@ -4034,7 +4034,7 @@
           <p:cNvPr id="11" name="accountability-source-rule-1">
             <a:extLst xmlns:a="http://schemas.openxmlformats.org/drawingml/2006/main">
               <a:ext uri="{FF2B5EF4-FFF2-40B4-BE49-F238E27FC236}">
-                <a16:creationId xmlns:a16="http://schemas.microsoft.com/office/drawing/2014/main" id="{3A227878-5620-4FD7-B819-A10D4F9D09D3}"/>
+                <a16:creationId xmlns:a16="http://schemas.microsoft.com/office/drawing/2014/main" id="{47D9072E-75BA-4451-AA6B-9059EF940CD2}"/>
               </a:ext>
             </a:extLst>
           </p:cNvPr>
@@ -4065,7 +4065,7 @@
           <p:cNvPr id="12" name="footer-accountability-caption-2">
             <a:extLst xmlns:a="http://schemas.openxmlformats.org/drawingml/2006/main">
               <a:ext uri="{FF2B5EF4-FFF2-40B4-BE49-F238E27FC236}">
-                <a16:creationId xmlns:a16="http://schemas.microsoft.com/office/drawing/2014/main" id="{E7E8C79D-2824-4574-85C7-F02020BC9DA4}"/>
+                <a16:creationId xmlns:a16="http://schemas.microsoft.com/office/drawing/2014/main" id="{AB17C0A6-1326-42D0-8D49-A1EBF7D4AB59}"/>
               </a:ext>
             </a:extLst>
           </p:cNvPr>
@@ -4123,7 +4123,7 @@
           <p:cNvPr id="13" name="accountability-source-rule-2">
             <a:extLst xmlns:a="http://schemas.openxmlformats.org/drawingml/2006/main">
               <a:ext uri="{FF2B5EF4-FFF2-40B4-BE49-F238E27FC236}">
-                <a16:creationId xmlns:a16="http://schemas.microsoft.com/office/drawing/2014/main" id="{661F3BF3-F55D-4A6A-BFCB-2A01D845F8FA}"/>
+                <a16:creationId xmlns:a16="http://schemas.microsoft.com/office/drawing/2014/main" id="{7E627656-2C74-41B5-9226-36DC0015970F}"/>
               </a:ext>
             </a:extLst>
           </p:cNvPr>
@@ -4154,7 +4154,7 @@
           <p:cNvPr id="14" name="footer-accountability-caption-3">
             <a:extLst xmlns:a="http://schemas.openxmlformats.org/drawingml/2006/main">
               <a:ext uri="{FF2B5EF4-FFF2-40B4-BE49-F238E27FC236}">
-                <a16:creationId xmlns:a16="http://schemas.microsoft.com/office/drawing/2014/main" id="{F21C67DB-C8B4-447F-B1F1-CC95C2D723F7}"/>
+                <a16:creationId xmlns:a16="http://schemas.microsoft.com/office/drawing/2014/main" id="{0531EEE4-FC26-41BE-94F6-95D71D2E6CD6}"/>
               </a:ext>
             </a:extLst>
           </p:cNvPr>
@@ -4212,7 +4212,7 @@
           <p:cNvPr id="15" name="accountability-source-rule-3">
             <a:extLst xmlns:a="http://schemas.openxmlformats.org/drawingml/2006/main">
               <a:ext uri="{FF2B5EF4-FFF2-40B4-BE49-F238E27FC236}">
-                <a16:creationId xmlns:a16="http://schemas.microsoft.com/office/drawing/2014/main" id="{B18DEAAC-8315-4C48-B77B-6315F75A8569}"/>
+                <a16:creationId xmlns:a16="http://schemas.microsoft.com/office/drawing/2014/main" id="{E163EFE4-5767-417E-B904-88265B8CE6C6}"/>
               </a:ext>
             </a:extLst>
           </p:cNvPr>
@@ -4243,7 +4243,7 @@
           <p:cNvPr id="16" name="accountability-evidence">
             <a:extLst xmlns:a="http://schemas.openxmlformats.org/drawingml/2006/main">
               <a:ext uri="{FF2B5EF4-FFF2-40B4-BE49-F238E27FC236}">
-                <a16:creationId xmlns:a16="http://schemas.microsoft.com/office/drawing/2014/main" id="{D8956D23-9DAC-4E9C-AF16-61CEC653FB2A}"/>
+                <a16:creationId xmlns:a16="http://schemas.microsoft.com/office/drawing/2014/main" id="{3A730EEA-2817-4D78-A86A-39F4D8B1EBDB}"/>
               </a:ext>
             </a:extLst>
           </p:cNvPr>
@@ -4301,7 +4301,7 @@
           <p:cNvPr id="17" name="accountability-unknowns">
             <a:extLst xmlns:a="http://schemas.openxmlformats.org/drawingml/2006/main">
               <a:ext uri="{FF2B5EF4-FFF2-40B4-BE49-F238E27FC236}">
-                <a16:creationId xmlns:a16="http://schemas.microsoft.com/office/drawing/2014/main" id="{37BAE2C6-2B73-4647-963E-B7C14111BD72}"/>
+                <a16:creationId xmlns:a16="http://schemas.microsoft.com/office/drawing/2014/main" id="{1FA6EF2D-4007-44BE-AAEC-80951585519A}"/>
               </a:ext>
             </a:extLst>
           </p:cNvPr>
@@ -4357,7 +4357,7 @@
     </p:spTree>
     <p:extLst>
       <p:ext uri="{BB962C8B-B14F-4D97-AF65-F5344CB8AC3E}">
-        <p14:creationId xmlns:p14="http://schemas.microsoft.com/office/powerpoint/2010/main" val="169805241"/>
+        <p14:creationId xmlns:p14="http://schemas.microsoft.com/office/powerpoint/2010/main" val="1075578534"/>
       </p:ext>
     </p:extLst>
   </p:cSld>
@@ -4388,7 +4388,7 @@
           <p:cNvPr id="14" name="brand-3">
             <a:extLst xmlns:a="http://schemas.openxmlformats.org/drawingml/2006/main">
               <a:ext uri="{FF2B5EF4-FFF2-40B4-BE49-F238E27FC236}">
-                <a16:creationId xmlns:a16="http://schemas.microsoft.com/office/drawing/2014/main" id="{315A9DFE-570F-495C-8304-9F1D353D383B}"/>
+                <a16:creationId xmlns:a16="http://schemas.microsoft.com/office/drawing/2014/main" id="{BAE23166-96F8-4234-BAA0-E59BD452733B}"/>
               </a:ext>
             </a:extLst>
           </p:cNvPr>
@@ -4446,7 +4446,7 @@
           <p:cNvPr id="2" name="title-3">
             <a:extLst xmlns:a="http://schemas.openxmlformats.org/drawingml/2006/main">
               <a:ext uri="{FF2B5EF4-FFF2-40B4-BE49-F238E27FC236}">
-                <a16:creationId xmlns:a16="http://schemas.microsoft.com/office/drawing/2014/main" id="{F85C880B-E823-4196-9B1D-0C965DF2BCB3}"/>
+                <a16:creationId xmlns:a16="http://schemas.microsoft.com/office/drawing/2014/main" id="{0486F919-0B1F-40AA-BC22-1BD8009A6543}"/>
               </a:ext>
             </a:extLst>
           </p:cNvPr>
@@ -4504,7 +4504,7 @@
           <p:cNvPr id="3" name="footer-rule-3">
             <a:extLst xmlns:a="http://schemas.openxmlformats.org/drawingml/2006/main">
               <a:ext uri="{FF2B5EF4-FFF2-40B4-BE49-F238E27FC236}">
-                <a16:creationId xmlns:a16="http://schemas.microsoft.com/office/drawing/2014/main" id="{2364EBD3-0D3A-4361-953A-8FBF425069E9}"/>
+                <a16:creationId xmlns:a16="http://schemas.microsoft.com/office/drawing/2014/main" id="{2793382D-949E-4D90-BAE5-F5E546B663AE}"/>
               </a:ext>
             </a:extLst>
           </p:cNvPr>
@@ -4535,7 +4535,7 @@
           <p:cNvPr id="4" name="footer-source-3">
             <a:extLst xmlns:a="http://schemas.openxmlformats.org/drawingml/2006/main">
               <a:ext uri="{FF2B5EF4-FFF2-40B4-BE49-F238E27FC236}">
-                <a16:creationId xmlns:a16="http://schemas.microsoft.com/office/drawing/2014/main" id="{A4A0BC92-D01E-469A-8BA2-EAA3B9A9F14F}"/>
+                <a16:creationId xmlns:a16="http://schemas.microsoft.com/office/drawing/2014/main" id="{1C89E6DA-E3A1-4D2C-A32B-7F304E02F9D7}"/>
               </a:ext>
             </a:extLst>
           </p:cNvPr>
@@ -4593,7 +4593,7 @@
           <p:cNvPr id="5" name="footer-page-3">
             <a:extLst xmlns:a="http://schemas.openxmlformats.org/drawingml/2006/main">
               <a:ext uri="{FF2B5EF4-FFF2-40B4-BE49-F238E27FC236}">
-                <a16:creationId xmlns:a16="http://schemas.microsoft.com/office/drawing/2014/main" id="{B5DCF227-A2D3-4094-B763-7509640310DE}"/>
+                <a16:creationId xmlns:a16="http://schemas.microsoft.com/office/drawing/2014/main" id="{D62B68B1-3EBC-4065-95EC-220A77B2ED6E}"/>
               </a:ext>
             </a:extLst>
           </p:cNvPr>
@@ -4651,7 +4651,7 @@
           <p:cNvPr id="6" name="boundary-left">
             <a:extLst xmlns:a="http://schemas.openxmlformats.org/drawingml/2006/main">
               <a:ext uri="{FF2B5EF4-FFF2-40B4-BE49-F238E27FC236}">
-                <a16:creationId xmlns:a16="http://schemas.microsoft.com/office/drawing/2014/main" id="{DF605CF2-CF2A-4348-B531-64999BDFFCF5}"/>
+                <a16:creationId xmlns:a16="http://schemas.microsoft.com/office/drawing/2014/main" id="{F88BF26A-E80D-4CB4-8F00-B08D75DF4051}"/>
               </a:ext>
             </a:extLst>
           </p:cNvPr>
@@ -4684,7 +4684,7 @@
           <p:cNvPr id="7" name="boundary-spine">
             <a:extLst xmlns:a="http://schemas.openxmlformats.org/drawingml/2006/main">
               <a:ext uri="{FF2B5EF4-FFF2-40B4-BE49-F238E27FC236}">
-                <a16:creationId xmlns:a16="http://schemas.microsoft.com/office/drawing/2014/main" id="{4F72DE0C-80EB-461B-ACA2-174F9583980A}"/>
+                <a16:creationId xmlns:a16="http://schemas.microsoft.com/office/drawing/2014/main" id="{BB5EF693-22EE-4943-88FA-432639F62152}"/>
               </a:ext>
             </a:extLst>
           </p:cNvPr>
@@ -4715,7 +4715,7 @@
           <p:cNvPr id="8" name="boundary-drr">
             <a:extLst xmlns:a="http://schemas.openxmlformats.org/drawingml/2006/main">
               <a:ext uri="{FF2B5EF4-FFF2-40B4-BE49-F238E27FC236}">
-                <a16:creationId xmlns:a16="http://schemas.microsoft.com/office/drawing/2014/main" id="{978AD53D-2E70-4954-9787-20651EAB5B48}"/>
+                <a16:creationId xmlns:a16="http://schemas.microsoft.com/office/drawing/2014/main" id="{22752193-F23B-483A-A92C-3BE88B970E08}"/>
               </a:ext>
             </a:extLst>
           </p:cNvPr>
@@ -4773,7 +4773,7 @@
           <p:cNvPr id="9" name="boundary-drr-copy">
             <a:extLst xmlns:a="http://schemas.openxmlformats.org/drawingml/2006/main">
               <a:ext uri="{FF2B5EF4-FFF2-40B4-BE49-F238E27FC236}">
-                <a16:creationId xmlns:a16="http://schemas.microsoft.com/office/drawing/2014/main" id="{00A783FF-8049-49F6-8ED7-1A78708D056E}"/>
+                <a16:creationId xmlns:a16="http://schemas.microsoft.com/office/drawing/2014/main" id="{9AFBDE2F-3A9C-445D-9949-4A3904E47B8E}"/>
               </a:ext>
             </a:extLst>
           </p:cNvPr>
@@ -4831,7 +4831,7 @@
           <p:cNvPr id="10" name="boundary-attest">
             <a:extLst xmlns:a="http://schemas.openxmlformats.org/drawingml/2006/main">
               <a:ext uri="{FF2B5EF4-FFF2-40B4-BE49-F238E27FC236}">
-                <a16:creationId xmlns:a16="http://schemas.microsoft.com/office/drawing/2014/main" id="{59074284-2903-4475-932D-ACB6120EB4BC}"/>
+                <a16:creationId xmlns:a16="http://schemas.microsoft.com/office/drawing/2014/main" id="{44DD6B83-209E-43F0-81D0-700BEFBFE973}"/>
               </a:ext>
             </a:extLst>
           </p:cNvPr>
@@ -4889,7 +4889,7 @@
           <p:cNvPr id="11" name="boundary-attest-copy">
             <a:extLst xmlns:a="http://schemas.openxmlformats.org/drawingml/2006/main">
               <a:ext uri="{FF2B5EF4-FFF2-40B4-BE49-F238E27FC236}">
-                <a16:creationId xmlns:a16="http://schemas.microsoft.com/office/drawing/2014/main" id="{4B8E2AAC-A096-4E0F-93DF-53800515DBD1}"/>
+                <a16:creationId xmlns:a16="http://schemas.microsoft.com/office/drawing/2014/main" id="{F7C76B3C-24A0-427C-B690-5F376FBC575E}"/>
               </a:ext>
             </a:extLst>
           </p:cNvPr>
@@ -4947,7 +4947,7 @@
           <p:cNvPr id="12" name="boundary-limit">
             <a:extLst xmlns:a="http://schemas.openxmlformats.org/drawingml/2006/main">
               <a:ext uri="{FF2B5EF4-FFF2-40B4-BE49-F238E27FC236}">
-                <a16:creationId xmlns:a16="http://schemas.microsoft.com/office/drawing/2014/main" id="{234374A7-2FD8-45C4-96FB-9845AFD1A6B9}"/>
+                <a16:creationId xmlns:a16="http://schemas.microsoft.com/office/drawing/2014/main" id="{B53B91C6-DA77-482D-81A4-E57183070FED}"/>
               </a:ext>
             </a:extLst>
           </p:cNvPr>
@@ -5005,7 +5005,7 @@
           <p:cNvPr id="13" name="boundary-absence">
             <a:extLst xmlns:a="http://schemas.openxmlformats.org/drawingml/2006/main">
               <a:ext uri="{FF2B5EF4-FFF2-40B4-BE49-F238E27FC236}">
-                <a16:creationId xmlns:a16="http://schemas.microsoft.com/office/drawing/2014/main" id="{379097CC-AE1E-41F7-8C18-717FF8F2E401}"/>
+                <a16:creationId xmlns:a16="http://schemas.microsoft.com/office/drawing/2014/main" id="{A96A5B6F-E37F-4DDF-884C-2D9F02BFFC2A}"/>
               </a:ext>
             </a:extLst>
           </p:cNvPr>
@@ -5061,7 +5061,7 @@
     </p:spTree>
     <p:extLst>
       <p:ext uri="{BB962C8B-B14F-4D97-AF65-F5344CB8AC3E}">
-        <p14:creationId xmlns:p14="http://schemas.microsoft.com/office/powerpoint/2010/main" val="572006445"/>
+        <p14:creationId xmlns:p14="http://schemas.microsoft.com/office/powerpoint/2010/main" val="493247843"/>
       </p:ext>
     </p:extLst>
   </p:cSld>
@@ -5092,7 +5092,7 @@
           <p:cNvPr id="22" name="brand-4">
             <a:extLst xmlns:a="http://schemas.openxmlformats.org/drawingml/2006/main">
               <a:ext uri="{FF2B5EF4-FFF2-40B4-BE49-F238E27FC236}">
-                <a16:creationId xmlns:a16="http://schemas.microsoft.com/office/drawing/2014/main" id="{82F689D1-9B94-4090-8E37-4DC0A48FF1F6}"/>
+                <a16:creationId xmlns:a16="http://schemas.microsoft.com/office/drawing/2014/main" id="{6CECD602-4F9E-402D-8756-82ED046DD255}"/>
               </a:ext>
             </a:extLst>
           </p:cNvPr>
@@ -5150,7 +5150,7 @@
           <p:cNvPr id="2" name="title-4">
             <a:extLst xmlns:a="http://schemas.openxmlformats.org/drawingml/2006/main">
               <a:ext uri="{FF2B5EF4-FFF2-40B4-BE49-F238E27FC236}">
-                <a16:creationId xmlns:a16="http://schemas.microsoft.com/office/drawing/2014/main" id="{ED1F2187-3750-4E75-A298-52D0C6869B11}"/>
+                <a16:creationId xmlns:a16="http://schemas.microsoft.com/office/drawing/2014/main" id="{2FA0F33B-C122-42A5-A536-2B45CE2F4A26}"/>
               </a:ext>
             </a:extLst>
           </p:cNvPr>
@@ -5208,7 +5208,7 @@
           <p:cNvPr id="3" name="footer-rule-4">
             <a:extLst xmlns:a="http://schemas.openxmlformats.org/drawingml/2006/main">
               <a:ext uri="{FF2B5EF4-FFF2-40B4-BE49-F238E27FC236}">
-                <a16:creationId xmlns:a16="http://schemas.microsoft.com/office/drawing/2014/main" id="{4F6F0EC0-8B5D-46AC-BBF1-42671086265B}"/>
+                <a16:creationId xmlns:a16="http://schemas.microsoft.com/office/drawing/2014/main" id="{BA5397BF-3D91-4059-ABB9-4B8175613E4F}"/>
               </a:ext>
             </a:extLst>
           </p:cNvPr>
@@ -5239,7 +5239,7 @@
           <p:cNvPr id="4" name="footer-source-4">
             <a:extLst xmlns:a="http://schemas.openxmlformats.org/drawingml/2006/main">
               <a:ext uri="{FF2B5EF4-FFF2-40B4-BE49-F238E27FC236}">
-                <a16:creationId xmlns:a16="http://schemas.microsoft.com/office/drawing/2014/main" id="{E94416CF-78AD-423D-94DC-5414569CBD62}"/>
+                <a16:creationId xmlns:a16="http://schemas.microsoft.com/office/drawing/2014/main" id="{1D655F3A-CAD6-48E1-9969-CF8BF9F2474B}"/>
               </a:ext>
             </a:extLst>
           </p:cNvPr>
@@ -5297,7 +5297,7 @@
           <p:cNvPr id="5" name="footer-page-4">
             <a:extLst xmlns:a="http://schemas.openxmlformats.org/drawingml/2006/main">
               <a:ext uri="{FF2B5EF4-FFF2-40B4-BE49-F238E27FC236}">
-                <a16:creationId xmlns:a16="http://schemas.microsoft.com/office/drawing/2014/main" id="{4EA6A1F7-1C0F-4180-A03A-B3E1DE1BF2CF}"/>
+                <a16:creationId xmlns:a16="http://schemas.microsoft.com/office/drawing/2014/main" id="{C1AC1C35-36CF-4373-9A01-55AC40A3F544}"/>
               </a:ext>
             </a:extLst>
           </p:cNvPr>
@@ -5355,7 +5355,7 @@
           <p:cNvPr id="6" name="case-entity">
             <a:extLst xmlns:a="http://schemas.openxmlformats.org/drawingml/2006/main">
               <a:ext uri="{FF2B5EF4-FFF2-40B4-BE49-F238E27FC236}">
-                <a16:creationId xmlns:a16="http://schemas.microsoft.com/office/drawing/2014/main" id="{BF48C93F-B661-43F3-9EA0-300AFC1794F5}"/>
+                <a16:creationId xmlns:a16="http://schemas.microsoft.com/office/drawing/2014/main" id="{35D1B3B9-6D89-41B2-A783-D1C7D0D695BC}"/>
               </a:ext>
             </a:extLst>
           </p:cNvPr>
@@ -5413,7 +5413,7 @@
           <p:cNvPr id="7" name="case-period">
             <a:extLst xmlns:a="http://schemas.openxmlformats.org/drawingml/2006/main">
               <a:ext uri="{FF2B5EF4-FFF2-40B4-BE49-F238E27FC236}">
-                <a16:creationId xmlns:a16="http://schemas.microsoft.com/office/drawing/2014/main" id="{E1722C7D-7E30-44EA-829E-2887433B1562}"/>
+                <a16:creationId xmlns:a16="http://schemas.microsoft.com/office/drawing/2014/main" id="{FA4B7DEF-7EF4-4FE3-ADB2-9EF603A8CDEC}"/>
               </a:ext>
             </a:extLst>
           </p:cNvPr>
@@ -5471,7 +5471,7 @@
           <p:cNvPr id="8" name="case-marker">
             <a:extLst xmlns:a="http://schemas.openxmlformats.org/drawingml/2006/main">
               <a:ext uri="{FF2B5EF4-FFF2-40B4-BE49-F238E27FC236}">
-                <a16:creationId xmlns:a16="http://schemas.microsoft.com/office/drawing/2014/main" id="{36113BCA-3098-456C-8D4A-15CCA0018592}"/>
+                <a16:creationId xmlns:a16="http://schemas.microsoft.com/office/drawing/2014/main" id="{87ECAA54-D382-493C-A5FF-641B84F73382}"/>
               </a:ext>
             </a:extLst>
           </p:cNvPr>
@@ -5529,7 +5529,7 @@
           <p:cNvPr id="9" name="case-divider">
             <a:extLst xmlns:a="http://schemas.openxmlformats.org/drawingml/2006/main">
               <a:ext uri="{FF2B5EF4-FFF2-40B4-BE49-F238E27FC236}">
-                <a16:creationId xmlns:a16="http://schemas.microsoft.com/office/drawing/2014/main" id="{A4362507-65BC-4EAD-8234-B885A50524BF}"/>
+                <a16:creationId xmlns:a16="http://schemas.microsoft.com/office/drawing/2014/main" id="{85379972-0F5E-4B29-8B89-051167E69996}"/>
               </a:ext>
             </a:extLst>
           </p:cNvPr>
@@ -5560,7 +5560,7 @@
           <p:cNvPr id="10" name="case-row-rule-1">
             <a:extLst xmlns:a="http://schemas.openxmlformats.org/drawingml/2006/main">
               <a:ext uri="{FF2B5EF4-FFF2-40B4-BE49-F238E27FC236}">
-                <a16:creationId xmlns:a16="http://schemas.microsoft.com/office/drawing/2014/main" id="{0EE2FD0E-11EC-43F1-8B59-A2B95DBD780C}"/>
+                <a16:creationId xmlns:a16="http://schemas.microsoft.com/office/drawing/2014/main" id="{A6E27DEE-0C21-4C75-A160-16EF949BADA7}"/>
               </a:ext>
             </a:extLst>
           </p:cNvPr>
@@ -5591,7 +5591,7 @@
           <p:cNvPr id="11" name="case-row-status-1">
             <a:extLst xmlns:a="http://schemas.openxmlformats.org/drawingml/2006/main">
               <a:ext uri="{FF2B5EF4-FFF2-40B4-BE49-F238E27FC236}">
-                <a16:creationId xmlns:a16="http://schemas.microsoft.com/office/drawing/2014/main" id="{B8909839-33A9-4CEA-853D-FEE062EEEF41}"/>
+                <a16:creationId xmlns:a16="http://schemas.microsoft.com/office/drawing/2014/main" id="{67D93016-6F00-4809-BF8A-F1CF84CB4622}"/>
               </a:ext>
             </a:extLst>
           </p:cNvPr>
@@ -5649,7 +5649,7 @@
           <p:cNvPr id="12" name="case-row-label-1">
             <a:extLst xmlns:a="http://schemas.openxmlformats.org/drawingml/2006/main">
               <a:ext uri="{FF2B5EF4-FFF2-40B4-BE49-F238E27FC236}">
-                <a16:creationId xmlns:a16="http://schemas.microsoft.com/office/drawing/2014/main" id="{67225747-565F-4E1F-B5BB-78389B793346}"/>
+                <a16:creationId xmlns:a16="http://schemas.microsoft.com/office/drawing/2014/main" id="{1B8AA4E8-4832-42BE-B175-8B06C550CD66}"/>
               </a:ext>
             </a:extLst>
           </p:cNvPr>
@@ -5707,7 +5707,7 @@
           <p:cNvPr id="13" name="case-row-copy-1">
             <a:extLst xmlns:a="http://schemas.openxmlformats.org/drawingml/2006/main">
               <a:ext uri="{FF2B5EF4-FFF2-40B4-BE49-F238E27FC236}">
-                <a16:creationId xmlns:a16="http://schemas.microsoft.com/office/drawing/2014/main" id="{1A646FDB-67F5-4C92-ACF6-53D58101F542}"/>
+                <a16:creationId xmlns:a16="http://schemas.microsoft.com/office/drawing/2014/main" id="{C7356FAB-C612-4B0A-8069-B0BC8D4C3546}"/>
               </a:ext>
             </a:extLst>
           </p:cNvPr>
@@ -5765,7 +5765,7 @@
           <p:cNvPr id="14" name="case-row-rule-2">
             <a:extLst xmlns:a="http://schemas.openxmlformats.org/drawingml/2006/main">
               <a:ext uri="{FF2B5EF4-FFF2-40B4-BE49-F238E27FC236}">
-                <a16:creationId xmlns:a16="http://schemas.microsoft.com/office/drawing/2014/main" id="{990C6465-C66E-4022-B0D1-CBBC8C800D15}"/>
+                <a16:creationId xmlns:a16="http://schemas.microsoft.com/office/drawing/2014/main" id="{B3AB5365-1B3E-4330-96C8-72B4BD1F8164}"/>
               </a:ext>
             </a:extLst>
           </p:cNvPr>
@@ -5796,7 +5796,7 @@
           <p:cNvPr id="15" name="case-row-status-2">
             <a:extLst xmlns:a="http://schemas.openxmlformats.org/drawingml/2006/main">
               <a:ext uri="{FF2B5EF4-FFF2-40B4-BE49-F238E27FC236}">
-                <a16:creationId xmlns:a16="http://schemas.microsoft.com/office/drawing/2014/main" id="{8D34D2E6-40D8-4DA3-B4BC-D9A717F4318F}"/>
+                <a16:creationId xmlns:a16="http://schemas.microsoft.com/office/drawing/2014/main" id="{9BC9C06D-9AC5-447E-AA04-C473CEAD640B}"/>
               </a:ext>
             </a:extLst>
           </p:cNvPr>
@@ -5854,7 +5854,7 @@
           <p:cNvPr id="16" name="case-row-label-2">
             <a:extLst xmlns:a="http://schemas.openxmlformats.org/drawingml/2006/main">
               <a:ext uri="{FF2B5EF4-FFF2-40B4-BE49-F238E27FC236}">
-                <a16:creationId xmlns:a16="http://schemas.microsoft.com/office/drawing/2014/main" id="{E0FC6972-51D3-41BA-8DAC-1315AF133C43}"/>
+                <a16:creationId xmlns:a16="http://schemas.microsoft.com/office/drawing/2014/main" id="{B80D2B04-E8CE-452C-B00D-91AB33F3E179}"/>
               </a:ext>
             </a:extLst>
           </p:cNvPr>
@@ -5912,7 +5912,7 @@
           <p:cNvPr id="17" name="case-row-copy-2">
             <a:extLst xmlns:a="http://schemas.openxmlformats.org/drawingml/2006/main">
               <a:ext uri="{FF2B5EF4-FFF2-40B4-BE49-F238E27FC236}">
-                <a16:creationId xmlns:a16="http://schemas.microsoft.com/office/drawing/2014/main" id="{54621B36-6F05-4DD8-878F-D96D3BDA754B}"/>
+                <a16:creationId xmlns:a16="http://schemas.microsoft.com/office/drawing/2014/main" id="{25C4AC7A-7986-409E-86AD-EA43B0B15A2E}"/>
               </a:ext>
             </a:extLst>
           </p:cNvPr>
@@ -5970,7 +5970,7 @@
           <p:cNvPr id="18" name="case-row-rule-3">
             <a:extLst xmlns:a="http://schemas.openxmlformats.org/drawingml/2006/main">
               <a:ext uri="{FF2B5EF4-FFF2-40B4-BE49-F238E27FC236}">
-                <a16:creationId xmlns:a16="http://schemas.microsoft.com/office/drawing/2014/main" id="{06B33CE9-13FD-4FBC-BA01-94AC7EB23803}"/>
+                <a16:creationId xmlns:a16="http://schemas.microsoft.com/office/drawing/2014/main" id="{918B263F-2E7F-4EA2-A82F-EE4ED7333039}"/>
               </a:ext>
             </a:extLst>
           </p:cNvPr>
@@ -6001,7 +6001,7 @@
           <p:cNvPr id="19" name="case-row-status-3">
             <a:extLst xmlns:a="http://schemas.openxmlformats.org/drawingml/2006/main">
               <a:ext uri="{FF2B5EF4-FFF2-40B4-BE49-F238E27FC236}">
-                <a16:creationId xmlns:a16="http://schemas.microsoft.com/office/drawing/2014/main" id="{F63CC6FB-8E19-48ED-837D-46855753A4AE}"/>
+                <a16:creationId xmlns:a16="http://schemas.microsoft.com/office/drawing/2014/main" id="{B14B8BEF-A1D7-4FF3-86F4-F90B2F8BFE0C}"/>
               </a:ext>
             </a:extLst>
           </p:cNvPr>
@@ -6059,7 +6059,7 @@
           <p:cNvPr id="20" name="case-row-label-3">
             <a:extLst xmlns:a="http://schemas.openxmlformats.org/drawingml/2006/main">
               <a:ext uri="{FF2B5EF4-FFF2-40B4-BE49-F238E27FC236}">
-                <a16:creationId xmlns:a16="http://schemas.microsoft.com/office/drawing/2014/main" id="{BA93B6AC-CC25-4DC9-B65F-2C8DEAFD0EE0}"/>
+                <a16:creationId xmlns:a16="http://schemas.microsoft.com/office/drawing/2014/main" id="{82552732-0A6D-4B67-9EAE-7ACEB413C415}"/>
               </a:ext>
             </a:extLst>
           </p:cNvPr>
@@ -6117,7 +6117,7 @@
           <p:cNvPr id="21" name="case-row-copy-3">
             <a:extLst xmlns:a="http://schemas.openxmlformats.org/drawingml/2006/main">
               <a:ext uri="{FF2B5EF4-FFF2-40B4-BE49-F238E27FC236}">
-                <a16:creationId xmlns:a16="http://schemas.microsoft.com/office/drawing/2014/main" id="{11D2D166-3798-4C9F-8652-64D6EFF09267}"/>
+                <a16:creationId xmlns:a16="http://schemas.microsoft.com/office/drawing/2014/main" id="{8433842B-C615-4D0A-87B8-D554DF38DBB8}"/>
               </a:ext>
             </a:extLst>
           </p:cNvPr>
@@ -6173,7 +6173,7 @@
     </p:spTree>
     <p:extLst>
       <p:ext uri="{BB962C8B-B14F-4D97-AF65-F5344CB8AC3E}">
-        <p14:creationId xmlns:p14="http://schemas.microsoft.com/office/powerpoint/2010/main" val="942550303"/>
+        <p14:creationId xmlns:p14="http://schemas.microsoft.com/office/powerpoint/2010/main" val="1523347470"/>
       </p:ext>
     </p:extLst>
   </p:cSld>
@@ -6204,7 +6204,7 @@
           <p:cNvPr id="17" name="brand-5">
             <a:extLst xmlns:a="http://schemas.openxmlformats.org/drawingml/2006/main">
               <a:ext uri="{FF2B5EF4-FFF2-40B4-BE49-F238E27FC236}">
-                <a16:creationId xmlns:a16="http://schemas.microsoft.com/office/drawing/2014/main" id="{E4DA99D2-E7EC-4A2A-90C0-D8C1507892F9}"/>
+                <a16:creationId xmlns:a16="http://schemas.microsoft.com/office/drawing/2014/main" id="{F2EF9ADF-E62E-4F89-8B07-A07E8524B4D9}"/>
               </a:ext>
             </a:extLst>
           </p:cNvPr>
@@ -6262,7 +6262,7 @@
           <p:cNvPr id="2" name="title-5">
             <a:extLst xmlns:a="http://schemas.openxmlformats.org/drawingml/2006/main">
               <a:ext uri="{FF2B5EF4-FFF2-40B4-BE49-F238E27FC236}">
-                <a16:creationId xmlns:a16="http://schemas.microsoft.com/office/drawing/2014/main" id="{33DBB377-EA0E-4432-8EA2-8C4E88BE2117}"/>
+                <a16:creationId xmlns:a16="http://schemas.microsoft.com/office/drawing/2014/main" id="{37166FED-DE7E-458C-9220-DC40BFD8884C}"/>
               </a:ext>
             </a:extLst>
           </p:cNvPr>
@@ -6320,7 +6320,7 @@
           <p:cNvPr id="3" name="footer-rule-5">
             <a:extLst xmlns:a="http://schemas.openxmlformats.org/drawingml/2006/main">
               <a:ext uri="{FF2B5EF4-FFF2-40B4-BE49-F238E27FC236}">
-                <a16:creationId xmlns:a16="http://schemas.microsoft.com/office/drawing/2014/main" id="{06A4BCD4-C699-4DA0-8605-C40212B9F75E}"/>
+                <a16:creationId xmlns:a16="http://schemas.microsoft.com/office/drawing/2014/main" id="{F9EE294D-37F3-4C0F-BDFA-F4CD2335BB16}"/>
               </a:ext>
             </a:extLst>
           </p:cNvPr>
@@ -6351,7 +6351,7 @@
           <p:cNvPr id="4" name="footer-source-5">
             <a:extLst xmlns:a="http://schemas.openxmlformats.org/drawingml/2006/main">
               <a:ext uri="{FF2B5EF4-FFF2-40B4-BE49-F238E27FC236}">
-                <a16:creationId xmlns:a16="http://schemas.microsoft.com/office/drawing/2014/main" id="{46AC43F5-614A-47A8-95B4-F0B928B5DDA3}"/>
+                <a16:creationId xmlns:a16="http://schemas.microsoft.com/office/drawing/2014/main" id="{26774910-91B4-43AE-B923-5F3F99DA6621}"/>
               </a:ext>
             </a:extLst>
           </p:cNvPr>
@@ -6409,7 +6409,7 @@
           <p:cNvPr id="5" name="footer-page-5">
             <a:extLst xmlns:a="http://schemas.openxmlformats.org/drawingml/2006/main">
               <a:ext uri="{FF2B5EF4-FFF2-40B4-BE49-F238E27FC236}">
-                <a16:creationId xmlns:a16="http://schemas.microsoft.com/office/drawing/2014/main" id="{64065D31-69F8-4184-A6D8-154B11793855}"/>
+                <a16:creationId xmlns:a16="http://schemas.microsoft.com/office/drawing/2014/main" id="{298A160C-8730-435B-9007-7066BCC1CD64}"/>
               </a:ext>
             </a:extLst>
           </p:cNvPr>
@@ -6467,7 +6467,7 @@
           <p:cNvPr id="6" name="workflow-rail">
             <a:extLst xmlns:a="http://schemas.openxmlformats.org/drawingml/2006/main">
               <a:ext uri="{FF2B5EF4-FFF2-40B4-BE49-F238E27FC236}">
-                <a16:creationId xmlns:a16="http://schemas.microsoft.com/office/drawing/2014/main" id="{F86146BE-127A-4989-8A2E-66959D0C5C56}"/>
+                <a16:creationId xmlns:a16="http://schemas.microsoft.com/office/drawing/2014/main" id="{B8628C73-6E47-4AB2-B848-25A70B486954}"/>
               </a:ext>
             </a:extLst>
           </p:cNvPr>
@@ -6498,7 +6498,7 @@
           <p:cNvPr id="7" name="workflow-tick-1">
             <a:extLst xmlns:a="http://schemas.openxmlformats.org/drawingml/2006/main">
               <a:ext uri="{FF2B5EF4-FFF2-40B4-BE49-F238E27FC236}">
-                <a16:creationId xmlns:a16="http://schemas.microsoft.com/office/drawing/2014/main" id="{BF19BCFF-FE17-4289-A3D4-E371678F4D00}"/>
+                <a16:creationId xmlns:a16="http://schemas.microsoft.com/office/drawing/2014/main" id="{9EAC902D-EFAC-4B39-A1AD-18BD825EC88C}"/>
               </a:ext>
             </a:extLst>
           </p:cNvPr>
@@ -6529,7 +6529,7 @@
           <p:cNvPr id="8" name="workflow-step-1">
             <a:extLst xmlns:a="http://schemas.openxmlformats.org/drawingml/2006/main">
               <a:ext uri="{FF2B5EF4-FFF2-40B4-BE49-F238E27FC236}">
-                <a16:creationId xmlns:a16="http://schemas.microsoft.com/office/drawing/2014/main" id="{089C8012-5D72-45D0-BF69-1035C409D4B4}"/>
+                <a16:creationId xmlns:a16="http://schemas.microsoft.com/office/drawing/2014/main" id="{81B5573F-6685-4D0E-8E7E-68C9576E7C98}"/>
               </a:ext>
             </a:extLst>
           </p:cNvPr>
@@ -6587,7 +6587,7 @@
           <p:cNvPr id="9" name="workflow-tick-2">
             <a:extLst xmlns:a="http://schemas.openxmlformats.org/drawingml/2006/main">
               <a:ext uri="{FF2B5EF4-FFF2-40B4-BE49-F238E27FC236}">
-                <a16:creationId xmlns:a16="http://schemas.microsoft.com/office/drawing/2014/main" id="{37F7DF3E-A4AB-473E-B2DF-63C4F912EA7E}"/>
+                <a16:creationId xmlns:a16="http://schemas.microsoft.com/office/drawing/2014/main" id="{E5679DDF-F8F7-4438-8E71-85D57E49EA4C}"/>
               </a:ext>
             </a:extLst>
           </p:cNvPr>
@@ -6618,7 +6618,7 @@
           <p:cNvPr id="10" name="workflow-step-2">
             <a:extLst xmlns:a="http://schemas.openxmlformats.org/drawingml/2006/main">
               <a:ext uri="{FF2B5EF4-FFF2-40B4-BE49-F238E27FC236}">
-                <a16:creationId xmlns:a16="http://schemas.microsoft.com/office/drawing/2014/main" id="{8B058FEB-02B4-4144-AEB8-20DF070AC7F5}"/>
+                <a16:creationId xmlns:a16="http://schemas.microsoft.com/office/drawing/2014/main" id="{EC48741A-B1CB-45BB-A3F6-7E327984B5E4}"/>
               </a:ext>
             </a:extLst>
           </p:cNvPr>
@@ -6676,7 +6676,7 @@
           <p:cNvPr id="11" name="workflow-tick-3">
             <a:extLst xmlns:a="http://schemas.openxmlformats.org/drawingml/2006/main">
               <a:ext uri="{FF2B5EF4-FFF2-40B4-BE49-F238E27FC236}">
-                <a16:creationId xmlns:a16="http://schemas.microsoft.com/office/drawing/2014/main" id="{21BF1CDF-9A58-48FA-9160-DA1BC380C20B}"/>
+                <a16:creationId xmlns:a16="http://schemas.microsoft.com/office/drawing/2014/main" id="{80BAE232-41F0-4015-916D-B2ECC9A71611}"/>
               </a:ext>
             </a:extLst>
           </p:cNvPr>
@@ -6707,7 +6707,7 @@
           <p:cNvPr id="12" name="workflow-step-3">
             <a:extLst xmlns:a="http://schemas.openxmlformats.org/drawingml/2006/main">
               <a:ext uri="{FF2B5EF4-FFF2-40B4-BE49-F238E27FC236}">
-                <a16:creationId xmlns:a16="http://schemas.microsoft.com/office/drawing/2014/main" id="{210512FE-A174-4D29-B197-1293D5D6A50E}"/>
+                <a16:creationId xmlns:a16="http://schemas.microsoft.com/office/drawing/2014/main" id="{5EDE5F60-ACDD-472B-AA18-3496FC182D20}"/>
               </a:ext>
             </a:extLst>
           </p:cNvPr>
@@ -6765,7 +6765,7 @@
           <p:cNvPr id="13" name="workflow-tick-4">
             <a:extLst xmlns:a="http://schemas.openxmlformats.org/drawingml/2006/main">
               <a:ext uri="{FF2B5EF4-FFF2-40B4-BE49-F238E27FC236}">
-                <a16:creationId xmlns:a16="http://schemas.microsoft.com/office/drawing/2014/main" id="{64103D35-84C6-48ED-BA33-F22E33FEEEBC}"/>
+                <a16:creationId xmlns:a16="http://schemas.microsoft.com/office/drawing/2014/main" id="{D4F9CCC4-29E1-4BAF-9A30-9A59781FBC3D}"/>
               </a:ext>
             </a:extLst>
           </p:cNvPr>
@@ -6796,7 +6796,7 @@
           <p:cNvPr id="14" name="workflow-step-4">
             <a:extLst xmlns:a="http://schemas.openxmlformats.org/drawingml/2006/main">
               <a:ext uri="{FF2B5EF4-FFF2-40B4-BE49-F238E27FC236}">
-                <a16:creationId xmlns:a16="http://schemas.microsoft.com/office/drawing/2014/main" id="{50D2B3DE-AFAF-4EDF-8690-1248E53BD8ED}"/>
+                <a16:creationId xmlns:a16="http://schemas.microsoft.com/office/drawing/2014/main" id="{7B6A2C6D-3897-4C6A-AFC5-FDF8EAE7BFD4}"/>
               </a:ext>
             </a:extLst>
           </p:cNvPr>
@@ -6854,7 +6854,7 @@
           <p:cNvPr id="15" name="workflow-tick-5">
             <a:extLst xmlns:a="http://schemas.openxmlformats.org/drawingml/2006/main">
               <a:ext uri="{FF2B5EF4-FFF2-40B4-BE49-F238E27FC236}">
-                <a16:creationId xmlns:a16="http://schemas.microsoft.com/office/drawing/2014/main" id="{64FCDFCD-0645-4D0B-8461-A1F66F01A6BA}"/>
+                <a16:creationId xmlns:a16="http://schemas.microsoft.com/office/drawing/2014/main" id="{AB62E838-9CA2-41C9-9833-6E8DFFA36C19}"/>
               </a:ext>
             </a:extLst>
           </p:cNvPr>
@@ -6885,7 +6885,7 @@
           <p:cNvPr id="16" name="workflow-step-5">
             <a:extLst xmlns:a="http://schemas.openxmlformats.org/drawingml/2006/main">
               <a:ext uri="{FF2B5EF4-FFF2-40B4-BE49-F238E27FC236}">
-                <a16:creationId xmlns:a16="http://schemas.microsoft.com/office/drawing/2014/main" id="{688CD65B-C2D6-4FAF-8F43-ACCE26A1AF67}"/>
+                <a16:creationId xmlns:a16="http://schemas.microsoft.com/office/drawing/2014/main" id="{CEF3956A-9AA5-4607-A7AF-B5A7C578A12A}"/>
               </a:ext>
             </a:extLst>
           </p:cNvPr>
@@ -6941,7 +6941,7 @@
     </p:spTree>
     <p:extLst>
       <p:ext uri="{BB962C8B-B14F-4D97-AF65-F5344CB8AC3E}">
-        <p14:creationId xmlns:p14="http://schemas.microsoft.com/office/powerpoint/2010/main" val="1214121636"/>
+        <p14:creationId xmlns:p14="http://schemas.microsoft.com/office/powerpoint/2010/main" val="1176288002"/>
       </p:ext>
     </p:extLst>
   </p:cSld>
@@ -6972,7 +6972,7 @@
           <p:cNvPr id="16" name="brand-6">
             <a:extLst xmlns:a="http://schemas.openxmlformats.org/drawingml/2006/main">
               <a:ext uri="{FF2B5EF4-FFF2-40B4-BE49-F238E27FC236}">
-                <a16:creationId xmlns:a16="http://schemas.microsoft.com/office/drawing/2014/main" id="{BDE91300-AEEA-4819-A1E1-01ECB09A4B49}"/>
+                <a16:creationId xmlns:a16="http://schemas.microsoft.com/office/drawing/2014/main" id="{1D16B1B1-2FB8-4E41-ADF3-3A0721C1688E}"/>
               </a:ext>
             </a:extLst>
           </p:cNvPr>
@@ -7030,7 +7030,7 @@
           <p:cNvPr id="2" name="title-6">
             <a:extLst xmlns:a="http://schemas.openxmlformats.org/drawingml/2006/main">
               <a:ext uri="{FF2B5EF4-FFF2-40B4-BE49-F238E27FC236}">
-                <a16:creationId xmlns:a16="http://schemas.microsoft.com/office/drawing/2014/main" id="{2A86D89A-2ABF-4E12-91AE-CEEBEC7214D2}"/>
+                <a16:creationId xmlns:a16="http://schemas.microsoft.com/office/drawing/2014/main" id="{D6B0749F-B29D-458F-9D0D-224B9DA6C96D}"/>
               </a:ext>
             </a:extLst>
           </p:cNvPr>
@@ -7088,7 +7088,7 @@
           <p:cNvPr id="3" name="footer-rule-6">
             <a:extLst xmlns:a="http://schemas.openxmlformats.org/drawingml/2006/main">
               <a:ext uri="{FF2B5EF4-FFF2-40B4-BE49-F238E27FC236}">
-                <a16:creationId xmlns:a16="http://schemas.microsoft.com/office/drawing/2014/main" id="{5C4E2F7D-1C6C-4FB9-B0AF-EB1182A3A770}"/>
+                <a16:creationId xmlns:a16="http://schemas.microsoft.com/office/drawing/2014/main" id="{0A8D0246-45A9-4B91-A3C5-8A460700765E}"/>
               </a:ext>
             </a:extLst>
           </p:cNvPr>
@@ -7119,7 +7119,7 @@
           <p:cNvPr id="4" name="footer-source-6">
             <a:extLst xmlns:a="http://schemas.openxmlformats.org/drawingml/2006/main">
               <a:ext uri="{FF2B5EF4-FFF2-40B4-BE49-F238E27FC236}">
-                <a16:creationId xmlns:a16="http://schemas.microsoft.com/office/drawing/2014/main" id="{85388F93-08BE-4DEA-B350-BC9B52A5FBDC}"/>
+                <a16:creationId xmlns:a16="http://schemas.microsoft.com/office/drawing/2014/main" id="{464F718D-1242-43E0-8CA3-55EB55340F8E}"/>
               </a:ext>
             </a:extLst>
           </p:cNvPr>
@@ -7177,7 +7177,7 @@
           <p:cNvPr id="5" name="footer-page-6">
             <a:extLst xmlns:a="http://schemas.openxmlformats.org/drawingml/2006/main">
               <a:ext uri="{FF2B5EF4-FFF2-40B4-BE49-F238E27FC236}">
-                <a16:creationId xmlns:a16="http://schemas.microsoft.com/office/drawing/2014/main" id="{0CCC41E0-1FA3-40DC-8FDB-1EA36E5219E4}"/>
+                <a16:creationId xmlns:a16="http://schemas.microsoft.com/office/drawing/2014/main" id="{E15AFA2E-99B6-45C9-9A8C-51C086D8F79D}"/>
               </a:ext>
             </a:extLst>
           </p:cNvPr>
@@ -7235,7 +7235,7 @@
           <p:cNvPr id="6" name="agent-trace-label">
             <a:extLst xmlns:a="http://schemas.openxmlformats.org/drawingml/2006/main">
               <a:ext uri="{FF2B5EF4-FFF2-40B4-BE49-F238E27FC236}">
-                <a16:creationId xmlns:a16="http://schemas.microsoft.com/office/drawing/2014/main" id="{1F43A5A6-5DF6-41DB-B800-95EFAC0349C1}"/>
+                <a16:creationId xmlns:a16="http://schemas.microsoft.com/office/drawing/2014/main" id="{AF88FC5B-3297-4E0F-AFE0-FF2C31F32B38}"/>
               </a:ext>
             </a:extLst>
           </p:cNvPr>
@@ -7293,7 +7293,7 @@
           <p:cNvPr id="7" name="agent-trace-spine">
             <a:extLst xmlns:a="http://schemas.openxmlformats.org/drawingml/2006/main">
               <a:ext uri="{FF2B5EF4-FFF2-40B4-BE49-F238E27FC236}">
-                <a16:creationId xmlns:a16="http://schemas.microsoft.com/office/drawing/2014/main" id="{AED06A9F-E31C-4DE2-A32E-85CC35DAE098}"/>
+                <a16:creationId xmlns:a16="http://schemas.microsoft.com/office/drawing/2014/main" id="{F24CA72F-AE1F-4238-8017-FBE89FB5CF21}"/>
               </a:ext>
             </a:extLst>
           </p:cNvPr>
@@ -7324,7 +7324,7 @@
           <p:cNvPr id="8" name="agent-propose">
             <a:extLst xmlns:a="http://schemas.openxmlformats.org/drawingml/2006/main">
               <a:ext uri="{FF2B5EF4-FFF2-40B4-BE49-F238E27FC236}">
-                <a16:creationId xmlns:a16="http://schemas.microsoft.com/office/drawing/2014/main" id="{14A01665-BAC3-4BCC-ADFE-F10DF98A726A}"/>
+                <a16:creationId xmlns:a16="http://schemas.microsoft.com/office/drawing/2014/main" id="{744BA642-E9AB-464C-8B25-2962C3071422}"/>
               </a:ext>
             </a:extLst>
           </p:cNvPr>
@@ -7382,7 +7382,7 @@
           <p:cNvPr id="9" name="agent-propose-copy">
             <a:extLst xmlns:a="http://schemas.openxmlformats.org/drawingml/2006/main">
               <a:ext uri="{FF2B5EF4-FFF2-40B4-BE49-F238E27FC236}">
-                <a16:creationId xmlns:a16="http://schemas.microsoft.com/office/drawing/2014/main" id="{5FD3012E-4E40-46A1-A6B8-C9008D9CBE8F}"/>
+                <a16:creationId xmlns:a16="http://schemas.microsoft.com/office/drawing/2014/main" id="{6465D55D-E20D-4B79-BC46-3D93279FE387}"/>
               </a:ext>
             </a:extLst>
           </p:cNvPr>
@@ -7440,7 +7440,7 @@
           <p:cNvPr id="10" name="agent-abstain">
             <a:extLst xmlns:a="http://schemas.openxmlformats.org/drawingml/2006/main">
               <a:ext uri="{FF2B5EF4-FFF2-40B4-BE49-F238E27FC236}">
-                <a16:creationId xmlns:a16="http://schemas.microsoft.com/office/drawing/2014/main" id="{5FA0D4DE-5B6A-4455-AAC6-EA3FEAADCCDC}"/>
+                <a16:creationId xmlns:a16="http://schemas.microsoft.com/office/drawing/2014/main" id="{36FB67B7-7E14-4685-984B-D1AD76280B64}"/>
               </a:ext>
             </a:extLst>
           </p:cNvPr>
@@ -7498,7 +7498,7 @@
           <p:cNvPr id="11" name="agent-abstain-copy">
             <a:extLst xmlns:a="http://schemas.openxmlformats.org/drawingml/2006/main">
               <a:ext uri="{FF2B5EF4-FFF2-40B4-BE49-F238E27FC236}">
-                <a16:creationId xmlns:a16="http://schemas.microsoft.com/office/drawing/2014/main" id="{519E0572-D19A-4E03-BDA7-A24960D35313}"/>
+                <a16:creationId xmlns:a16="http://schemas.microsoft.com/office/drawing/2014/main" id="{9F593706-ED12-4B5C-A40B-5DC57796EFF5}"/>
               </a:ext>
             </a:extLst>
           </p:cNvPr>
@@ -7556,7 +7556,7 @@
           <p:cNvPr id="12" name="agent-decide">
             <a:extLst xmlns:a="http://schemas.openxmlformats.org/drawingml/2006/main">
               <a:ext uri="{FF2B5EF4-FFF2-40B4-BE49-F238E27FC236}">
-                <a16:creationId xmlns:a16="http://schemas.microsoft.com/office/drawing/2014/main" id="{E3D9A3BC-0571-42C9-AB0E-99FA250684FE}"/>
+                <a16:creationId xmlns:a16="http://schemas.microsoft.com/office/drawing/2014/main" id="{5A353405-019C-4C9F-8506-998C79C86725}"/>
               </a:ext>
             </a:extLst>
           </p:cNvPr>
@@ -7614,7 +7614,7 @@
           <p:cNvPr id="13" name="agent-decide-copy">
             <a:extLst xmlns:a="http://schemas.openxmlformats.org/drawingml/2006/main">
               <a:ext uri="{FF2B5EF4-FFF2-40B4-BE49-F238E27FC236}">
-                <a16:creationId xmlns:a16="http://schemas.microsoft.com/office/drawing/2014/main" id="{B759E6ED-5C98-4252-89B9-86412A2D4471}"/>
+                <a16:creationId xmlns:a16="http://schemas.microsoft.com/office/drawing/2014/main" id="{E6BA24BF-81D0-4251-98B6-A84E6012DA41}"/>
               </a:ext>
             </a:extLst>
           </p:cNvPr>
@@ -7672,7 +7672,7 @@
           <p:cNvPr id="14" name="agent-boundary-rule">
             <a:extLst xmlns:a="http://schemas.openxmlformats.org/drawingml/2006/main">
               <a:ext uri="{FF2B5EF4-FFF2-40B4-BE49-F238E27FC236}">
-                <a16:creationId xmlns:a16="http://schemas.microsoft.com/office/drawing/2014/main" id="{D63EE846-C5FA-4CDA-95A2-99DA34316BDD}"/>
+                <a16:creationId xmlns:a16="http://schemas.microsoft.com/office/drawing/2014/main" id="{98F06A96-6944-4338-AA42-9811BA9A64E0}"/>
               </a:ext>
             </a:extLst>
           </p:cNvPr>
@@ -7703,7 +7703,7 @@
           <p:cNvPr id="15" name="agent-boundary-copy">
             <a:extLst xmlns:a="http://schemas.openxmlformats.org/drawingml/2006/main">
               <a:ext uri="{FF2B5EF4-FFF2-40B4-BE49-F238E27FC236}">
-                <a16:creationId xmlns:a16="http://schemas.microsoft.com/office/drawing/2014/main" id="{F3FDF385-66C3-49C9-B47C-608665C7DF54}"/>
+                <a16:creationId xmlns:a16="http://schemas.microsoft.com/office/drawing/2014/main" id="{A15D304F-82E4-44FE-BBB3-43CF31590042}"/>
               </a:ext>
             </a:extLst>
           </p:cNvPr>
@@ -7759,7 +7759,7 @@
     </p:spTree>
     <p:extLst>
       <p:ext uri="{BB962C8B-B14F-4D97-AF65-F5344CB8AC3E}">
-        <p14:creationId xmlns:p14="http://schemas.microsoft.com/office/powerpoint/2010/main" val="526058206"/>
+        <p14:creationId xmlns:p14="http://schemas.microsoft.com/office/powerpoint/2010/main" val="1152360368"/>
       </p:ext>
     </p:extLst>
   </p:cSld>
@@ -7790,7 +7790,7 @@
           <p:cNvPr id="15" name="brand-7">
             <a:extLst xmlns:a="http://schemas.openxmlformats.org/drawingml/2006/main">
               <a:ext uri="{FF2B5EF4-FFF2-40B4-BE49-F238E27FC236}">
-                <a16:creationId xmlns:a16="http://schemas.microsoft.com/office/drawing/2014/main" id="{A1E1C9B6-E67E-497B-B849-66B524D6FC1E}"/>
+                <a16:creationId xmlns:a16="http://schemas.microsoft.com/office/drawing/2014/main" id="{E2BCE0D4-44A8-4C15-A986-336DB30EE561}"/>
               </a:ext>
             </a:extLst>
           </p:cNvPr>
@@ -7848,7 +7848,7 @@
           <p:cNvPr id="2" name="title-7">
             <a:extLst xmlns:a="http://schemas.openxmlformats.org/drawingml/2006/main">
               <a:ext uri="{FF2B5EF4-FFF2-40B4-BE49-F238E27FC236}">
-                <a16:creationId xmlns:a16="http://schemas.microsoft.com/office/drawing/2014/main" id="{B596BE8A-2B11-4F32-B428-D38E85F0924F}"/>
+                <a16:creationId xmlns:a16="http://schemas.microsoft.com/office/drawing/2014/main" id="{BDEADBE9-F76B-46B0-969B-79E69B85E21D}"/>
               </a:ext>
             </a:extLst>
           </p:cNvPr>
@@ -7906,7 +7906,7 @@
           <p:cNvPr id="3" name="footer-rule-7">
             <a:extLst xmlns:a="http://schemas.openxmlformats.org/drawingml/2006/main">
               <a:ext uri="{FF2B5EF4-FFF2-40B4-BE49-F238E27FC236}">
-                <a16:creationId xmlns:a16="http://schemas.microsoft.com/office/drawing/2014/main" id="{0A0C0DC9-6964-4FFE-AFE9-B026C695D0A4}"/>
+                <a16:creationId xmlns:a16="http://schemas.microsoft.com/office/drawing/2014/main" id="{8055BC13-BCEB-4087-8B7A-C64E6659A923}"/>
               </a:ext>
             </a:extLst>
           </p:cNvPr>
@@ -7937,7 +7937,7 @@
           <p:cNvPr id="4" name="footer-source-7">
             <a:extLst xmlns:a="http://schemas.openxmlformats.org/drawingml/2006/main">
               <a:ext uri="{FF2B5EF4-FFF2-40B4-BE49-F238E27FC236}">
-                <a16:creationId xmlns:a16="http://schemas.microsoft.com/office/drawing/2014/main" id="{D5DCDDFB-D422-412E-A449-4E2574436912}"/>
+                <a16:creationId xmlns:a16="http://schemas.microsoft.com/office/drawing/2014/main" id="{C67693F0-3BB6-440A-BA5C-54FBACCA1753}"/>
               </a:ext>
             </a:extLst>
           </p:cNvPr>
@@ -7995,7 +7995,7 @@
           <p:cNvPr id="5" name="footer-page-7">
             <a:extLst xmlns:a="http://schemas.openxmlformats.org/drawingml/2006/main">
               <a:ext uri="{FF2B5EF4-FFF2-40B4-BE49-F238E27FC236}">
-                <a16:creationId xmlns:a16="http://schemas.microsoft.com/office/drawing/2014/main" id="{DEB05FFE-BA6B-4D7B-A621-A89D3FE89FFE}"/>
+                <a16:creationId xmlns:a16="http://schemas.microsoft.com/office/drawing/2014/main" id="{7F950B24-5174-4589-9B90-9506047A9B03}"/>
               </a:ext>
             </a:extLst>
           </p:cNvPr>
@@ -8053,7 +8053,7 @@
           <p:cNvPr id="6" name="prototype-proof-label">
             <a:extLst xmlns:a="http://schemas.openxmlformats.org/drawingml/2006/main">
               <a:ext uri="{FF2B5EF4-FFF2-40B4-BE49-F238E27FC236}">
-                <a16:creationId xmlns:a16="http://schemas.microsoft.com/office/drawing/2014/main" id="{1D0311B3-51FB-4109-BC17-786AC209684C}"/>
+                <a16:creationId xmlns:a16="http://schemas.microsoft.com/office/drawing/2014/main" id="{3FCD8AC6-592D-4242-AAEA-6BBB40099515}"/>
               </a:ext>
             </a:extLst>
           </p:cNvPr>
@@ -8115,7 +8115,7 @@
           <p:nvPr/>
         </p:nvPicPr>
         <p:blipFill>
-          <a:blip xmlns:r="http://schemas.openxmlformats.org/officeDocument/2006/relationships" xmlns:a="http://schemas.openxmlformats.org/drawingml/2006/main" r:embed="R686740e650fc4f7c"/>
+          <a:blip xmlns:r="http://schemas.openxmlformats.org/officeDocument/2006/relationships" xmlns:a="http://schemas.openxmlformats.org/drawingml/2006/main" r:embed="R5af87368242f4434"/>
           <a:srcRect xmlns:a="http://schemas.openxmlformats.org/drawingml/2006/main" l="0" t="9" r="0" b="9"/>
           <a:stretch xmlns:a="http://schemas.openxmlformats.org/drawingml/2006/main">
             <a:fillRect l="0" t="0" r="0" b="0"/>
@@ -8136,7 +8136,7 @@
           <p:cNvPr id="8" name="prototype-conflict-border">
             <a:extLst xmlns:a="http://schemas.openxmlformats.org/drawingml/2006/main">
               <a:ext uri="{FF2B5EF4-FFF2-40B4-BE49-F238E27FC236}">
-                <a16:creationId xmlns:a16="http://schemas.microsoft.com/office/drawing/2014/main" id="{0FE1E28A-A021-428D-8A48-17C20CE682C6}"/>
+                <a16:creationId xmlns:a16="http://schemas.microsoft.com/office/drawing/2014/main" id="{52982A98-C98E-425A-8680-C7D20CB53ECC}"/>
               </a:ext>
             </a:extLst>
           </p:cNvPr>
@@ -8171,7 +8171,7 @@
           <p:nvPr/>
         </p:nvPicPr>
         <p:blipFill>
-          <a:blip xmlns:r="http://schemas.openxmlformats.org/officeDocument/2006/relationships" xmlns:a="http://schemas.openxmlformats.org/drawingml/2006/main" r:embed="R717042d5d0204ad4"/>
+          <a:blip xmlns:r="http://schemas.openxmlformats.org/officeDocument/2006/relationships" xmlns:a="http://schemas.openxmlformats.org/drawingml/2006/main" r:embed="R5991bfc67f8d40e2"/>
           <a:srcRect xmlns:a="http://schemas.openxmlformats.org/drawingml/2006/main" l="19" t="0" r="19" b="0"/>
           <a:stretch xmlns:a="http://schemas.openxmlformats.org/drawingml/2006/main">
             <a:fillRect l="0" t="0" r="0" b="0"/>
@@ -8192,7 +8192,7 @@
           <p:cNvPr id="10" name="prototype-receipt-border">
             <a:extLst xmlns:a="http://schemas.openxmlformats.org/drawingml/2006/main">
               <a:ext uri="{FF2B5EF4-FFF2-40B4-BE49-F238E27FC236}">
-                <a16:creationId xmlns:a16="http://schemas.microsoft.com/office/drawing/2014/main" id="{33298CAB-3FEB-478A-94E2-A64F1154DCCA}"/>
+                <a16:creationId xmlns:a16="http://schemas.microsoft.com/office/drawing/2014/main" id="{8FC7D5D9-8FF8-47C5-9C5C-177AC283A3ED}"/>
               </a:ext>
             </a:extLst>
           </p:cNvPr>
@@ -8223,7 +8223,7 @@
           <p:cNvPr id="11" name="prototype-callout-1">
             <a:extLst xmlns:a="http://schemas.openxmlformats.org/drawingml/2006/main">
               <a:ext uri="{FF2B5EF4-FFF2-40B4-BE49-F238E27FC236}">
-                <a16:creationId xmlns:a16="http://schemas.microsoft.com/office/drawing/2014/main" id="{54382E01-7EF3-417C-88E3-07C6A6447234}"/>
+                <a16:creationId xmlns:a16="http://schemas.microsoft.com/office/drawing/2014/main" id="{ADD48A61-FFEA-484C-BF42-A23C03E81BB8}"/>
               </a:ext>
             </a:extLst>
           </p:cNvPr>
@@ -8281,7 +8281,7 @@
           <p:cNvPr id="12" name="prototype-callout-2">
             <a:extLst xmlns:a="http://schemas.openxmlformats.org/drawingml/2006/main">
               <a:ext uri="{FF2B5EF4-FFF2-40B4-BE49-F238E27FC236}">
-                <a16:creationId xmlns:a16="http://schemas.microsoft.com/office/drawing/2014/main" id="{453974C6-54A9-4A12-876A-0A50B7B28EDE}"/>
+                <a16:creationId xmlns:a16="http://schemas.microsoft.com/office/drawing/2014/main" id="{2690611F-7F7D-4B62-BAA6-A7BD41FD44FF}"/>
               </a:ext>
             </a:extLst>
           </p:cNvPr>
@@ -8339,7 +8339,7 @@
           <p:cNvPr id="13" name="prototype-callout-3">
             <a:extLst xmlns:a="http://schemas.openxmlformats.org/drawingml/2006/main">
               <a:ext uri="{FF2B5EF4-FFF2-40B4-BE49-F238E27FC236}">
-                <a16:creationId xmlns:a16="http://schemas.microsoft.com/office/drawing/2014/main" id="{7B6FE59D-CB03-4AF9-B46A-62F1E2196FE2}"/>
+                <a16:creationId xmlns:a16="http://schemas.microsoft.com/office/drawing/2014/main" id="{283AB623-BF26-48C2-9291-ED8B02F056D4}"/>
               </a:ext>
             </a:extLst>
           </p:cNvPr>
@@ -8397,7 +8397,7 @@
           <p:cNvPr id="14" name="prototype-callout-4">
             <a:extLst xmlns:a="http://schemas.openxmlformats.org/drawingml/2006/main">
               <a:ext uri="{FF2B5EF4-FFF2-40B4-BE49-F238E27FC236}">
-                <a16:creationId xmlns:a16="http://schemas.microsoft.com/office/drawing/2014/main" id="{626D0704-1EEB-410D-B33A-D62912B8FB20}"/>
+                <a16:creationId xmlns:a16="http://schemas.microsoft.com/office/drawing/2014/main" id="{83565B9E-4FB2-4242-A174-6FBBC1C853E3}"/>
               </a:ext>
             </a:extLst>
           </p:cNvPr>
@@ -8453,7 +8453,7 @@
     </p:spTree>
     <p:extLst>
       <p:ext uri="{BB962C8B-B14F-4D97-AF65-F5344CB8AC3E}">
-        <p14:creationId xmlns:p14="http://schemas.microsoft.com/office/powerpoint/2010/main" val="462260120"/>
+        <p14:creationId xmlns:p14="http://schemas.microsoft.com/office/powerpoint/2010/main" val="1440311214"/>
       </p:ext>
     </p:extLst>
   </p:cSld>
@@ -8484,7 +8484,7 @@
           <p:cNvPr id="24" name="brand-8">
             <a:extLst xmlns:a="http://schemas.openxmlformats.org/drawingml/2006/main">
               <a:ext uri="{FF2B5EF4-FFF2-40B4-BE49-F238E27FC236}">
-                <a16:creationId xmlns:a16="http://schemas.microsoft.com/office/drawing/2014/main" id="{9385E0F0-4B50-4105-930F-9AEE835B3AEE}"/>
+                <a16:creationId xmlns:a16="http://schemas.microsoft.com/office/drawing/2014/main" id="{C393EB5C-76F7-4FB3-B1F9-9BEDD84CB9EF}"/>
               </a:ext>
             </a:extLst>
           </p:cNvPr>
@@ -8542,7 +8542,7 @@
           <p:cNvPr id="2" name="title-8">
             <a:extLst xmlns:a="http://schemas.openxmlformats.org/drawingml/2006/main">
               <a:ext uri="{FF2B5EF4-FFF2-40B4-BE49-F238E27FC236}">
-                <a16:creationId xmlns:a16="http://schemas.microsoft.com/office/drawing/2014/main" id="{C0CE5AC8-B109-40AE-9DE6-A737D1CDDCA5}"/>
+                <a16:creationId xmlns:a16="http://schemas.microsoft.com/office/drawing/2014/main" id="{056EE1AA-4225-4C0B-8B2D-E94299C03DE2}"/>
               </a:ext>
             </a:extLst>
           </p:cNvPr>
@@ -8600,7 +8600,7 @@
           <p:cNvPr id="3" name="footer-rule-8">
             <a:extLst xmlns:a="http://schemas.openxmlformats.org/drawingml/2006/main">
               <a:ext uri="{FF2B5EF4-FFF2-40B4-BE49-F238E27FC236}">
-                <a16:creationId xmlns:a16="http://schemas.microsoft.com/office/drawing/2014/main" id="{8302B38E-0060-46B6-8C29-31D366B65F8E}"/>
+                <a16:creationId xmlns:a16="http://schemas.microsoft.com/office/drawing/2014/main" id="{244245E5-A828-4D7C-99D9-BA8765CDCA44}"/>
               </a:ext>
             </a:extLst>
           </p:cNvPr>
@@ -8631,7 +8631,7 @@
           <p:cNvPr id="4" name="footer-source-8">
             <a:extLst xmlns:a="http://schemas.openxmlformats.org/drawingml/2006/main">
               <a:ext uri="{FF2B5EF4-FFF2-40B4-BE49-F238E27FC236}">
-                <a16:creationId xmlns:a16="http://schemas.microsoft.com/office/drawing/2014/main" id="{108D24D8-7860-4680-8650-9D85655EF7AB}"/>
+                <a16:creationId xmlns:a16="http://schemas.microsoft.com/office/drawing/2014/main" id="{6A3EA32E-5350-4A41-9E38-5A35F059BC05}"/>
               </a:ext>
             </a:extLst>
           </p:cNvPr>
@@ -8689,7 +8689,7 @@
           <p:cNvPr id="5" name="footer-page-8">
             <a:extLst xmlns:a="http://schemas.openxmlformats.org/drawingml/2006/main">
               <a:ext uri="{FF2B5EF4-FFF2-40B4-BE49-F238E27FC236}">
-                <a16:creationId xmlns:a16="http://schemas.microsoft.com/office/drawing/2014/main" id="{2B52EFE2-B1ED-400E-86E4-48CBC7573BDC}"/>
+                <a16:creationId xmlns:a16="http://schemas.microsoft.com/office/drawing/2014/main" id="{C11D7712-0085-4FF1-9881-D8B32B964238}"/>
               </a:ext>
             </a:extLst>
           </p:cNvPr>
@@ -8747,7 +8747,7 @@
           <p:cNvPr id="6" name="sensitivity-label">
             <a:extLst xmlns:a="http://schemas.openxmlformats.org/drawingml/2006/main">
               <a:ext uri="{FF2B5EF4-FFF2-40B4-BE49-F238E27FC236}">
-                <a16:creationId xmlns:a16="http://schemas.microsoft.com/office/drawing/2014/main" id="{BAD60377-63F2-4D41-97EE-40FB18E1D69B}"/>
+                <a16:creationId xmlns:a16="http://schemas.microsoft.com/office/drawing/2014/main" id="{E58C721B-1F66-4218-8B26-A62F23717336}"/>
               </a:ext>
             </a:extLst>
           </p:cNvPr>
@@ -8805,7 +8805,7 @@
           <p:cNvPr id="7" name="sensitivity-row-0">
             <a:extLst xmlns:a="http://schemas.openxmlformats.org/drawingml/2006/main">
               <a:ext uri="{FF2B5EF4-FFF2-40B4-BE49-F238E27FC236}">
-                <a16:creationId xmlns:a16="http://schemas.microsoft.com/office/drawing/2014/main" id="{60064A4B-802C-41F3-85C9-F5CEE8422411}"/>
+                <a16:creationId xmlns:a16="http://schemas.microsoft.com/office/drawing/2014/main" id="{9A68329D-752D-40D7-8657-152C8ADC37EE}"/>
               </a:ext>
             </a:extLst>
           </p:cNvPr>
@@ -8836,7 +8836,7 @@
           <p:cNvPr id="8" name="sensitivity-0-0">
             <a:extLst xmlns:a="http://schemas.openxmlformats.org/drawingml/2006/main">
               <a:ext uri="{FF2B5EF4-FFF2-40B4-BE49-F238E27FC236}">
-                <a16:creationId xmlns:a16="http://schemas.microsoft.com/office/drawing/2014/main" id="{522A3949-CFD1-4058-9763-5FFD88C3E31C}"/>
+                <a16:creationId xmlns:a16="http://schemas.microsoft.com/office/drawing/2014/main" id="{BF239B8A-DB38-4178-99B3-1FA94544C393}"/>
               </a:ext>
             </a:extLst>
           </p:cNvPr>
@@ -8894,7 +8894,7 @@
           <p:cNvPr id="9" name="sensitivity-0-1">
             <a:extLst xmlns:a="http://schemas.openxmlformats.org/drawingml/2006/main">
               <a:ext uri="{FF2B5EF4-FFF2-40B4-BE49-F238E27FC236}">
-                <a16:creationId xmlns:a16="http://schemas.microsoft.com/office/drawing/2014/main" id="{2ABAF12D-30DC-43DE-8A83-4C1E1A19F2A3}"/>
+                <a16:creationId xmlns:a16="http://schemas.microsoft.com/office/drawing/2014/main" id="{D7EB377B-A100-4975-83BA-AD4C8803591D}"/>
               </a:ext>
             </a:extLst>
           </p:cNvPr>
@@ -8952,7 +8952,7 @@
           <p:cNvPr id="10" name="sensitivity-0-2">
             <a:extLst xmlns:a="http://schemas.openxmlformats.org/drawingml/2006/main">
               <a:ext uri="{FF2B5EF4-FFF2-40B4-BE49-F238E27FC236}">
-                <a16:creationId xmlns:a16="http://schemas.microsoft.com/office/drawing/2014/main" id="{9E8F5172-E2B0-4F9F-BB1D-DA373BB8258A}"/>
+                <a16:creationId xmlns:a16="http://schemas.microsoft.com/office/drawing/2014/main" id="{1DB424AF-5968-43DA-8185-A0600F6EDB6A}"/>
               </a:ext>
             </a:extLst>
           </p:cNvPr>
@@ -9010,7 +9010,7 @@
           <p:cNvPr id="11" name="sensitivity-row-1">
             <a:extLst xmlns:a="http://schemas.openxmlformats.org/drawingml/2006/main">
               <a:ext uri="{FF2B5EF4-FFF2-40B4-BE49-F238E27FC236}">
-                <a16:creationId xmlns:a16="http://schemas.microsoft.com/office/drawing/2014/main" id="{9EB82347-1098-4413-B242-D27E25A6B844}"/>
+                <a16:creationId xmlns:a16="http://schemas.microsoft.com/office/drawing/2014/main" id="{396D2DCA-D27A-410D-8503-6D5DD9887DB9}"/>
               </a:ext>
             </a:extLst>
           </p:cNvPr>
@@ -9041,7 +9041,7 @@
           <p:cNvPr id="12" name="sensitivity-1-0">
             <a:extLst xmlns:a="http://schemas.openxmlformats.org/drawingml/2006/main">
               <a:ext uri="{FF2B5EF4-FFF2-40B4-BE49-F238E27FC236}">
-                <a16:creationId xmlns:a16="http://schemas.microsoft.com/office/drawing/2014/main" id="{546FD19B-8F5B-4D1D-BFB5-77D5E6723ADC}"/>
+                <a16:creationId xmlns:a16="http://schemas.microsoft.com/office/drawing/2014/main" id="{51F65D88-A456-4409-A904-5DA168DBD233}"/>
               </a:ext>
             </a:extLst>
           </p:cNvPr>
@@ -9099,7 +9099,7 @@
           <p:cNvPr id="13" name="sensitivity-1-1">
             <a:extLst xmlns:a="http://schemas.openxmlformats.org/drawingml/2006/main">
               <a:ext uri="{FF2B5EF4-FFF2-40B4-BE49-F238E27FC236}">
-                <a16:creationId xmlns:a16="http://schemas.microsoft.com/office/drawing/2014/main" id="{BF273F9B-9008-45B7-BD11-2750779286E3}"/>
+                <a16:creationId xmlns:a16="http://schemas.microsoft.com/office/drawing/2014/main" id="{F1D95808-0229-4603-84C6-F02DD582EA04}"/>
               </a:ext>
             </a:extLst>
           </p:cNvPr>
@@ -9157,7 +9157,7 @@
           <p:cNvPr id="14" name="sensitivity-1-2">
             <a:extLst xmlns:a="http://schemas.openxmlformats.org/drawingml/2006/main">
               <a:ext uri="{FF2B5EF4-FFF2-40B4-BE49-F238E27FC236}">
-                <a16:creationId xmlns:a16="http://schemas.microsoft.com/office/drawing/2014/main" id="{6780FE40-5BB0-4856-9C2A-74CF7F69E26F}"/>
+                <a16:creationId xmlns:a16="http://schemas.microsoft.com/office/drawing/2014/main" id="{E4C0A8E2-3D48-463D-9B7B-6B39DFF24273}"/>
               </a:ext>
             </a:extLst>
           </p:cNvPr>
@@ -9215,7 +9215,7 @@
           <p:cNvPr id="15" name="sensitivity-row-2">
             <a:extLst xmlns:a="http://schemas.openxmlformats.org/drawingml/2006/main">
               <a:ext uri="{FF2B5EF4-FFF2-40B4-BE49-F238E27FC236}">
-                <a16:creationId xmlns:a16="http://schemas.microsoft.com/office/drawing/2014/main" id="{11FF56B9-06ED-45E6-A025-73B34AAAFBA2}"/>
+                <a16:creationId xmlns:a16="http://schemas.microsoft.com/office/drawing/2014/main" id="{1D7C3EDB-81BC-4310-AB03-18C09ED7069D}"/>
               </a:ext>
             </a:extLst>
           </p:cNvPr>
@@ -9246,7 +9246,7 @@
           <p:cNvPr id="16" name="sensitivity-2-0">
             <a:extLst xmlns:a="http://schemas.openxmlformats.org/drawingml/2006/main">
               <a:ext uri="{FF2B5EF4-FFF2-40B4-BE49-F238E27FC236}">
-                <a16:creationId xmlns:a16="http://schemas.microsoft.com/office/drawing/2014/main" id="{72CC6D68-390A-4715-9EBA-CD5D31B038F5}"/>
+                <a16:creationId xmlns:a16="http://schemas.microsoft.com/office/drawing/2014/main" id="{DAB92C71-95CF-4872-A6C0-B992C7B58CF6}"/>
               </a:ext>
             </a:extLst>
           </p:cNvPr>
@@ -9304,7 +9304,7 @@
           <p:cNvPr id="17" name="sensitivity-2-1">
             <a:extLst xmlns:a="http://schemas.openxmlformats.org/drawingml/2006/main">
               <a:ext uri="{FF2B5EF4-FFF2-40B4-BE49-F238E27FC236}">
-                <a16:creationId xmlns:a16="http://schemas.microsoft.com/office/drawing/2014/main" id="{B63764D2-A1A1-408F-8030-CDC3ED1A8B00}"/>
+                <a16:creationId xmlns:a16="http://schemas.microsoft.com/office/drawing/2014/main" id="{E87B8FB9-49C2-41A7-939A-55C9BBCC4B34}"/>
               </a:ext>
             </a:extLst>
           </p:cNvPr>
@@ -9362,7 +9362,7 @@
           <p:cNvPr id="18" name="sensitivity-2-2">
             <a:extLst xmlns:a="http://schemas.openxmlformats.org/drawingml/2006/main">
               <a:ext uri="{FF2B5EF4-FFF2-40B4-BE49-F238E27FC236}">
-                <a16:creationId xmlns:a16="http://schemas.microsoft.com/office/drawing/2014/main" id="{D25E0BB6-210C-47B8-82B6-659453809C2B}"/>
+                <a16:creationId xmlns:a16="http://schemas.microsoft.com/office/drawing/2014/main" id="{48CCD3C7-2E44-4F90-9698-CF7857E3884B}"/>
               </a:ext>
             </a:extLst>
           </p:cNvPr>
@@ -9420,7 +9420,7 @@
           <p:cNvPr id="19" name="sensitivity-divider">
             <a:extLst xmlns:a="http://schemas.openxmlformats.org/drawingml/2006/main">
               <a:ext uri="{FF2B5EF4-FFF2-40B4-BE49-F238E27FC236}">
-                <a16:creationId xmlns:a16="http://schemas.microsoft.com/office/drawing/2014/main" id="{CF4DAC7F-0BC4-466D-BAC8-A1CD15E353EF}"/>
+                <a16:creationId xmlns:a16="http://schemas.microsoft.com/office/drawing/2014/main" id="{D0CFAFDA-4F62-49D0-BEC4-34A60A1AB924}"/>
               </a:ext>
             </a:extLst>
           </p:cNvPr>
@@ -9451,7 +9451,7 @@
           <p:cNvPr id="20" name="sensitivity-gates">
             <a:extLst xmlns:a="http://schemas.openxmlformats.org/drawingml/2006/main">
               <a:ext uri="{FF2B5EF4-FFF2-40B4-BE49-F238E27FC236}">
-                <a16:creationId xmlns:a16="http://schemas.microsoft.com/office/drawing/2014/main" id="{3BB6BCF6-A353-43FC-A910-133DC9FE0CB9}"/>
+                <a16:creationId xmlns:a16="http://schemas.microsoft.com/office/drawing/2014/main" id="{40F9F9F8-E982-4C4D-B4D6-2003E8A7761E}"/>
               </a:ext>
             </a:extLst>
           </p:cNvPr>
@@ -9509,7 +9509,7 @@
           <p:cNvPr id="21" name="footer-sensitivity-hypothesis-label">
             <a:extLst xmlns:a="http://schemas.openxmlformats.org/drawingml/2006/main">
               <a:ext uri="{FF2B5EF4-FFF2-40B4-BE49-F238E27FC236}">
-                <a16:creationId xmlns:a16="http://schemas.microsoft.com/office/drawing/2014/main" id="{9865058F-1B48-40F9-A362-F1D0E119FFD4}"/>
+                <a16:creationId xmlns:a16="http://schemas.microsoft.com/office/drawing/2014/main" id="{975121EB-8515-4224-89B9-FC72CAAAEEBA}"/>
               </a:ext>
             </a:extLst>
           </p:cNvPr>
@@ -9567,7 +9567,7 @@
           <p:cNvPr id="22" name="sensitivity-hypothesis">
             <a:extLst xmlns:a="http://schemas.openxmlformats.org/drawingml/2006/main">
               <a:ext uri="{FF2B5EF4-FFF2-40B4-BE49-F238E27FC236}">
-                <a16:creationId xmlns:a16="http://schemas.microsoft.com/office/drawing/2014/main" id="{1EB80EAB-4895-4B18-B75B-182E6F8F1A1E}"/>
+                <a16:creationId xmlns:a16="http://schemas.microsoft.com/office/drawing/2014/main" id="{D3A2EEC9-8916-4EFE-8757-2D986585F77B}"/>
               </a:ext>
             </a:extLst>
           </p:cNvPr>
@@ -9625,7 +9625,7 @@
           <p:cNvPr id="23" name="sensitivity-disclaimer">
             <a:extLst xmlns:a="http://schemas.openxmlformats.org/drawingml/2006/main">
               <a:ext uri="{FF2B5EF4-FFF2-40B4-BE49-F238E27FC236}">
-                <a16:creationId xmlns:a16="http://schemas.microsoft.com/office/drawing/2014/main" id="{D55F80FB-01D6-439B-BF1B-4D7F8396674B}"/>
+                <a16:creationId xmlns:a16="http://schemas.microsoft.com/office/drawing/2014/main" id="{12BAC862-31CA-442E-B9AC-1775979618E7}"/>
               </a:ext>
             </a:extLst>
           </p:cNvPr>
@@ -9681,7 +9681,7 @@
     </p:spTree>
     <p:extLst>
       <p:ext uri="{BB962C8B-B14F-4D97-AF65-F5344CB8AC3E}">
-        <p14:creationId xmlns:p14="http://schemas.microsoft.com/office/powerpoint/2010/main" val="1070236789"/>
+        <p14:creationId xmlns:p14="http://schemas.microsoft.com/office/powerpoint/2010/main" val="2138941659"/>
       </p:ext>
     </p:extLst>
   </p:cSld>
@@ -9712,7 +9712,7 @@
           <p:cNvPr id="13" name="brand-9">
             <a:extLst xmlns:a="http://schemas.openxmlformats.org/drawingml/2006/main">
               <a:ext uri="{FF2B5EF4-FFF2-40B4-BE49-F238E27FC236}">
-                <a16:creationId xmlns:a16="http://schemas.microsoft.com/office/drawing/2014/main" id="{683148D7-0C21-4C22-BC7B-B168DFB1C4CE}"/>
+                <a16:creationId xmlns:a16="http://schemas.microsoft.com/office/drawing/2014/main" id="{5E3FCE95-F6B0-4C3D-87E8-212ACF88E834}"/>
               </a:ext>
             </a:extLst>
           </p:cNvPr>
@@ -9770,7 +9770,7 @@
           <p:cNvPr id="2" name="title-9">
             <a:extLst xmlns:a="http://schemas.openxmlformats.org/drawingml/2006/main">
               <a:ext uri="{FF2B5EF4-FFF2-40B4-BE49-F238E27FC236}">
-                <a16:creationId xmlns:a16="http://schemas.microsoft.com/office/drawing/2014/main" id="{DEA4D588-C8F5-47B8-ACFA-9FA428E2E715}"/>
+                <a16:creationId xmlns:a16="http://schemas.microsoft.com/office/drawing/2014/main" id="{5F5F0988-BBF1-4587-B214-2EB37E7A6A88}"/>
               </a:ext>
             </a:extLst>
           </p:cNvPr>
@@ -9828,7 +9828,7 @@
           <p:cNvPr id="3" name="footer-rule-9">
             <a:extLst xmlns:a="http://schemas.openxmlformats.org/drawingml/2006/main">
               <a:ext uri="{FF2B5EF4-FFF2-40B4-BE49-F238E27FC236}">
-                <a16:creationId xmlns:a16="http://schemas.microsoft.com/office/drawing/2014/main" id="{1EE0E0F8-544A-4C51-B83B-C82DD670D29E}"/>
+                <a16:creationId xmlns:a16="http://schemas.microsoft.com/office/drawing/2014/main" id="{4D275454-BC12-4803-A876-ECFDB5F336C4}"/>
               </a:ext>
             </a:extLst>
           </p:cNvPr>
@@ -9859,7 +9859,7 @@
           <p:cNvPr id="4" name="footer-source-9">
             <a:extLst xmlns:a="http://schemas.openxmlformats.org/drawingml/2006/main">
               <a:ext uri="{FF2B5EF4-FFF2-40B4-BE49-F238E27FC236}">
-                <a16:creationId xmlns:a16="http://schemas.microsoft.com/office/drawing/2014/main" id="{D68F26DC-D339-4410-BE96-D2DC9D66B696}"/>
+                <a16:creationId xmlns:a16="http://schemas.microsoft.com/office/drawing/2014/main" id="{29D24269-69B0-4931-966B-EB5B8575A267}"/>
               </a:ext>
             </a:extLst>
           </p:cNvPr>
@@ -9917,7 +9917,7 @@
           <p:cNvPr id="5" name="footer-page-9">
             <a:extLst xmlns:a="http://schemas.openxmlformats.org/drawingml/2006/main">
               <a:ext uri="{FF2B5EF4-FFF2-40B4-BE49-F238E27FC236}">
-                <a16:creationId xmlns:a16="http://schemas.microsoft.com/office/drawing/2014/main" id="{2628C3C1-6982-49CE-91EE-31867104A662}"/>
+                <a16:creationId xmlns:a16="http://schemas.microsoft.com/office/drawing/2014/main" id="{5689CE29-1D90-4B60-B12D-BE2D67123A9A}"/>
               </a:ext>
             </a:extLst>
           </p:cNvPr>
@@ -9975,7 +9975,7 @@
           <p:cNvPr id="6" name="ownership-divider">
             <a:extLst xmlns:a="http://schemas.openxmlformats.org/drawingml/2006/main">
               <a:ext uri="{FF2B5EF4-FFF2-40B4-BE49-F238E27FC236}">
-                <a16:creationId xmlns:a16="http://schemas.microsoft.com/office/drawing/2014/main" id="{77EA703D-79F4-4508-91EF-377D1B44E413}"/>
+                <a16:creationId xmlns:a16="http://schemas.microsoft.com/office/drawing/2014/main" id="{69F3A8AE-CA80-4EA6-B781-667BB141B5E8}"/>
               </a:ext>
             </a:extLst>
           </p:cNvPr>
@@ -10006,7 +10006,7 @@
           <p:cNvPr id="7" name="ownership-ayush-label">
             <a:extLst xmlns:a="http://schemas.openxmlformats.org/drawingml/2006/main">
               <a:ext uri="{FF2B5EF4-FFF2-40B4-BE49-F238E27FC236}">
-                <a16:creationId xmlns:a16="http://schemas.microsoft.com/office/drawing/2014/main" id="{ED27CB52-DD02-44B4-85D6-5BF2FFF251B1}"/>
+                <a16:creationId xmlns:a16="http://schemas.microsoft.com/office/drawing/2014/main" id="{B7492922-6295-49BD-A8A5-5E034DE3578B}"/>
               </a:ext>
             </a:extLst>
           </p:cNvPr>
@@ -10064,7 +10064,7 @@
           <p:cNvPr id="8" name="ownership-ayush-copy">
             <a:extLst xmlns:a="http://schemas.openxmlformats.org/drawingml/2006/main">
               <a:ext uri="{FF2B5EF4-FFF2-40B4-BE49-F238E27FC236}">
-                <a16:creationId xmlns:a16="http://schemas.microsoft.com/office/drawing/2014/main" id="{1C51E47D-D686-4AEE-8955-BBE4457FC4C9}"/>
+                <a16:creationId xmlns:a16="http://schemas.microsoft.com/office/drawing/2014/main" id="{62C6EF1D-78F9-442B-BEFF-DAA3658F3E91}"/>
               </a:ext>
             </a:extLst>
           </p:cNvPr>
@@ -10122,7 +10122,7 @@
           <p:cNvPr id="9" name="ownership-finance-label">
             <a:extLst xmlns:a="http://schemas.openxmlformats.org/drawingml/2006/main">
               <a:ext uri="{FF2B5EF4-FFF2-40B4-BE49-F238E27FC236}">
-                <a16:creationId xmlns:a16="http://schemas.microsoft.com/office/drawing/2014/main" id="{017232C9-F113-4C92-BACE-07D46F0CC57F}"/>
+                <a16:creationId xmlns:a16="http://schemas.microsoft.com/office/drawing/2014/main" id="{08ECCB14-61B2-4254-9232-2CD072403E95}"/>
               </a:ext>
             </a:extLst>
           </p:cNvPr>
@@ -10180,7 +10180,7 @@
           <p:cNvPr id="10" name="ownership-finance-copy">
             <a:extLst xmlns:a="http://schemas.openxmlformats.org/drawingml/2006/main">
               <a:ext uri="{FF2B5EF4-FFF2-40B4-BE49-F238E27FC236}">
-                <a16:creationId xmlns:a16="http://schemas.microsoft.com/office/drawing/2014/main" id="{BEB8A2E8-F9EF-4366-8542-09072E5A4891}"/>
+                <a16:creationId xmlns:a16="http://schemas.microsoft.com/office/drawing/2014/main" id="{632FA287-4005-4C75-BAF4-80A6B6DC8788}"/>
               </a:ext>
             </a:extLst>
           </p:cNvPr>
@@ -10238,7 +10238,7 @@
           <p:cNvPr id="11" name="ownership-gate-band">
             <a:extLst xmlns:a="http://schemas.openxmlformats.org/drawingml/2006/main">
               <a:ext uri="{FF2B5EF4-FFF2-40B4-BE49-F238E27FC236}">
-                <a16:creationId xmlns:a16="http://schemas.microsoft.com/office/drawing/2014/main" id="{186EDFBF-F074-409C-AB02-41C48300E403}"/>
+                <a16:creationId xmlns:a16="http://schemas.microsoft.com/office/drawing/2014/main" id="{B9667BE7-CB82-48BA-8634-6B69C1914874}"/>
               </a:ext>
             </a:extLst>
           </p:cNvPr>
@@ -10271,7 +10271,7 @@
           <p:cNvPr id="12" name="ownership-gate">
             <a:extLst xmlns:a="http://schemas.openxmlformats.org/drawingml/2006/main">
               <a:ext uri="{FF2B5EF4-FFF2-40B4-BE49-F238E27FC236}">
-                <a16:creationId xmlns:a16="http://schemas.microsoft.com/office/drawing/2014/main" id="{CF523057-8482-422A-8536-EA34C4245B74}"/>
+                <a16:creationId xmlns:a16="http://schemas.microsoft.com/office/drawing/2014/main" id="{E79403AA-6A34-44DB-BF09-27F0347C57C9}"/>
               </a:ext>
             </a:extLst>
           </p:cNvPr>
@@ -10327,7 +10327,7 @@
     </p:spTree>
     <p:extLst>
       <p:ext uri="{BB962C8B-B14F-4D97-AF65-F5344CB8AC3E}">
-        <p14:creationId xmlns:p14="http://schemas.microsoft.com/office/powerpoint/2010/main" val="1978350242"/>
+        <p14:creationId xmlns:p14="http://schemas.microsoft.com/office/powerpoint/2010/main" val="1244912320"/>
       </p:ext>
     </p:extLst>
   </p:cSld>

</xml_diff>

<commit_message>
release: final submission package with demo personas, guided walkthrough, and complete README
</commit_message>
<xml_diff>
--- a/deck/KRISEVA_ATTEST_GIFT_2026.pptx
+++ b/deck/KRISEVA_ATTEST_GIFT_2026.pptx
@@ -2,22 +2,22 @@
 <file path=ppt/presentation.xml><?xml version="1.0" encoding="utf-8"?>
 <p:presentation xmlns:p="http://schemas.openxmlformats.org/presentationml/2006/main">
   <p:sldMasterIdLst>
-    <p:sldMasterId xmlns:r="http://schemas.openxmlformats.org/officeDocument/2006/relationships" id="2147483648" r:id="Rf3227bbac48c4fc8"/>
+    <p:sldMasterId xmlns:r="http://schemas.openxmlformats.org/officeDocument/2006/relationships" id="2147483648" r:id="R0041bb2eca3e4204"/>
   </p:sldMasterIdLst>
   <p:notesMasterIdLst>
-    <p:notesMasterId xmlns:r="http://schemas.openxmlformats.org/officeDocument/2006/relationships" r:id="Rb6fbf07064cb4d22"/>
+    <p:notesMasterId xmlns:r="http://schemas.openxmlformats.org/officeDocument/2006/relationships" r:id="Rf55acdc3a1c54409"/>
   </p:notesMasterIdLst>
   <p:sldIdLst>
-    <p:sldId xmlns:r="http://schemas.openxmlformats.org/officeDocument/2006/relationships" id="256" r:id="R96266747072f41e6"/>
-    <p:sldId xmlns:r="http://schemas.openxmlformats.org/officeDocument/2006/relationships" id="257" r:id="R158506ae99c8497e"/>
-    <p:sldId xmlns:r="http://schemas.openxmlformats.org/officeDocument/2006/relationships" id="258" r:id="Re9a0b82851bf4788"/>
-    <p:sldId xmlns:r="http://schemas.openxmlformats.org/officeDocument/2006/relationships" id="259" r:id="Rcf72f3a179fb49a5"/>
-    <p:sldId xmlns:r="http://schemas.openxmlformats.org/officeDocument/2006/relationships" id="260" r:id="R4dde3d9cfa5d4745"/>
-    <p:sldId xmlns:r="http://schemas.openxmlformats.org/officeDocument/2006/relationships" id="261" r:id="Rb7963c4aed304f86"/>
-    <p:sldId xmlns:r="http://schemas.openxmlformats.org/officeDocument/2006/relationships" id="262" r:id="R5338240f51d04577"/>
-    <p:sldId xmlns:r="http://schemas.openxmlformats.org/officeDocument/2006/relationships" id="263" r:id="R98aec4958a1e4252"/>
-    <p:sldId xmlns:r="http://schemas.openxmlformats.org/officeDocument/2006/relationships" id="264" r:id="R302ad8efb92540ab"/>
-    <p:sldId xmlns:r="http://schemas.openxmlformats.org/officeDocument/2006/relationships" id="265" r:id="Rb83628f4ef794bb2"/>
+    <p:sldId xmlns:r="http://schemas.openxmlformats.org/officeDocument/2006/relationships" id="256" r:id="R6aa22112ae424434"/>
+    <p:sldId xmlns:r="http://schemas.openxmlformats.org/officeDocument/2006/relationships" id="257" r:id="R7eb1c9f10cd341b0"/>
+    <p:sldId xmlns:r="http://schemas.openxmlformats.org/officeDocument/2006/relationships" id="258" r:id="R7d32c8a5b6484b21"/>
+    <p:sldId xmlns:r="http://schemas.openxmlformats.org/officeDocument/2006/relationships" id="259" r:id="Rd6f3bdd642044fde"/>
+    <p:sldId xmlns:r="http://schemas.openxmlformats.org/officeDocument/2006/relationships" id="260" r:id="R588cbf08494443c0"/>
+    <p:sldId xmlns:r="http://schemas.openxmlformats.org/officeDocument/2006/relationships" id="261" r:id="Rea90a5687dc3446d"/>
+    <p:sldId xmlns:r="http://schemas.openxmlformats.org/officeDocument/2006/relationships" id="262" r:id="R73d508ac850f43bc"/>
+    <p:sldId xmlns:r="http://schemas.openxmlformats.org/officeDocument/2006/relationships" id="263" r:id="Rb56e0cfadbb04c85"/>
+    <p:sldId xmlns:r="http://schemas.openxmlformats.org/officeDocument/2006/relationships" id="264" r:id="R413eb121d91a4ae7"/>
+    <p:sldId xmlns:r="http://schemas.openxmlformats.org/officeDocument/2006/relationships" id="265" r:id="Rb5fe6f79a6194d54"/>
   </p:sldIdLst>
   <p:sldSz cx="12192000" cy="6858000"/>
   <p:notesSz cx="6858000" cy="9144000"/>
@@ -1339,7 +1339,7 @@
   </p:cSld>
   <p:clrMap bg1="lt1" tx1="dk1" bg2="lt2" tx2="dk2" accent1="accent1" accent2="accent2" accent3="accent3" accent4="accent4" accent5="accent5" accent6="accent6" hlink="hlink" folHlink="folHlink"/>
   <p:sldLayoutIdLst>
-    <p:sldLayoutId xmlns:r="http://schemas.openxmlformats.org/officeDocument/2006/relationships" id="2147483649" r:id="Rc2fa58d1cd0a409a"/>
+    <p:sldLayoutId xmlns:r="http://schemas.openxmlformats.org/officeDocument/2006/relationships" id="2147483649" r:id="Rc778e3692527432e"/>
   </p:sldLayoutIdLst>
   <p:txStyles>
     <p:titleStyle>
@@ -1890,7 +1890,7 @@
           <p:cNvPr id="13" name="cover-navy-field">
             <a:extLst xmlns:a="http://schemas.openxmlformats.org/drawingml/2006/main">
               <a:ext uri="{FF2B5EF4-FFF2-40B4-BE49-F238E27FC236}">
-                <a16:creationId xmlns:a16="http://schemas.microsoft.com/office/drawing/2014/main" id="{ECAE0C58-9A95-4EB7-B6E3-A66CC1B9153C}"/>
+                <a16:creationId xmlns:a16="http://schemas.microsoft.com/office/drawing/2014/main" id="{1E03D334-A29E-4FD2-AF63-697903736AB9}"/>
               </a:ext>
             </a:extLst>
           </p:cNvPr>
@@ -1923,7 +1923,7 @@
           <p:cNvPr id="2" name="cover-brass-spine">
             <a:extLst xmlns:a="http://schemas.openxmlformats.org/drawingml/2006/main">
               <a:ext uri="{FF2B5EF4-FFF2-40B4-BE49-F238E27FC236}">
-                <a16:creationId xmlns:a16="http://schemas.microsoft.com/office/drawing/2014/main" id="{E66CE90F-0747-4694-9429-06737F47138D}"/>
+                <a16:creationId xmlns:a16="http://schemas.microsoft.com/office/drawing/2014/main" id="{EC5C5F2C-102B-491F-97A5-0C89648A7410}"/>
               </a:ext>
             </a:extLst>
           </p:cNvPr>
@@ -1954,7 +1954,7 @@
           <p:cNvPr id="3" name="brand-1">
             <a:extLst xmlns:a="http://schemas.openxmlformats.org/drawingml/2006/main">
               <a:ext uri="{FF2B5EF4-FFF2-40B4-BE49-F238E27FC236}">
-                <a16:creationId xmlns:a16="http://schemas.microsoft.com/office/drawing/2014/main" id="{9A15F9E1-8C37-42B8-9728-A7784F51484C}"/>
+                <a16:creationId xmlns:a16="http://schemas.microsoft.com/office/drawing/2014/main" id="{5E1ACBFF-E6D2-4A9E-94F5-4C1AF883E66A}"/>
               </a:ext>
             </a:extLst>
           </p:cNvPr>
@@ -2012,7 +2012,7 @@
           <p:cNvPr id="4" name="cover-title">
             <a:extLst xmlns:a="http://schemas.openxmlformats.org/drawingml/2006/main">
               <a:ext uri="{FF2B5EF4-FFF2-40B4-BE49-F238E27FC236}">
-                <a16:creationId xmlns:a16="http://schemas.microsoft.com/office/drawing/2014/main" id="{77EEC7EA-4F5C-4813-988B-9D497B229813}"/>
+                <a16:creationId xmlns:a16="http://schemas.microsoft.com/office/drawing/2014/main" id="{E0DF43EA-4B82-4AA4-9FF0-F08DAF720DD9}"/>
               </a:ext>
             </a:extLst>
           </p:cNvPr>
@@ -2070,7 +2070,7 @@
           <p:cNvPr id="5" name="cover-subtitle">
             <a:extLst xmlns:a="http://schemas.openxmlformats.org/drawingml/2006/main">
               <a:ext uri="{FF2B5EF4-FFF2-40B4-BE49-F238E27FC236}">
-                <a16:creationId xmlns:a16="http://schemas.microsoft.com/office/drawing/2014/main" id="{840A6919-D0B0-484A-BADA-2FE33436A328}"/>
+                <a16:creationId xmlns:a16="http://schemas.microsoft.com/office/drawing/2014/main" id="{C5BBCCEE-0D4D-4D36-BB55-146594AED174}"/>
               </a:ext>
             </a:extLst>
           </p:cNvPr>
@@ -2128,7 +2128,7 @@
           <p:cNvPr id="6" name="cover-rule">
             <a:extLst xmlns:a="http://schemas.openxmlformats.org/drawingml/2006/main">
               <a:ext uri="{FF2B5EF4-FFF2-40B4-BE49-F238E27FC236}">
-                <a16:creationId xmlns:a16="http://schemas.microsoft.com/office/drawing/2014/main" id="{FE1C2740-C63A-4AE6-9BFD-61A97DF35145}"/>
+                <a16:creationId xmlns:a16="http://schemas.microsoft.com/office/drawing/2014/main" id="{8CDE2358-832C-452A-8C06-26CA1CC28F46}"/>
               </a:ext>
             </a:extLst>
           </p:cNvPr>
@@ -2159,7 +2159,7 @@
           <p:cNvPr id="7" name="cover-lock">
             <a:extLst xmlns:a="http://schemas.openxmlformats.org/drawingml/2006/main">
               <a:ext uri="{FF2B5EF4-FFF2-40B4-BE49-F238E27FC236}">
-                <a16:creationId xmlns:a16="http://schemas.microsoft.com/office/drawing/2014/main" id="{851A4A76-B55D-4814-86B6-007D7D791674}"/>
+                <a16:creationId xmlns:a16="http://schemas.microsoft.com/office/drawing/2014/main" id="{9028EE72-A972-4B5C-AED5-E90DBA3B31F7}"/>
               </a:ext>
             </a:extLst>
           </p:cNvPr>
@@ -2217,7 +2217,7 @@
           <p:cNvPr id="8" name="cover-boundary">
             <a:extLst xmlns:a="http://schemas.openxmlformats.org/drawingml/2006/main">
               <a:ext uri="{FF2B5EF4-FFF2-40B4-BE49-F238E27FC236}">
-                <a16:creationId xmlns:a16="http://schemas.microsoft.com/office/drawing/2014/main" id="{D7C227E2-EFCF-4EC6-A9D0-99445C32A1F0}"/>
+                <a16:creationId xmlns:a16="http://schemas.microsoft.com/office/drawing/2014/main" id="{2D828A48-D693-4011-A710-42FCA668B946}"/>
               </a:ext>
             </a:extLst>
           </p:cNvPr>
@@ -2275,7 +2275,7 @@
           <p:cNvPr id="9" name="cover-number">
             <a:extLst xmlns:a="http://schemas.openxmlformats.org/drawingml/2006/main">
               <a:ext uri="{FF2B5EF4-FFF2-40B4-BE49-F238E27FC236}">
-                <a16:creationId xmlns:a16="http://schemas.microsoft.com/office/drawing/2014/main" id="{F86FF196-F22A-414C-8671-1DA18B5DFF04}"/>
+                <a16:creationId xmlns:a16="http://schemas.microsoft.com/office/drawing/2014/main" id="{A2644E8A-3AAF-4BBD-9BF2-1D0CCC80EC35}"/>
               </a:ext>
             </a:extLst>
           </p:cNvPr>
@@ -2333,7 +2333,7 @@
           <p:cNvPr id="10" name="cover-classification">
             <a:extLst xmlns:a="http://schemas.openxmlformats.org/drawingml/2006/main">
               <a:ext uri="{FF2B5EF4-FFF2-40B4-BE49-F238E27FC236}">
-                <a16:creationId xmlns:a16="http://schemas.microsoft.com/office/drawing/2014/main" id="{2B4B381D-AD8B-42FD-89E0-0C619081768B}"/>
+                <a16:creationId xmlns:a16="http://schemas.microsoft.com/office/drawing/2014/main" id="{2E35C270-BAB1-4B55-ACDA-A4A47E405197}"/>
               </a:ext>
             </a:extLst>
           </p:cNvPr>
@@ -2437,7 +2437,7 @@
           <p:cNvPr id="11" name="cover-page">
             <a:extLst xmlns:a="http://schemas.openxmlformats.org/drawingml/2006/main">
               <a:ext uri="{FF2B5EF4-FFF2-40B4-BE49-F238E27FC236}">
-                <a16:creationId xmlns:a16="http://schemas.microsoft.com/office/drawing/2014/main" id="{EFE5A2BA-C557-46E1-847A-D15A205E46AE}"/>
+                <a16:creationId xmlns:a16="http://schemas.microsoft.com/office/drawing/2014/main" id="{32CC0432-B234-4E27-9264-A0844FD1DC03}"/>
               </a:ext>
             </a:extLst>
           </p:cNvPr>
@@ -2495,7 +2495,7 @@
           <p:cNvPr id="12" name="footer-cover-url">
             <a:extLst xmlns:a="http://schemas.openxmlformats.org/drawingml/2006/main">
               <a:ext uri="{FF2B5EF4-FFF2-40B4-BE49-F238E27FC236}">
-                <a16:creationId xmlns:a16="http://schemas.microsoft.com/office/drawing/2014/main" id="{80AD3597-C50B-43DA-9319-82D2338566D9}"/>
+                <a16:creationId xmlns:a16="http://schemas.microsoft.com/office/drawing/2014/main" id="{B3D5599F-9E90-4FA1-9C73-97448D28FB18}"/>
               </a:ext>
             </a:extLst>
           </p:cNvPr>
@@ -2574,7 +2574,7 @@
     </p:spTree>
     <p:extLst>
       <p:ext uri="{BB962C8B-B14F-4D97-AF65-F5344CB8AC3E}">
-        <p14:creationId xmlns:p14="http://schemas.microsoft.com/office/powerpoint/2010/main" val="1820702860"/>
+        <p14:creationId xmlns:p14="http://schemas.microsoft.com/office/powerpoint/2010/main" val="733423459"/>
       </p:ext>
     </p:extLst>
   </p:cSld>
@@ -2605,7 +2605,7 @@
           <p:cNvPr id="17" name="brand-10">
             <a:extLst xmlns:a="http://schemas.openxmlformats.org/drawingml/2006/main">
               <a:ext uri="{FF2B5EF4-FFF2-40B4-BE49-F238E27FC236}">
-                <a16:creationId xmlns:a16="http://schemas.microsoft.com/office/drawing/2014/main" id="{75C87787-6BFC-4044-AEF7-911F4561689B}"/>
+                <a16:creationId xmlns:a16="http://schemas.microsoft.com/office/drawing/2014/main" id="{12A899BB-C16C-4F4D-AEAD-C598348EE653}"/>
               </a:ext>
             </a:extLst>
           </p:cNvPr>
@@ -2663,7 +2663,7 @@
           <p:cNvPr id="2" name="title-10">
             <a:extLst xmlns:a="http://schemas.openxmlformats.org/drawingml/2006/main">
               <a:ext uri="{FF2B5EF4-FFF2-40B4-BE49-F238E27FC236}">
-                <a16:creationId xmlns:a16="http://schemas.microsoft.com/office/drawing/2014/main" id="{7FE1D891-C371-4152-BCFF-D57FD026A902}"/>
+                <a16:creationId xmlns:a16="http://schemas.microsoft.com/office/drawing/2014/main" id="{C7139B1B-AC24-4A76-A61D-928F2AF03B31}"/>
               </a:ext>
             </a:extLst>
           </p:cNvPr>
@@ -2721,7 +2721,7 @@
           <p:cNvPr id="3" name="footer-rule-10">
             <a:extLst xmlns:a="http://schemas.openxmlformats.org/drawingml/2006/main">
               <a:ext uri="{FF2B5EF4-FFF2-40B4-BE49-F238E27FC236}">
-                <a16:creationId xmlns:a16="http://schemas.microsoft.com/office/drawing/2014/main" id="{B4F6C2AC-13D9-4B82-B744-8ED03548A611}"/>
+                <a16:creationId xmlns:a16="http://schemas.microsoft.com/office/drawing/2014/main" id="{C000A2BF-410E-4EB6-97B6-AA923C983E34}"/>
               </a:ext>
             </a:extLst>
           </p:cNvPr>
@@ -2752,7 +2752,7 @@
           <p:cNvPr id="4" name="footer-source-10">
             <a:extLst xmlns:a="http://schemas.openxmlformats.org/drawingml/2006/main">
               <a:ext uri="{FF2B5EF4-FFF2-40B4-BE49-F238E27FC236}">
-                <a16:creationId xmlns:a16="http://schemas.microsoft.com/office/drawing/2014/main" id="{918458B9-CFC0-4AE2-AD85-E15AC8E67EA0}"/>
+                <a16:creationId xmlns:a16="http://schemas.microsoft.com/office/drawing/2014/main" id="{AE55A568-5BDA-4305-8C9D-89C093D5B275}"/>
               </a:ext>
             </a:extLst>
           </p:cNvPr>
@@ -2810,7 +2810,7 @@
           <p:cNvPr id="5" name="footer-page-10">
             <a:extLst xmlns:a="http://schemas.openxmlformats.org/drawingml/2006/main">
               <a:ext uri="{FF2B5EF4-FFF2-40B4-BE49-F238E27FC236}">
-                <a16:creationId xmlns:a16="http://schemas.microsoft.com/office/drawing/2014/main" id="{6EC571A5-91C1-4FE8-B18D-CDD64C076D2B}"/>
+                <a16:creationId xmlns:a16="http://schemas.microsoft.com/office/drawing/2014/main" id="{8ADAAA79-DB41-4C9E-94D7-C28C11967B23}"/>
               </a:ext>
             </a:extLst>
           </p:cNvPr>
@@ -2868,7 +2868,7 @@
           <p:cNvPr id="6" name="ask-spine">
             <a:extLst xmlns:a="http://schemas.openxmlformats.org/drawingml/2006/main">
               <a:ext uri="{FF2B5EF4-FFF2-40B4-BE49-F238E27FC236}">
-                <a16:creationId xmlns:a16="http://schemas.microsoft.com/office/drawing/2014/main" id="{37791D56-050D-4A78-B0C1-EFBCDFD432A9}"/>
+                <a16:creationId xmlns:a16="http://schemas.microsoft.com/office/drawing/2014/main" id="{350B07F6-3E66-43F4-8474-7EE95FBD4AEE}"/>
               </a:ext>
             </a:extLst>
           </p:cNvPr>
@@ -2899,7 +2899,7 @@
           <p:cNvPr id="7" name="ask-access-label">
             <a:extLst xmlns:a="http://schemas.openxmlformats.org/drawingml/2006/main">
               <a:ext uri="{FF2B5EF4-FFF2-40B4-BE49-F238E27FC236}">
-                <a16:creationId xmlns:a16="http://schemas.microsoft.com/office/drawing/2014/main" id="{D86F18A2-56E1-47A2-9E5C-B26DD524414B}"/>
+                <a16:creationId xmlns:a16="http://schemas.microsoft.com/office/drawing/2014/main" id="{E11B24DB-BACF-497A-9462-FC8A15E5C5B1}"/>
               </a:ext>
             </a:extLst>
           </p:cNvPr>
@@ -2957,7 +2957,7 @@
           <p:cNvPr id="8" name="ask-access-copy">
             <a:extLst xmlns:a="http://schemas.openxmlformats.org/drawingml/2006/main">
               <a:ext uri="{FF2B5EF4-FFF2-40B4-BE49-F238E27FC236}">
-                <a16:creationId xmlns:a16="http://schemas.microsoft.com/office/drawing/2014/main" id="{AAC6FC8B-75A6-454A-AF69-068FA62D9F1D}"/>
+                <a16:creationId xmlns:a16="http://schemas.microsoft.com/office/drawing/2014/main" id="{E3090557-2750-42AF-A013-698E62FC840A}"/>
               </a:ext>
             </a:extLst>
           </p:cNvPr>
@@ -3015,7 +3015,7 @@
           <p:cNvPr id="9" name="ask-falsify">
             <a:extLst xmlns:a="http://schemas.openxmlformats.org/drawingml/2006/main">
               <a:ext uri="{FF2B5EF4-FFF2-40B4-BE49-F238E27FC236}">
-                <a16:creationId xmlns:a16="http://schemas.microsoft.com/office/drawing/2014/main" id="{53A0BCF6-E748-41C6-9A8D-EF52053B4FF5}"/>
+                <a16:creationId xmlns:a16="http://schemas.microsoft.com/office/drawing/2014/main" id="{3F677942-56EC-4B51-98CE-801373475A81}"/>
               </a:ext>
             </a:extLst>
           </p:cNvPr>
@@ -3073,7 +3073,7 @@
           <p:cNvPr id="10" name="ask-challenge-label">
             <a:extLst xmlns:a="http://schemas.openxmlformats.org/drawingml/2006/main">
               <a:ext uri="{FF2B5EF4-FFF2-40B4-BE49-F238E27FC236}">
-                <a16:creationId xmlns:a16="http://schemas.microsoft.com/office/drawing/2014/main" id="{180F8B98-31AC-4E21-BA99-E41878A1CB8E}"/>
+                <a16:creationId xmlns:a16="http://schemas.microsoft.com/office/drawing/2014/main" id="{221C2CD2-9612-464F-A646-05DDE2B1322F}"/>
               </a:ext>
             </a:extLst>
           </p:cNvPr>
@@ -3131,7 +3131,7 @@
           <p:cNvPr id="11" name="ask-challenge-copy">
             <a:extLst xmlns:a="http://schemas.openxmlformats.org/drawingml/2006/main">
               <a:ext uri="{FF2B5EF4-FFF2-40B4-BE49-F238E27FC236}">
-                <a16:creationId xmlns:a16="http://schemas.microsoft.com/office/drawing/2014/main" id="{C49BA21A-ADD4-4C45-8B3A-C6629D3418B1}"/>
+                <a16:creationId xmlns:a16="http://schemas.microsoft.com/office/drawing/2014/main" id="{BF5555E3-CDF2-4DC4-9140-81B133C56345}"/>
               </a:ext>
             </a:extLst>
           </p:cNvPr>
@@ -3189,7 +3189,7 @@
           <p:cNvPr id="12" name="ask-test-label">
             <a:extLst xmlns:a="http://schemas.openxmlformats.org/drawingml/2006/main">
               <a:ext uri="{FF2B5EF4-FFF2-40B4-BE49-F238E27FC236}">
-                <a16:creationId xmlns:a16="http://schemas.microsoft.com/office/drawing/2014/main" id="{280C98E4-6110-483B-AE43-33278D92AC55}"/>
+                <a16:creationId xmlns:a16="http://schemas.microsoft.com/office/drawing/2014/main" id="{61FAF683-70CC-4724-BD48-F31096A394D4}"/>
               </a:ext>
             </a:extLst>
           </p:cNvPr>
@@ -3247,7 +3247,7 @@
           <p:cNvPr id="13" name="ask-test-copy">
             <a:extLst xmlns:a="http://schemas.openxmlformats.org/drawingml/2006/main">
               <a:ext uri="{FF2B5EF4-FFF2-40B4-BE49-F238E27FC236}">
-                <a16:creationId xmlns:a16="http://schemas.microsoft.com/office/drawing/2014/main" id="{781EAB79-6BB6-4172-B1EA-6762125423C0}"/>
+                <a16:creationId xmlns:a16="http://schemas.microsoft.com/office/drawing/2014/main" id="{FCCC15E2-24EB-4C11-B45A-48E6C6058FE1}"/>
               </a:ext>
             </a:extLst>
           </p:cNvPr>
@@ -3305,7 +3305,7 @@
           <p:cNvPr id="14" name="ask-decide-label">
             <a:extLst xmlns:a="http://schemas.openxmlformats.org/drawingml/2006/main">
               <a:ext uri="{FF2B5EF4-FFF2-40B4-BE49-F238E27FC236}">
-                <a16:creationId xmlns:a16="http://schemas.microsoft.com/office/drawing/2014/main" id="{7BFC0B19-6C69-4F0C-B80B-531A1037399A}"/>
+                <a16:creationId xmlns:a16="http://schemas.microsoft.com/office/drawing/2014/main" id="{C6152312-28D6-4AB9-93AD-F4A4ECD2DD45}"/>
               </a:ext>
             </a:extLst>
           </p:cNvPr>
@@ -3363,7 +3363,7 @@
           <p:cNvPr id="15" name="ask-decide-copy">
             <a:extLst xmlns:a="http://schemas.openxmlformats.org/drawingml/2006/main">
               <a:ext uri="{FF2B5EF4-FFF2-40B4-BE49-F238E27FC236}">
-                <a16:creationId xmlns:a16="http://schemas.microsoft.com/office/drawing/2014/main" id="{D6584F64-58E5-492B-B147-BE42E04C1F5E}"/>
+                <a16:creationId xmlns:a16="http://schemas.microsoft.com/office/drawing/2014/main" id="{7CAA2700-3A99-4437-AD3B-A694A0AB49FF}"/>
               </a:ext>
             </a:extLst>
           </p:cNvPr>
@@ -3421,7 +3421,7 @@
           <p:cNvPr id="16" name="footer-ask-links">
             <a:extLst xmlns:a="http://schemas.openxmlformats.org/drawingml/2006/main">
               <a:ext uri="{FF2B5EF4-FFF2-40B4-BE49-F238E27FC236}">
-                <a16:creationId xmlns:a16="http://schemas.microsoft.com/office/drawing/2014/main" id="{1B15656D-B57F-49E5-8E19-3381C09B14DB}"/>
+                <a16:creationId xmlns:a16="http://schemas.microsoft.com/office/drawing/2014/main" id="{1E62F9C7-FC5F-4C8A-8671-81D137363F96}"/>
               </a:ext>
             </a:extLst>
           </p:cNvPr>
@@ -3477,7 +3477,7 @@
     </p:spTree>
     <p:extLst>
       <p:ext uri="{BB962C8B-B14F-4D97-AF65-F5344CB8AC3E}">
-        <p14:creationId xmlns:p14="http://schemas.microsoft.com/office/powerpoint/2010/main" val="338198850"/>
+        <p14:creationId xmlns:p14="http://schemas.microsoft.com/office/powerpoint/2010/main" val="193132310"/>
       </p:ext>
     </p:extLst>
   </p:cSld>
@@ -3508,7 +3508,7 @@
           <p:cNvPr id="18" name="brand-2">
             <a:extLst xmlns:a="http://schemas.openxmlformats.org/drawingml/2006/main">
               <a:ext uri="{FF2B5EF4-FFF2-40B4-BE49-F238E27FC236}">
-                <a16:creationId xmlns:a16="http://schemas.microsoft.com/office/drawing/2014/main" id="{483AD6F6-7ABF-4DAE-9973-FE574A3C7BE0}"/>
+                <a16:creationId xmlns:a16="http://schemas.microsoft.com/office/drawing/2014/main" id="{17ECFF49-4459-4C01-AE30-44F3298DD75D}"/>
               </a:ext>
             </a:extLst>
           </p:cNvPr>
@@ -3566,7 +3566,7 @@
           <p:cNvPr id="2" name="title-2">
             <a:extLst xmlns:a="http://schemas.openxmlformats.org/drawingml/2006/main">
               <a:ext uri="{FF2B5EF4-FFF2-40B4-BE49-F238E27FC236}">
-                <a16:creationId xmlns:a16="http://schemas.microsoft.com/office/drawing/2014/main" id="{F9D8DE36-8DA2-409E-A218-65AAD20C8CCD}"/>
+                <a16:creationId xmlns:a16="http://schemas.microsoft.com/office/drawing/2014/main" id="{1BF67A2D-F421-4F1C-B8C0-3015C7F00691}"/>
               </a:ext>
             </a:extLst>
           </p:cNvPr>
@@ -3624,7 +3624,7 @@
           <p:cNvPr id="3" name="footer-rule-2">
             <a:extLst xmlns:a="http://schemas.openxmlformats.org/drawingml/2006/main">
               <a:ext uri="{FF2B5EF4-FFF2-40B4-BE49-F238E27FC236}">
-                <a16:creationId xmlns:a16="http://schemas.microsoft.com/office/drawing/2014/main" id="{2535721F-A868-449C-9649-290DE64C61E4}"/>
+                <a16:creationId xmlns:a16="http://schemas.microsoft.com/office/drawing/2014/main" id="{A82B5EC8-01BA-4195-963D-F414827BA047}"/>
               </a:ext>
             </a:extLst>
           </p:cNvPr>
@@ -3655,7 +3655,7 @@
           <p:cNvPr id="4" name="footer-source-2">
             <a:extLst xmlns:a="http://schemas.openxmlformats.org/drawingml/2006/main">
               <a:ext uri="{FF2B5EF4-FFF2-40B4-BE49-F238E27FC236}">
-                <a16:creationId xmlns:a16="http://schemas.microsoft.com/office/drawing/2014/main" id="{731B2884-1F18-484B-B508-BB6CE2708FF9}"/>
+                <a16:creationId xmlns:a16="http://schemas.microsoft.com/office/drawing/2014/main" id="{9FA3CA59-73AC-4593-AAC3-49EBC92CBF0B}"/>
               </a:ext>
             </a:extLst>
           </p:cNvPr>
@@ -3713,7 +3713,7 @@
           <p:cNvPr id="5" name="footer-page-2">
             <a:extLst xmlns:a="http://schemas.openxmlformats.org/drawingml/2006/main">
               <a:ext uri="{FF2B5EF4-FFF2-40B4-BE49-F238E27FC236}">
-                <a16:creationId xmlns:a16="http://schemas.microsoft.com/office/drawing/2014/main" id="{FD982E19-D6DB-49B8-851B-620A4E58C8B1}"/>
+                <a16:creationId xmlns:a16="http://schemas.microsoft.com/office/drawing/2014/main" id="{A3863613-6438-4AE2-ABA0-E568EF44F5CF}"/>
               </a:ext>
             </a:extLst>
           </p:cNvPr>
@@ -3771,7 +3771,7 @@
           <p:cNvPr id="6" name="accountability-divider">
             <a:extLst xmlns:a="http://schemas.openxmlformats.org/drawingml/2006/main">
               <a:ext uri="{FF2B5EF4-FFF2-40B4-BE49-F238E27FC236}">
-                <a16:creationId xmlns:a16="http://schemas.microsoft.com/office/drawing/2014/main" id="{DB296407-80E9-4F9E-A0E0-FE1E032F39D8}"/>
+                <a16:creationId xmlns:a16="http://schemas.microsoft.com/office/drawing/2014/main" id="{223FE0C5-4164-43D6-BEBE-550058F3E77E}"/>
               </a:ext>
             </a:extLst>
           </p:cNvPr>
@@ -3802,7 +3802,7 @@
           <p:cNvPr id="7" name="accountability-label">
             <a:extLst xmlns:a="http://schemas.openxmlformats.org/drawingml/2006/main">
               <a:ext uri="{FF2B5EF4-FFF2-40B4-BE49-F238E27FC236}">
-                <a16:creationId xmlns:a16="http://schemas.microsoft.com/office/drawing/2014/main" id="{5567905A-60F0-402A-99F6-807456B9F337}"/>
+                <a16:creationId xmlns:a16="http://schemas.microsoft.com/office/drawing/2014/main" id="{DB4F07DC-441D-4D82-AE01-06350A582175}"/>
               </a:ext>
             </a:extLst>
           </p:cNvPr>
@@ -3860,7 +3860,7 @@
           <p:cNvPr id="8" name="accountability-structured">
             <a:extLst xmlns:a="http://schemas.openxmlformats.org/drawingml/2006/main">
               <a:ext uri="{FF2B5EF4-FFF2-40B4-BE49-F238E27FC236}">
-                <a16:creationId xmlns:a16="http://schemas.microsoft.com/office/drawing/2014/main" id="{854AD8B5-DDFE-4CD5-8097-ABAFD96CD7E4}"/>
+                <a16:creationId xmlns:a16="http://schemas.microsoft.com/office/drawing/2014/main" id="{83C2B51C-F674-4A70-9CAA-04A074DD6679}"/>
               </a:ext>
             </a:extLst>
           </p:cNvPr>
@@ -3918,7 +3918,7 @@
           <p:cNvPr id="9" name="accountability-question">
             <a:extLst xmlns:a="http://schemas.openxmlformats.org/drawingml/2006/main">
               <a:ext uri="{FF2B5EF4-FFF2-40B4-BE49-F238E27FC236}">
-                <a16:creationId xmlns:a16="http://schemas.microsoft.com/office/drawing/2014/main" id="{7FD5189C-0482-47C9-900A-52171AB645DD}"/>
+                <a16:creationId xmlns:a16="http://schemas.microsoft.com/office/drawing/2014/main" id="{F668417F-8F29-4D89-B053-9326FEC7D2C9}"/>
               </a:ext>
             </a:extLst>
           </p:cNvPr>
@@ -3976,7 +3976,7 @@
           <p:cNvPr id="10" name="footer-accountability-caption-1">
             <a:extLst xmlns:a="http://schemas.openxmlformats.org/drawingml/2006/main">
               <a:ext uri="{FF2B5EF4-FFF2-40B4-BE49-F238E27FC236}">
-                <a16:creationId xmlns:a16="http://schemas.microsoft.com/office/drawing/2014/main" id="{0A73404A-3F72-4D4E-938B-77DB654293BC}"/>
+                <a16:creationId xmlns:a16="http://schemas.microsoft.com/office/drawing/2014/main" id="{997747FD-57FE-430D-B9A9-433F4387ADC5}"/>
               </a:ext>
             </a:extLst>
           </p:cNvPr>
@@ -4034,7 +4034,7 @@
           <p:cNvPr id="11" name="accountability-source-rule-1">
             <a:extLst xmlns:a="http://schemas.openxmlformats.org/drawingml/2006/main">
               <a:ext uri="{FF2B5EF4-FFF2-40B4-BE49-F238E27FC236}">
-                <a16:creationId xmlns:a16="http://schemas.microsoft.com/office/drawing/2014/main" id="{47D9072E-75BA-4451-AA6B-9059EF940CD2}"/>
+                <a16:creationId xmlns:a16="http://schemas.microsoft.com/office/drawing/2014/main" id="{12602C2D-91AA-41D6-BEED-9A0C3FAD29B7}"/>
               </a:ext>
             </a:extLst>
           </p:cNvPr>
@@ -4065,7 +4065,7 @@
           <p:cNvPr id="12" name="footer-accountability-caption-2">
             <a:extLst xmlns:a="http://schemas.openxmlformats.org/drawingml/2006/main">
               <a:ext uri="{FF2B5EF4-FFF2-40B4-BE49-F238E27FC236}">
-                <a16:creationId xmlns:a16="http://schemas.microsoft.com/office/drawing/2014/main" id="{AB17C0A6-1326-42D0-8D49-A1EBF7D4AB59}"/>
+                <a16:creationId xmlns:a16="http://schemas.microsoft.com/office/drawing/2014/main" id="{A60D14DF-34E1-42F8-B59B-C3BB4C158687}"/>
               </a:ext>
             </a:extLst>
           </p:cNvPr>
@@ -4123,7 +4123,7 @@
           <p:cNvPr id="13" name="accountability-source-rule-2">
             <a:extLst xmlns:a="http://schemas.openxmlformats.org/drawingml/2006/main">
               <a:ext uri="{FF2B5EF4-FFF2-40B4-BE49-F238E27FC236}">
-                <a16:creationId xmlns:a16="http://schemas.microsoft.com/office/drawing/2014/main" id="{7E627656-2C74-41B5-9226-36DC0015970F}"/>
+                <a16:creationId xmlns:a16="http://schemas.microsoft.com/office/drawing/2014/main" id="{616B42C9-D545-4208-B658-32C19C1BA847}"/>
               </a:ext>
             </a:extLst>
           </p:cNvPr>
@@ -4154,7 +4154,7 @@
           <p:cNvPr id="14" name="footer-accountability-caption-3">
             <a:extLst xmlns:a="http://schemas.openxmlformats.org/drawingml/2006/main">
               <a:ext uri="{FF2B5EF4-FFF2-40B4-BE49-F238E27FC236}">
-                <a16:creationId xmlns:a16="http://schemas.microsoft.com/office/drawing/2014/main" id="{0531EEE4-FC26-41BE-94F6-95D71D2E6CD6}"/>
+                <a16:creationId xmlns:a16="http://schemas.microsoft.com/office/drawing/2014/main" id="{8AA5D57A-5452-445E-9794-CCC643949844}"/>
               </a:ext>
             </a:extLst>
           </p:cNvPr>
@@ -4212,7 +4212,7 @@
           <p:cNvPr id="15" name="accountability-source-rule-3">
             <a:extLst xmlns:a="http://schemas.openxmlformats.org/drawingml/2006/main">
               <a:ext uri="{FF2B5EF4-FFF2-40B4-BE49-F238E27FC236}">
-                <a16:creationId xmlns:a16="http://schemas.microsoft.com/office/drawing/2014/main" id="{E163EFE4-5767-417E-B904-88265B8CE6C6}"/>
+                <a16:creationId xmlns:a16="http://schemas.microsoft.com/office/drawing/2014/main" id="{6C27F3DF-AF85-4637-8174-D35084BAA61F}"/>
               </a:ext>
             </a:extLst>
           </p:cNvPr>
@@ -4243,7 +4243,7 @@
           <p:cNvPr id="16" name="accountability-evidence">
             <a:extLst xmlns:a="http://schemas.openxmlformats.org/drawingml/2006/main">
               <a:ext uri="{FF2B5EF4-FFF2-40B4-BE49-F238E27FC236}">
-                <a16:creationId xmlns:a16="http://schemas.microsoft.com/office/drawing/2014/main" id="{3A730EEA-2817-4D78-A86A-39F4D8B1EBDB}"/>
+                <a16:creationId xmlns:a16="http://schemas.microsoft.com/office/drawing/2014/main" id="{DC9A9A74-B70A-4AA8-AE0A-A4185726F313}"/>
               </a:ext>
             </a:extLst>
           </p:cNvPr>
@@ -4301,7 +4301,7 @@
           <p:cNvPr id="17" name="accountability-unknowns">
             <a:extLst xmlns:a="http://schemas.openxmlformats.org/drawingml/2006/main">
               <a:ext uri="{FF2B5EF4-FFF2-40B4-BE49-F238E27FC236}">
-                <a16:creationId xmlns:a16="http://schemas.microsoft.com/office/drawing/2014/main" id="{1FA6EF2D-4007-44BE-AAEC-80951585519A}"/>
+                <a16:creationId xmlns:a16="http://schemas.microsoft.com/office/drawing/2014/main" id="{D9DC75F4-A829-430B-90B9-6FCB26AC0EC2}"/>
               </a:ext>
             </a:extLst>
           </p:cNvPr>
@@ -4357,7 +4357,7 @@
     </p:spTree>
     <p:extLst>
       <p:ext uri="{BB962C8B-B14F-4D97-AF65-F5344CB8AC3E}">
-        <p14:creationId xmlns:p14="http://schemas.microsoft.com/office/powerpoint/2010/main" val="1075578534"/>
+        <p14:creationId xmlns:p14="http://schemas.microsoft.com/office/powerpoint/2010/main" val="106420799"/>
       </p:ext>
     </p:extLst>
   </p:cSld>
@@ -4388,7 +4388,7 @@
           <p:cNvPr id="14" name="brand-3">
             <a:extLst xmlns:a="http://schemas.openxmlformats.org/drawingml/2006/main">
               <a:ext uri="{FF2B5EF4-FFF2-40B4-BE49-F238E27FC236}">
-                <a16:creationId xmlns:a16="http://schemas.microsoft.com/office/drawing/2014/main" id="{BAE23166-96F8-4234-BAA0-E59BD452733B}"/>
+                <a16:creationId xmlns:a16="http://schemas.microsoft.com/office/drawing/2014/main" id="{83205BBA-2AD4-4C0C-9269-1F7D40EEB0DB}"/>
               </a:ext>
             </a:extLst>
           </p:cNvPr>
@@ -4446,7 +4446,7 @@
           <p:cNvPr id="2" name="title-3">
             <a:extLst xmlns:a="http://schemas.openxmlformats.org/drawingml/2006/main">
               <a:ext uri="{FF2B5EF4-FFF2-40B4-BE49-F238E27FC236}">
-                <a16:creationId xmlns:a16="http://schemas.microsoft.com/office/drawing/2014/main" id="{0486F919-0B1F-40AA-BC22-1BD8009A6543}"/>
+                <a16:creationId xmlns:a16="http://schemas.microsoft.com/office/drawing/2014/main" id="{49AE28FA-C5C4-49A1-9EAD-04CF0E8F3701}"/>
               </a:ext>
             </a:extLst>
           </p:cNvPr>
@@ -4504,7 +4504,7 @@
           <p:cNvPr id="3" name="footer-rule-3">
             <a:extLst xmlns:a="http://schemas.openxmlformats.org/drawingml/2006/main">
               <a:ext uri="{FF2B5EF4-FFF2-40B4-BE49-F238E27FC236}">
-                <a16:creationId xmlns:a16="http://schemas.microsoft.com/office/drawing/2014/main" id="{2793382D-949E-4D90-BAE5-F5E546B663AE}"/>
+                <a16:creationId xmlns:a16="http://schemas.microsoft.com/office/drawing/2014/main" id="{62527A10-FC71-414E-811A-52F1D6381EE9}"/>
               </a:ext>
             </a:extLst>
           </p:cNvPr>
@@ -4535,7 +4535,7 @@
           <p:cNvPr id="4" name="footer-source-3">
             <a:extLst xmlns:a="http://schemas.openxmlformats.org/drawingml/2006/main">
               <a:ext uri="{FF2B5EF4-FFF2-40B4-BE49-F238E27FC236}">
-                <a16:creationId xmlns:a16="http://schemas.microsoft.com/office/drawing/2014/main" id="{1C89E6DA-E3A1-4D2C-A32B-7F304E02F9D7}"/>
+                <a16:creationId xmlns:a16="http://schemas.microsoft.com/office/drawing/2014/main" id="{095B92E5-CBCD-4E0D-8591-E8BFC1E1916C}"/>
               </a:ext>
             </a:extLst>
           </p:cNvPr>
@@ -4593,7 +4593,7 @@
           <p:cNvPr id="5" name="footer-page-3">
             <a:extLst xmlns:a="http://schemas.openxmlformats.org/drawingml/2006/main">
               <a:ext uri="{FF2B5EF4-FFF2-40B4-BE49-F238E27FC236}">
-                <a16:creationId xmlns:a16="http://schemas.microsoft.com/office/drawing/2014/main" id="{D62B68B1-3EBC-4065-95EC-220A77B2ED6E}"/>
+                <a16:creationId xmlns:a16="http://schemas.microsoft.com/office/drawing/2014/main" id="{8AD04C8D-5292-448B-BFF2-A2B60E6A2804}"/>
               </a:ext>
             </a:extLst>
           </p:cNvPr>
@@ -4651,7 +4651,7 @@
           <p:cNvPr id="6" name="boundary-left">
             <a:extLst xmlns:a="http://schemas.openxmlformats.org/drawingml/2006/main">
               <a:ext uri="{FF2B5EF4-FFF2-40B4-BE49-F238E27FC236}">
-                <a16:creationId xmlns:a16="http://schemas.microsoft.com/office/drawing/2014/main" id="{F88BF26A-E80D-4CB4-8F00-B08D75DF4051}"/>
+                <a16:creationId xmlns:a16="http://schemas.microsoft.com/office/drawing/2014/main" id="{62681918-BC6A-4E03-BBF0-DED058E9FCF8}"/>
               </a:ext>
             </a:extLst>
           </p:cNvPr>
@@ -4684,7 +4684,7 @@
           <p:cNvPr id="7" name="boundary-spine">
             <a:extLst xmlns:a="http://schemas.openxmlformats.org/drawingml/2006/main">
               <a:ext uri="{FF2B5EF4-FFF2-40B4-BE49-F238E27FC236}">
-                <a16:creationId xmlns:a16="http://schemas.microsoft.com/office/drawing/2014/main" id="{BB5EF693-22EE-4943-88FA-432639F62152}"/>
+                <a16:creationId xmlns:a16="http://schemas.microsoft.com/office/drawing/2014/main" id="{266A9D79-EAED-49F4-89F3-5E71FE150CC5}"/>
               </a:ext>
             </a:extLst>
           </p:cNvPr>
@@ -4715,7 +4715,7 @@
           <p:cNvPr id="8" name="boundary-drr">
             <a:extLst xmlns:a="http://schemas.openxmlformats.org/drawingml/2006/main">
               <a:ext uri="{FF2B5EF4-FFF2-40B4-BE49-F238E27FC236}">
-                <a16:creationId xmlns:a16="http://schemas.microsoft.com/office/drawing/2014/main" id="{22752193-F23B-483A-A92C-3BE88B970E08}"/>
+                <a16:creationId xmlns:a16="http://schemas.microsoft.com/office/drawing/2014/main" id="{913F6CF4-248E-435B-ADCA-9087D0FC296F}"/>
               </a:ext>
             </a:extLst>
           </p:cNvPr>
@@ -4773,7 +4773,7 @@
           <p:cNvPr id="9" name="boundary-drr-copy">
             <a:extLst xmlns:a="http://schemas.openxmlformats.org/drawingml/2006/main">
               <a:ext uri="{FF2B5EF4-FFF2-40B4-BE49-F238E27FC236}">
-                <a16:creationId xmlns:a16="http://schemas.microsoft.com/office/drawing/2014/main" id="{9AFBDE2F-3A9C-445D-9949-4A3904E47B8E}"/>
+                <a16:creationId xmlns:a16="http://schemas.microsoft.com/office/drawing/2014/main" id="{D4C32D96-E8A0-46AE-B167-9F0ECF88A2CE}"/>
               </a:ext>
             </a:extLst>
           </p:cNvPr>
@@ -4831,7 +4831,7 @@
           <p:cNvPr id="10" name="boundary-attest">
             <a:extLst xmlns:a="http://schemas.openxmlformats.org/drawingml/2006/main">
               <a:ext uri="{FF2B5EF4-FFF2-40B4-BE49-F238E27FC236}">
-                <a16:creationId xmlns:a16="http://schemas.microsoft.com/office/drawing/2014/main" id="{44DD6B83-209E-43F0-81D0-700BEFBFE973}"/>
+                <a16:creationId xmlns:a16="http://schemas.microsoft.com/office/drawing/2014/main" id="{764E3AA1-CFB8-4E8A-8EE4-46E4861B3C58}"/>
               </a:ext>
             </a:extLst>
           </p:cNvPr>
@@ -4889,7 +4889,7 @@
           <p:cNvPr id="11" name="boundary-attest-copy">
             <a:extLst xmlns:a="http://schemas.openxmlformats.org/drawingml/2006/main">
               <a:ext uri="{FF2B5EF4-FFF2-40B4-BE49-F238E27FC236}">
-                <a16:creationId xmlns:a16="http://schemas.microsoft.com/office/drawing/2014/main" id="{F7C76B3C-24A0-427C-B690-5F376FBC575E}"/>
+                <a16:creationId xmlns:a16="http://schemas.microsoft.com/office/drawing/2014/main" id="{B913B582-0638-4890-AEB0-62C8F60121A3}"/>
               </a:ext>
             </a:extLst>
           </p:cNvPr>
@@ -4947,7 +4947,7 @@
           <p:cNvPr id="12" name="boundary-limit">
             <a:extLst xmlns:a="http://schemas.openxmlformats.org/drawingml/2006/main">
               <a:ext uri="{FF2B5EF4-FFF2-40B4-BE49-F238E27FC236}">
-                <a16:creationId xmlns:a16="http://schemas.microsoft.com/office/drawing/2014/main" id="{B53B91C6-DA77-482D-81A4-E57183070FED}"/>
+                <a16:creationId xmlns:a16="http://schemas.microsoft.com/office/drawing/2014/main" id="{E9876D9B-F800-4EF2-99FE-5C36A6C3BA5C}"/>
               </a:ext>
             </a:extLst>
           </p:cNvPr>
@@ -5005,7 +5005,7 @@
           <p:cNvPr id="13" name="boundary-absence">
             <a:extLst xmlns:a="http://schemas.openxmlformats.org/drawingml/2006/main">
               <a:ext uri="{FF2B5EF4-FFF2-40B4-BE49-F238E27FC236}">
-                <a16:creationId xmlns:a16="http://schemas.microsoft.com/office/drawing/2014/main" id="{A96A5B6F-E37F-4DDF-884C-2D9F02BFFC2A}"/>
+                <a16:creationId xmlns:a16="http://schemas.microsoft.com/office/drawing/2014/main" id="{B24DCD06-0E7F-4FB9-B529-270D5CDC4404}"/>
               </a:ext>
             </a:extLst>
           </p:cNvPr>
@@ -5061,7 +5061,7 @@
     </p:spTree>
     <p:extLst>
       <p:ext uri="{BB962C8B-B14F-4D97-AF65-F5344CB8AC3E}">
-        <p14:creationId xmlns:p14="http://schemas.microsoft.com/office/powerpoint/2010/main" val="493247843"/>
+        <p14:creationId xmlns:p14="http://schemas.microsoft.com/office/powerpoint/2010/main" val="1460950517"/>
       </p:ext>
     </p:extLst>
   </p:cSld>
@@ -5092,7 +5092,7 @@
           <p:cNvPr id="22" name="brand-4">
             <a:extLst xmlns:a="http://schemas.openxmlformats.org/drawingml/2006/main">
               <a:ext uri="{FF2B5EF4-FFF2-40B4-BE49-F238E27FC236}">
-                <a16:creationId xmlns:a16="http://schemas.microsoft.com/office/drawing/2014/main" id="{6CECD602-4F9E-402D-8756-82ED046DD255}"/>
+                <a16:creationId xmlns:a16="http://schemas.microsoft.com/office/drawing/2014/main" id="{450965DB-7940-4ABD-80EB-2EF41728F903}"/>
               </a:ext>
             </a:extLst>
           </p:cNvPr>
@@ -5150,7 +5150,7 @@
           <p:cNvPr id="2" name="title-4">
             <a:extLst xmlns:a="http://schemas.openxmlformats.org/drawingml/2006/main">
               <a:ext uri="{FF2B5EF4-FFF2-40B4-BE49-F238E27FC236}">
-                <a16:creationId xmlns:a16="http://schemas.microsoft.com/office/drawing/2014/main" id="{2FA0F33B-C122-42A5-A536-2B45CE2F4A26}"/>
+                <a16:creationId xmlns:a16="http://schemas.microsoft.com/office/drawing/2014/main" id="{E5C8CCA8-A210-4CAD-9D89-122AB84D0EB2}"/>
               </a:ext>
             </a:extLst>
           </p:cNvPr>
@@ -5208,7 +5208,7 @@
           <p:cNvPr id="3" name="footer-rule-4">
             <a:extLst xmlns:a="http://schemas.openxmlformats.org/drawingml/2006/main">
               <a:ext uri="{FF2B5EF4-FFF2-40B4-BE49-F238E27FC236}">
-                <a16:creationId xmlns:a16="http://schemas.microsoft.com/office/drawing/2014/main" id="{BA5397BF-3D91-4059-ABB9-4B8175613E4F}"/>
+                <a16:creationId xmlns:a16="http://schemas.microsoft.com/office/drawing/2014/main" id="{189EB567-2602-4835-892D-A124D97F7555}"/>
               </a:ext>
             </a:extLst>
           </p:cNvPr>
@@ -5239,7 +5239,7 @@
           <p:cNvPr id="4" name="footer-source-4">
             <a:extLst xmlns:a="http://schemas.openxmlformats.org/drawingml/2006/main">
               <a:ext uri="{FF2B5EF4-FFF2-40B4-BE49-F238E27FC236}">
-                <a16:creationId xmlns:a16="http://schemas.microsoft.com/office/drawing/2014/main" id="{1D655F3A-CAD6-48E1-9969-CF8BF9F2474B}"/>
+                <a16:creationId xmlns:a16="http://schemas.microsoft.com/office/drawing/2014/main" id="{6389C735-8BB7-4447-92D7-484BAE4F3E74}"/>
               </a:ext>
             </a:extLst>
           </p:cNvPr>
@@ -5297,7 +5297,7 @@
           <p:cNvPr id="5" name="footer-page-4">
             <a:extLst xmlns:a="http://schemas.openxmlformats.org/drawingml/2006/main">
               <a:ext uri="{FF2B5EF4-FFF2-40B4-BE49-F238E27FC236}">
-                <a16:creationId xmlns:a16="http://schemas.microsoft.com/office/drawing/2014/main" id="{C1AC1C35-36CF-4373-9A01-55AC40A3F544}"/>
+                <a16:creationId xmlns:a16="http://schemas.microsoft.com/office/drawing/2014/main" id="{11854EDE-BCB4-400A-ABEF-930FA59B153B}"/>
               </a:ext>
             </a:extLst>
           </p:cNvPr>
@@ -5355,7 +5355,7 @@
           <p:cNvPr id="6" name="case-entity">
             <a:extLst xmlns:a="http://schemas.openxmlformats.org/drawingml/2006/main">
               <a:ext uri="{FF2B5EF4-FFF2-40B4-BE49-F238E27FC236}">
-                <a16:creationId xmlns:a16="http://schemas.microsoft.com/office/drawing/2014/main" id="{35D1B3B9-6D89-41B2-A783-D1C7D0D695BC}"/>
+                <a16:creationId xmlns:a16="http://schemas.microsoft.com/office/drawing/2014/main" id="{75099179-E8C4-463E-87CA-E23371C0AD93}"/>
               </a:ext>
             </a:extLst>
           </p:cNvPr>
@@ -5413,7 +5413,7 @@
           <p:cNvPr id="7" name="case-period">
             <a:extLst xmlns:a="http://schemas.openxmlformats.org/drawingml/2006/main">
               <a:ext uri="{FF2B5EF4-FFF2-40B4-BE49-F238E27FC236}">
-                <a16:creationId xmlns:a16="http://schemas.microsoft.com/office/drawing/2014/main" id="{FA4B7DEF-7EF4-4FE3-ADB2-9EF603A8CDEC}"/>
+                <a16:creationId xmlns:a16="http://schemas.microsoft.com/office/drawing/2014/main" id="{CD3F8DC4-DD1B-469D-9581-69B34B118C25}"/>
               </a:ext>
             </a:extLst>
           </p:cNvPr>
@@ -5471,7 +5471,7 @@
           <p:cNvPr id="8" name="case-marker">
             <a:extLst xmlns:a="http://schemas.openxmlformats.org/drawingml/2006/main">
               <a:ext uri="{FF2B5EF4-FFF2-40B4-BE49-F238E27FC236}">
-                <a16:creationId xmlns:a16="http://schemas.microsoft.com/office/drawing/2014/main" id="{87ECAA54-D382-493C-A5FF-641B84F73382}"/>
+                <a16:creationId xmlns:a16="http://schemas.microsoft.com/office/drawing/2014/main" id="{9A061E1B-EE83-4D42-A5CD-4DA6A34611E2}"/>
               </a:ext>
             </a:extLst>
           </p:cNvPr>
@@ -5529,7 +5529,7 @@
           <p:cNvPr id="9" name="case-divider">
             <a:extLst xmlns:a="http://schemas.openxmlformats.org/drawingml/2006/main">
               <a:ext uri="{FF2B5EF4-FFF2-40B4-BE49-F238E27FC236}">
-                <a16:creationId xmlns:a16="http://schemas.microsoft.com/office/drawing/2014/main" id="{85379972-0F5E-4B29-8B89-051167E69996}"/>
+                <a16:creationId xmlns:a16="http://schemas.microsoft.com/office/drawing/2014/main" id="{91778BF4-D5BA-495B-A974-F88C149A634F}"/>
               </a:ext>
             </a:extLst>
           </p:cNvPr>
@@ -5560,7 +5560,7 @@
           <p:cNvPr id="10" name="case-row-rule-1">
             <a:extLst xmlns:a="http://schemas.openxmlformats.org/drawingml/2006/main">
               <a:ext uri="{FF2B5EF4-FFF2-40B4-BE49-F238E27FC236}">
-                <a16:creationId xmlns:a16="http://schemas.microsoft.com/office/drawing/2014/main" id="{A6E27DEE-0C21-4C75-A160-16EF949BADA7}"/>
+                <a16:creationId xmlns:a16="http://schemas.microsoft.com/office/drawing/2014/main" id="{31A8DE3F-0FEE-4AE8-9999-638ED9BBBDBB}"/>
               </a:ext>
             </a:extLst>
           </p:cNvPr>
@@ -5591,7 +5591,7 @@
           <p:cNvPr id="11" name="case-row-status-1">
             <a:extLst xmlns:a="http://schemas.openxmlformats.org/drawingml/2006/main">
               <a:ext uri="{FF2B5EF4-FFF2-40B4-BE49-F238E27FC236}">
-                <a16:creationId xmlns:a16="http://schemas.microsoft.com/office/drawing/2014/main" id="{67D93016-6F00-4809-BF8A-F1CF84CB4622}"/>
+                <a16:creationId xmlns:a16="http://schemas.microsoft.com/office/drawing/2014/main" id="{4F732D8A-AD7D-4F4C-AC25-72576AC174CA}"/>
               </a:ext>
             </a:extLst>
           </p:cNvPr>
@@ -5649,7 +5649,7 @@
           <p:cNvPr id="12" name="case-row-label-1">
             <a:extLst xmlns:a="http://schemas.openxmlformats.org/drawingml/2006/main">
               <a:ext uri="{FF2B5EF4-FFF2-40B4-BE49-F238E27FC236}">
-                <a16:creationId xmlns:a16="http://schemas.microsoft.com/office/drawing/2014/main" id="{1B8AA4E8-4832-42BE-B175-8B06C550CD66}"/>
+                <a16:creationId xmlns:a16="http://schemas.microsoft.com/office/drawing/2014/main" id="{B7FD92FB-2E0B-4927-94AC-894EE71A16F1}"/>
               </a:ext>
             </a:extLst>
           </p:cNvPr>
@@ -5707,7 +5707,7 @@
           <p:cNvPr id="13" name="case-row-copy-1">
             <a:extLst xmlns:a="http://schemas.openxmlformats.org/drawingml/2006/main">
               <a:ext uri="{FF2B5EF4-FFF2-40B4-BE49-F238E27FC236}">
-                <a16:creationId xmlns:a16="http://schemas.microsoft.com/office/drawing/2014/main" id="{C7356FAB-C612-4B0A-8069-B0BC8D4C3546}"/>
+                <a16:creationId xmlns:a16="http://schemas.microsoft.com/office/drawing/2014/main" id="{04998589-B4E5-4940-84BB-0C9BE9ECC823}"/>
               </a:ext>
             </a:extLst>
           </p:cNvPr>
@@ -5765,7 +5765,7 @@
           <p:cNvPr id="14" name="case-row-rule-2">
             <a:extLst xmlns:a="http://schemas.openxmlformats.org/drawingml/2006/main">
               <a:ext uri="{FF2B5EF4-FFF2-40B4-BE49-F238E27FC236}">
-                <a16:creationId xmlns:a16="http://schemas.microsoft.com/office/drawing/2014/main" id="{B3AB5365-1B3E-4330-96C8-72B4BD1F8164}"/>
+                <a16:creationId xmlns:a16="http://schemas.microsoft.com/office/drawing/2014/main" id="{F26ABA6F-647B-482D-8C40-0D1C071C4BD9}"/>
               </a:ext>
             </a:extLst>
           </p:cNvPr>
@@ -5796,7 +5796,7 @@
           <p:cNvPr id="15" name="case-row-status-2">
             <a:extLst xmlns:a="http://schemas.openxmlformats.org/drawingml/2006/main">
               <a:ext uri="{FF2B5EF4-FFF2-40B4-BE49-F238E27FC236}">
-                <a16:creationId xmlns:a16="http://schemas.microsoft.com/office/drawing/2014/main" id="{9BC9C06D-9AC5-447E-AA04-C473CEAD640B}"/>
+                <a16:creationId xmlns:a16="http://schemas.microsoft.com/office/drawing/2014/main" id="{81AE5696-9298-47B1-A010-DCC15D40B256}"/>
               </a:ext>
             </a:extLst>
           </p:cNvPr>
@@ -5854,7 +5854,7 @@
           <p:cNvPr id="16" name="case-row-label-2">
             <a:extLst xmlns:a="http://schemas.openxmlformats.org/drawingml/2006/main">
               <a:ext uri="{FF2B5EF4-FFF2-40B4-BE49-F238E27FC236}">
-                <a16:creationId xmlns:a16="http://schemas.microsoft.com/office/drawing/2014/main" id="{B80D2B04-E8CE-452C-B00D-91AB33F3E179}"/>
+                <a16:creationId xmlns:a16="http://schemas.microsoft.com/office/drawing/2014/main" id="{50669B62-B55B-4546-8486-28E9BF1217CB}"/>
               </a:ext>
             </a:extLst>
           </p:cNvPr>
@@ -5912,7 +5912,7 @@
           <p:cNvPr id="17" name="case-row-copy-2">
             <a:extLst xmlns:a="http://schemas.openxmlformats.org/drawingml/2006/main">
               <a:ext uri="{FF2B5EF4-FFF2-40B4-BE49-F238E27FC236}">
-                <a16:creationId xmlns:a16="http://schemas.microsoft.com/office/drawing/2014/main" id="{25C4AC7A-7986-409E-86AD-EA43B0B15A2E}"/>
+                <a16:creationId xmlns:a16="http://schemas.microsoft.com/office/drawing/2014/main" id="{49ADF299-454D-42A1-B495-FAB49B2E6B6D}"/>
               </a:ext>
             </a:extLst>
           </p:cNvPr>
@@ -5970,7 +5970,7 @@
           <p:cNvPr id="18" name="case-row-rule-3">
             <a:extLst xmlns:a="http://schemas.openxmlformats.org/drawingml/2006/main">
               <a:ext uri="{FF2B5EF4-FFF2-40B4-BE49-F238E27FC236}">
-                <a16:creationId xmlns:a16="http://schemas.microsoft.com/office/drawing/2014/main" id="{918B263F-2E7F-4EA2-A82F-EE4ED7333039}"/>
+                <a16:creationId xmlns:a16="http://schemas.microsoft.com/office/drawing/2014/main" id="{E42D067A-916D-4862-8ED1-5E80AF332FCA}"/>
               </a:ext>
             </a:extLst>
           </p:cNvPr>
@@ -6001,7 +6001,7 @@
           <p:cNvPr id="19" name="case-row-status-3">
             <a:extLst xmlns:a="http://schemas.openxmlformats.org/drawingml/2006/main">
               <a:ext uri="{FF2B5EF4-FFF2-40B4-BE49-F238E27FC236}">
-                <a16:creationId xmlns:a16="http://schemas.microsoft.com/office/drawing/2014/main" id="{B14B8BEF-A1D7-4FF3-86F4-F90B2F8BFE0C}"/>
+                <a16:creationId xmlns:a16="http://schemas.microsoft.com/office/drawing/2014/main" id="{C5712362-4E0E-465A-9307-D722992341B6}"/>
               </a:ext>
             </a:extLst>
           </p:cNvPr>
@@ -6059,7 +6059,7 @@
           <p:cNvPr id="20" name="case-row-label-3">
             <a:extLst xmlns:a="http://schemas.openxmlformats.org/drawingml/2006/main">
               <a:ext uri="{FF2B5EF4-FFF2-40B4-BE49-F238E27FC236}">
-                <a16:creationId xmlns:a16="http://schemas.microsoft.com/office/drawing/2014/main" id="{82552732-0A6D-4B67-9EAE-7ACEB413C415}"/>
+                <a16:creationId xmlns:a16="http://schemas.microsoft.com/office/drawing/2014/main" id="{E7430D88-D1AF-45A3-A08B-1CB03DC77E25}"/>
               </a:ext>
             </a:extLst>
           </p:cNvPr>
@@ -6117,7 +6117,7 @@
           <p:cNvPr id="21" name="case-row-copy-3">
             <a:extLst xmlns:a="http://schemas.openxmlformats.org/drawingml/2006/main">
               <a:ext uri="{FF2B5EF4-FFF2-40B4-BE49-F238E27FC236}">
-                <a16:creationId xmlns:a16="http://schemas.microsoft.com/office/drawing/2014/main" id="{8433842B-C615-4D0A-87B8-D554DF38DBB8}"/>
+                <a16:creationId xmlns:a16="http://schemas.microsoft.com/office/drawing/2014/main" id="{497D4F46-866D-4C9F-BA83-7F68F6A76465}"/>
               </a:ext>
             </a:extLst>
           </p:cNvPr>
@@ -6173,7 +6173,7 @@
     </p:spTree>
     <p:extLst>
       <p:ext uri="{BB962C8B-B14F-4D97-AF65-F5344CB8AC3E}">
-        <p14:creationId xmlns:p14="http://schemas.microsoft.com/office/powerpoint/2010/main" val="1523347470"/>
+        <p14:creationId xmlns:p14="http://schemas.microsoft.com/office/powerpoint/2010/main" val="1166752041"/>
       </p:ext>
     </p:extLst>
   </p:cSld>
@@ -6204,7 +6204,7 @@
           <p:cNvPr id="17" name="brand-5">
             <a:extLst xmlns:a="http://schemas.openxmlformats.org/drawingml/2006/main">
               <a:ext uri="{FF2B5EF4-FFF2-40B4-BE49-F238E27FC236}">
-                <a16:creationId xmlns:a16="http://schemas.microsoft.com/office/drawing/2014/main" id="{F2EF9ADF-E62E-4F89-8B07-A07E8524B4D9}"/>
+                <a16:creationId xmlns:a16="http://schemas.microsoft.com/office/drawing/2014/main" id="{F4C04FC7-3236-4101-81B4-7A795F1DED8D}"/>
               </a:ext>
             </a:extLst>
           </p:cNvPr>
@@ -6262,7 +6262,7 @@
           <p:cNvPr id="2" name="title-5">
             <a:extLst xmlns:a="http://schemas.openxmlformats.org/drawingml/2006/main">
               <a:ext uri="{FF2B5EF4-FFF2-40B4-BE49-F238E27FC236}">
-                <a16:creationId xmlns:a16="http://schemas.microsoft.com/office/drawing/2014/main" id="{37166FED-DE7E-458C-9220-DC40BFD8884C}"/>
+                <a16:creationId xmlns:a16="http://schemas.microsoft.com/office/drawing/2014/main" id="{E4064B66-FE7D-4307-A04B-C86E8D8F1F02}"/>
               </a:ext>
             </a:extLst>
           </p:cNvPr>
@@ -6320,7 +6320,7 @@
           <p:cNvPr id="3" name="footer-rule-5">
             <a:extLst xmlns:a="http://schemas.openxmlformats.org/drawingml/2006/main">
               <a:ext uri="{FF2B5EF4-FFF2-40B4-BE49-F238E27FC236}">
-                <a16:creationId xmlns:a16="http://schemas.microsoft.com/office/drawing/2014/main" id="{F9EE294D-37F3-4C0F-BDFA-F4CD2335BB16}"/>
+                <a16:creationId xmlns:a16="http://schemas.microsoft.com/office/drawing/2014/main" id="{EC9DF677-AB81-4AFA-B731-E49C3FC8DC79}"/>
               </a:ext>
             </a:extLst>
           </p:cNvPr>
@@ -6351,7 +6351,7 @@
           <p:cNvPr id="4" name="footer-source-5">
             <a:extLst xmlns:a="http://schemas.openxmlformats.org/drawingml/2006/main">
               <a:ext uri="{FF2B5EF4-FFF2-40B4-BE49-F238E27FC236}">
-                <a16:creationId xmlns:a16="http://schemas.microsoft.com/office/drawing/2014/main" id="{26774910-91B4-43AE-B923-5F3F99DA6621}"/>
+                <a16:creationId xmlns:a16="http://schemas.microsoft.com/office/drawing/2014/main" id="{E4E6C982-6911-4F06-9FC8-1E746EDE58A5}"/>
               </a:ext>
             </a:extLst>
           </p:cNvPr>
@@ -6409,7 +6409,7 @@
           <p:cNvPr id="5" name="footer-page-5">
             <a:extLst xmlns:a="http://schemas.openxmlformats.org/drawingml/2006/main">
               <a:ext uri="{FF2B5EF4-FFF2-40B4-BE49-F238E27FC236}">
-                <a16:creationId xmlns:a16="http://schemas.microsoft.com/office/drawing/2014/main" id="{298A160C-8730-435B-9007-7066BCC1CD64}"/>
+                <a16:creationId xmlns:a16="http://schemas.microsoft.com/office/drawing/2014/main" id="{E6A889B1-D051-4880-8DB6-38A7076F0BCB}"/>
               </a:ext>
             </a:extLst>
           </p:cNvPr>
@@ -6467,7 +6467,7 @@
           <p:cNvPr id="6" name="workflow-rail">
             <a:extLst xmlns:a="http://schemas.openxmlformats.org/drawingml/2006/main">
               <a:ext uri="{FF2B5EF4-FFF2-40B4-BE49-F238E27FC236}">
-                <a16:creationId xmlns:a16="http://schemas.microsoft.com/office/drawing/2014/main" id="{B8628C73-6E47-4AB2-B848-25A70B486954}"/>
+                <a16:creationId xmlns:a16="http://schemas.microsoft.com/office/drawing/2014/main" id="{E67E50EF-E8B4-499E-95AC-C673342AA424}"/>
               </a:ext>
             </a:extLst>
           </p:cNvPr>
@@ -6498,7 +6498,7 @@
           <p:cNvPr id="7" name="workflow-tick-1">
             <a:extLst xmlns:a="http://schemas.openxmlformats.org/drawingml/2006/main">
               <a:ext uri="{FF2B5EF4-FFF2-40B4-BE49-F238E27FC236}">
-                <a16:creationId xmlns:a16="http://schemas.microsoft.com/office/drawing/2014/main" id="{9EAC902D-EFAC-4B39-A1AD-18BD825EC88C}"/>
+                <a16:creationId xmlns:a16="http://schemas.microsoft.com/office/drawing/2014/main" id="{01E830B8-3C15-46D8-B6C8-BE5DC654858E}"/>
               </a:ext>
             </a:extLst>
           </p:cNvPr>
@@ -6529,7 +6529,7 @@
           <p:cNvPr id="8" name="workflow-step-1">
             <a:extLst xmlns:a="http://schemas.openxmlformats.org/drawingml/2006/main">
               <a:ext uri="{FF2B5EF4-FFF2-40B4-BE49-F238E27FC236}">
-                <a16:creationId xmlns:a16="http://schemas.microsoft.com/office/drawing/2014/main" id="{81B5573F-6685-4D0E-8E7E-68C9576E7C98}"/>
+                <a16:creationId xmlns:a16="http://schemas.microsoft.com/office/drawing/2014/main" id="{1EB1E598-701E-4AAA-9689-DD04D23560CF}"/>
               </a:ext>
             </a:extLst>
           </p:cNvPr>
@@ -6587,7 +6587,7 @@
           <p:cNvPr id="9" name="workflow-tick-2">
             <a:extLst xmlns:a="http://schemas.openxmlformats.org/drawingml/2006/main">
               <a:ext uri="{FF2B5EF4-FFF2-40B4-BE49-F238E27FC236}">
-                <a16:creationId xmlns:a16="http://schemas.microsoft.com/office/drawing/2014/main" id="{E5679DDF-F8F7-4438-8E71-85D57E49EA4C}"/>
+                <a16:creationId xmlns:a16="http://schemas.microsoft.com/office/drawing/2014/main" id="{515637E6-1B22-4AE1-A498-464C0D8B2DD5}"/>
               </a:ext>
             </a:extLst>
           </p:cNvPr>
@@ -6618,7 +6618,7 @@
           <p:cNvPr id="10" name="workflow-step-2">
             <a:extLst xmlns:a="http://schemas.openxmlformats.org/drawingml/2006/main">
               <a:ext uri="{FF2B5EF4-FFF2-40B4-BE49-F238E27FC236}">
-                <a16:creationId xmlns:a16="http://schemas.microsoft.com/office/drawing/2014/main" id="{EC48741A-B1CB-45BB-A3F6-7E327984B5E4}"/>
+                <a16:creationId xmlns:a16="http://schemas.microsoft.com/office/drawing/2014/main" id="{504459A1-4654-4211-95DF-99F11DBFB5A7}"/>
               </a:ext>
             </a:extLst>
           </p:cNvPr>
@@ -6676,7 +6676,7 @@
           <p:cNvPr id="11" name="workflow-tick-3">
             <a:extLst xmlns:a="http://schemas.openxmlformats.org/drawingml/2006/main">
               <a:ext uri="{FF2B5EF4-FFF2-40B4-BE49-F238E27FC236}">
-                <a16:creationId xmlns:a16="http://schemas.microsoft.com/office/drawing/2014/main" id="{80BAE232-41F0-4015-916D-B2ECC9A71611}"/>
+                <a16:creationId xmlns:a16="http://schemas.microsoft.com/office/drawing/2014/main" id="{6072EF5B-505B-463F-8960-6E6B17060CB4}"/>
               </a:ext>
             </a:extLst>
           </p:cNvPr>
@@ -6707,7 +6707,7 @@
           <p:cNvPr id="12" name="workflow-step-3">
             <a:extLst xmlns:a="http://schemas.openxmlformats.org/drawingml/2006/main">
               <a:ext uri="{FF2B5EF4-FFF2-40B4-BE49-F238E27FC236}">
-                <a16:creationId xmlns:a16="http://schemas.microsoft.com/office/drawing/2014/main" id="{5EDE5F60-ACDD-472B-AA18-3496FC182D20}"/>
+                <a16:creationId xmlns:a16="http://schemas.microsoft.com/office/drawing/2014/main" id="{2FEA545D-3C27-447F-9B6D-DD24188620A5}"/>
               </a:ext>
             </a:extLst>
           </p:cNvPr>
@@ -6765,7 +6765,7 @@
           <p:cNvPr id="13" name="workflow-tick-4">
             <a:extLst xmlns:a="http://schemas.openxmlformats.org/drawingml/2006/main">
               <a:ext uri="{FF2B5EF4-FFF2-40B4-BE49-F238E27FC236}">
-                <a16:creationId xmlns:a16="http://schemas.microsoft.com/office/drawing/2014/main" id="{D4F9CCC4-29E1-4BAF-9A30-9A59781FBC3D}"/>
+                <a16:creationId xmlns:a16="http://schemas.microsoft.com/office/drawing/2014/main" id="{7AD01CFE-DD00-4C73-BD3F-F153F1E0F707}"/>
               </a:ext>
             </a:extLst>
           </p:cNvPr>
@@ -6796,7 +6796,7 @@
           <p:cNvPr id="14" name="workflow-step-4">
             <a:extLst xmlns:a="http://schemas.openxmlformats.org/drawingml/2006/main">
               <a:ext uri="{FF2B5EF4-FFF2-40B4-BE49-F238E27FC236}">
-                <a16:creationId xmlns:a16="http://schemas.microsoft.com/office/drawing/2014/main" id="{7B6A2C6D-3897-4C6A-AFC5-FDF8EAE7BFD4}"/>
+                <a16:creationId xmlns:a16="http://schemas.microsoft.com/office/drawing/2014/main" id="{E9C4DBC2-6EC2-451D-8981-A215FA738E86}"/>
               </a:ext>
             </a:extLst>
           </p:cNvPr>
@@ -6854,7 +6854,7 @@
           <p:cNvPr id="15" name="workflow-tick-5">
             <a:extLst xmlns:a="http://schemas.openxmlformats.org/drawingml/2006/main">
               <a:ext uri="{FF2B5EF4-FFF2-40B4-BE49-F238E27FC236}">
-                <a16:creationId xmlns:a16="http://schemas.microsoft.com/office/drawing/2014/main" id="{AB62E838-9CA2-41C9-9833-6E8DFFA36C19}"/>
+                <a16:creationId xmlns:a16="http://schemas.microsoft.com/office/drawing/2014/main" id="{716C6A7A-7C37-4928-941F-469293DCD246}"/>
               </a:ext>
             </a:extLst>
           </p:cNvPr>
@@ -6885,7 +6885,7 @@
           <p:cNvPr id="16" name="workflow-step-5">
             <a:extLst xmlns:a="http://schemas.openxmlformats.org/drawingml/2006/main">
               <a:ext uri="{FF2B5EF4-FFF2-40B4-BE49-F238E27FC236}">
-                <a16:creationId xmlns:a16="http://schemas.microsoft.com/office/drawing/2014/main" id="{CEF3956A-9AA5-4607-A7AF-B5A7C578A12A}"/>
+                <a16:creationId xmlns:a16="http://schemas.microsoft.com/office/drawing/2014/main" id="{ED9E3918-7224-4427-97F4-994209271182}"/>
               </a:ext>
             </a:extLst>
           </p:cNvPr>
@@ -6941,7 +6941,7 @@
     </p:spTree>
     <p:extLst>
       <p:ext uri="{BB962C8B-B14F-4D97-AF65-F5344CB8AC3E}">
-        <p14:creationId xmlns:p14="http://schemas.microsoft.com/office/powerpoint/2010/main" val="1176288002"/>
+        <p14:creationId xmlns:p14="http://schemas.microsoft.com/office/powerpoint/2010/main" val="330121730"/>
       </p:ext>
     </p:extLst>
   </p:cSld>
@@ -6972,7 +6972,7 @@
           <p:cNvPr id="16" name="brand-6">
             <a:extLst xmlns:a="http://schemas.openxmlformats.org/drawingml/2006/main">
               <a:ext uri="{FF2B5EF4-FFF2-40B4-BE49-F238E27FC236}">
-                <a16:creationId xmlns:a16="http://schemas.microsoft.com/office/drawing/2014/main" id="{1D16B1B1-2FB8-4E41-ADF3-3A0721C1688E}"/>
+                <a16:creationId xmlns:a16="http://schemas.microsoft.com/office/drawing/2014/main" id="{5E0796A0-716D-49DB-8FCC-8369ACA8DF52}"/>
               </a:ext>
             </a:extLst>
           </p:cNvPr>
@@ -7030,7 +7030,7 @@
           <p:cNvPr id="2" name="title-6">
             <a:extLst xmlns:a="http://schemas.openxmlformats.org/drawingml/2006/main">
               <a:ext uri="{FF2B5EF4-FFF2-40B4-BE49-F238E27FC236}">
-                <a16:creationId xmlns:a16="http://schemas.microsoft.com/office/drawing/2014/main" id="{D6B0749F-B29D-458F-9D0D-224B9DA6C96D}"/>
+                <a16:creationId xmlns:a16="http://schemas.microsoft.com/office/drawing/2014/main" id="{D91528ED-E2C7-4894-BD41-C7C97C04D459}"/>
               </a:ext>
             </a:extLst>
           </p:cNvPr>
@@ -7088,7 +7088,7 @@
           <p:cNvPr id="3" name="footer-rule-6">
             <a:extLst xmlns:a="http://schemas.openxmlformats.org/drawingml/2006/main">
               <a:ext uri="{FF2B5EF4-FFF2-40B4-BE49-F238E27FC236}">
-                <a16:creationId xmlns:a16="http://schemas.microsoft.com/office/drawing/2014/main" id="{0A8D0246-45A9-4B91-A3C5-8A460700765E}"/>
+                <a16:creationId xmlns:a16="http://schemas.microsoft.com/office/drawing/2014/main" id="{14415B55-DE70-4A8D-B5D9-C9A86AE1418F}"/>
               </a:ext>
             </a:extLst>
           </p:cNvPr>
@@ -7119,7 +7119,7 @@
           <p:cNvPr id="4" name="footer-source-6">
             <a:extLst xmlns:a="http://schemas.openxmlformats.org/drawingml/2006/main">
               <a:ext uri="{FF2B5EF4-FFF2-40B4-BE49-F238E27FC236}">
-                <a16:creationId xmlns:a16="http://schemas.microsoft.com/office/drawing/2014/main" id="{464F718D-1242-43E0-8CA3-55EB55340F8E}"/>
+                <a16:creationId xmlns:a16="http://schemas.microsoft.com/office/drawing/2014/main" id="{4C258916-745C-4124-9CBA-B9739E9E6694}"/>
               </a:ext>
             </a:extLst>
           </p:cNvPr>
@@ -7177,7 +7177,7 @@
           <p:cNvPr id="5" name="footer-page-6">
             <a:extLst xmlns:a="http://schemas.openxmlformats.org/drawingml/2006/main">
               <a:ext uri="{FF2B5EF4-FFF2-40B4-BE49-F238E27FC236}">
-                <a16:creationId xmlns:a16="http://schemas.microsoft.com/office/drawing/2014/main" id="{E15AFA2E-99B6-45C9-9A8C-51C086D8F79D}"/>
+                <a16:creationId xmlns:a16="http://schemas.microsoft.com/office/drawing/2014/main" id="{7D80F287-0E43-47C6-97A1-A6384C84D503}"/>
               </a:ext>
             </a:extLst>
           </p:cNvPr>
@@ -7235,7 +7235,7 @@
           <p:cNvPr id="6" name="agent-trace-label">
             <a:extLst xmlns:a="http://schemas.openxmlformats.org/drawingml/2006/main">
               <a:ext uri="{FF2B5EF4-FFF2-40B4-BE49-F238E27FC236}">
-                <a16:creationId xmlns:a16="http://schemas.microsoft.com/office/drawing/2014/main" id="{AF88FC5B-3297-4E0F-AFE0-FF2C31F32B38}"/>
+                <a16:creationId xmlns:a16="http://schemas.microsoft.com/office/drawing/2014/main" id="{FD63B491-CA54-4DE7-B586-5FBA70A789F9}"/>
               </a:ext>
             </a:extLst>
           </p:cNvPr>
@@ -7293,7 +7293,7 @@
           <p:cNvPr id="7" name="agent-trace-spine">
             <a:extLst xmlns:a="http://schemas.openxmlformats.org/drawingml/2006/main">
               <a:ext uri="{FF2B5EF4-FFF2-40B4-BE49-F238E27FC236}">
-                <a16:creationId xmlns:a16="http://schemas.microsoft.com/office/drawing/2014/main" id="{F24CA72F-AE1F-4238-8017-FBE89FB5CF21}"/>
+                <a16:creationId xmlns:a16="http://schemas.microsoft.com/office/drawing/2014/main" id="{E48825D8-BDAA-4CEE-82A3-292ABB78F445}"/>
               </a:ext>
             </a:extLst>
           </p:cNvPr>
@@ -7324,7 +7324,7 @@
           <p:cNvPr id="8" name="agent-propose">
             <a:extLst xmlns:a="http://schemas.openxmlformats.org/drawingml/2006/main">
               <a:ext uri="{FF2B5EF4-FFF2-40B4-BE49-F238E27FC236}">
-                <a16:creationId xmlns:a16="http://schemas.microsoft.com/office/drawing/2014/main" id="{744BA642-E9AB-464C-8B25-2962C3071422}"/>
+                <a16:creationId xmlns:a16="http://schemas.microsoft.com/office/drawing/2014/main" id="{E7A919F6-1C99-4830-A5E8-0BF34AC39526}"/>
               </a:ext>
             </a:extLst>
           </p:cNvPr>
@@ -7382,7 +7382,7 @@
           <p:cNvPr id="9" name="agent-propose-copy">
             <a:extLst xmlns:a="http://schemas.openxmlformats.org/drawingml/2006/main">
               <a:ext uri="{FF2B5EF4-FFF2-40B4-BE49-F238E27FC236}">
-                <a16:creationId xmlns:a16="http://schemas.microsoft.com/office/drawing/2014/main" id="{6465D55D-E20D-4B79-BC46-3D93279FE387}"/>
+                <a16:creationId xmlns:a16="http://schemas.microsoft.com/office/drawing/2014/main" id="{8691C1C0-992E-42E9-A187-C3F92D8D2C1E}"/>
               </a:ext>
             </a:extLst>
           </p:cNvPr>
@@ -7440,7 +7440,7 @@
           <p:cNvPr id="10" name="agent-abstain">
             <a:extLst xmlns:a="http://schemas.openxmlformats.org/drawingml/2006/main">
               <a:ext uri="{FF2B5EF4-FFF2-40B4-BE49-F238E27FC236}">
-                <a16:creationId xmlns:a16="http://schemas.microsoft.com/office/drawing/2014/main" id="{36FB67B7-7E14-4685-984B-D1AD76280B64}"/>
+                <a16:creationId xmlns:a16="http://schemas.microsoft.com/office/drawing/2014/main" id="{17FE4DEE-576E-4EEA-B352-B038D53CB251}"/>
               </a:ext>
             </a:extLst>
           </p:cNvPr>
@@ -7498,7 +7498,7 @@
           <p:cNvPr id="11" name="agent-abstain-copy">
             <a:extLst xmlns:a="http://schemas.openxmlformats.org/drawingml/2006/main">
               <a:ext uri="{FF2B5EF4-FFF2-40B4-BE49-F238E27FC236}">
-                <a16:creationId xmlns:a16="http://schemas.microsoft.com/office/drawing/2014/main" id="{9F593706-ED12-4B5C-A40B-5DC57796EFF5}"/>
+                <a16:creationId xmlns:a16="http://schemas.microsoft.com/office/drawing/2014/main" id="{FBB37F69-94E4-4C1B-A9FE-FF24736D5D48}"/>
               </a:ext>
             </a:extLst>
           </p:cNvPr>
@@ -7556,7 +7556,7 @@
           <p:cNvPr id="12" name="agent-decide">
             <a:extLst xmlns:a="http://schemas.openxmlformats.org/drawingml/2006/main">
               <a:ext uri="{FF2B5EF4-FFF2-40B4-BE49-F238E27FC236}">
-                <a16:creationId xmlns:a16="http://schemas.microsoft.com/office/drawing/2014/main" id="{5A353405-019C-4C9F-8506-998C79C86725}"/>
+                <a16:creationId xmlns:a16="http://schemas.microsoft.com/office/drawing/2014/main" id="{DB47C65C-2A6D-486E-9A78-67F27E994B1D}"/>
               </a:ext>
             </a:extLst>
           </p:cNvPr>
@@ -7614,7 +7614,7 @@
           <p:cNvPr id="13" name="agent-decide-copy">
             <a:extLst xmlns:a="http://schemas.openxmlformats.org/drawingml/2006/main">
               <a:ext uri="{FF2B5EF4-FFF2-40B4-BE49-F238E27FC236}">
-                <a16:creationId xmlns:a16="http://schemas.microsoft.com/office/drawing/2014/main" id="{E6BA24BF-81D0-4251-98B6-A84E6012DA41}"/>
+                <a16:creationId xmlns:a16="http://schemas.microsoft.com/office/drawing/2014/main" id="{7710185D-99D4-4EF6-99C1-1A8FCDD01438}"/>
               </a:ext>
             </a:extLst>
           </p:cNvPr>
@@ -7672,7 +7672,7 @@
           <p:cNvPr id="14" name="agent-boundary-rule">
             <a:extLst xmlns:a="http://schemas.openxmlformats.org/drawingml/2006/main">
               <a:ext uri="{FF2B5EF4-FFF2-40B4-BE49-F238E27FC236}">
-                <a16:creationId xmlns:a16="http://schemas.microsoft.com/office/drawing/2014/main" id="{98F06A96-6944-4338-AA42-9811BA9A64E0}"/>
+                <a16:creationId xmlns:a16="http://schemas.microsoft.com/office/drawing/2014/main" id="{43638DDE-F8B3-414E-8883-9F447129A646}"/>
               </a:ext>
             </a:extLst>
           </p:cNvPr>
@@ -7703,7 +7703,7 @@
           <p:cNvPr id="15" name="agent-boundary-copy">
             <a:extLst xmlns:a="http://schemas.openxmlformats.org/drawingml/2006/main">
               <a:ext uri="{FF2B5EF4-FFF2-40B4-BE49-F238E27FC236}">
-                <a16:creationId xmlns:a16="http://schemas.microsoft.com/office/drawing/2014/main" id="{A15D304F-82E4-44FE-BBB3-43CF31590042}"/>
+                <a16:creationId xmlns:a16="http://schemas.microsoft.com/office/drawing/2014/main" id="{7DB312F8-09EB-4D3C-8CCB-6094CB64FD46}"/>
               </a:ext>
             </a:extLst>
           </p:cNvPr>
@@ -7759,7 +7759,7 @@
     </p:spTree>
     <p:extLst>
       <p:ext uri="{BB962C8B-B14F-4D97-AF65-F5344CB8AC3E}">
-        <p14:creationId xmlns:p14="http://schemas.microsoft.com/office/powerpoint/2010/main" val="1152360368"/>
+        <p14:creationId xmlns:p14="http://schemas.microsoft.com/office/powerpoint/2010/main" val="90336934"/>
       </p:ext>
     </p:extLst>
   </p:cSld>
@@ -7790,7 +7790,7 @@
           <p:cNvPr id="15" name="brand-7">
             <a:extLst xmlns:a="http://schemas.openxmlformats.org/drawingml/2006/main">
               <a:ext uri="{FF2B5EF4-FFF2-40B4-BE49-F238E27FC236}">
-                <a16:creationId xmlns:a16="http://schemas.microsoft.com/office/drawing/2014/main" id="{E2BCE0D4-44A8-4C15-A986-336DB30EE561}"/>
+                <a16:creationId xmlns:a16="http://schemas.microsoft.com/office/drawing/2014/main" id="{FA84ACA7-52B6-471D-B1DA-DDD36BCD3DA7}"/>
               </a:ext>
             </a:extLst>
           </p:cNvPr>
@@ -7848,7 +7848,7 @@
           <p:cNvPr id="2" name="title-7">
             <a:extLst xmlns:a="http://schemas.openxmlformats.org/drawingml/2006/main">
               <a:ext uri="{FF2B5EF4-FFF2-40B4-BE49-F238E27FC236}">
-                <a16:creationId xmlns:a16="http://schemas.microsoft.com/office/drawing/2014/main" id="{BDEADBE9-F76B-46B0-969B-79E69B85E21D}"/>
+                <a16:creationId xmlns:a16="http://schemas.microsoft.com/office/drawing/2014/main" id="{07CD6305-0F12-49A5-9E7D-CB2FD74F1F54}"/>
               </a:ext>
             </a:extLst>
           </p:cNvPr>
@@ -7906,7 +7906,7 @@
           <p:cNvPr id="3" name="footer-rule-7">
             <a:extLst xmlns:a="http://schemas.openxmlformats.org/drawingml/2006/main">
               <a:ext uri="{FF2B5EF4-FFF2-40B4-BE49-F238E27FC236}">
-                <a16:creationId xmlns:a16="http://schemas.microsoft.com/office/drawing/2014/main" id="{8055BC13-BCEB-4087-8B7A-C64E6659A923}"/>
+                <a16:creationId xmlns:a16="http://schemas.microsoft.com/office/drawing/2014/main" id="{53C10EA6-309B-499A-A14F-45093D6467BD}"/>
               </a:ext>
             </a:extLst>
           </p:cNvPr>
@@ -7937,7 +7937,7 @@
           <p:cNvPr id="4" name="footer-source-7">
             <a:extLst xmlns:a="http://schemas.openxmlformats.org/drawingml/2006/main">
               <a:ext uri="{FF2B5EF4-FFF2-40B4-BE49-F238E27FC236}">
-                <a16:creationId xmlns:a16="http://schemas.microsoft.com/office/drawing/2014/main" id="{C67693F0-3BB6-440A-BA5C-54FBACCA1753}"/>
+                <a16:creationId xmlns:a16="http://schemas.microsoft.com/office/drawing/2014/main" id="{16B566EA-8151-44FE-B86D-4242B60767B7}"/>
               </a:ext>
             </a:extLst>
           </p:cNvPr>
@@ -7995,7 +7995,7 @@
           <p:cNvPr id="5" name="footer-page-7">
             <a:extLst xmlns:a="http://schemas.openxmlformats.org/drawingml/2006/main">
               <a:ext uri="{FF2B5EF4-FFF2-40B4-BE49-F238E27FC236}">
-                <a16:creationId xmlns:a16="http://schemas.microsoft.com/office/drawing/2014/main" id="{7F950B24-5174-4589-9B90-9506047A9B03}"/>
+                <a16:creationId xmlns:a16="http://schemas.microsoft.com/office/drawing/2014/main" id="{3273F246-3118-4ED9-92F3-41C08BAE6250}"/>
               </a:ext>
             </a:extLst>
           </p:cNvPr>
@@ -8053,7 +8053,7 @@
           <p:cNvPr id="6" name="prototype-proof-label">
             <a:extLst xmlns:a="http://schemas.openxmlformats.org/drawingml/2006/main">
               <a:ext uri="{FF2B5EF4-FFF2-40B4-BE49-F238E27FC236}">
-                <a16:creationId xmlns:a16="http://schemas.microsoft.com/office/drawing/2014/main" id="{3FCD8AC6-592D-4242-AAEA-6BBB40099515}"/>
+                <a16:creationId xmlns:a16="http://schemas.microsoft.com/office/drawing/2014/main" id="{FD075043-030C-41E0-8874-91663B17D32F}"/>
               </a:ext>
             </a:extLst>
           </p:cNvPr>
@@ -8115,7 +8115,7 @@
           <p:nvPr/>
         </p:nvPicPr>
         <p:blipFill>
-          <a:blip xmlns:r="http://schemas.openxmlformats.org/officeDocument/2006/relationships" xmlns:a="http://schemas.openxmlformats.org/drawingml/2006/main" r:embed="R5af87368242f4434"/>
+          <a:blip xmlns:r="http://schemas.openxmlformats.org/officeDocument/2006/relationships" xmlns:a="http://schemas.openxmlformats.org/drawingml/2006/main" r:embed="R9c51eb1a70064336"/>
           <a:srcRect xmlns:a="http://schemas.openxmlformats.org/drawingml/2006/main" l="0" t="9" r="0" b="9"/>
           <a:stretch xmlns:a="http://schemas.openxmlformats.org/drawingml/2006/main">
             <a:fillRect l="0" t="0" r="0" b="0"/>
@@ -8136,7 +8136,7 @@
           <p:cNvPr id="8" name="prototype-conflict-border">
             <a:extLst xmlns:a="http://schemas.openxmlformats.org/drawingml/2006/main">
               <a:ext uri="{FF2B5EF4-FFF2-40B4-BE49-F238E27FC236}">
-                <a16:creationId xmlns:a16="http://schemas.microsoft.com/office/drawing/2014/main" id="{52982A98-C98E-425A-8680-C7D20CB53ECC}"/>
+                <a16:creationId xmlns:a16="http://schemas.microsoft.com/office/drawing/2014/main" id="{59ED0209-495F-4F3A-8558-BEC161743D36}"/>
               </a:ext>
             </a:extLst>
           </p:cNvPr>
@@ -8171,7 +8171,7 @@
           <p:nvPr/>
         </p:nvPicPr>
         <p:blipFill>
-          <a:blip xmlns:r="http://schemas.openxmlformats.org/officeDocument/2006/relationships" xmlns:a="http://schemas.openxmlformats.org/drawingml/2006/main" r:embed="R5991bfc67f8d40e2"/>
+          <a:blip xmlns:r="http://schemas.openxmlformats.org/officeDocument/2006/relationships" xmlns:a="http://schemas.openxmlformats.org/drawingml/2006/main" r:embed="R99d189f6ad9e47d2"/>
           <a:srcRect xmlns:a="http://schemas.openxmlformats.org/drawingml/2006/main" l="19" t="0" r="19" b="0"/>
           <a:stretch xmlns:a="http://schemas.openxmlformats.org/drawingml/2006/main">
             <a:fillRect l="0" t="0" r="0" b="0"/>
@@ -8192,7 +8192,7 @@
           <p:cNvPr id="10" name="prototype-receipt-border">
             <a:extLst xmlns:a="http://schemas.openxmlformats.org/drawingml/2006/main">
               <a:ext uri="{FF2B5EF4-FFF2-40B4-BE49-F238E27FC236}">
-                <a16:creationId xmlns:a16="http://schemas.microsoft.com/office/drawing/2014/main" id="{8FC7D5D9-8FF8-47C5-9C5C-177AC283A3ED}"/>
+                <a16:creationId xmlns:a16="http://schemas.microsoft.com/office/drawing/2014/main" id="{9C08AD83-3F64-48EB-9244-F2DFDCAC248A}"/>
               </a:ext>
             </a:extLst>
           </p:cNvPr>
@@ -8223,7 +8223,7 @@
           <p:cNvPr id="11" name="prototype-callout-1">
             <a:extLst xmlns:a="http://schemas.openxmlformats.org/drawingml/2006/main">
               <a:ext uri="{FF2B5EF4-FFF2-40B4-BE49-F238E27FC236}">
-                <a16:creationId xmlns:a16="http://schemas.microsoft.com/office/drawing/2014/main" id="{ADD48A61-FFEA-484C-BF42-A23C03E81BB8}"/>
+                <a16:creationId xmlns:a16="http://schemas.microsoft.com/office/drawing/2014/main" id="{CA324B51-B7ED-4C5A-B87D-16BC57708F6D}"/>
               </a:ext>
             </a:extLst>
           </p:cNvPr>
@@ -8281,7 +8281,7 @@
           <p:cNvPr id="12" name="prototype-callout-2">
             <a:extLst xmlns:a="http://schemas.openxmlformats.org/drawingml/2006/main">
               <a:ext uri="{FF2B5EF4-FFF2-40B4-BE49-F238E27FC236}">
-                <a16:creationId xmlns:a16="http://schemas.microsoft.com/office/drawing/2014/main" id="{2690611F-7F7D-4B62-BAA6-A7BD41FD44FF}"/>
+                <a16:creationId xmlns:a16="http://schemas.microsoft.com/office/drawing/2014/main" id="{9FB3076E-B8F8-43CC-85E2-C1EDD1DA0F68}"/>
               </a:ext>
             </a:extLst>
           </p:cNvPr>
@@ -8339,7 +8339,7 @@
           <p:cNvPr id="13" name="prototype-callout-3">
             <a:extLst xmlns:a="http://schemas.openxmlformats.org/drawingml/2006/main">
               <a:ext uri="{FF2B5EF4-FFF2-40B4-BE49-F238E27FC236}">
-                <a16:creationId xmlns:a16="http://schemas.microsoft.com/office/drawing/2014/main" id="{283AB623-BF26-48C2-9291-ED8B02F056D4}"/>
+                <a16:creationId xmlns:a16="http://schemas.microsoft.com/office/drawing/2014/main" id="{04617FE5-19C1-4D75-8BA4-E1C05D3E9405}"/>
               </a:ext>
             </a:extLst>
           </p:cNvPr>
@@ -8397,7 +8397,7 @@
           <p:cNvPr id="14" name="prototype-callout-4">
             <a:extLst xmlns:a="http://schemas.openxmlformats.org/drawingml/2006/main">
               <a:ext uri="{FF2B5EF4-FFF2-40B4-BE49-F238E27FC236}">
-                <a16:creationId xmlns:a16="http://schemas.microsoft.com/office/drawing/2014/main" id="{83565B9E-4FB2-4242-A174-6FBBC1C853E3}"/>
+                <a16:creationId xmlns:a16="http://schemas.microsoft.com/office/drawing/2014/main" id="{95277337-348D-4E94-9EA1-52C5C2571864}"/>
               </a:ext>
             </a:extLst>
           </p:cNvPr>
@@ -8453,7 +8453,7 @@
     </p:spTree>
     <p:extLst>
       <p:ext uri="{BB962C8B-B14F-4D97-AF65-F5344CB8AC3E}">
-        <p14:creationId xmlns:p14="http://schemas.microsoft.com/office/powerpoint/2010/main" val="1440311214"/>
+        <p14:creationId xmlns:p14="http://schemas.microsoft.com/office/powerpoint/2010/main" val="1415848836"/>
       </p:ext>
     </p:extLst>
   </p:cSld>
@@ -8484,7 +8484,7 @@
           <p:cNvPr id="24" name="brand-8">
             <a:extLst xmlns:a="http://schemas.openxmlformats.org/drawingml/2006/main">
               <a:ext uri="{FF2B5EF4-FFF2-40B4-BE49-F238E27FC236}">
-                <a16:creationId xmlns:a16="http://schemas.microsoft.com/office/drawing/2014/main" id="{C393EB5C-76F7-4FB3-B1F9-9BEDD84CB9EF}"/>
+                <a16:creationId xmlns:a16="http://schemas.microsoft.com/office/drawing/2014/main" id="{32FCC807-09E1-4450-AE93-E29331BA2C74}"/>
               </a:ext>
             </a:extLst>
           </p:cNvPr>
@@ -8542,7 +8542,7 @@
           <p:cNvPr id="2" name="title-8">
             <a:extLst xmlns:a="http://schemas.openxmlformats.org/drawingml/2006/main">
               <a:ext uri="{FF2B5EF4-FFF2-40B4-BE49-F238E27FC236}">
-                <a16:creationId xmlns:a16="http://schemas.microsoft.com/office/drawing/2014/main" id="{056EE1AA-4225-4C0B-8B2D-E94299C03DE2}"/>
+                <a16:creationId xmlns:a16="http://schemas.microsoft.com/office/drawing/2014/main" id="{218E0838-9203-461E-BDFE-1D8F6C49447D}"/>
               </a:ext>
             </a:extLst>
           </p:cNvPr>
@@ -8600,7 +8600,7 @@
           <p:cNvPr id="3" name="footer-rule-8">
             <a:extLst xmlns:a="http://schemas.openxmlformats.org/drawingml/2006/main">
               <a:ext uri="{FF2B5EF4-FFF2-40B4-BE49-F238E27FC236}">
-                <a16:creationId xmlns:a16="http://schemas.microsoft.com/office/drawing/2014/main" id="{244245E5-A828-4D7C-99D9-BA8765CDCA44}"/>
+                <a16:creationId xmlns:a16="http://schemas.microsoft.com/office/drawing/2014/main" id="{25C671D0-FD32-43DF-93DD-E7E8116E492D}"/>
               </a:ext>
             </a:extLst>
           </p:cNvPr>
@@ -8631,7 +8631,7 @@
           <p:cNvPr id="4" name="footer-source-8">
             <a:extLst xmlns:a="http://schemas.openxmlformats.org/drawingml/2006/main">
               <a:ext uri="{FF2B5EF4-FFF2-40B4-BE49-F238E27FC236}">
-                <a16:creationId xmlns:a16="http://schemas.microsoft.com/office/drawing/2014/main" id="{6A3EA32E-5350-4A41-9E38-5A35F059BC05}"/>
+                <a16:creationId xmlns:a16="http://schemas.microsoft.com/office/drawing/2014/main" id="{9E488A63-DA7B-4A28-83F1-93D801661E55}"/>
               </a:ext>
             </a:extLst>
           </p:cNvPr>
@@ -8689,7 +8689,7 @@
           <p:cNvPr id="5" name="footer-page-8">
             <a:extLst xmlns:a="http://schemas.openxmlformats.org/drawingml/2006/main">
               <a:ext uri="{FF2B5EF4-FFF2-40B4-BE49-F238E27FC236}">
-                <a16:creationId xmlns:a16="http://schemas.microsoft.com/office/drawing/2014/main" id="{C11D7712-0085-4FF1-9881-D8B32B964238}"/>
+                <a16:creationId xmlns:a16="http://schemas.microsoft.com/office/drawing/2014/main" id="{C234A498-E95A-481F-A8EA-C10F0A9AD812}"/>
               </a:ext>
             </a:extLst>
           </p:cNvPr>
@@ -8747,7 +8747,7 @@
           <p:cNvPr id="6" name="sensitivity-label">
             <a:extLst xmlns:a="http://schemas.openxmlformats.org/drawingml/2006/main">
               <a:ext uri="{FF2B5EF4-FFF2-40B4-BE49-F238E27FC236}">
-                <a16:creationId xmlns:a16="http://schemas.microsoft.com/office/drawing/2014/main" id="{E58C721B-1F66-4218-8B26-A62F23717336}"/>
+                <a16:creationId xmlns:a16="http://schemas.microsoft.com/office/drawing/2014/main" id="{C91DCF8D-84AE-4EA7-AB2B-634D0CAFCA63}"/>
               </a:ext>
             </a:extLst>
           </p:cNvPr>
@@ -8805,7 +8805,7 @@
           <p:cNvPr id="7" name="sensitivity-row-0">
             <a:extLst xmlns:a="http://schemas.openxmlformats.org/drawingml/2006/main">
               <a:ext uri="{FF2B5EF4-FFF2-40B4-BE49-F238E27FC236}">
-                <a16:creationId xmlns:a16="http://schemas.microsoft.com/office/drawing/2014/main" id="{9A68329D-752D-40D7-8657-152C8ADC37EE}"/>
+                <a16:creationId xmlns:a16="http://schemas.microsoft.com/office/drawing/2014/main" id="{0AE7CCE4-0F1C-402A-95CC-B62CEE8F7B1A}"/>
               </a:ext>
             </a:extLst>
           </p:cNvPr>
@@ -8836,7 +8836,7 @@
           <p:cNvPr id="8" name="sensitivity-0-0">
             <a:extLst xmlns:a="http://schemas.openxmlformats.org/drawingml/2006/main">
               <a:ext uri="{FF2B5EF4-FFF2-40B4-BE49-F238E27FC236}">
-                <a16:creationId xmlns:a16="http://schemas.microsoft.com/office/drawing/2014/main" id="{BF239B8A-DB38-4178-99B3-1FA94544C393}"/>
+                <a16:creationId xmlns:a16="http://schemas.microsoft.com/office/drawing/2014/main" id="{30CFA534-5FC5-432E-ADF1-AC0774352158}"/>
               </a:ext>
             </a:extLst>
           </p:cNvPr>
@@ -8894,7 +8894,7 @@
           <p:cNvPr id="9" name="sensitivity-0-1">
             <a:extLst xmlns:a="http://schemas.openxmlformats.org/drawingml/2006/main">
               <a:ext uri="{FF2B5EF4-FFF2-40B4-BE49-F238E27FC236}">
-                <a16:creationId xmlns:a16="http://schemas.microsoft.com/office/drawing/2014/main" id="{D7EB377B-A100-4975-83BA-AD4C8803591D}"/>
+                <a16:creationId xmlns:a16="http://schemas.microsoft.com/office/drawing/2014/main" id="{14ABF6F8-C2F1-4819-975B-1C3985895B20}"/>
               </a:ext>
             </a:extLst>
           </p:cNvPr>
@@ -8952,7 +8952,7 @@
           <p:cNvPr id="10" name="sensitivity-0-2">
             <a:extLst xmlns:a="http://schemas.openxmlformats.org/drawingml/2006/main">
               <a:ext uri="{FF2B5EF4-FFF2-40B4-BE49-F238E27FC236}">
-                <a16:creationId xmlns:a16="http://schemas.microsoft.com/office/drawing/2014/main" id="{1DB424AF-5968-43DA-8185-A0600F6EDB6A}"/>
+                <a16:creationId xmlns:a16="http://schemas.microsoft.com/office/drawing/2014/main" id="{28764708-50F9-4F9E-BFBC-D84A8ECB99BB}"/>
               </a:ext>
             </a:extLst>
           </p:cNvPr>
@@ -9010,7 +9010,7 @@
           <p:cNvPr id="11" name="sensitivity-row-1">
             <a:extLst xmlns:a="http://schemas.openxmlformats.org/drawingml/2006/main">
               <a:ext uri="{FF2B5EF4-FFF2-40B4-BE49-F238E27FC236}">
-                <a16:creationId xmlns:a16="http://schemas.microsoft.com/office/drawing/2014/main" id="{396D2DCA-D27A-410D-8503-6D5DD9887DB9}"/>
+                <a16:creationId xmlns:a16="http://schemas.microsoft.com/office/drawing/2014/main" id="{43E4CBE1-9EFA-48AF-BA5E-9B6F5BFD0AC9}"/>
               </a:ext>
             </a:extLst>
           </p:cNvPr>
@@ -9041,7 +9041,7 @@
           <p:cNvPr id="12" name="sensitivity-1-0">
             <a:extLst xmlns:a="http://schemas.openxmlformats.org/drawingml/2006/main">
               <a:ext uri="{FF2B5EF4-FFF2-40B4-BE49-F238E27FC236}">
-                <a16:creationId xmlns:a16="http://schemas.microsoft.com/office/drawing/2014/main" id="{51F65D88-A456-4409-A904-5DA168DBD233}"/>
+                <a16:creationId xmlns:a16="http://schemas.microsoft.com/office/drawing/2014/main" id="{D7B6B4ED-095A-44AE-B6CB-FAA659094280}"/>
               </a:ext>
             </a:extLst>
           </p:cNvPr>
@@ -9099,7 +9099,7 @@
           <p:cNvPr id="13" name="sensitivity-1-1">
             <a:extLst xmlns:a="http://schemas.openxmlformats.org/drawingml/2006/main">
               <a:ext uri="{FF2B5EF4-FFF2-40B4-BE49-F238E27FC236}">
-                <a16:creationId xmlns:a16="http://schemas.microsoft.com/office/drawing/2014/main" id="{F1D95808-0229-4603-84C6-F02DD582EA04}"/>
+                <a16:creationId xmlns:a16="http://schemas.microsoft.com/office/drawing/2014/main" id="{FC303B40-A1F3-4AE4-B189-F1666A4AC259}"/>
               </a:ext>
             </a:extLst>
           </p:cNvPr>
@@ -9157,7 +9157,7 @@
           <p:cNvPr id="14" name="sensitivity-1-2">
             <a:extLst xmlns:a="http://schemas.openxmlformats.org/drawingml/2006/main">
               <a:ext uri="{FF2B5EF4-FFF2-40B4-BE49-F238E27FC236}">
-                <a16:creationId xmlns:a16="http://schemas.microsoft.com/office/drawing/2014/main" id="{E4C0A8E2-3D48-463D-9B7B-6B39DFF24273}"/>
+                <a16:creationId xmlns:a16="http://schemas.microsoft.com/office/drawing/2014/main" id="{68ED996B-6024-49FC-8705-D76EBAAF9FC3}"/>
               </a:ext>
             </a:extLst>
           </p:cNvPr>
@@ -9215,7 +9215,7 @@
           <p:cNvPr id="15" name="sensitivity-row-2">
             <a:extLst xmlns:a="http://schemas.openxmlformats.org/drawingml/2006/main">
               <a:ext uri="{FF2B5EF4-FFF2-40B4-BE49-F238E27FC236}">
-                <a16:creationId xmlns:a16="http://schemas.microsoft.com/office/drawing/2014/main" id="{1D7C3EDB-81BC-4310-AB03-18C09ED7069D}"/>
+                <a16:creationId xmlns:a16="http://schemas.microsoft.com/office/drawing/2014/main" id="{3331641A-4FD2-4B79-8634-1C58C8DADA36}"/>
               </a:ext>
             </a:extLst>
           </p:cNvPr>
@@ -9246,7 +9246,7 @@
           <p:cNvPr id="16" name="sensitivity-2-0">
             <a:extLst xmlns:a="http://schemas.openxmlformats.org/drawingml/2006/main">
               <a:ext uri="{FF2B5EF4-FFF2-40B4-BE49-F238E27FC236}">
-                <a16:creationId xmlns:a16="http://schemas.microsoft.com/office/drawing/2014/main" id="{DAB92C71-95CF-4872-A6C0-B992C7B58CF6}"/>
+                <a16:creationId xmlns:a16="http://schemas.microsoft.com/office/drawing/2014/main" id="{2A2C698E-0404-4FA4-ACBD-A6C8E45FC70D}"/>
               </a:ext>
             </a:extLst>
           </p:cNvPr>
@@ -9304,7 +9304,7 @@
           <p:cNvPr id="17" name="sensitivity-2-1">
             <a:extLst xmlns:a="http://schemas.openxmlformats.org/drawingml/2006/main">
               <a:ext uri="{FF2B5EF4-FFF2-40B4-BE49-F238E27FC236}">
-                <a16:creationId xmlns:a16="http://schemas.microsoft.com/office/drawing/2014/main" id="{E87B8FB9-49C2-41A7-939A-55C9BBCC4B34}"/>
+                <a16:creationId xmlns:a16="http://schemas.microsoft.com/office/drawing/2014/main" id="{AA831E64-676F-48DC-9426-06906F46C7C8}"/>
               </a:ext>
             </a:extLst>
           </p:cNvPr>
@@ -9362,7 +9362,7 @@
           <p:cNvPr id="18" name="sensitivity-2-2">
             <a:extLst xmlns:a="http://schemas.openxmlformats.org/drawingml/2006/main">
               <a:ext uri="{FF2B5EF4-FFF2-40B4-BE49-F238E27FC236}">
-                <a16:creationId xmlns:a16="http://schemas.microsoft.com/office/drawing/2014/main" id="{48CCD3C7-2E44-4F90-9698-CF7857E3884B}"/>
+                <a16:creationId xmlns:a16="http://schemas.microsoft.com/office/drawing/2014/main" id="{035F0983-26BA-417E-99C7-FA0C26A6A567}"/>
               </a:ext>
             </a:extLst>
           </p:cNvPr>
@@ -9420,7 +9420,7 @@
           <p:cNvPr id="19" name="sensitivity-divider">
             <a:extLst xmlns:a="http://schemas.openxmlformats.org/drawingml/2006/main">
               <a:ext uri="{FF2B5EF4-FFF2-40B4-BE49-F238E27FC236}">
-                <a16:creationId xmlns:a16="http://schemas.microsoft.com/office/drawing/2014/main" id="{D0CFAFDA-4F62-49D0-BEC4-34A60A1AB924}"/>
+                <a16:creationId xmlns:a16="http://schemas.microsoft.com/office/drawing/2014/main" id="{35CE4064-4D43-4368-A6C7-446496E4E44A}"/>
               </a:ext>
             </a:extLst>
           </p:cNvPr>
@@ -9451,7 +9451,7 @@
           <p:cNvPr id="20" name="sensitivity-gates">
             <a:extLst xmlns:a="http://schemas.openxmlformats.org/drawingml/2006/main">
               <a:ext uri="{FF2B5EF4-FFF2-40B4-BE49-F238E27FC236}">
-                <a16:creationId xmlns:a16="http://schemas.microsoft.com/office/drawing/2014/main" id="{40F9F9F8-E982-4C4D-B4D6-2003E8A7761E}"/>
+                <a16:creationId xmlns:a16="http://schemas.microsoft.com/office/drawing/2014/main" id="{2E2391E1-7B75-4D79-81EC-9ACB7A5229AB}"/>
               </a:ext>
             </a:extLst>
           </p:cNvPr>
@@ -9509,7 +9509,7 @@
           <p:cNvPr id="21" name="footer-sensitivity-hypothesis-label">
             <a:extLst xmlns:a="http://schemas.openxmlformats.org/drawingml/2006/main">
               <a:ext uri="{FF2B5EF4-FFF2-40B4-BE49-F238E27FC236}">
-                <a16:creationId xmlns:a16="http://schemas.microsoft.com/office/drawing/2014/main" id="{975121EB-8515-4224-89B9-FC72CAAAEEBA}"/>
+                <a16:creationId xmlns:a16="http://schemas.microsoft.com/office/drawing/2014/main" id="{CEA9E006-B709-4640-99F4-DF859596BEBC}"/>
               </a:ext>
             </a:extLst>
           </p:cNvPr>
@@ -9567,7 +9567,7 @@
           <p:cNvPr id="22" name="sensitivity-hypothesis">
             <a:extLst xmlns:a="http://schemas.openxmlformats.org/drawingml/2006/main">
               <a:ext uri="{FF2B5EF4-FFF2-40B4-BE49-F238E27FC236}">
-                <a16:creationId xmlns:a16="http://schemas.microsoft.com/office/drawing/2014/main" id="{D3A2EEC9-8916-4EFE-8757-2D986585F77B}"/>
+                <a16:creationId xmlns:a16="http://schemas.microsoft.com/office/drawing/2014/main" id="{E5CF6E96-8196-49FF-ACC2-8916BE5FE046}"/>
               </a:ext>
             </a:extLst>
           </p:cNvPr>
@@ -9625,7 +9625,7 @@
           <p:cNvPr id="23" name="sensitivity-disclaimer">
             <a:extLst xmlns:a="http://schemas.openxmlformats.org/drawingml/2006/main">
               <a:ext uri="{FF2B5EF4-FFF2-40B4-BE49-F238E27FC236}">
-                <a16:creationId xmlns:a16="http://schemas.microsoft.com/office/drawing/2014/main" id="{12BAC862-31CA-442E-B9AC-1775979618E7}"/>
+                <a16:creationId xmlns:a16="http://schemas.microsoft.com/office/drawing/2014/main" id="{1FF650C8-3639-4051-BC35-BCCAC3AD0D35}"/>
               </a:ext>
             </a:extLst>
           </p:cNvPr>
@@ -9681,7 +9681,7 @@
     </p:spTree>
     <p:extLst>
       <p:ext uri="{BB962C8B-B14F-4D97-AF65-F5344CB8AC3E}">
-        <p14:creationId xmlns:p14="http://schemas.microsoft.com/office/powerpoint/2010/main" val="2138941659"/>
+        <p14:creationId xmlns:p14="http://schemas.microsoft.com/office/powerpoint/2010/main" val="1677375077"/>
       </p:ext>
     </p:extLst>
   </p:cSld>
@@ -9712,7 +9712,7 @@
           <p:cNvPr id="13" name="brand-9">
             <a:extLst xmlns:a="http://schemas.openxmlformats.org/drawingml/2006/main">
               <a:ext uri="{FF2B5EF4-FFF2-40B4-BE49-F238E27FC236}">
-                <a16:creationId xmlns:a16="http://schemas.microsoft.com/office/drawing/2014/main" id="{5E3FCE95-F6B0-4C3D-87E8-212ACF88E834}"/>
+                <a16:creationId xmlns:a16="http://schemas.microsoft.com/office/drawing/2014/main" id="{C79BC4A6-B01C-466E-82E0-FE5661E39CA7}"/>
               </a:ext>
             </a:extLst>
           </p:cNvPr>
@@ -9770,7 +9770,7 @@
           <p:cNvPr id="2" name="title-9">
             <a:extLst xmlns:a="http://schemas.openxmlformats.org/drawingml/2006/main">
               <a:ext uri="{FF2B5EF4-FFF2-40B4-BE49-F238E27FC236}">
-                <a16:creationId xmlns:a16="http://schemas.microsoft.com/office/drawing/2014/main" id="{5F5F0988-BBF1-4587-B214-2EB37E7A6A88}"/>
+                <a16:creationId xmlns:a16="http://schemas.microsoft.com/office/drawing/2014/main" id="{D91E5955-2DB0-4B5C-829B-CABA5837CD7E}"/>
               </a:ext>
             </a:extLst>
           </p:cNvPr>
@@ -9828,7 +9828,7 @@
           <p:cNvPr id="3" name="footer-rule-9">
             <a:extLst xmlns:a="http://schemas.openxmlformats.org/drawingml/2006/main">
               <a:ext uri="{FF2B5EF4-FFF2-40B4-BE49-F238E27FC236}">
-                <a16:creationId xmlns:a16="http://schemas.microsoft.com/office/drawing/2014/main" id="{4D275454-BC12-4803-A876-ECFDB5F336C4}"/>
+                <a16:creationId xmlns:a16="http://schemas.microsoft.com/office/drawing/2014/main" id="{A09B3B47-1A1D-4374-9129-E3A4D702713E}"/>
               </a:ext>
             </a:extLst>
           </p:cNvPr>
@@ -9859,7 +9859,7 @@
           <p:cNvPr id="4" name="footer-source-9">
             <a:extLst xmlns:a="http://schemas.openxmlformats.org/drawingml/2006/main">
               <a:ext uri="{FF2B5EF4-FFF2-40B4-BE49-F238E27FC236}">
-                <a16:creationId xmlns:a16="http://schemas.microsoft.com/office/drawing/2014/main" id="{29D24269-69B0-4931-966B-EB5B8575A267}"/>
+                <a16:creationId xmlns:a16="http://schemas.microsoft.com/office/drawing/2014/main" id="{00F4602E-3D56-44B8-9E84-E2D87619F04E}"/>
               </a:ext>
             </a:extLst>
           </p:cNvPr>
@@ -9917,7 +9917,7 @@
           <p:cNvPr id="5" name="footer-page-9">
             <a:extLst xmlns:a="http://schemas.openxmlformats.org/drawingml/2006/main">
               <a:ext uri="{FF2B5EF4-FFF2-40B4-BE49-F238E27FC236}">
-                <a16:creationId xmlns:a16="http://schemas.microsoft.com/office/drawing/2014/main" id="{5689CE29-1D90-4B60-B12D-BE2D67123A9A}"/>
+                <a16:creationId xmlns:a16="http://schemas.microsoft.com/office/drawing/2014/main" id="{B3126B7C-34FD-45C6-AE26-F921BAAA59EC}"/>
               </a:ext>
             </a:extLst>
           </p:cNvPr>
@@ -9975,7 +9975,7 @@
           <p:cNvPr id="6" name="ownership-divider">
             <a:extLst xmlns:a="http://schemas.openxmlformats.org/drawingml/2006/main">
               <a:ext uri="{FF2B5EF4-FFF2-40B4-BE49-F238E27FC236}">
-                <a16:creationId xmlns:a16="http://schemas.microsoft.com/office/drawing/2014/main" id="{69F3A8AE-CA80-4EA6-B781-667BB141B5E8}"/>
+                <a16:creationId xmlns:a16="http://schemas.microsoft.com/office/drawing/2014/main" id="{81F2E6A7-C631-46DD-8CE7-D09A82A41278}"/>
               </a:ext>
             </a:extLst>
           </p:cNvPr>
@@ -10006,7 +10006,7 @@
           <p:cNvPr id="7" name="ownership-ayush-label">
             <a:extLst xmlns:a="http://schemas.openxmlformats.org/drawingml/2006/main">
               <a:ext uri="{FF2B5EF4-FFF2-40B4-BE49-F238E27FC236}">
-                <a16:creationId xmlns:a16="http://schemas.microsoft.com/office/drawing/2014/main" id="{B7492922-6295-49BD-A8A5-5E034DE3578B}"/>
+                <a16:creationId xmlns:a16="http://schemas.microsoft.com/office/drawing/2014/main" id="{3453E2F5-8FF2-4B99-ADBE-5369F4BEA384}"/>
               </a:ext>
             </a:extLst>
           </p:cNvPr>
@@ -10064,7 +10064,7 @@
           <p:cNvPr id="8" name="ownership-ayush-copy">
             <a:extLst xmlns:a="http://schemas.openxmlformats.org/drawingml/2006/main">
               <a:ext uri="{FF2B5EF4-FFF2-40B4-BE49-F238E27FC236}">
-                <a16:creationId xmlns:a16="http://schemas.microsoft.com/office/drawing/2014/main" id="{62C6EF1D-78F9-442B-BEFF-DAA3658F3E91}"/>
+                <a16:creationId xmlns:a16="http://schemas.microsoft.com/office/drawing/2014/main" id="{9FC51FBC-CE49-4492-8606-82FC269C8B8B}"/>
               </a:ext>
             </a:extLst>
           </p:cNvPr>
@@ -10122,7 +10122,7 @@
           <p:cNvPr id="9" name="ownership-finance-label">
             <a:extLst xmlns:a="http://schemas.openxmlformats.org/drawingml/2006/main">
               <a:ext uri="{FF2B5EF4-FFF2-40B4-BE49-F238E27FC236}">
-                <a16:creationId xmlns:a16="http://schemas.microsoft.com/office/drawing/2014/main" id="{08ECCB14-61B2-4254-9232-2CD072403E95}"/>
+                <a16:creationId xmlns:a16="http://schemas.microsoft.com/office/drawing/2014/main" id="{17C7E9AA-6474-4FE9-A900-EC904DBC7B53}"/>
               </a:ext>
             </a:extLst>
           </p:cNvPr>
@@ -10180,7 +10180,7 @@
           <p:cNvPr id="10" name="ownership-finance-copy">
             <a:extLst xmlns:a="http://schemas.openxmlformats.org/drawingml/2006/main">
               <a:ext uri="{FF2B5EF4-FFF2-40B4-BE49-F238E27FC236}">
-                <a16:creationId xmlns:a16="http://schemas.microsoft.com/office/drawing/2014/main" id="{632FA287-4005-4C75-BAF4-80A6B6DC8788}"/>
+                <a16:creationId xmlns:a16="http://schemas.microsoft.com/office/drawing/2014/main" id="{070EDE1C-8BC2-47FC-9FA1-0D5E95B77751}"/>
               </a:ext>
             </a:extLst>
           </p:cNvPr>
@@ -10238,7 +10238,7 @@
           <p:cNvPr id="11" name="ownership-gate-band">
             <a:extLst xmlns:a="http://schemas.openxmlformats.org/drawingml/2006/main">
               <a:ext uri="{FF2B5EF4-FFF2-40B4-BE49-F238E27FC236}">
-                <a16:creationId xmlns:a16="http://schemas.microsoft.com/office/drawing/2014/main" id="{B9667BE7-CB82-48BA-8634-6B69C1914874}"/>
+                <a16:creationId xmlns:a16="http://schemas.microsoft.com/office/drawing/2014/main" id="{B6BA8D10-053B-47CF-B58D-E43B9A02C36F}"/>
               </a:ext>
             </a:extLst>
           </p:cNvPr>
@@ -10271,7 +10271,7 @@
           <p:cNvPr id="12" name="ownership-gate">
             <a:extLst xmlns:a="http://schemas.openxmlformats.org/drawingml/2006/main">
               <a:ext uri="{FF2B5EF4-FFF2-40B4-BE49-F238E27FC236}">
-                <a16:creationId xmlns:a16="http://schemas.microsoft.com/office/drawing/2014/main" id="{E79403AA-6A34-44DB-BF09-27F0347C57C9}"/>
+                <a16:creationId xmlns:a16="http://schemas.microsoft.com/office/drawing/2014/main" id="{BAB86EFC-21FB-46BE-A103-DF55E77224E8}"/>
               </a:ext>
             </a:extLst>
           </p:cNvPr>
@@ -10327,7 +10327,7 @@
     </p:spTree>
     <p:extLst>
       <p:ext uri="{BB962C8B-B14F-4D97-AF65-F5344CB8AC3E}">
-        <p14:creationId xmlns:p14="http://schemas.microsoft.com/office/powerpoint/2010/main" val="1244912320"/>
+        <p14:creationId xmlns:p14="http://schemas.microsoft.com/office/powerpoint/2010/main" val="1664582312"/>
       </p:ext>
     </p:extLst>
   </p:cSld>

</xml_diff>

<commit_message>
release: KRISEVA monogram across all surfaces, full README dossier, problem-first deck
</commit_message>
<xml_diff>
--- a/deck/KRISEVA_ATTEST_GIFT_2026.pptx
+++ b/deck/KRISEVA_ATTEST_GIFT_2026.pptx
@@ -2,22 +2,22 @@
 <file path=ppt/presentation.xml><?xml version="1.0" encoding="utf-8"?>
 <p:presentation xmlns:p="http://schemas.openxmlformats.org/presentationml/2006/main">
   <p:sldMasterIdLst>
-    <p:sldMasterId xmlns:r="http://schemas.openxmlformats.org/officeDocument/2006/relationships" id="2147483648" r:id="R0041bb2eca3e4204"/>
+    <p:sldMasterId xmlns:r="http://schemas.openxmlformats.org/officeDocument/2006/relationships" id="2147483648" r:id="R308fafd9177444c2"/>
   </p:sldMasterIdLst>
   <p:notesMasterIdLst>
-    <p:notesMasterId xmlns:r="http://schemas.openxmlformats.org/officeDocument/2006/relationships" r:id="Rf55acdc3a1c54409"/>
+    <p:notesMasterId xmlns:r="http://schemas.openxmlformats.org/officeDocument/2006/relationships" r:id="R8f53c30944b14813"/>
   </p:notesMasterIdLst>
   <p:sldIdLst>
-    <p:sldId xmlns:r="http://schemas.openxmlformats.org/officeDocument/2006/relationships" id="256" r:id="R6aa22112ae424434"/>
-    <p:sldId xmlns:r="http://schemas.openxmlformats.org/officeDocument/2006/relationships" id="257" r:id="R7eb1c9f10cd341b0"/>
-    <p:sldId xmlns:r="http://schemas.openxmlformats.org/officeDocument/2006/relationships" id="258" r:id="R7d32c8a5b6484b21"/>
-    <p:sldId xmlns:r="http://schemas.openxmlformats.org/officeDocument/2006/relationships" id="259" r:id="Rd6f3bdd642044fde"/>
-    <p:sldId xmlns:r="http://schemas.openxmlformats.org/officeDocument/2006/relationships" id="260" r:id="R588cbf08494443c0"/>
-    <p:sldId xmlns:r="http://schemas.openxmlformats.org/officeDocument/2006/relationships" id="261" r:id="Rea90a5687dc3446d"/>
-    <p:sldId xmlns:r="http://schemas.openxmlformats.org/officeDocument/2006/relationships" id="262" r:id="R73d508ac850f43bc"/>
-    <p:sldId xmlns:r="http://schemas.openxmlformats.org/officeDocument/2006/relationships" id="263" r:id="Rb56e0cfadbb04c85"/>
-    <p:sldId xmlns:r="http://schemas.openxmlformats.org/officeDocument/2006/relationships" id="264" r:id="R413eb121d91a4ae7"/>
-    <p:sldId xmlns:r="http://schemas.openxmlformats.org/officeDocument/2006/relationships" id="265" r:id="Rb5fe6f79a6194d54"/>
+    <p:sldId xmlns:r="http://schemas.openxmlformats.org/officeDocument/2006/relationships" id="256" r:id="R0330afcb8ae0444c"/>
+    <p:sldId xmlns:r="http://schemas.openxmlformats.org/officeDocument/2006/relationships" id="257" r:id="R701789b35f744f3e"/>
+    <p:sldId xmlns:r="http://schemas.openxmlformats.org/officeDocument/2006/relationships" id="258" r:id="R0b0d1fa8216f441e"/>
+    <p:sldId xmlns:r="http://schemas.openxmlformats.org/officeDocument/2006/relationships" id="259" r:id="R7feb51b4e50d41c2"/>
+    <p:sldId xmlns:r="http://schemas.openxmlformats.org/officeDocument/2006/relationships" id="260" r:id="R8266a89712b846f7"/>
+    <p:sldId xmlns:r="http://schemas.openxmlformats.org/officeDocument/2006/relationships" id="261" r:id="R694ba341a5ea4134"/>
+    <p:sldId xmlns:r="http://schemas.openxmlformats.org/officeDocument/2006/relationships" id="262" r:id="R67552f2c82bf4700"/>
+    <p:sldId xmlns:r="http://schemas.openxmlformats.org/officeDocument/2006/relationships" id="263" r:id="R3a5edbe4b02e41fa"/>
+    <p:sldId xmlns:r="http://schemas.openxmlformats.org/officeDocument/2006/relationships" id="264" r:id="Reef34c8f4a5d4cca"/>
+    <p:sldId xmlns:r="http://schemas.openxmlformats.org/officeDocument/2006/relationships" id="265" r:id="Rd52539d6fdd34a33"/>
   </p:sldIdLst>
   <p:sldSz cx="12192000" cy="6858000"/>
   <p:notesSz cx="6858000" cy="9144000"/>
@@ -1339,7 +1339,7 @@
   </p:cSld>
   <p:clrMap bg1="lt1" tx1="dk1" bg2="lt2" tx2="dk2" accent1="accent1" accent2="accent2" accent3="accent3" accent4="accent4" accent5="accent5" accent6="accent6" hlink="hlink" folHlink="folHlink"/>
   <p:sldLayoutIdLst>
-    <p:sldLayoutId xmlns:r="http://schemas.openxmlformats.org/officeDocument/2006/relationships" id="2147483649" r:id="Rc778e3692527432e"/>
+    <p:sldLayoutId xmlns:r="http://schemas.openxmlformats.org/officeDocument/2006/relationships" id="2147483649" r:id="R30c328f447de40cb"/>
   </p:sldLayoutIdLst>
   <p:txStyles>
     <p:titleStyle>
@@ -1887,10 +1887,10 @@
       </p:grpSpPr>
       <p:sp>
         <p:nvSpPr>
-          <p:cNvPr id="13" name="cover-navy-field">
-            <a:extLst xmlns:a="http://schemas.openxmlformats.org/drawingml/2006/main">
-              <a:ext uri="{FF2B5EF4-FFF2-40B4-BE49-F238E27FC236}">
-                <a16:creationId xmlns:a16="http://schemas.microsoft.com/office/drawing/2014/main" id="{1E03D334-A29E-4FD2-AF63-697903736AB9}"/>
+          <p:cNvPr id="14" name="cover-navy-field">
+            <a:extLst xmlns:a="http://schemas.openxmlformats.org/drawingml/2006/main">
+              <a:ext uri="{FF2B5EF4-FFF2-40B4-BE49-F238E27FC236}">
+                <a16:creationId xmlns:a16="http://schemas.microsoft.com/office/drawing/2014/main" id="{F4AA2631-D68D-42BF-8EFE-C706836B4C6C}"/>
               </a:ext>
             </a:extLst>
           </p:cNvPr>
@@ -1923,7 +1923,7 @@
           <p:cNvPr id="2" name="cover-brass-spine">
             <a:extLst xmlns:a="http://schemas.openxmlformats.org/drawingml/2006/main">
               <a:ext uri="{FF2B5EF4-FFF2-40B4-BE49-F238E27FC236}">
-                <a16:creationId xmlns:a16="http://schemas.microsoft.com/office/drawing/2014/main" id="{EC5C5F2C-102B-491F-97A5-0C89648A7410}"/>
+                <a16:creationId xmlns:a16="http://schemas.microsoft.com/office/drawing/2014/main" id="{842821FA-C2AD-46EA-9250-51CFADF7F831}"/>
               </a:ext>
             </a:extLst>
           </p:cNvPr>
@@ -1954,7 +1954,7 @@
           <p:cNvPr id="3" name="brand-1">
             <a:extLst xmlns:a="http://schemas.openxmlformats.org/drawingml/2006/main">
               <a:ext uri="{FF2B5EF4-FFF2-40B4-BE49-F238E27FC236}">
-                <a16:creationId xmlns:a16="http://schemas.microsoft.com/office/drawing/2014/main" id="{5E1ACBFF-E6D2-4A9E-94F5-4C1AF883E66A}"/>
+                <a16:creationId xmlns:a16="http://schemas.microsoft.com/office/drawing/2014/main" id="{E82BBEBB-4F60-4D91-B496-945951E28C5D}"/>
               </a:ext>
             </a:extLst>
           </p:cNvPr>
@@ -2007,12 +2007,37 @@
           </a:p>
         </p:txBody>
       </p:sp>
-      <p:sp>
-        <p:nvSpPr>
-          <p:cNvPr id="4" name="cover-title">
-            <a:extLst xmlns:a="http://schemas.openxmlformats.org/drawingml/2006/main">
-              <a:ext uri="{FF2B5EF4-FFF2-40B4-BE49-F238E27FC236}">
-                <a16:creationId xmlns:a16="http://schemas.microsoft.com/office/drawing/2014/main" id="{E0DF43EA-4B82-4AA4-9FF0-F08DAF720DD9}"/>
+      <p:pic>
+        <p:nvPicPr>
+          <p:cNvPr id="17" name=""/>
+          <p:cNvPicPr>
+            <a:picLocks xmlns:a="http://schemas.openxmlformats.org/drawingml/2006/main" noChangeAspect="1"/>
+          </p:cNvPicPr>
+          <p:nvPr/>
+        </p:nvPicPr>
+        <p:blipFill>
+          <a:blip xmlns:r="http://schemas.openxmlformats.org/officeDocument/2006/relationships" xmlns:a="http://schemas.openxmlformats.org/drawingml/2006/main" r:embed="R1162a6dfa1a3469a"/>
+          <a:srcRect xmlns:a="http://schemas.openxmlformats.org/drawingml/2006/main" l="0" t="0" r="0" b="0"/>
+          <a:stretch xmlns:a="http://schemas.openxmlformats.org/drawingml/2006/main">
+            <a:fillRect l="0" t="0" r="0" b="0"/>
+          </a:stretch>
+        </p:blipFill>
+        <p:spPr>
+          <a:xfrm xmlns:a="http://schemas.openxmlformats.org/drawingml/2006/main">
+            <a:off x="10458450" y="419100"/>
+            <a:ext cx="876300" cy="876300"/>
+          </a:xfrm>
+          <a:prstGeom xmlns:a="http://schemas.openxmlformats.org/drawingml/2006/main" prst="rect">
+            <a:avLst/>
+          </a:prstGeom>
+        </p:spPr>
+      </p:pic>
+      <p:sp>
+        <p:nvSpPr>
+          <p:cNvPr id="5" name="cover-title">
+            <a:extLst xmlns:a="http://schemas.openxmlformats.org/drawingml/2006/main">
+              <a:ext uri="{FF2B5EF4-FFF2-40B4-BE49-F238E27FC236}">
+                <a16:creationId xmlns:a16="http://schemas.microsoft.com/office/drawing/2014/main" id="{B5A5B573-4CAF-4CC8-A995-016B0E3F13FF}"/>
               </a:ext>
             </a:extLst>
           </p:cNvPr>
@@ -2067,10 +2092,10 @@
       </p:sp>
       <p:sp>
         <p:nvSpPr>
-          <p:cNvPr id="5" name="cover-subtitle">
-            <a:extLst xmlns:a="http://schemas.openxmlformats.org/drawingml/2006/main">
-              <a:ext uri="{FF2B5EF4-FFF2-40B4-BE49-F238E27FC236}">
-                <a16:creationId xmlns:a16="http://schemas.microsoft.com/office/drawing/2014/main" id="{C5BBCCEE-0D4D-4D36-BB55-146594AED174}"/>
+          <p:cNvPr id="6" name="cover-subtitle">
+            <a:extLst xmlns:a="http://schemas.openxmlformats.org/drawingml/2006/main">
+              <a:ext uri="{FF2B5EF4-FFF2-40B4-BE49-F238E27FC236}">
+                <a16:creationId xmlns:a16="http://schemas.microsoft.com/office/drawing/2014/main" id="{E9F98030-E3DA-4E0D-9BC2-DC15660FA7A3}"/>
               </a:ext>
             </a:extLst>
           </p:cNvPr>
@@ -2125,10 +2150,10 @@
       </p:sp>
       <p:sp>
         <p:nvSpPr>
-          <p:cNvPr id="6" name="cover-rule">
-            <a:extLst xmlns:a="http://schemas.openxmlformats.org/drawingml/2006/main">
-              <a:ext uri="{FF2B5EF4-FFF2-40B4-BE49-F238E27FC236}">
-                <a16:creationId xmlns:a16="http://schemas.microsoft.com/office/drawing/2014/main" id="{8CDE2358-832C-452A-8C06-26CA1CC28F46}"/>
+          <p:cNvPr id="7" name="cover-rule">
+            <a:extLst xmlns:a="http://schemas.openxmlformats.org/drawingml/2006/main">
+              <a:ext uri="{FF2B5EF4-FFF2-40B4-BE49-F238E27FC236}">
+                <a16:creationId xmlns:a16="http://schemas.microsoft.com/office/drawing/2014/main" id="{7D7875C6-CA41-414E-B6B4-FB4F17E53C8E}"/>
               </a:ext>
             </a:extLst>
           </p:cNvPr>
@@ -2156,10 +2181,10 @@
       </p:sp>
       <p:sp>
         <p:nvSpPr>
-          <p:cNvPr id="7" name="cover-lock">
-            <a:extLst xmlns:a="http://schemas.openxmlformats.org/drawingml/2006/main">
-              <a:ext uri="{FF2B5EF4-FFF2-40B4-BE49-F238E27FC236}">
-                <a16:creationId xmlns:a16="http://schemas.microsoft.com/office/drawing/2014/main" id="{9028EE72-A972-4B5C-AED5-E90DBA3B31F7}"/>
+          <p:cNvPr id="8" name="cover-lock">
+            <a:extLst xmlns:a="http://schemas.openxmlformats.org/drawingml/2006/main">
+              <a:ext uri="{FF2B5EF4-FFF2-40B4-BE49-F238E27FC236}">
+                <a16:creationId xmlns:a16="http://schemas.microsoft.com/office/drawing/2014/main" id="{642B9BFA-2020-416E-99B6-8009C013F1AA}"/>
               </a:ext>
             </a:extLst>
           </p:cNvPr>
@@ -2214,10 +2239,10 @@
       </p:sp>
       <p:sp>
         <p:nvSpPr>
-          <p:cNvPr id="8" name="cover-boundary">
-            <a:extLst xmlns:a="http://schemas.openxmlformats.org/drawingml/2006/main">
-              <a:ext uri="{FF2B5EF4-FFF2-40B4-BE49-F238E27FC236}">
-                <a16:creationId xmlns:a16="http://schemas.microsoft.com/office/drawing/2014/main" id="{2D828A48-D693-4011-A710-42FCA668B946}"/>
+          <p:cNvPr id="9" name="cover-boundary">
+            <a:extLst xmlns:a="http://schemas.openxmlformats.org/drawingml/2006/main">
+              <a:ext uri="{FF2B5EF4-FFF2-40B4-BE49-F238E27FC236}">
+                <a16:creationId xmlns:a16="http://schemas.microsoft.com/office/drawing/2014/main" id="{BDCBBCF3-DEF7-4B69-AD76-7548DDADF101}"/>
               </a:ext>
             </a:extLst>
           </p:cNvPr>
@@ -2272,10 +2297,10 @@
       </p:sp>
       <p:sp>
         <p:nvSpPr>
-          <p:cNvPr id="9" name="cover-number">
-            <a:extLst xmlns:a="http://schemas.openxmlformats.org/drawingml/2006/main">
-              <a:ext uri="{FF2B5EF4-FFF2-40B4-BE49-F238E27FC236}">
-                <a16:creationId xmlns:a16="http://schemas.microsoft.com/office/drawing/2014/main" id="{A2644E8A-3AAF-4BBD-9BF2-1D0CCC80EC35}"/>
+          <p:cNvPr id="10" name="cover-number">
+            <a:extLst xmlns:a="http://schemas.openxmlformats.org/drawingml/2006/main">
+              <a:ext uri="{FF2B5EF4-FFF2-40B4-BE49-F238E27FC236}">
+                <a16:creationId xmlns:a16="http://schemas.microsoft.com/office/drawing/2014/main" id="{7B1F0A43-F849-4591-8C92-B35107209A95}"/>
               </a:ext>
             </a:extLst>
           </p:cNvPr>
@@ -2330,10 +2355,10 @@
       </p:sp>
       <p:sp>
         <p:nvSpPr>
-          <p:cNvPr id="10" name="cover-classification">
-            <a:extLst xmlns:a="http://schemas.openxmlformats.org/drawingml/2006/main">
-              <a:ext uri="{FF2B5EF4-FFF2-40B4-BE49-F238E27FC236}">
-                <a16:creationId xmlns:a16="http://schemas.microsoft.com/office/drawing/2014/main" id="{2E35C270-BAB1-4B55-ACDA-A4A47E405197}"/>
+          <p:cNvPr id="11" name="cover-classification">
+            <a:extLst xmlns:a="http://schemas.openxmlformats.org/drawingml/2006/main">
+              <a:ext uri="{FF2B5EF4-FFF2-40B4-BE49-F238E27FC236}">
+                <a16:creationId xmlns:a16="http://schemas.microsoft.com/office/drawing/2014/main" id="{BA0B73B6-B70C-446F-9F23-8A46744B7BF6}"/>
               </a:ext>
             </a:extLst>
           </p:cNvPr>
@@ -2434,10 +2459,10 @@
       </p:sp>
       <p:sp>
         <p:nvSpPr>
-          <p:cNvPr id="11" name="cover-page">
-            <a:extLst xmlns:a="http://schemas.openxmlformats.org/drawingml/2006/main">
-              <a:ext uri="{FF2B5EF4-FFF2-40B4-BE49-F238E27FC236}">
-                <a16:creationId xmlns:a16="http://schemas.microsoft.com/office/drawing/2014/main" id="{32CC0432-B234-4E27-9264-A0844FD1DC03}"/>
+          <p:cNvPr id="12" name="cover-page">
+            <a:extLst xmlns:a="http://schemas.openxmlformats.org/drawingml/2006/main">
+              <a:ext uri="{FF2B5EF4-FFF2-40B4-BE49-F238E27FC236}">
+                <a16:creationId xmlns:a16="http://schemas.microsoft.com/office/drawing/2014/main" id="{0B9465ED-9D81-4550-B99E-CE1EDAADF417}"/>
               </a:ext>
             </a:extLst>
           </p:cNvPr>
@@ -2492,10 +2517,10 @@
       </p:sp>
       <p:sp>
         <p:nvSpPr>
-          <p:cNvPr id="12" name="footer-cover-url">
-            <a:extLst xmlns:a="http://schemas.openxmlformats.org/drawingml/2006/main">
-              <a:ext uri="{FF2B5EF4-FFF2-40B4-BE49-F238E27FC236}">
-                <a16:creationId xmlns:a16="http://schemas.microsoft.com/office/drawing/2014/main" id="{B3D5599F-9E90-4FA1-9C73-97448D28FB18}"/>
+          <p:cNvPr id="13" name="footer-cover-url">
+            <a:extLst xmlns:a="http://schemas.openxmlformats.org/drawingml/2006/main">
+              <a:ext uri="{FF2B5EF4-FFF2-40B4-BE49-F238E27FC236}">
+                <a16:creationId xmlns:a16="http://schemas.microsoft.com/office/drawing/2014/main" id="{3F16C25D-511F-4805-9920-AEC0B2F8559B}"/>
               </a:ext>
             </a:extLst>
           </p:cNvPr>
@@ -2574,7 +2599,7 @@
     </p:spTree>
     <p:extLst>
       <p:ext uri="{BB962C8B-B14F-4D97-AF65-F5344CB8AC3E}">
-        <p14:creationId xmlns:p14="http://schemas.microsoft.com/office/powerpoint/2010/main" val="733423459"/>
+        <p14:creationId xmlns:p14="http://schemas.microsoft.com/office/powerpoint/2010/main" val="1180656032"/>
       </p:ext>
     </p:extLst>
   </p:cSld>
@@ -2605,7 +2630,7 @@
           <p:cNvPr id="17" name="brand-10">
             <a:extLst xmlns:a="http://schemas.openxmlformats.org/drawingml/2006/main">
               <a:ext uri="{FF2B5EF4-FFF2-40B4-BE49-F238E27FC236}">
-                <a16:creationId xmlns:a16="http://schemas.microsoft.com/office/drawing/2014/main" id="{12A899BB-C16C-4F4D-AEAD-C598348EE653}"/>
+                <a16:creationId xmlns:a16="http://schemas.microsoft.com/office/drawing/2014/main" id="{27D516B9-7681-4BFD-A77E-4AC07FD1970E}"/>
               </a:ext>
             </a:extLst>
           </p:cNvPr>
@@ -2663,7 +2688,7 @@
           <p:cNvPr id="2" name="title-10">
             <a:extLst xmlns:a="http://schemas.openxmlformats.org/drawingml/2006/main">
               <a:ext uri="{FF2B5EF4-FFF2-40B4-BE49-F238E27FC236}">
-                <a16:creationId xmlns:a16="http://schemas.microsoft.com/office/drawing/2014/main" id="{C7139B1B-AC24-4A76-A61D-928F2AF03B31}"/>
+                <a16:creationId xmlns:a16="http://schemas.microsoft.com/office/drawing/2014/main" id="{2EFDBD3E-1FA8-4A21-A17C-969018E52AD7}"/>
               </a:ext>
             </a:extLst>
           </p:cNvPr>
@@ -2721,7 +2746,7 @@
           <p:cNvPr id="3" name="footer-rule-10">
             <a:extLst xmlns:a="http://schemas.openxmlformats.org/drawingml/2006/main">
               <a:ext uri="{FF2B5EF4-FFF2-40B4-BE49-F238E27FC236}">
-                <a16:creationId xmlns:a16="http://schemas.microsoft.com/office/drawing/2014/main" id="{C000A2BF-410E-4EB6-97B6-AA923C983E34}"/>
+                <a16:creationId xmlns:a16="http://schemas.microsoft.com/office/drawing/2014/main" id="{150BDCBA-EB3A-4174-8C09-6F218E42C9EE}"/>
               </a:ext>
             </a:extLst>
           </p:cNvPr>
@@ -2752,7 +2777,7 @@
           <p:cNvPr id="4" name="footer-source-10">
             <a:extLst xmlns:a="http://schemas.openxmlformats.org/drawingml/2006/main">
               <a:ext uri="{FF2B5EF4-FFF2-40B4-BE49-F238E27FC236}">
-                <a16:creationId xmlns:a16="http://schemas.microsoft.com/office/drawing/2014/main" id="{AE55A568-5BDA-4305-8C9D-89C093D5B275}"/>
+                <a16:creationId xmlns:a16="http://schemas.microsoft.com/office/drawing/2014/main" id="{3CF9DB8B-6EA4-4DDA-9DD3-3A582D0AE120}"/>
               </a:ext>
             </a:extLst>
           </p:cNvPr>
@@ -2810,7 +2835,7 @@
           <p:cNvPr id="5" name="footer-page-10">
             <a:extLst xmlns:a="http://schemas.openxmlformats.org/drawingml/2006/main">
               <a:ext uri="{FF2B5EF4-FFF2-40B4-BE49-F238E27FC236}">
-                <a16:creationId xmlns:a16="http://schemas.microsoft.com/office/drawing/2014/main" id="{8ADAAA79-DB41-4C9E-94D7-C28C11967B23}"/>
+                <a16:creationId xmlns:a16="http://schemas.microsoft.com/office/drawing/2014/main" id="{CB8EE582-D35D-454E-9EFF-7A8E5C9CBC28}"/>
               </a:ext>
             </a:extLst>
           </p:cNvPr>
@@ -2868,7 +2893,7 @@
           <p:cNvPr id="6" name="ask-spine">
             <a:extLst xmlns:a="http://schemas.openxmlformats.org/drawingml/2006/main">
               <a:ext uri="{FF2B5EF4-FFF2-40B4-BE49-F238E27FC236}">
-                <a16:creationId xmlns:a16="http://schemas.microsoft.com/office/drawing/2014/main" id="{350B07F6-3E66-43F4-8474-7EE95FBD4AEE}"/>
+                <a16:creationId xmlns:a16="http://schemas.microsoft.com/office/drawing/2014/main" id="{EC0BFD09-3875-4A85-B8FF-8DDA2CFF56C1}"/>
               </a:ext>
             </a:extLst>
           </p:cNvPr>
@@ -2899,7 +2924,7 @@
           <p:cNvPr id="7" name="ask-access-label">
             <a:extLst xmlns:a="http://schemas.openxmlformats.org/drawingml/2006/main">
               <a:ext uri="{FF2B5EF4-FFF2-40B4-BE49-F238E27FC236}">
-                <a16:creationId xmlns:a16="http://schemas.microsoft.com/office/drawing/2014/main" id="{E11B24DB-BACF-497A-9462-FC8A15E5C5B1}"/>
+                <a16:creationId xmlns:a16="http://schemas.microsoft.com/office/drawing/2014/main" id="{BCDCBB66-1609-4776-9C07-2F7AED6E2D4F}"/>
               </a:ext>
             </a:extLst>
           </p:cNvPr>
@@ -2957,7 +2982,7 @@
           <p:cNvPr id="8" name="ask-access-copy">
             <a:extLst xmlns:a="http://schemas.openxmlformats.org/drawingml/2006/main">
               <a:ext uri="{FF2B5EF4-FFF2-40B4-BE49-F238E27FC236}">
-                <a16:creationId xmlns:a16="http://schemas.microsoft.com/office/drawing/2014/main" id="{E3090557-2750-42AF-A013-698E62FC840A}"/>
+                <a16:creationId xmlns:a16="http://schemas.microsoft.com/office/drawing/2014/main" id="{2C544711-F167-42E8-9893-EE73F6CC4F15}"/>
               </a:ext>
             </a:extLst>
           </p:cNvPr>
@@ -3015,7 +3040,7 @@
           <p:cNvPr id="9" name="ask-falsify">
             <a:extLst xmlns:a="http://schemas.openxmlformats.org/drawingml/2006/main">
               <a:ext uri="{FF2B5EF4-FFF2-40B4-BE49-F238E27FC236}">
-                <a16:creationId xmlns:a16="http://schemas.microsoft.com/office/drawing/2014/main" id="{3F677942-56EC-4B51-98CE-801373475A81}"/>
+                <a16:creationId xmlns:a16="http://schemas.microsoft.com/office/drawing/2014/main" id="{C2EFE3B0-F1CE-42EC-9EDE-F4F53C107984}"/>
               </a:ext>
             </a:extLst>
           </p:cNvPr>
@@ -3073,7 +3098,7 @@
           <p:cNvPr id="10" name="ask-challenge-label">
             <a:extLst xmlns:a="http://schemas.openxmlformats.org/drawingml/2006/main">
               <a:ext uri="{FF2B5EF4-FFF2-40B4-BE49-F238E27FC236}">
-                <a16:creationId xmlns:a16="http://schemas.microsoft.com/office/drawing/2014/main" id="{221C2CD2-9612-464F-A646-05DDE2B1322F}"/>
+                <a16:creationId xmlns:a16="http://schemas.microsoft.com/office/drawing/2014/main" id="{8C73DCEF-A0A7-4067-A735-BB94B6EB92DE}"/>
               </a:ext>
             </a:extLst>
           </p:cNvPr>
@@ -3131,7 +3156,7 @@
           <p:cNvPr id="11" name="ask-challenge-copy">
             <a:extLst xmlns:a="http://schemas.openxmlformats.org/drawingml/2006/main">
               <a:ext uri="{FF2B5EF4-FFF2-40B4-BE49-F238E27FC236}">
-                <a16:creationId xmlns:a16="http://schemas.microsoft.com/office/drawing/2014/main" id="{BF5555E3-CDF2-4DC4-9140-81B133C56345}"/>
+                <a16:creationId xmlns:a16="http://schemas.microsoft.com/office/drawing/2014/main" id="{052E36EF-351F-48D7-ADCE-9708DCE7F44E}"/>
               </a:ext>
             </a:extLst>
           </p:cNvPr>
@@ -3189,7 +3214,7 @@
           <p:cNvPr id="12" name="ask-test-label">
             <a:extLst xmlns:a="http://schemas.openxmlformats.org/drawingml/2006/main">
               <a:ext uri="{FF2B5EF4-FFF2-40B4-BE49-F238E27FC236}">
-                <a16:creationId xmlns:a16="http://schemas.microsoft.com/office/drawing/2014/main" id="{61FAF683-70CC-4724-BD48-F31096A394D4}"/>
+                <a16:creationId xmlns:a16="http://schemas.microsoft.com/office/drawing/2014/main" id="{FCF8980F-B355-4B29-A1D8-7A5A4DF2E56E}"/>
               </a:ext>
             </a:extLst>
           </p:cNvPr>
@@ -3247,7 +3272,7 @@
           <p:cNvPr id="13" name="ask-test-copy">
             <a:extLst xmlns:a="http://schemas.openxmlformats.org/drawingml/2006/main">
               <a:ext uri="{FF2B5EF4-FFF2-40B4-BE49-F238E27FC236}">
-                <a16:creationId xmlns:a16="http://schemas.microsoft.com/office/drawing/2014/main" id="{FCCC15E2-24EB-4C11-B45A-48E6C6058FE1}"/>
+                <a16:creationId xmlns:a16="http://schemas.microsoft.com/office/drawing/2014/main" id="{DE64D126-2BCF-4F2B-93DF-77B19C5D9627}"/>
               </a:ext>
             </a:extLst>
           </p:cNvPr>
@@ -3305,7 +3330,7 @@
           <p:cNvPr id="14" name="ask-decide-label">
             <a:extLst xmlns:a="http://schemas.openxmlformats.org/drawingml/2006/main">
               <a:ext uri="{FF2B5EF4-FFF2-40B4-BE49-F238E27FC236}">
-                <a16:creationId xmlns:a16="http://schemas.microsoft.com/office/drawing/2014/main" id="{C6152312-28D6-4AB9-93AD-F4A4ECD2DD45}"/>
+                <a16:creationId xmlns:a16="http://schemas.microsoft.com/office/drawing/2014/main" id="{9B05F96B-A14C-475D-AA19-936B235EE940}"/>
               </a:ext>
             </a:extLst>
           </p:cNvPr>
@@ -3363,7 +3388,7 @@
           <p:cNvPr id="15" name="ask-decide-copy">
             <a:extLst xmlns:a="http://schemas.openxmlformats.org/drawingml/2006/main">
               <a:ext uri="{FF2B5EF4-FFF2-40B4-BE49-F238E27FC236}">
-                <a16:creationId xmlns:a16="http://schemas.microsoft.com/office/drawing/2014/main" id="{7CAA2700-3A99-4437-AD3B-A694A0AB49FF}"/>
+                <a16:creationId xmlns:a16="http://schemas.microsoft.com/office/drawing/2014/main" id="{97B39DDC-E93F-4A1B-84C8-782E6B897B6A}"/>
               </a:ext>
             </a:extLst>
           </p:cNvPr>
@@ -3421,7 +3446,7 @@
           <p:cNvPr id="16" name="footer-ask-links">
             <a:extLst xmlns:a="http://schemas.openxmlformats.org/drawingml/2006/main">
               <a:ext uri="{FF2B5EF4-FFF2-40B4-BE49-F238E27FC236}">
-                <a16:creationId xmlns:a16="http://schemas.microsoft.com/office/drawing/2014/main" id="{1E62F9C7-FC5F-4C8A-8671-81D137363F96}"/>
+                <a16:creationId xmlns:a16="http://schemas.microsoft.com/office/drawing/2014/main" id="{89B5EA08-9E19-470D-8E8F-1E9F3BDB361B}"/>
               </a:ext>
             </a:extLst>
           </p:cNvPr>
@@ -3477,7 +3502,7 @@
     </p:spTree>
     <p:extLst>
       <p:ext uri="{BB962C8B-B14F-4D97-AF65-F5344CB8AC3E}">
-        <p14:creationId xmlns:p14="http://schemas.microsoft.com/office/powerpoint/2010/main" val="193132310"/>
+        <p14:creationId xmlns:p14="http://schemas.microsoft.com/office/powerpoint/2010/main" val="865553641"/>
       </p:ext>
     </p:extLst>
   </p:cSld>
@@ -3508,7 +3533,7 @@
           <p:cNvPr id="18" name="brand-2">
             <a:extLst xmlns:a="http://schemas.openxmlformats.org/drawingml/2006/main">
               <a:ext uri="{FF2B5EF4-FFF2-40B4-BE49-F238E27FC236}">
-                <a16:creationId xmlns:a16="http://schemas.microsoft.com/office/drawing/2014/main" id="{17ECFF49-4459-4C01-AE30-44F3298DD75D}"/>
+                <a16:creationId xmlns:a16="http://schemas.microsoft.com/office/drawing/2014/main" id="{97238A98-49EC-4553-B32D-22A1321526F6}"/>
               </a:ext>
             </a:extLst>
           </p:cNvPr>
@@ -3566,7 +3591,7 @@
           <p:cNvPr id="2" name="title-2">
             <a:extLst xmlns:a="http://schemas.openxmlformats.org/drawingml/2006/main">
               <a:ext uri="{FF2B5EF4-FFF2-40B4-BE49-F238E27FC236}">
-                <a16:creationId xmlns:a16="http://schemas.microsoft.com/office/drawing/2014/main" id="{1BF67A2D-F421-4F1C-B8C0-3015C7F00691}"/>
+                <a16:creationId xmlns:a16="http://schemas.microsoft.com/office/drawing/2014/main" id="{24BE217B-B070-4DA8-BF0D-817C98124C8D}"/>
               </a:ext>
             </a:extLst>
           </p:cNvPr>
@@ -3614,7 +3639,7 @@
                 <a:ea typeface="Georgia"/>
                 <a:cs typeface="Georgia"/>
               </a:rPr>
-              <a:t>A human still owns the source question</a:t>
+              <a:t>The problem: which source backs a reported field?</a:t>
             </a:r>
           </a:p>
         </p:txBody>
@@ -3624,7 +3649,7 @@
           <p:cNvPr id="3" name="footer-rule-2">
             <a:extLst xmlns:a="http://schemas.openxmlformats.org/drawingml/2006/main">
               <a:ext uri="{FF2B5EF4-FFF2-40B4-BE49-F238E27FC236}">
-                <a16:creationId xmlns:a16="http://schemas.microsoft.com/office/drawing/2014/main" id="{A82B5EC8-01BA-4195-963D-F414827BA047}"/>
+                <a16:creationId xmlns:a16="http://schemas.microsoft.com/office/drawing/2014/main" id="{652E011F-529D-4E3C-A94B-83006F284D98}"/>
               </a:ext>
             </a:extLst>
           </p:cNvPr>
@@ -3655,7 +3680,7 @@
           <p:cNvPr id="4" name="footer-source-2">
             <a:extLst xmlns:a="http://schemas.openxmlformats.org/drawingml/2006/main">
               <a:ext uri="{FF2B5EF4-FFF2-40B4-BE49-F238E27FC236}">
-                <a16:creationId xmlns:a16="http://schemas.microsoft.com/office/drawing/2014/main" id="{9FA3CA59-73AC-4593-AAC3-49EBC92CBF0B}"/>
+                <a16:creationId xmlns:a16="http://schemas.microsoft.com/office/drawing/2014/main" id="{11E93A89-165F-4228-BD15-45E48AD594F1}"/>
               </a:ext>
             </a:extLst>
           </p:cNvPr>
@@ -3713,7 +3738,7 @@
           <p:cNvPr id="5" name="footer-page-2">
             <a:extLst xmlns:a="http://schemas.openxmlformats.org/drawingml/2006/main">
               <a:ext uri="{FF2B5EF4-FFF2-40B4-BE49-F238E27FC236}">
-                <a16:creationId xmlns:a16="http://schemas.microsoft.com/office/drawing/2014/main" id="{A3863613-6438-4AE2-ABA0-E568EF44F5CF}"/>
+                <a16:creationId xmlns:a16="http://schemas.microsoft.com/office/drawing/2014/main" id="{B05085C5-075D-4327-A496-83537E0EB37F}"/>
               </a:ext>
             </a:extLst>
           </p:cNvPr>
@@ -3771,7 +3796,7 @@
           <p:cNvPr id="6" name="accountability-divider">
             <a:extLst xmlns:a="http://schemas.openxmlformats.org/drawingml/2006/main">
               <a:ext uri="{FF2B5EF4-FFF2-40B4-BE49-F238E27FC236}">
-                <a16:creationId xmlns:a16="http://schemas.microsoft.com/office/drawing/2014/main" id="{223FE0C5-4164-43D6-BEBE-550058F3E77E}"/>
+                <a16:creationId xmlns:a16="http://schemas.microsoft.com/office/drawing/2014/main" id="{5C6431BB-7C4A-4198-9401-97925CC5CA69}"/>
               </a:ext>
             </a:extLst>
           </p:cNvPr>
@@ -3802,7 +3827,7 @@
           <p:cNvPr id="7" name="accountability-label">
             <a:extLst xmlns:a="http://schemas.openxmlformats.org/drawingml/2006/main">
               <a:ext uri="{FF2B5EF4-FFF2-40B4-BE49-F238E27FC236}">
-                <a16:creationId xmlns:a16="http://schemas.microsoft.com/office/drawing/2014/main" id="{DB4F07DC-441D-4D82-AE01-06350A582175}"/>
+                <a16:creationId xmlns:a16="http://schemas.microsoft.com/office/drawing/2014/main" id="{946851CC-9672-40C1-9267-D6104E6BDFB2}"/>
               </a:ext>
             </a:extLst>
           </p:cNvPr>
@@ -3860,7 +3885,7 @@
           <p:cNvPr id="8" name="accountability-structured">
             <a:extLst xmlns:a="http://schemas.openxmlformats.org/drawingml/2006/main">
               <a:ext uri="{FF2B5EF4-FFF2-40B4-BE49-F238E27FC236}">
-                <a16:creationId xmlns:a16="http://schemas.microsoft.com/office/drawing/2014/main" id="{83C2B51C-F674-4A70-9CAA-04A074DD6679}"/>
+                <a16:creationId xmlns:a16="http://schemas.microsoft.com/office/drawing/2014/main" id="{0969EB97-CECA-4CC0-A976-254CDEE7C783}"/>
               </a:ext>
             </a:extLst>
           </p:cNvPr>
@@ -3918,7 +3943,7 @@
           <p:cNvPr id="9" name="accountability-question">
             <a:extLst xmlns:a="http://schemas.openxmlformats.org/drawingml/2006/main">
               <a:ext uri="{FF2B5EF4-FFF2-40B4-BE49-F238E27FC236}">
-                <a16:creationId xmlns:a16="http://schemas.microsoft.com/office/drawing/2014/main" id="{F668417F-8F29-4D89-B053-9326FEC7D2C9}"/>
+                <a16:creationId xmlns:a16="http://schemas.microsoft.com/office/drawing/2014/main" id="{10AA0F30-459C-410A-9495-2453C6C0BCCD}"/>
               </a:ext>
             </a:extLst>
           </p:cNvPr>
@@ -3976,7 +4001,7 @@
           <p:cNvPr id="10" name="footer-accountability-caption-1">
             <a:extLst xmlns:a="http://schemas.openxmlformats.org/drawingml/2006/main">
               <a:ext uri="{FF2B5EF4-FFF2-40B4-BE49-F238E27FC236}">
-                <a16:creationId xmlns:a16="http://schemas.microsoft.com/office/drawing/2014/main" id="{997747FD-57FE-430D-B9A9-433F4387ADC5}"/>
+                <a16:creationId xmlns:a16="http://schemas.microsoft.com/office/drawing/2014/main" id="{C3AA4CCA-B81E-446F-928F-1C98075A522D}"/>
               </a:ext>
             </a:extLst>
           </p:cNvPr>
@@ -4034,7 +4059,7 @@
           <p:cNvPr id="11" name="accountability-source-rule-1">
             <a:extLst xmlns:a="http://schemas.openxmlformats.org/drawingml/2006/main">
               <a:ext uri="{FF2B5EF4-FFF2-40B4-BE49-F238E27FC236}">
-                <a16:creationId xmlns:a16="http://schemas.microsoft.com/office/drawing/2014/main" id="{12602C2D-91AA-41D6-BEED-9A0C3FAD29B7}"/>
+                <a16:creationId xmlns:a16="http://schemas.microsoft.com/office/drawing/2014/main" id="{39775B19-2C1F-4FDA-A81D-42E520BFA759}"/>
               </a:ext>
             </a:extLst>
           </p:cNvPr>
@@ -4065,7 +4090,7 @@
           <p:cNvPr id="12" name="footer-accountability-caption-2">
             <a:extLst xmlns:a="http://schemas.openxmlformats.org/drawingml/2006/main">
               <a:ext uri="{FF2B5EF4-FFF2-40B4-BE49-F238E27FC236}">
-                <a16:creationId xmlns:a16="http://schemas.microsoft.com/office/drawing/2014/main" id="{A60D14DF-34E1-42F8-B59B-C3BB4C158687}"/>
+                <a16:creationId xmlns:a16="http://schemas.microsoft.com/office/drawing/2014/main" id="{056AB5E7-8C36-4E10-94E7-938DDB1EDE48}"/>
               </a:ext>
             </a:extLst>
           </p:cNvPr>
@@ -4123,7 +4148,7 @@
           <p:cNvPr id="13" name="accountability-source-rule-2">
             <a:extLst xmlns:a="http://schemas.openxmlformats.org/drawingml/2006/main">
               <a:ext uri="{FF2B5EF4-FFF2-40B4-BE49-F238E27FC236}">
-                <a16:creationId xmlns:a16="http://schemas.microsoft.com/office/drawing/2014/main" id="{616B42C9-D545-4208-B658-32C19C1BA847}"/>
+                <a16:creationId xmlns:a16="http://schemas.microsoft.com/office/drawing/2014/main" id="{59F9671A-C212-4229-8FD0-0D4D548CF79E}"/>
               </a:ext>
             </a:extLst>
           </p:cNvPr>
@@ -4154,7 +4179,7 @@
           <p:cNvPr id="14" name="footer-accountability-caption-3">
             <a:extLst xmlns:a="http://schemas.openxmlformats.org/drawingml/2006/main">
               <a:ext uri="{FF2B5EF4-FFF2-40B4-BE49-F238E27FC236}">
-                <a16:creationId xmlns:a16="http://schemas.microsoft.com/office/drawing/2014/main" id="{8AA5D57A-5452-445E-9794-CCC643949844}"/>
+                <a16:creationId xmlns:a16="http://schemas.microsoft.com/office/drawing/2014/main" id="{C2CF98DA-F2D7-4BCA-B577-75FA2A44488C}"/>
               </a:ext>
             </a:extLst>
           </p:cNvPr>
@@ -4212,7 +4237,7 @@
           <p:cNvPr id="15" name="accountability-source-rule-3">
             <a:extLst xmlns:a="http://schemas.openxmlformats.org/drawingml/2006/main">
               <a:ext uri="{FF2B5EF4-FFF2-40B4-BE49-F238E27FC236}">
-                <a16:creationId xmlns:a16="http://schemas.microsoft.com/office/drawing/2014/main" id="{6C27F3DF-AF85-4637-8174-D35084BAA61F}"/>
+                <a16:creationId xmlns:a16="http://schemas.microsoft.com/office/drawing/2014/main" id="{B3D417C2-C1F9-4B4D-83F8-CC07F6A00A13}"/>
               </a:ext>
             </a:extLst>
           </p:cNvPr>
@@ -4243,7 +4268,7 @@
           <p:cNvPr id="16" name="accountability-evidence">
             <a:extLst xmlns:a="http://schemas.openxmlformats.org/drawingml/2006/main">
               <a:ext uri="{FF2B5EF4-FFF2-40B4-BE49-F238E27FC236}">
-                <a16:creationId xmlns:a16="http://schemas.microsoft.com/office/drawing/2014/main" id="{DC9A9A74-B70A-4AA8-AE0A-A4185726F313}"/>
+                <a16:creationId xmlns:a16="http://schemas.microsoft.com/office/drawing/2014/main" id="{FAE4E58E-E286-4844-8003-93D556F9F41E}"/>
               </a:ext>
             </a:extLst>
           </p:cNvPr>
@@ -4301,7 +4326,7 @@
           <p:cNvPr id="17" name="accountability-unknowns">
             <a:extLst xmlns:a="http://schemas.openxmlformats.org/drawingml/2006/main">
               <a:ext uri="{FF2B5EF4-FFF2-40B4-BE49-F238E27FC236}">
-                <a16:creationId xmlns:a16="http://schemas.microsoft.com/office/drawing/2014/main" id="{D9DC75F4-A829-430B-90B9-6FCB26AC0EC2}"/>
+                <a16:creationId xmlns:a16="http://schemas.microsoft.com/office/drawing/2014/main" id="{A628B3C8-127C-4CC2-AD33-A8EEEC272D0D}"/>
               </a:ext>
             </a:extLst>
           </p:cNvPr>
@@ -4357,7 +4382,7 @@
     </p:spTree>
     <p:extLst>
       <p:ext uri="{BB962C8B-B14F-4D97-AF65-F5344CB8AC3E}">
-        <p14:creationId xmlns:p14="http://schemas.microsoft.com/office/powerpoint/2010/main" val="106420799"/>
+        <p14:creationId xmlns:p14="http://schemas.microsoft.com/office/powerpoint/2010/main" val="1161151699"/>
       </p:ext>
     </p:extLst>
   </p:cSld>
@@ -4388,7 +4413,7 @@
           <p:cNvPr id="14" name="brand-3">
             <a:extLst xmlns:a="http://schemas.openxmlformats.org/drawingml/2006/main">
               <a:ext uri="{FF2B5EF4-FFF2-40B4-BE49-F238E27FC236}">
-                <a16:creationId xmlns:a16="http://schemas.microsoft.com/office/drawing/2014/main" id="{83205BBA-2AD4-4C0C-9269-1F7D40EEB0DB}"/>
+                <a16:creationId xmlns:a16="http://schemas.microsoft.com/office/drawing/2014/main" id="{3282CEEA-3449-4F36-B020-0374386111E6}"/>
               </a:ext>
             </a:extLst>
           </p:cNvPr>
@@ -4446,7 +4471,7 @@
           <p:cNvPr id="2" name="title-3">
             <a:extLst xmlns:a="http://schemas.openxmlformats.org/drawingml/2006/main">
               <a:ext uri="{FF2B5EF4-FFF2-40B4-BE49-F238E27FC236}">
-                <a16:creationId xmlns:a16="http://schemas.microsoft.com/office/drawing/2014/main" id="{49AE28FA-C5C4-49A1-9EAD-04CF0E8F3701}"/>
+                <a16:creationId xmlns:a16="http://schemas.microsoft.com/office/drawing/2014/main" id="{DCC29FF5-B191-4A9E-BE50-B6BDAE1BD9C1}"/>
               </a:ext>
             </a:extLst>
           </p:cNvPr>
@@ -4504,7 +4529,7 @@
           <p:cNvPr id="3" name="footer-rule-3">
             <a:extLst xmlns:a="http://schemas.openxmlformats.org/drawingml/2006/main">
               <a:ext uri="{FF2B5EF4-FFF2-40B4-BE49-F238E27FC236}">
-                <a16:creationId xmlns:a16="http://schemas.microsoft.com/office/drawing/2014/main" id="{62527A10-FC71-414E-811A-52F1D6381EE9}"/>
+                <a16:creationId xmlns:a16="http://schemas.microsoft.com/office/drawing/2014/main" id="{07883276-FBE1-451B-8B71-78AF50F419B4}"/>
               </a:ext>
             </a:extLst>
           </p:cNvPr>
@@ -4535,7 +4560,7 @@
           <p:cNvPr id="4" name="footer-source-3">
             <a:extLst xmlns:a="http://schemas.openxmlformats.org/drawingml/2006/main">
               <a:ext uri="{FF2B5EF4-FFF2-40B4-BE49-F238E27FC236}">
-                <a16:creationId xmlns:a16="http://schemas.microsoft.com/office/drawing/2014/main" id="{095B92E5-CBCD-4E0D-8591-E8BFC1E1916C}"/>
+                <a16:creationId xmlns:a16="http://schemas.microsoft.com/office/drawing/2014/main" id="{1B53BFC3-106E-4A16-89F9-5E9EA753F19F}"/>
               </a:ext>
             </a:extLst>
           </p:cNvPr>
@@ -4593,7 +4618,7 @@
           <p:cNvPr id="5" name="footer-page-3">
             <a:extLst xmlns:a="http://schemas.openxmlformats.org/drawingml/2006/main">
               <a:ext uri="{FF2B5EF4-FFF2-40B4-BE49-F238E27FC236}">
-                <a16:creationId xmlns:a16="http://schemas.microsoft.com/office/drawing/2014/main" id="{8AD04C8D-5292-448B-BFF2-A2B60E6A2804}"/>
+                <a16:creationId xmlns:a16="http://schemas.microsoft.com/office/drawing/2014/main" id="{CF6788E3-3159-4A89-8E3A-D41C7F23569D}"/>
               </a:ext>
             </a:extLst>
           </p:cNvPr>
@@ -4651,7 +4676,7 @@
           <p:cNvPr id="6" name="boundary-left">
             <a:extLst xmlns:a="http://schemas.openxmlformats.org/drawingml/2006/main">
               <a:ext uri="{FF2B5EF4-FFF2-40B4-BE49-F238E27FC236}">
-                <a16:creationId xmlns:a16="http://schemas.microsoft.com/office/drawing/2014/main" id="{62681918-BC6A-4E03-BBF0-DED058E9FCF8}"/>
+                <a16:creationId xmlns:a16="http://schemas.microsoft.com/office/drawing/2014/main" id="{A8F9996F-8385-44EF-B247-123581C55310}"/>
               </a:ext>
             </a:extLst>
           </p:cNvPr>
@@ -4684,7 +4709,7 @@
           <p:cNvPr id="7" name="boundary-spine">
             <a:extLst xmlns:a="http://schemas.openxmlformats.org/drawingml/2006/main">
               <a:ext uri="{FF2B5EF4-FFF2-40B4-BE49-F238E27FC236}">
-                <a16:creationId xmlns:a16="http://schemas.microsoft.com/office/drawing/2014/main" id="{266A9D79-EAED-49F4-89F3-5E71FE150CC5}"/>
+                <a16:creationId xmlns:a16="http://schemas.microsoft.com/office/drawing/2014/main" id="{BF6DDBF2-4C53-455B-8668-FD9D3B8830D2}"/>
               </a:ext>
             </a:extLst>
           </p:cNvPr>
@@ -4715,7 +4740,7 @@
           <p:cNvPr id="8" name="boundary-drr">
             <a:extLst xmlns:a="http://schemas.openxmlformats.org/drawingml/2006/main">
               <a:ext uri="{FF2B5EF4-FFF2-40B4-BE49-F238E27FC236}">
-                <a16:creationId xmlns:a16="http://schemas.microsoft.com/office/drawing/2014/main" id="{913F6CF4-248E-435B-ADCA-9087D0FC296F}"/>
+                <a16:creationId xmlns:a16="http://schemas.microsoft.com/office/drawing/2014/main" id="{B11B3559-A41C-448D-A79D-ACFEB9867B28}"/>
               </a:ext>
             </a:extLst>
           </p:cNvPr>
@@ -4773,7 +4798,7 @@
           <p:cNvPr id="9" name="boundary-drr-copy">
             <a:extLst xmlns:a="http://schemas.openxmlformats.org/drawingml/2006/main">
               <a:ext uri="{FF2B5EF4-FFF2-40B4-BE49-F238E27FC236}">
-                <a16:creationId xmlns:a16="http://schemas.microsoft.com/office/drawing/2014/main" id="{D4C32D96-E8A0-46AE-B167-9F0ECF88A2CE}"/>
+                <a16:creationId xmlns:a16="http://schemas.microsoft.com/office/drawing/2014/main" id="{A2EF459F-D44D-4B70-B9E6-326D9ECC3721}"/>
               </a:ext>
             </a:extLst>
           </p:cNvPr>
@@ -4831,7 +4856,7 @@
           <p:cNvPr id="10" name="boundary-attest">
             <a:extLst xmlns:a="http://schemas.openxmlformats.org/drawingml/2006/main">
               <a:ext uri="{FF2B5EF4-FFF2-40B4-BE49-F238E27FC236}">
-                <a16:creationId xmlns:a16="http://schemas.microsoft.com/office/drawing/2014/main" id="{764E3AA1-CFB8-4E8A-8EE4-46E4861B3C58}"/>
+                <a16:creationId xmlns:a16="http://schemas.microsoft.com/office/drawing/2014/main" id="{6DC587BD-2664-4CC4-9035-92B8AD3DE764}"/>
               </a:ext>
             </a:extLst>
           </p:cNvPr>
@@ -4889,7 +4914,7 @@
           <p:cNvPr id="11" name="boundary-attest-copy">
             <a:extLst xmlns:a="http://schemas.openxmlformats.org/drawingml/2006/main">
               <a:ext uri="{FF2B5EF4-FFF2-40B4-BE49-F238E27FC236}">
-                <a16:creationId xmlns:a16="http://schemas.microsoft.com/office/drawing/2014/main" id="{B913B582-0638-4890-AEB0-62C8F60121A3}"/>
+                <a16:creationId xmlns:a16="http://schemas.microsoft.com/office/drawing/2014/main" id="{9C902F75-CFF8-40A0-B3B4-0C6A14603B96}"/>
               </a:ext>
             </a:extLst>
           </p:cNvPr>
@@ -4947,7 +4972,7 @@
           <p:cNvPr id="12" name="boundary-limit">
             <a:extLst xmlns:a="http://schemas.openxmlformats.org/drawingml/2006/main">
               <a:ext uri="{FF2B5EF4-FFF2-40B4-BE49-F238E27FC236}">
-                <a16:creationId xmlns:a16="http://schemas.microsoft.com/office/drawing/2014/main" id="{E9876D9B-F800-4EF2-99FE-5C36A6C3BA5C}"/>
+                <a16:creationId xmlns:a16="http://schemas.microsoft.com/office/drawing/2014/main" id="{A659047E-9D76-4526-AE9C-F8C1C370B6B5}"/>
               </a:ext>
             </a:extLst>
           </p:cNvPr>
@@ -5005,7 +5030,7 @@
           <p:cNvPr id="13" name="boundary-absence">
             <a:extLst xmlns:a="http://schemas.openxmlformats.org/drawingml/2006/main">
               <a:ext uri="{FF2B5EF4-FFF2-40B4-BE49-F238E27FC236}">
-                <a16:creationId xmlns:a16="http://schemas.microsoft.com/office/drawing/2014/main" id="{B24DCD06-0E7F-4FB9-B529-270D5CDC4404}"/>
+                <a16:creationId xmlns:a16="http://schemas.microsoft.com/office/drawing/2014/main" id="{041A36DD-65A1-48E6-B231-954664D2C3F5}"/>
               </a:ext>
             </a:extLst>
           </p:cNvPr>
@@ -5061,7 +5086,7 @@
     </p:spTree>
     <p:extLst>
       <p:ext uri="{BB962C8B-B14F-4D97-AF65-F5344CB8AC3E}">
-        <p14:creationId xmlns:p14="http://schemas.microsoft.com/office/powerpoint/2010/main" val="1460950517"/>
+        <p14:creationId xmlns:p14="http://schemas.microsoft.com/office/powerpoint/2010/main" val="1665413055"/>
       </p:ext>
     </p:extLst>
   </p:cSld>
@@ -5092,7 +5117,7 @@
           <p:cNvPr id="22" name="brand-4">
             <a:extLst xmlns:a="http://schemas.openxmlformats.org/drawingml/2006/main">
               <a:ext uri="{FF2B5EF4-FFF2-40B4-BE49-F238E27FC236}">
-                <a16:creationId xmlns:a16="http://schemas.microsoft.com/office/drawing/2014/main" id="{450965DB-7940-4ABD-80EB-2EF41728F903}"/>
+                <a16:creationId xmlns:a16="http://schemas.microsoft.com/office/drawing/2014/main" id="{A1356B80-DAFF-4D04-8924-71904397DE4B}"/>
               </a:ext>
             </a:extLst>
           </p:cNvPr>
@@ -5150,7 +5175,7 @@
           <p:cNvPr id="2" name="title-4">
             <a:extLst xmlns:a="http://schemas.openxmlformats.org/drawingml/2006/main">
               <a:ext uri="{FF2B5EF4-FFF2-40B4-BE49-F238E27FC236}">
-                <a16:creationId xmlns:a16="http://schemas.microsoft.com/office/drawing/2014/main" id="{E5C8CCA8-A210-4CAD-9D89-122AB84D0EB2}"/>
+                <a16:creationId xmlns:a16="http://schemas.microsoft.com/office/drawing/2014/main" id="{D2FFE3BB-ACE0-4048-B7DA-A441E834C519}"/>
               </a:ext>
             </a:extLst>
           </p:cNvPr>
@@ -5208,7 +5233,7 @@
           <p:cNvPr id="3" name="footer-rule-4">
             <a:extLst xmlns:a="http://schemas.openxmlformats.org/drawingml/2006/main">
               <a:ext uri="{FF2B5EF4-FFF2-40B4-BE49-F238E27FC236}">
-                <a16:creationId xmlns:a16="http://schemas.microsoft.com/office/drawing/2014/main" id="{189EB567-2602-4835-892D-A124D97F7555}"/>
+                <a16:creationId xmlns:a16="http://schemas.microsoft.com/office/drawing/2014/main" id="{27EDF418-CD0A-4469-AF14-4339F6EC213F}"/>
               </a:ext>
             </a:extLst>
           </p:cNvPr>
@@ -5239,7 +5264,7 @@
           <p:cNvPr id="4" name="footer-source-4">
             <a:extLst xmlns:a="http://schemas.openxmlformats.org/drawingml/2006/main">
               <a:ext uri="{FF2B5EF4-FFF2-40B4-BE49-F238E27FC236}">
-                <a16:creationId xmlns:a16="http://schemas.microsoft.com/office/drawing/2014/main" id="{6389C735-8BB7-4447-92D7-484BAE4F3E74}"/>
+                <a16:creationId xmlns:a16="http://schemas.microsoft.com/office/drawing/2014/main" id="{B6D1675A-AE50-479A-A1D4-8A5FED0807D8}"/>
               </a:ext>
             </a:extLst>
           </p:cNvPr>
@@ -5297,7 +5322,7 @@
           <p:cNvPr id="5" name="footer-page-4">
             <a:extLst xmlns:a="http://schemas.openxmlformats.org/drawingml/2006/main">
               <a:ext uri="{FF2B5EF4-FFF2-40B4-BE49-F238E27FC236}">
-                <a16:creationId xmlns:a16="http://schemas.microsoft.com/office/drawing/2014/main" id="{11854EDE-BCB4-400A-ABEF-930FA59B153B}"/>
+                <a16:creationId xmlns:a16="http://schemas.microsoft.com/office/drawing/2014/main" id="{ACA0E632-E184-4FAF-B795-E2530DF984A0}"/>
               </a:ext>
             </a:extLst>
           </p:cNvPr>
@@ -5355,7 +5380,7 @@
           <p:cNvPr id="6" name="case-entity">
             <a:extLst xmlns:a="http://schemas.openxmlformats.org/drawingml/2006/main">
               <a:ext uri="{FF2B5EF4-FFF2-40B4-BE49-F238E27FC236}">
-                <a16:creationId xmlns:a16="http://schemas.microsoft.com/office/drawing/2014/main" id="{75099179-E8C4-463E-87CA-E23371C0AD93}"/>
+                <a16:creationId xmlns:a16="http://schemas.microsoft.com/office/drawing/2014/main" id="{E5749479-D11D-4D58-B5CA-F30F456C6FD2}"/>
               </a:ext>
             </a:extLst>
           </p:cNvPr>
@@ -5413,7 +5438,7 @@
           <p:cNvPr id="7" name="case-period">
             <a:extLst xmlns:a="http://schemas.openxmlformats.org/drawingml/2006/main">
               <a:ext uri="{FF2B5EF4-FFF2-40B4-BE49-F238E27FC236}">
-                <a16:creationId xmlns:a16="http://schemas.microsoft.com/office/drawing/2014/main" id="{CD3F8DC4-DD1B-469D-9581-69B34B118C25}"/>
+                <a16:creationId xmlns:a16="http://schemas.microsoft.com/office/drawing/2014/main" id="{64727C02-05E8-46E4-A410-275607D83AF7}"/>
               </a:ext>
             </a:extLst>
           </p:cNvPr>
@@ -5471,7 +5496,7 @@
           <p:cNvPr id="8" name="case-marker">
             <a:extLst xmlns:a="http://schemas.openxmlformats.org/drawingml/2006/main">
               <a:ext uri="{FF2B5EF4-FFF2-40B4-BE49-F238E27FC236}">
-                <a16:creationId xmlns:a16="http://schemas.microsoft.com/office/drawing/2014/main" id="{9A061E1B-EE83-4D42-A5CD-4DA6A34611E2}"/>
+                <a16:creationId xmlns:a16="http://schemas.microsoft.com/office/drawing/2014/main" id="{331BD626-BD64-4AB8-9284-000D850C20A8}"/>
               </a:ext>
             </a:extLst>
           </p:cNvPr>
@@ -5529,7 +5554,7 @@
           <p:cNvPr id="9" name="case-divider">
             <a:extLst xmlns:a="http://schemas.openxmlformats.org/drawingml/2006/main">
               <a:ext uri="{FF2B5EF4-FFF2-40B4-BE49-F238E27FC236}">
-                <a16:creationId xmlns:a16="http://schemas.microsoft.com/office/drawing/2014/main" id="{91778BF4-D5BA-495B-A974-F88C149A634F}"/>
+                <a16:creationId xmlns:a16="http://schemas.microsoft.com/office/drawing/2014/main" id="{C916801D-CFDD-478F-9F10-150E41968518}"/>
               </a:ext>
             </a:extLst>
           </p:cNvPr>
@@ -5560,7 +5585,7 @@
           <p:cNvPr id="10" name="case-row-rule-1">
             <a:extLst xmlns:a="http://schemas.openxmlformats.org/drawingml/2006/main">
               <a:ext uri="{FF2B5EF4-FFF2-40B4-BE49-F238E27FC236}">
-                <a16:creationId xmlns:a16="http://schemas.microsoft.com/office/drawing/2014/main" id="{31A8DE3F-0FEE-4AE8-9999-638ED9BBBDBB}"/>
+                <a16:creationId xmlns:a16="http://schemas.microsoft.com/office/drawing/2014/main" id="{445C5213-BD45-4236-88B0-3852C4DC9B24}"/>
               </a:ext>
             </a:extLst>
           </p:cNvPr>
@@ -5591,7 +5616,7 @@
           <p:cNvPr id="11" name="case-row-status-1">
             <a:extLst xmlns:a="http://schemas.openxmlformats.org/drawingml/2006/main">
               <a:ext uri="{FF2B5EF4-FFF2-40B4-BE49-F238E27FC236}">
-                <a16:creationId xmlns:a16="http://schemas.microsoft.com/office/drawing/2014/main" id="{4F732D8A-AD7D-4F4C-AC25-72576AC174CA}"/>
+                <a16:creationId xmlns:a16="http://schemas.microsoft.com/office/drawing/2014/main" id="{68C53440-2CFE-4F51-B6B4-C8E97B5C2BE6}"/>
               </a:ext>
             </a:extLst>
           </p:cNvPr>
@@ -5649,7 +5674,7 @@
           <p:cNvPr id="12" name="case-row-label-1">
             <a:extLst xmlns:a="http://schemas.openxmlformats.org/drawingml/2006/main">
               <a:ext uri="{FF2B5EF4-FFF2-40B4-BE49-F238E27FC236}">
-                <a16:creationId xmlns:a16="http://schemas.microsoft.com/office/drawing/2014/main" id="{B7FD92FB-2E0B-4927-94AC-894EE71A16F1}"/>
+                <a16:creationId xmlns:a16="http://schemas.microsoft.com/office/drawing/2014/main" id="{25D2DD0A-82A8-451E-AD0D-670DADC02B8E}"/>
               </a:ext>
             </a:extLst>
           </p:cNvPr>
@@ -5707,7 +5732,7 @@
           <p:cNvPr id="13" name="case-row-copy-1">
             <a:extLst xmlns:a="http://schemas.openxmlformats.org/drawingml/2006/main">
               <a:ext uri="{FF2B5EF4-FFF2-40B4-BE49-F238E27FC236}">
-                <a16:creationId xmlns:a16="http://schemas.microsoft.com/office/drawing/2014/main" id="{04998589-B4E5-4940-84BB-0C9BE9ECC823}"/>
+                <a16:creationId xmlns:a16="http://schemas.microsoft.com/office/drawing/2014/main" id="{93C8084A-8314-4ECA-BFEA-4D60D7754033}"/>
               </a:ext>
             </a:extLst>
           </p:cNvPr>
@@ -5765,7 +5790,7 @@
           <p:cNvPr id="14" name="case-row-rule-2">
             <a:extLst xmlns:a="http://schemas.openxmlformats.org/drawingml/2006/main">
               <a:ext uri="{FF2B5EF4-FFF2-40B4-BE49-F238E27FC236}">
-                <a16:creationId xmlns:a16="http://schemas.microsoft.com/office/drawing/2014/main" id="{F26ABA6F-647B-482D-8C40-0D1C071C4BD9}"/>
+                <a16:creationId xmlns:a16="http://schemas.microsoft.com/office/drawing/2014/main" id="{78AE843A-43E9-4304-B7EC-601F12443D4C}"/>
               </a:ext>
             </a:extLst>
           </p:cNvPr>
@@ -5796,7 +5821,7 @@
           <p:cNvPr id="15" name="case-row-status-2">
             <a:extLst xmlns:a="http://schemas.openxmlformats.org/drawingml/2006/main">
               <a:ext uri="{FF2B5EF4-FFF2-40B4-BE49-F238E27FC236}">
-                <a16:creationId xmlns:a16="http://schemas.microsoft.com/office/drawing/2014/main" id="{81AE5696-9298-47B1-A010-DCC15D40B256}"/>
+                <a16:creationId xmlns:a16="http://schemas.microsoft.com/office/drawing/2014/main" id="{74486688-0C33-49C3-B9B7-502DAFD40E40}"/>
               </a:ext>
             </a:extLst>
           </p:cNvPr>
@@ -5854,7 +5879,7 @@
           <p:cNvPr id="16" name="case-row-label-2">
             <a:extLst xmlns:a="http://schemas.openxmlformats.org/drawingml/2006/main">
               <a:ext uri="{FF2B5EF4-FFF2-40B4-BE49-F238E27FC236}">
-                <a16:creationId xmlns:a16="http://schemas.microsoft.com/office/drawing/2014/main" id="{50669B62-B55B-4546-8486-28E9BF1217CB}"/>
+                <a16:creationId xmlns:a16="http://schemas.microsoft.com/office/drawing/2014/main" id="{23889F33-0426-44FE-BBA6-14C6EB03710B}"/>
               </a:ext>
             </a:extLst>
           </p:cNvPr>
@@ -5912,7 +5937,7 @@
           <p:cNvPr id="17" name="case-row-copy-2">
             <a:extLst xmlns:a="http://schemas.openxmlformats.org/drawingml/2006/main">
               <a:ext uri="{FF2B5EF4-FFF2-40B4-BE49-F238E27FC236}">
-                <a16:creationId xmlns:a16="http://schemas.microsoft.com/office/drawing/2014/main" id="{49ADF299-454D-42A1-B495-FAB49B2E6B6D}"/>
+                <a16:creationId xmlns:a16="http://schemas.microsoft.com/office/drawing/2014/main" id="{B89F242C-A454-4020-AC29-ECA69F4AE022}"/>
               </a:ext>
             </a:extLst>
           </p:cNvPr>
@@ -5970,7 +5995,7 @@
           <p:cNvPr id="18" name="case-row-rule-3">
             <a:extLst xmlns:a="http://schemas.openxmlformats.org/drawingml/2006/main">
               <a:ext uri="{FF2B5EF4-FFF2-40B4-BE49-F238E27FC236}">
-                <a16:creationId xmlns:a16="http://schemas.microsoft.com/office/drawing/2014/main" id="{E42D067A-916D-4862-8ED1-5E80AF332FCA}"/>
+                <a16:creationId xmlns:a16="http://schemas.microsoft.com/office/drawing/2014/main" id="{806C2479-ABAC-47D9-A913-ECB25656D562}"/>
               </a:ext>
             </a:extLst>
           </p:cNvPr>
@@ -6001,7 +6026,7 @@
           <p:cNvPr id="19" name="case-row-status-3">
             <a:extLst xmlns:a="http://schemas.openxmlformats.org/drawingml/2006/main">
               <a:ext uri="{FF2B5EF4-FFF2-40B4-BE49-F238E27FC236}">
-                <a16:creationId xmlns:a16="http://schemas.microsoft.com/office/drawing/2014/main" id="{C5712362-4E0E-465A-9307-D722992341B6}"/>
+                <a16:creationId xmlns:a16="http://schemas.microsoft.com/office/drawing/2014/main" id="{CC8EA99A-C779-4560-A17B-9477F31EF8F3}"/>
               </a:ext>
             </a:extLst>
           </p:cNvPr>
@@ -6059,7 +6084,7 @@
           <p:cNvPr id="20" name="case-row-label-3">
             <a:extLst xmlns:a="http://schemas.openxmlformats.org/drawingml/2006/main">
               <a:ext uri="{FF2B5EF4-FFF2-40B4-BE49-F238E27FC236}">
-                <a16:creationId xmlns:a16="http://schemas.microsoft.com/office/drawing/2014/main" id="{E7430D88-D1AF-45A3-A08B-1CB03DC77E25}"/>
+                <a16:creationId xmlns:a16="http://schemas.microsoft.com/office/drawing/2014/main" id="{F8DF9460-CF1C-4B4F-BCE1-5C0BF09FF65D}"/>
               </a:ext>
             </a:extLst>
           </p:cNvPr>
@@ -6117,7 +6142,7 @@
           <p:cNvPr id="21" name="case-row-copy-3">
             <a:extLst xmlns:a="http://schemas.openxmlformats.org/drawingml/2006/main">
               <a:ext uri="{FF2B5EF4-FFF2-40B4-BE49-F238E27FC236}">
-                <a16:creationId xmlns:a16="http://schemas.microsoft.com/office/drawing/2014/main" id="{497D4F46-866D-4C9F-BA83-7F68F6A76465}"/>
+                <a16:creationId xmlns:a16="http://schemas.microsoft.com/office/drawing/2014/main" id="{24E8FC64-9FC9-4596-BBF4-0CDAC85515D0}"/>
               </a:ext>
             </a:extLst>
           </p:cNvPr>
@@ -6173,7 +6198,7 @@
     </p:spTree>
     <p:extLst>
       <p:ext uri="{BB962C8B-B14F-4D97-AF65-F5344CB8AC3E}">
-        <p14:creationId xmlns:p14="http://schemas.microsoft.com/office/powerpoint/2010/main" val="1166752041"/>
+        <p14:creationId xmlns:p14="http://schemas.microsoft.com/office/powerpoint/2010/main" val="1282930387"/>
       </p:ext>
     </p:extLst>
   </p:cSld>
@@ -6204,7 +6229,7 @@
           <p:cNvPr id="17" name="brand-5">
             <a:extLst xmlns:a="http://schemas.openxmlformats.org/drawingml/2006/main">
               <a:ext uri="{FF2B5EF4-FFF2-40B4-BE49-F238E27FC236}">
-                <a16:creationId xmlns:a16="http://schemas.microsoft.com/office/drawing/2014/main" id="{F4C04FC7-3236-4101-81B4-7A795F1DED8D}"/>
+                <a16:creationId xmlns:a16="http://schemas.microsoft.com/office/drawing/2014/main" id="{29EB6A1C-98C8-40EC-AAD8-D67787DCEF9F}"/>
               </a:ext>
             </a:extLst>
           </p:cNvPr>
@@ -6262,7 +6287,7 @@
           <p:cNvPr id="2" name="title-5">
             <a:extLst xmlns:a="http://schemas.openxmlformats.org/drawingml/2006/main">
               <a:ext uri="{FF2B5EF4-FFF2-40B4-BE49-F238E27FC236}">
-                <a16:creationId xmlns:a16="http://schemas.microsoft.com/office/drawing/2014/main" id="{E4064B66-FE7D-4307-A04B-C86E8D8F1F02}"/>
+                <a16:creationId xmlns:a16="http://schemas.microsoft.com/office/drawing/2014/main" id="{58EF20D4-0043-497C-AE45-CD7BC1F29FF7}"/>
               </a:ext>
             </a:extLst>
           </p:cNvPr>
@@ -6320,7 +6345,7 @@
           <p:cNvPr id="3" name="footer-rule-5">
             <a:extLst xmlns:a="http://schemas.openxmlformats.org/drawingml/2006/main">
               <a:ext uri="{FF2B5EF4-FFF2-40B4-BE49-F238E27FC236}">
-                <a16:creationId xmlns:a16="http://schemas.microsoft.com/office/drawing/2014/main" id="{EC9DF677-AB81-4AFA-B731-E49C3FC8DC79}"/>
+                <a16:creationId xmlns:a16="http://schemas.microsoft.com/office/drawing/2014/main" id="{1C664C8C-640D-409F-95AD-749D10F92CAA}"/>
               </a:ext>
             </a:extLst>
           </p:cNvPr>
@@ -6351,7 +6376,7 @@
           <p:cNvPr id="4" name="footer-source-5">
             <a:extLst xmlns:a="http://schemas.openxmlformats.org/drawingml/2006/main">
               <a:ext uri="{FF2B5EF4-FFF2-40B4-BE49-F238E27FC236}">
-                <a16:creationId xmlns:a16="http://schemas.microsoft.com/office/drawing/2014/main" id="{E4E6C982-6911-4F06-9FC8-1E746EDE58A5}"/>
+                <a16:creationId xmlns:a16="http://schemas.microsoft.com/office/drawing/2014/main" id="{832F6A1B-EC1D-4D42-B19A-7038D1DC7426}"/>
               </a:ext>
             </a:extLst>
           </p:cNvPr>
@@ -6409,7 +6434,7 @@
           <p:cNvPr id="5" name="footer-page-5">
             <a:extLst xmlns:a="http://schemas.openxmlformats.org/drawingml/2006/main">
               <a:ext uri="{FF2B5EF4-FFF2-40B4-BE49-F238E27FC236}">
-                <a16:creationId xmlns:a16="http://schemas.microsoft.com/office/drawing/2014/main" id="{E6A889B1-D051-4880-8DB6-38A7076F0BCB}"/>
+                <a16:creationId xmlns:a16="http://schemas.microsoft.com/office/drawing/2014/main" id="{E7327203-4680-49D9-B1C9-0D0285486DE1}"/>
               </a:ext>
             </a:extLst>
           </p:cNvPr>
@@ -6467,7 +6492,7 @@
           <p:cNvPr id="6" name="workflow-rail">
             <a:extLst xmlns:a="http://schemas.openxmlformats.org/drawingml/2006/main">
               <a:ext uri="{FF2B5EF4-FFF2-40B4-BE49-F238E27FC236}">
-                <a16:creationId xmlns:a16="http://schemas.microsoft.com/office/drawing/2014/main" id="{E67E50EF-E8B4-499E-95AC-C673342AA424}"/>
+                <a16:creationId xmlns:a16="http://schemas.microsoft.com/office/drawing/2014/main" id="{52FDD5A8-B5C8-472E-A1D0-594864314AFF}"/>
               </a:ext>
             </a:extLst>
           </p:cNvPr>
@@ -6498,7 +6523,7 @@
           <p:cNvPr id="7" name="workflow-tick-1">
             <a:extLst xmlns:a="http://schemas.openxmlformats.org/drawingml/2006/main">
               <a:ext uri="{FF2B5EF4-FFF2-40B4-BE49-F238E27FC236}">
-                <a16:creationId xmlns:a16="http://schemas.microsoft.com/office/drawing/2014/main" id="{01E830B8-3C15-46D8-B6C8-BE5DC654858E}"/>
+                <a16:creationId xmlns:a16="http://schemas.microsoft.com/office/drawing/2014/main" id="{B504B0D0-8ADF-44E2-89C2-C351775F454D}"/>
               </a:ext>
             </a:extLst>
           </p:cNvPr>
@@ -6529,7 +6554,7 @@
           <p:cNvPr id="8" name="workflow-step-1">
             <a:extLst xmlns:a="http://schemas.openxmlformats.org/drawingml/2006/main">
               <a:ext uri="{FF2B5EF4-FFF2-40B4-BE49-F238E27FC236}">
-                <a16:creationId xmlns:a16="http://schemas.microsoft.com/office/drawing/2014/main" id="{1EB1E598-701E-4AAA-9689-DD04D23560CF}"/>
+                <a16:creationId xmlns:a16="http://schemas.microsoft.com/office/drawing/2014/main" id="{63CFC816-1A87-488B-89B8-ADE823205455}"/>
               </a:ext>
             </a:extLst>
           </p:cNvPr>
@@ -6587,7 +6612,7 @@
           <p:cNvPr id="9" name="workflow-tick-2">
             <a:extLst xmlns:a="http://schemas.openxmlformats.org/drawingml/2006/main">
               <a:ext uri="{FF2B5EF4-FFF2-40B4-BE49-F238E27FC236}">
-                <a16:creationId xmlns:a16="http://schemas.microsoft.com/office/drawing/2014/main" id="{515637E6-1B22-4AE1-A498-464C0D8B2DD5}"/>
+                <a16:creationId xmlns:a16="http://schemas.microsoft.com/office/drawing/2014/main" id="{884780F3-C200-44E5-A346-717B048E7D2B}"/>
               </a:ext>
             </a:extLst>
           </p:cNvPr>
@@ -6618,7 +6643,7 @@
           <p:cNvPr id="10" name="workflow-step-2">
             <a:extLst xmlns:a="http://schemas.openxmlformats.org/drawingml/2006/main">
               <a:ext uri="{FF2B5EF4-FFF2-40B4-BE49-F238E27FC236}">
-                <a16:creationId xmlns:a16="http://schemas.microsoft.com/office/drawing/2014/main" id="{504459A1-4654-4211-95DF-99F11DBFB5A7}"/>
+                <a16:creationId xmlns:a16="http://schemas.microsoft.com/office/drawing/2014/main" id="{2AF8860D-CBEF-4986-955E-DACC62B4DAB1}"/>
               </a:ext>
             </a:extLst>
           </p:cNvPr>
@@ -6676,7 +6701,7 @@
           <p:cNvPr id="11" name="workflow-tick-3">
             <a:extLst xmlns:a="http://schemas.openxmlformats.org/drawingml/2006/main">
               <a:ext uri="{FF2B5EF4-FFF2-40B4-BE49-F238E27FC236}">
-                <a16:creationId xmlns:a16="http://schemas.microsoft.com/office/drawing/2014/main" id="{6072EF5B-505B-463F-8960-6E6B17060CB4}"/>
+                <a16:creationId xmlns:a16="http://schemas.microsoft.com/office/drawing/2014/main" id="{D2F3CD00-CF67-4C7F-8F9D-DD8F37932898}"/>
               </a:ext>
             </a:extLst>
           </p:cNvPr>
@@ -6707,7 +6732,7 @@
           <p:cNvPr id="12" name="workflow-step-3">
             <a:extLst xmlns:a="http://schemas.openxmlformats.org/drawingml/2006/main">
               <a:ext uri="{FF2B5EF4-FFF2-40B4-BE49-F238E27FC236}">
-                <a16:creationId xmlns:a16="http://schemas.microsoft.com/office/drawing/2014/main" id="{2FEA545D-3C27-447F-9B6D-DD24188620A5}"/>
+                <a16:creationId xmlns:a16="http://schemas.microsoft.com/office/drawing/2014/main" id="{AEBF5E23-F8F2-42E7-A004-9D9880A66620}"/>
               </a:ext>
             </a:extLst>
           </p:cNvPr>
@@ -6765,7 +6790,7 @@
           <p:cNvPr id="13" name="workflow-tick-4">
             <a:extLst xmlns:a="http://schemas.openxmlformats.org/drawingml/2006/main">
               <a:ext uri="{FF2B5EF4-FFF2-40B4-BE49-F238E27FC236}">
-                <a16:creationId xmlns:a16="http://schemas.microsoft.com/office/drawing/2014/main" id="{7AD01CFE-DD00-4C73-BD3F-F153F1E0F707}"/>
+                <a16:creationId xmlns:a16="http://schemas.microsoft.com/office/drawing/2014/main" id="{F142AF83-EC20-49D8-9126-1796DD618908}"/>
               </a:ext>
             </a:extLst>
           </p:cNvPr>
@@ -6796,7 +6821,7 @@
           <p:cNvPr id="14" name="workflow-step-4">
             <a:extLst xmlns:a="http://schemas.openxmlformats.org/drawingml/2006/main">
               <a:ext uri="{FF2B5EF4-FFF2-40B4-BE49-F238E27FC236}">
-                <a16:creationId xmlns:a16="http://schemas.microsoft.com/office/drawing/2014/main" id="{E9C4DBC2-6EC2-451D-8981-A215FA738E86}"/>
+                <a16:creationId xmlns:a16="http://schemas.microsoft.com/office/drawing/2014/main" id="{F70EC9F1-E1E1-458C-AF7E-5CFFFA60334C}"/>
               </a:ext>
             </a:extLst>
           </p:cNvPr>
@@ -6854,7 +6879,7 @@
           <p:cNvPr id="15" name="workflow-tick-5">
             <a:extLst xmlns:a="http://schemas.openxmlformats.org/drawingml/2006/main">
               <a:ext uri="{FF2B5EF4-FFF2-40B4-BE49-F238E27FC236}">
-                <a16:creationId xmlns:a16="http://schemas.microsoft.com/office/drawing/2014/main" id="{716C6A7A-7C37-4928-941F-469293DCD246}"/>
+                <a16:creationId xmlns:a16="http://schemas.microsoft.com/office/drawing/2014/main" id="{E6BB926B-0493-401A-8FEC-7C1E03F23280}"/>
               </a:ext>
             </a:extLst>
           </p:cNvPr>
@@ -6885,7 +6910,7 @@
           <p:cNvPr id="16" name="workflow-step-5">
             <a:extLst xmlns:a="http://schemas.openxmlformats.org/drawingml/2006/main">
               <a:ext uri="{FF2B5EF4-FFF2-40B4-BE49-F238E27FC236}">
-                <a16:creationId xmlns:a16="http://schemas.microsoft.com/office/drawing/2014/main" id="{ED9E3918-7224-4427-97F4-994209271182}"/>
+                <a16:creationId xmlns:a16="http://schemas.microsoft.com/office/drawing/2014/main" id="{B4DFA130-18E9-4221-ACE0-22F317E8AFCE}"/>
               </a:ext>
             </a:extLst>
           </p:cNvPr>
@@ -6941,7 +6966,7 @@
     </p:spTree>
     <p:extLst>
       <p:ext uri="{BB962C8B-B14F-4D97-AF65-F5344CB8AC3E}">
-        <p14:creationId xmlns:p14="http://schemas.microsoft.com/office/powerpoint/2010/main" val="330121730"/>
+        <p14:creationId xmlns:p14="http://schemas.microsoft.com/office/powerpoint/2010/main" val="551981599"/>
       </p:ext>
     </p:extLst>
   </p:cSld>
@@ -6972,7 +6997,7 @@
           <p:cNvPr id="16" name="brand-6">
             <a:extLst xmlns:a="http://schemas.openxmlformats.org/drawingml/2006/main">
               <a:ext uri="{FF2B5EF4-FFF2-40B4-BE49-F238E27FC236}">
-                <a16:creationId xmlns:a16="http://schemas.microsoft.com/office/drawing/2014/main" id="{5E0796A0-716D-49DB-8FCC-8369ACA8DF52}"/>
+                <a16:creationId xmlns:a16="http://schemas.microsoft.com/office/drawing/2014/main" id="{7CA53371-EE21-4C97-B569-ECEFFBE00A4E}"/>
               </a:ext>
             </a:extLst>
           </p:cNvPr>
@@ -7030,7 +7055,7 @@
           <p:cNvPr id="2" name="title-6">
             <a:extLst xmlns:a="http://schemas.openxmlformats.org/drawingml/2006/main">
               <a:ext uri="{FF2B5EF4-FFF2-40B4-BE49-F238E27FC236}">
-                <a16:creationId xmlns:a16="http://schemas.microsoft.com/office/drawing/2014/main" id="{D91528ED-E2C7-4894-BD41-C7C97C04D459}"/>
+                <a16:creationId xmlns:a16="http://schemas.microsoft.com/office/drawing/2014/main" id="{5195CA86-5AE7-4A49-96F4-FE0C168ACE28}"/>
               </a:ext>
             </a:extLst>
           </p:cNvPr>
@@ -7088,7 +7113,7 @@
           <p:cNvPr id="3" name="footer-rule-6">
             <a:extLst xmlns:a="http://schemas.openxmlformats.org/drawingml/2006/main">
               <a:ext uri="{FF2B5EF4-FFF2-40B4-BE49-F238E27FC236}">
-                <a16:creationId xmlns:a16="http://schemas.microsoft.com/office/drawing/2014/main" id="{14415B55-DE70-4A8D-B5D9-C9A86AE1418F}"/>
+                <a16:creationId xmlns:a16="http://schemas.microsoft.com/office/drawing/2014/main" id="{AA5A6D20-1459-4E0F-B971-B496E44F009A}"/>
               </a:ext>
             </a:extLst>
           </p:cNvPr>
@@ -7119,7 +7144,7 @@
           <p:cNvPr id="4" name="footer-source-6">
             <a:extLst xmlns:a="http://schemas.openxmlformats.org/drawingml/2006/main">
               <a:ext uri="{FF2B5EF4-FFF2-40B4-BE49-F238E27FC236}">
-                <a16:creationId xmlns:a16="http://schemas.microsoft.com/office/drawing/2014/main" id="{4C258916-745C-4124-9CBA-B9739E9E6694}"/>
+                <a16:creationId xmlns:a16="http://schemas.microsoft.com/office/drawing/2014/main" id="{F50F35B9-D50D-4F48-8831-938F43367C97}"/>
               </a:ext>
             </a:extLst>
           </p:cNvPr>
@@ -7177,7 +7202,7 @@
           <p:cNvPr id="5" name="footer-page-6">
             <a:extLst xmlns:a="http://schemas.openxmlformats.org/drawingml/2006/main">
               <a:ext uri="{FF2B5EF4-FFF2-40B4-BE49-F238E27FC236}">
-                <a16:creationId xmlns:a16="http://schemas.microsoft.com/office/drawing/2014/main" id="{7D80F287-0E43-47C6-97A1-A6384C84D503}"/>
+                <a16:creationId xmlns:a16="http://schemas.microsoft.com/office/drawing/2014/main" id="{591C8FBE-AD18-4984-A58E-9DFC41C97BD2}"/>
               </a:ext>
             </a:extLst>
           </p:cNvPr>
@@ -7235,7 +7260,7 @@
           <p:cNvPr id="6" name="agent-trace-label">
             <a:extLst xmlns:a="http://schemas.openxmlformats.org/drawingml/2006/main">
               <a:ext uri="{FF2B5EF4-FFF2-40B4-BE49-F238E27FC236}">
-                <a16:creationId xmlns:a16="http://schemas.microsoft.com/office/drawing/2014/main" id="{FD63B491-CA54-4DE7-B586-5FBA70A789F9}"/>
+                <a16:creationId xmlns:a16="http://schemas.microsoft.com/office/drawing/2014/main" id="{0F7BFAAF-1C31-4E7F-820D-1E5C6BADC6BC}"/>
               </a:ext>
             </a:extLst>
           </p:cNvPr>
@@ -7293,7 +7318,7 @@
           <p:cNvPr id="7" name="agent-trace-spine">
             <a:extLst xmlns:a="http://schemas.openxmlformats.org/drawingml/2006/main">
               <a:ext uri="{FF2B5EF4-FFF2-40B4-BE49-F238E27FC236}">
-                <a16:creationId xmlns:a16="http://schemas.microsoft.com/office/drawing/2014/main" id="{E48825D8-BDAA-4CEE-82A3-292ABB78F445}"/>
+                <a16:creationId xmlns:a16="http://schemas.microsoft.com/office/drawing/2014/main" id="{2E882589-073D-47EE-8CEA-BAAF52ACEAD1}"/>
               </a:ext>
             </a:extLst>
           </p:cNvPr>
@@ -7324,7 +7349,7 @@
           <p:cNvPr id="8" name="agent-propose">
             <a:extLst xmlns:a="http://schemas.openxmlformats.org/drawingml/2006/main">
               <a:ext uri="{FF2B5EF4-FFF2-40B4-BE49-F238E27FC236}">
-                <a16:creationId xmlns:a16="http://schemas.microsoft.com/office/drawing/2014/main" id="{E7A919F6-1C99-4830-A5E8-0BF34AC39526}"/>
+                <a16:creationId xmlns:a16="http://schemas.microsoft.com/office/drawing/2014/main" id="{F127438B-2DBF-49D0-9F28-BE5FAF0034E7}"/>
               </a:ext>
             </a:extLst>
           </p:cNvPr>
@@ -7382,7 +7407,7 @@
           <p:cNvPr id="9" name="agent-propose-copy">
             <a:extLst xmlns:a="http://schemas.openxmlformats.org/drawingml/2006/main">
               <a:ext uri="{FF2B5EF4-FFF2-40B4-BE49-F238E27FC236}">
-                <a16:creationId xmlns:a16="http://schemas.microsoft.com/office/drawing/2014/main" id="{8691C1C0-992E-42E9-A187-C3F92D8D2C1E}"/>
+                <a16:creationId xmlns:a16="http://schemas.microsoft.com/office/drawing/2014/main" id="{D38978A5-BE75-4DDC-90B9-86380A241300}"/>
               </a:ext>
             </a:extLst>
           </p:cNvPr>
@@ -7440,7 +7465,7 @@
           <p:cNvPr id="10" name="agent-abstain">
             <a:extLst xmlns:a="http://schemas.openxmlformats.org/drawingml/2006/main">
               <a:ext uri="{FF2B5EF4-FFF2-40B4-BE49-F238E27FC236}">
-                <a16:creationId xmlns:a16="http://schemas.microsoft.com/office/drawing/2014/main" id="{17FE4DEE-576E-4EEA-B352-B038D53CB251}"/>
+                <a16:creationId xmlns:a16="http://schemas.microsoft.com/office/drawing/2014/main" id="{622D6C0D-D005-4C4C-9BEA-CAF3C5694798}"/>
               </a:ext>
             </a:extLst>
           </p:cNvPr>
@@ -7498,7 +7523,7 @@
           <p:cNvPr id="11" name="agent-abstain-copy">
             <a:extLst xmlns:a="http://schemas.openxmlformats.org/drawingml/2006/main">
               <a:ext uri="{FF2B5EF4-FFF2-40B4-BE49-F238E27FC236}">
-                <a16:creationId xmlns:a16="http://schemas.microsoft.com/office/drawing/2014/main" id="{FBB37F69-94E4-4C1B-A9FE-FF24736D5D48}"/>
+                <a16:creationId xmlns:a16="http://schemas.microsoft.com/office/drawing/2014/main" id="{4829BE56-1B69-4493-BCC4-1407D02BEB4F}"/>
               </a:ext>
             </a:extLst>
           </p:cNvPr>
@@ -7556,7 +7581,7 @@
           <p:cNvPr id="12" name="agent-decide">
             <a:extLst xmlns:a="http://schemas.openxmlformats.org/drawingml/2006/main">
               <a:ext uri="{FF2B5EF4-FFF2-40B4-BE49-F238E27FC236}">
-                <a16:creationId xmlns:a16="http://schemas.microsoft.com/office/drawing/2014/main" id="{DB47C65C-2A6D-486E-9A78-67F27E994B1D}"/>
+                <a16:creationId xmlns:a16="http://schemas.microsoft.com/office/drawing/2014/main" id="{068095C6-73F2-4CE9-80A0-4ACB4F350F93}"/>
               </a:ext>
             </a:extLst>
           </p:cNvPr>
@@ -7614,7 +7639,7 @@
           <p:cNvPr id="13" name="agent-decide-copy">
             <a:extLst xmlns:a="http://schemas.openxmlformats.org/drawingml/2006/main">
               <a:ext uri="{FF2B5EF4-FFF2-40B4-BE49-F238E27FC236}">
-                <a16:creationId xmlns:a16="http://schemas.microsoft.com/office/drawing/2014/main" id="{7710185D-99D4-4EF6-99C1-1A8FCDD01438}"/>
+                <a16:creationId xmlns:a16="http://schemas.microsoft.com/office/drawing/2014/main" id="{B1AA80B7-539B-46D5-A237-D363E3366489}"/>
               </a:ext>
             </a:extLst>
           </p:cNvPr>
@@ -7672,7 +7697,7 @@
           <p:cNvPr id="14" name="agent-boundary-rule">
             <a:extLst xmlns:a="http://schemas.openxmlformats.org/drawingml/2006/main">
               <a:ext uri="{FF2B5EF4-FFF2-40B4-BE49-F238E27FC236}">
-                <a16:creationId xmlns:a16="http://schemas.microsoft.com/office/drawing/2014/main" id="{43638DDE-F8B3-414E-8883-9F447129A646}"/>
+                <a16:creationId xmlns:a16="http://schemas.microsoft.com/office/drawing/2014/main" id="{540511C1-C81B-4876-8701-85E32CA75B30}"/>
               </a:ext>
             </a:extLst>
           </p:cNvPr>
@@ -7703,7 +7728,7 @@
           <p:cNvPr id="15" name="agent-boundary-copy">
             <a:extLst xmlns:a="http://schemas.openxmlformats.org/drawingml/2006/main">
               <a:ext uri="{FF2B5EF4-FFF2-40B4-BE49-F238E27FC236}">
-                <a16:creationId xmlns:a16="http://schemas.microsoft.com/office/drawing/2014/main" id="{7DB312F8-09EB-4D3C-8CCB-6094CB64FD46}"/>
+                <a16:creationId xmlns:a16="http://schemas.microsoft.com/office/drawing/2014/main" id="{613C1AE8-8DB4-4040-B5EB-55635638AAE9}"/>
               </a:ext>
             </a:extLst>
           </p:cNvPr>
@@ -7759,7 +7784,7 @@
     </p:spTree>
     <p:extLst>
       <p:ext uri="{BB962C8B-B14F-4D97-AF65-F5344CB8AC3E}">
-        <p14:creationId xmlns:p14="http://schemas.microsoft.com/office/powerpoint/2010/main" val="90336934"/>
+        <p14:creationId xmlns:p14="http://schemas.microsoft.com/office/powerpoint/2010/main" val="1565904994"/>
       </p:ext>
     </p:extLst>
   </p:cSld>
@@ -7790,7 +7815,7 @@
           <p:cNvPr id="15" name="brand-7">
             <a:extLst xmlns:a="http://schemas.openxmlformats.org/drawingml/2006/main">
               <a:ext uri="{FF2B5EF4-FFF2-40B4-BE49-F238E27FC236}">
-                <a16:creationId xmlns:a16="http://schemas.microsoft.com/office/drawing/2014/main" id="{FA84ACA7-52B6-471D-B1DA-DDD36BCD3DA7}"/>
+                <a16:creationId xmlns:a16="http://schemas.microsoft.com/office/drawing/2014/main" id="{6129380F-E9D4-4F84-BD5F-03C2792E1811}"/>
               </a:ext>
             </a:extLst>
           </p:cNvPr>
@@ -7848,7 +7873,7 @@
           <p:cNvPr id="2" name="title-7">
             <a:extLst xmlns:a="http://schemas.openxmlformats.org/drawingml/2006/main">
               <a:ext uri="{FF2B5EF4-FFF2-40B4-BE49-F238E27FC236}">
-                <a16:creationId xmlns:a16="http://schemas.microsoft.com/office/drawing/2014/main" id="{07CD6305-0F12-49A5-9E7D-CB2FD74F1F54}"/>
+                <a16:creationId xmlns:a16="http://schemas.microsoft.com/office/drawing/2014/main" id="{0FDE7D00-8ECC-4A0E-9C82-52A8A9C1FA18}"/>
               </a:ext>
             </a:extLst>
           </p:cNvPr>
@@ -7906,7 +7931,7 @@
           <p:cNvPr id="3" name="footer-rule-7">
             <a:extLst xmlns:a="http://schemas.openxmlformats.org/drawingml/2006/main">
               <a:ext uri="{FF2B5EF4-FFF2-40B4-BE49-F238E27FC236}">
-                <a16:creationId xmlns:a16="http://schemas.microsoft.com/office/drawing/2014/main" id="{53C10EA6-309B-499A-A14F-45093D6467BD}"/>
+                <a16:creationId xmlns:a16="http://schemas.microsoft.com/office/drawing/2014/main" id="{2BD7E518-EC14-4273-8BC4-019E7F6E5CB7}"/>
               </a:ext>
             </a:extLst>
           </p:cNvPr>
@@ -7937,7 +7962,7 @@
           <p:cNvPr id="4" name="footer-source-7">
             <a:extLst xmlns:a="http://schemas.openxmlformats.org/drawingml/2006/main">
               <a:ext uri="{FF2B5EF4-FFF2-40B4-BE49-F238E27FC236}">
-                <a16:creationId xmlns:a16="http://schemas.microsoft.com/office/drawing/2014/main" id="{16B566EA-8151-44FE-B86D-4242B60767B7}"/>
+                <a16:creationId xmlns:a16="http://schemas.microsoft.com/office/drawing/2014/main" id="{14FA81A4-8E34-401A-8A46-16D65E57ABAD}"/>
               </a:ext>
             </a:extLst>
           </p:cNvPr>
@@ -7995,7 +8020,7 @@
           <p:cNvPr id="5" name="footer-page-7">
             <a:extLst xmlns:a="http://schemas.openxmlformats.org/drawingml/2006/main">
               <a:ext uri="{FF2B5EF4-FFF2-40B4-BE49-F238E27FC236}">
-                <a16:creationId xmlns:a16="http://schemas.microsoft.com/office/drawing/2014/main" id="{3273F246-3118-4ED9-92F3-41C08BAE6250}"/>
+                <a16:creationId xmlns:a16="http://schemas.microsoft.com/office/drawing/2014/main" id="{EFEFEAB1-BBFD-4EA1-A7BB-2B8D4C5E8D10}"/>
               </a:ext>
             </a:extLst>
           </p:cNvPr>
@@ -8053,7 +8078,7 @@
           <p:cNvPr id="6" name="prototype-proof-label">
             <a:extLst xmlns:a="http://schemas.openxmlformats.org/drawingml/2006/main">
               <a:ext uri="{FF2B5EF4-FFF2-40B4-BE49-F238E27FC236}">
-                <a16:creationId xmlns:a16="http://schemas.microsoft.com/office/drawing/2014/main" id="{FD075043-030C-41E0-8874-91663B17D32F}"/>
+                <a16:creationId xmlns:a16="http://schemas.microsoft.com/office/drawing/2014/main" id="{68F2278E-2EA6-48A0-A22C-1D7768651319}"/>
               </a:ext>
             </a:extLst>
           </p:cNvPr>
@@ -8115,7 +8140,7 @@
           <p:nvPr/>
         </p:nvPicPr>
         <p:blipFill>
-          <a:blip xmlns:r="http://schemas.openxmlformats.org/officeDocument/2006/relationships" xmlns:a="http://schemas.openxmlformats.org/drawingml/2006/main" r:embed="R9c51eb1a70064336"/>
+          <a:blip xmlns:r="http://schemas.openxmlformats.org/officeDocument/2006/relationships" xmlns:a="http://schemas.openxmlformats.org/drawingml/2006/main" r:embed="R6adcf1405be44c52"/>
           <a:srcRect xmlns:a="http://schemas.openxmlformats.org/drawingml/2006/main" l="0" t="9" r="0" b="9"/>
           <a:stretch xmlns:a="http://schemas.openxmlformats.org/drawingml/2006/main">
             <a:fillRect l="0" t="0" r="0" b="0"/>
@@ -8136,7 +8161,7 @@
           <p:cNvPr id="8" name="prototype-conflict-border">
             <a:extLst xmlns:a="http://schemas.openxmlformats.org/drawingml/2006/main">
               <a:ext uri="{FF2B5EF4-FFF2-40B4-BE49-F238E27FC236}">
-                <a16:creationId xmlns:a16="http://schemas.microsoft.com/office/drawing/2014/main" id="{59ED0209-495F-4F3A-8558-BEC161743D36}"/>
+                <a16:creationId xmlns:a16="http://schemas.microsoft.com/office/drawing/2014/main" id="{C3C3D9D7-6E08-48F1-9E20-11D3F9794AF1}"/>
               </a:ext>
             </a:extLst>
           </p:cNvPr>
@@ -8171,7 +8196,7 @@
           <p:nvPr/>
         </p:nvPicPr>
         <p:blipFill>
-          <a:blip xmlns:r="http://schemas.openxmlformats.org/officeDocument/2006/relationships" xmlns:a="http://schemas.openxmlformats.org/drawingml/2006/main" r:embed="R99d189f6ad9e47d2"/>
+          <a:blip xmlns:r="http://schemas.openxmlformats.org/officeDocument/2006/relationships" xmlns:a="http://schemas.openxmlformats.org/drawingml/2006/main" r:embed="R6ca86cada5f54360"/>
           <a:srcRect xmlns:a="http://schemas.openxmlformats.org/drawingml/2006/main" l="19" t="0" r="19" b="0"/>
           <a:stretch xmlns:a="http://schemas.openxmlformats.org/drawingml/2006/main">
             <a:fillRect l="0" t="0" r="0" b="0"/>
@@ -8192,7 +8217,7 @@
           <p:cNvPr id="10" name="prototype-receipt-border">
             <a:extLst xmlns:a="http://schemas.openxmlformats.org/drawingml/2006/main">
               <a:ext uri="{FF2B5EF4-FFF2-40B4-BE49-F238E27FC236}">
-                <a16:creationId xmlns:a16="http://schemas.microsoft.com/office/drawing/2014/main" id="{9C08AD83-3F64-48EB-9244-F2DFDCAC248A}"/>
+                <a16:creationId xmlns:a16="http://schemas.microsoft.com/office/drawing/2014/main" id="{D7F154F0-186B-4CE9-B08D-E683D5464A08}"/>
               </a:ext>
             </a:extLst>
           </p:cNvPr>
@@ -8223,7 +8248,7 @@
           <p:cNvPr id="11" name="prototype-callout-1">
             <a:extLst xmlns:a="http://schemas.openxmlformats.org/drawingml/2006/main">
               <a:ext uri="{FF2B5EF4-FFF2-40B4-BE49-F238E27FC236}">
-                <a16:creationId xmlns:a16="http://schemas.microsoft.com/office/drawing/2014/main" id="{CA324B51-B7ED-4C5A-B87D-16BC57708F6D}"/>
+                <a16:creationId xmlns:a16="http://schemas.microsoft.com/office/drawing/2014/main" id="{E2FE3118-4791-4F62-8AF2-BFCE8033701D}"/>
               </a:ext>
             </a:extLst>
           </p:cNvPr>
@@ -8281,7 +8306,7 @@
           <p:cNvPr id="12" name="prototype-callout-2">
             <a:extLst xmlns:a="http://schemas.openxmlformats.org/drawingml/2006/main">
               <a:ext uri="{FF2B5EF4-FFF2-40B4-BE49-F238E27FC236}">
-                <a16:creationId xmlns:a16="http://schemas.microsoft.com/office/drawing/2014/main" id="{9FB3076E-B8F8-43CC-85E2-C1EDD1DA0F68}"/>
+                <a16:creationId xmlns:a16="http://schemas.microsoft.com/office/drawing/2014/main" id="{13E0886E-B46F-403D-AD92-7A7BC8ADA8C4}"/>
               </a:ext>
             </a:extLst>
           </p:cNvPr>
@@ -8339,7 +8364,7 @@
           <p:cNvPr id="13" name="prototype-callout-3">
             <a:extLst xmlns:a="http://schemas.openxmlformats.org/drawingml/2006/main">
               <a:ext uri="{FF2B5EF4-FFF2-40B4-BE49-F238E27FC236}">
-                <a16:creationId xmlns:a16="http://schemas.microsoft.com/office/drawing/2014/main" id="{04617FE5-19C1-4D75-8BA4-E1C05D3E9405}"/>
+                <a16:creationId xmlns:a16="http://schemas.microsoft.com/office/drawing/2014/main" id="{C56B6142-98A2-40B4-A30E-842DF612C126}"/>
               </a:ext>
             </a:extLst>
           </p:cNvPr>
@@ -8397,7 +8422,7 @@
           <p:cNvPr id="14" name="prototype-callout-4">
             <a:extLst xmlns:a="http://schemas.openxmlformats.org/drawingml/2006/main">
               <a:ext uri="{FF2B5EF4-FFF2-40B4-BE49-F238E27FC236}">
-                <a16:creationId xmlns:a16="http://schemas.microsoft.com/office/drawing/2014/main" id="{95277337-348D-4E94-9EA1-52C5C2571864}"/>
+                <a16:creationId xmlns:a16="http://schemas.microsoft.com/office/drawing/2014/main" id="{A322432E-063E-42CA-B206-5539DC8F253C}"/>
               </a:ext>
             </a:extLst>
           </p:cNvPr>
@@ -8453,7 +8478,7 @@
     </p:spTree>
     <p:extLst>
       <p:ext uri="{BB962C8B-B14F-4D97-AF65-F5344CB8AC3E}">
-        <p14:creationId xmlns:p14="http://schemas.microsoft.com/office/powerpoint/2010/main" val="1415848836"/>
+        <p14:creationId xmlns:p14="http://schemas.microsoft.com/office/powerpoint/2010/main" val="1327674468"/>
       </p:ext>
     </p:extLst>
   </p:cSld>
@@ -8484,7 +8509,7 @@
           <p:cNvPr id="24" name="brand-8">
             <a:extLst xmlns:a="http://schemas.openxmlformats.org/drawingml/2006/main">
               <a:ext uri="{FF2B5EF4-FFF2-40B4-BE49-F238E27FC236}">
-                <a16:creationId xmlns:a16="http://schemas.microsoft.com/office/drawing/2014/main" id="{32FCC807-09E1-4450-AE93-E29331BA2C74}"/>
+                <a16:creationId xmlns:a16="http://schemas.microsoft.com/office/drawing/2014/main" id="{FD6DBA17-73F2-4EA2-BFDD-D6C967EF4455}"/>
               </a:ext>
             </a:extLst>
           </p:cNvPr>
@@ -8542,7 +8567,7 @@
           <p:cNvPr id="2" name="title-8">
             <a:extLst xmlns:a="http://schemas.openxmlformats.org/drawingml/2006/main">
               <a:ext uri="{FF2B5EF4-FFF2-40B4-BE49-F238E27FC236}">
-                <a16:creationId xmlns:a16="http://schemas.microsoft.com/office/drawing/2014/main" id="{218E0838-9203-461E-BDFE-1D8F6C49447D}"/>
+                <a16:creationId xmlns:a16="http://schemas.microsoft.com/office/drawing/2014/main" id="{5C0BADBD-3E69-4221-84E1-405325637AA2}"/>
               </a:ext>
             </a:extLst>
           </p:cNvPr>
@@ -8600,7 +8625,7 @@
           <p:cNvPr id="3" name="footer-rule-8">
             <a:extLst xmlns:a="http://schemas.openxmlformats.org/drawingml/2006/main">
               <a:ext uri="{FF2B5EF4-FFF2-40B4-BE49-F238E27FC236}">
-                <a16:creationId xmlns:a16="http://schemas.microsoft.com/office/drawing/2014/main" id="{25C671D0-FD32-43DF-93DD-E7E8116E492D}"/>
+                <a16:creationId xmlns:a16="http://schemas.microsoft.com/office/drawing/2014/main" id="{701C7B0C-9176-4F5B-B46C-79A075F0B58C}"/>
               </a:ext>
             </a:extLst>
           </p:cNvPr>
@@ -8631,7 +8656,7 @@
           <p:cNvPr id="4" name="footer-source-8">
             <a:extLst xmlns:a="http://schemas.openxmlformats.org/drawingml/2006/main">
               <a:ext uri="{FF2B5EF4-FFF2-40B4-BE49-F238E27FC236}">
-                <a16:creationId xmlns:a16="http://schemas.microsoft.com/office/drawing/2014/main" id="{9E488A63-DA7B-4A28-83F1-93D801661E55}"/>
+                <a16:creationId xmlns:a16="http://schemas.microsoft.com/office/drawing/2014/main" id="{C1C66C06-A791-4FB9-BC18-6307933FF8E8}"/>
               </a:ext>
             </a:extLst>
           </p:cNvPr>
@@ -8689,7 +8714,7 @@
           <p:cNvPr id="5" name="footer-page-8">
             <a:extLst xmlns:a="http://schemas.openxmlformats.org/drawingml/2006/main">
               <a:ext uri="{FF2B5EF4-FFF2-40B4-BE49-F238E27FC236}">
-                <a16:creationId xmlns:a16="http://schemas.microsoft.com/office/drawing/2014/main" id="{C234A498-E95A-481F-A8EA-C10F0A9AD812}"/>
+                <a16:creationId xmlns:a16="http://schemas.microsoft.com/office/drawing/2014/main" id="{60708295-E1D4-49E0-88B8-0CD3E5846BEC}"/>
               </a:ext>
             </a:extLst>
           </p:cNvPr>
@@ -8747,7 +8772,7 @@
           <p:cNvPr id="6" name="sensitivity-label">
             <a:extLst xmlns:a="http://schemas.openxmlformats.org/drawingml/2006/main">
               <a:ext uri="{FF2B5EF4-FFF2-40B4-BE49-F238E27FC236}">
-                <a16:creationId xmlns:a16="http://schemas.microsoft.com/office/drawing/2014/main" id="{C91DCF8D-84AE-4EA7-AB2B-634D0CAFCA63}"/>
+                <a16:creationId xmlns:a16="http://schemas.microsoft.com/office/drawing/2014/main" id="{0891D985-E8E6-47D2-BEBC-612093DA553D}"/>
               </a:ext>
             </a:extLst>
           </p:cNvPr>
@@ -8805,7 +8830,7 @@
           <p:cNvPr id="7" name="sensitivity-row-0">
             <a:extLst xmlns:a="http://schemas.openxmlformats.org/drawingml/2006/main">
               <a:ext uri="{FF2B5EF4-FFF2-40B4-BE49-F238E27FC236}">
-                <a16:creationId xmlns:a16="http://schemas.microsoft.com/office/drawing/2014/main" id="{0AE7CCE4-0F1C-402A-95CC-B62CEE8F7B1A}"/>
+                <a16:creationId xmlns:a16="http://schemas.microsoft.com/office/drawing/2014/main" id="{AFA94020-C898-414B-8682-F23C4A8406FE}"/>
               </a:ext>
             </a:extLst>
           </p:cNvPr>
@@ -8836,7 +8861,7 @@
           <p:cNvPr id="8" name="sensitivity-0-0">
             <a:extLst xmlns:a="http://schemas.openxmlformats.org/drawingml/2006/main">
               <a:ext uri="{FF2B5EF4-FFF2-40B4-BE49-F238E27FC236}">
-                <a16:creationId xmlns:a16="http://schemas.microsoft.com/office/drawing/2014/main" id="{30CFA534-5FC5-432E-ADF1-AC0774352158}"/>
+                <a16:creationId xmlns:a16="http://schemas.microsoft.com/office/drawing/2014/main" id="{22A934A8-E72C-4E2C-A451-602C1FDAABC1}"/>
               </a:ext>
             </a:extLst>
           </p:cNvPr>
@@ -8894,7 +8919,7 @@
           <p:cNvPr id="9" name="sensitivity-0-1">
             <a:extLst xmlns:a="http://schemas.openxmlformats.org/drawingml/2006/main">
               <a:ext uri="{FF2B5EF4-FFF2-40B4-BE49-F238E27FC236}">
-                <a16:creationId xmlns:a16="http://schemas.microsoft.com/office/drawing/2014/main" id="{14ABF6F8-C2F1-4819-975B-1C3985895B20}"/>
+                <a16:creationId xmlns:a16="http://schemas.microsoft.com/office/drawing/2014/main" id="{990479AA-6507-4DEF-A174-E888EDEB5759}"/>
               </a:ext>
             </a:extLst>
           </p:cNvPr>
@@ -8952,7 +8977,7 @@
           <p:cNvPr id="10" name="sensitivity-0-2">
             <a:extLst xmlns:a="http://schemas.openxmlformats.org/drawingml/2006/main">
               <a:ext uri="{FF2B5EF4-FFF2-40B4-BE49-F238E27FC236}">
-                <a16:creationId xmlns:a16="http://schemas.microsoft.com/office/drawing/2014/main" id="{28764708-50F9-4F9E-BFBC-D84A8ECB99BB}"/>
+                <a16:creationId xmlns:a16="http://schemas.microsoft.com/office/drawing/2014/main" id="{2E8C34F1-AEE8-467F-ADE7-91291F27F61A}"/>
               </a:ext>
             </a:extLst>
           </p:cNvPr>
@@ -9010,7 +9035,7 @@
           <p:cNvPr id="11" name="sensitivity-row-1">
             <a:extLst xmlns:a="http://schemas.openxmlformats.org/drawingml/2006/main">
               <a:ext uri="{FF2B5EF4-FFF2-40B4-BE49-F238E27FC236}">
-                <a16:creationId xmlns:a16="http://schemas.microsoft.com/office/drawing/2014/main" id="{43E4CBE1-9EFA-48AF-BA5E-9B6F5BFD0AC9}"/>
+                <a16:creationId xmlns:a16="http://schemas.microsoft.com/office/drawing/2014/main" id="{C17A2F64-553F-4492-8509-9201D8EFE20B}"/>
               </a:ext>
             </a:extLst>
           </p:cNvPr>
@@ -9041,7 +9066,7 @@
           <p:cNvPr id="12" name="sensitivity-1-0">
             <a:extLst xmlns:a="http://schemas.openxmlformats.org/drawingml/2006/main">
               <a:ext uri="{FF2B5EF4-FFF2-40B4-BE49-F238E27FC236}">
-                <a16:creationId xmlns:a16="http://schemas.microsoft.com/office/drawing/2014/main" id="{D7B6B4ED-095A-44AE-B6CB-FAA659094280}"/>
+                <a16:creationId xmlns:a16="http://schemas.microsoft.com/office/drawing/2014/main" id="{855519A3-191C-47CD-A45A-CB0FB10A7958}"/>
               </a:ext>
             </a:extLst>
           </p:cNvPr>
@@ -9099,7 +9124,7 @@
           <p:cNvPr id="13" name="sensitivity-1-1">
             <a:extLst xmlns:a="http://schemas.openxmlformats.org/drawingml/2006/main">
               <a:ext uri="{FF2B5EF4-FFF2-40B4-BE49-F238E27FC236}">
-                <a16:creationId xmlns:a16="http://schemas.microsoft.com/office/drawing/2014/main" id="{FC303B40-A1F3-4AE4-B189-F1666A4AC259}"/>
+                <a16:creationId xmlns:a16="http://schemas.microsoft.com/office/drawing/2014/main" id="{08D1C985-F300-42F1-929F-CA1DEAA60800}"/>
               </a:ext>
             </a:extLst>
           </p:cNvPr>
@@ -9157,7 +9182,7 @@
           <p:cNvPr id="14" name="sensitivity-1-2">
             <a:extLst xmlns:a="http://schemas.openxmlformats.org/drawingml/2006/main">
               <a:ext uri="{FF2B5EF4-FFF2-40B4-BE49-F238E27FC236}">
-                <a16:creationId xmlns:a16="http://schemas.microsoft.com/office/drawing/2014/main" id="{68ED996B-6024-49FC-8705-D76EBAAF9FC3}"/>
+                <a16:creationId xmlns:a16="http://schemas.microsoft.com/office/drawing/2014/main" id="{70DBAB46-43CB-44A4-A6F4-2B4DB8EDE588}"/>
               </a:ext>
             </a:extLst>
           </p:cNvPr>
@@ -9215,7 +9240,7 @@
           <p:cNvPr id="15" name="sensitivity-row-2">
             <a:extLst xmlns:a="http://schemas.openxmlformats.org/drawingml/2006/main">
               <a:ext uri="{FF2B5EF4-FFF2-40B4-BE49-F238E27FC236}">
-                <a16:creationId xmlns:a16="http://schemas.microsoft.com/office/drawing/2014/main" id="{3331641A-4FD2-4B79-8634-1C58C8DADA36}"/>
+                <a16:creationId xmlns:a16="http://schemas.microsoft.com/office/drawing/2014/main" id="{8C659FAB-9A19-4ECE-92F1-C9DCDAA8D8C5}"/>
               </a:ext>
             </a:extLst>
           </p:cNvPr>
@@ -9246,7 +9271,7 @@
           <p:cNvPr id="16" name="sensitivity-2-0">
             <a:extLst xmlns:a="http://schemas.openxmlformats.org/drawingml/2006/main">
               <a:ext uri="{FF2B5EF4-FFF2-40B4-BE49-F238E27FC236}">
-                <a16:creationId xmlns:a16="http://schemas.microsoft.com/office/drawing/2014/main" id="{2A2C698E-0404-4FA4-ACBD-A6C8E45FC70D}"/>
+                <a16:creationId xmlns:a16="http://schemas.microsoft.com/office/drawing/2014/main" id="{FCDD511A-DB09-4581-B2CE-B1ABE6630064}"/>
               </a:ext>
             </a:extLst>
           </p:cNvPr>
@@ -9304,7 +9329,7 @@
           <p:cNvPr id="17" name="sensitivity-2-1">
             <a:extLst xmlns:a="http://schemas.openxmlformats.org/drawingml/2006/main">
               <a:ext uri="{FF2B5EF4-FFF2-40B4-BE49-F238E27FC236}">
-                <a16:creationId xmlns:a16="http://schemas.microsoft.com/office/drawing/2014/main" id="{AA831E64-676F-48DC-9426-06906F46C7C8}"/>
+                <a16:creationId xmlns:a16="http://schemas.microsoft.com/office/drawing/2014/main" id="{0E9F9F5F-5062-495E-948A-5A015CA1C6DC}"/>
               </a:ext>
             </a:extLst>
           </p:cNvPr>
@@ -9362,7 +9387,7 @@
           <p:cNvPr id="18" name="sensitivity-2-2">
             <a:extLst xmlns:a="http://schemas.openxmlformats.org/drawingml/2006/main">
               <a:ext uri="{FF2B5EF4-FFF2-40B4-BE49-F238E27FC236}">
-                <a16:creationId xmlns:a16="http://schemas.microsoft.com/office/drawing/2014/main" id="{035F0983-26BA-417E-99C7-FA0C26A6A567}"/>
+                <a16:creationId xmlns:a16="http://schemas.microsoft.com/office/drawing/2014/main" id="{F2D7C0B9-2C56-4955-ABE4-CFEE2B77A8FF}"/>
               </a:ext>
             </a:extLst>
           </p:cNvPr>
@@ -9420,7 +9445,7 @@
           <p:cNvPr id="19" name="sensitivity-divider">
             <a:extLst xmlns:a="http://schemas.openxmlformats.org/drawingml/2006/main">
               <a:ext uri="{FF2B5EF4-FFF2-40B4-BE49-F238E27FC236}">
-                <a16:creationId xmlns:a16="http://schemas.microsoft.com/office/drawing/2014/main" id="{35CE4064-4D43-4368-A6C7-446496E4E44A}"/>
+                <a16:creationId xmlns:a16="http://schemas.microsoft.com/office/drawing/2014/main" id="{D058E4ED-FDDE-43BC-BA6F-FD9756A476DD}"/>
               </a:ext>
             </a:extLst>
           </p:cNvPr>
@@ -9451,7 +9476,7 @@
           <p:cNvPr id="20" name="sensitivity-gates">
             <a:extLst xmlns:a="http://schemas.openxmlformats.org/drawingml/2006/main">
               <a:ext uri="{FF2B5EF4-FFF2-40B4-BE49-F238E27FC236}">
-                <a16:creationId xmlns:a16="http://schemas.microsoft.com/office/drawing/2014/main" id="{2E2391E1-7B75-4D79-81EC-9ACB7A5229AB}"/>
+                <a16:creationId xmlns:a16="http://schemas.microsoft.com/office/drawing/2014/main" id="{C8260EC5-0B94-421B-8079-5A57CCB8497C}"/>
               </a:ext>
             </a:extLst>
           </p:cNvPr>
@@ -9509,7 +9534,7 @@
           <p:cNvPr id="21" name="footer-sensitivity-hypothesis-label">
             <a:extLst xmlns:a="http://schemas.openxmlformats.org/drawingml/2006/main">
               <a:ext uri="{FF2B5EF4-FFF2-40B4-BE49-F238E27FC236}">
-                <a16:creationId xmlns:a16="http://schemas.microsoft.com/office/drawing/2014/main" id="{CEA9E006-B709-4640-99F4-DF859596BEBC}"/>
+                <a16:creationId xmlns:a16="http://schemas.microsoft.com/office/drawing/2014/main" id="{C2509334-798A-4BA1-8E32-30A188C4A0E5}"/>
               </a:ext>
             </a:extLst>
           </p:cNvPr>
@@ -9567,7 +9592,7 @@
           <p:cNvPr id="22" name="sensitivity-hypothesis">
             <a:extLst xmlns:a="http://schemas.openxmlformats.org/drawingml/2006/main">
               <a:ext uri="{FF2B5EF4-FFF2-40B4-BE49-F238E27FC236}">
-                <a16:creationId xmlns:a16="http://schemas.microsoft.com/office/drawing/2014/main" id="{E5CF6E96-8196-49FF-ACC2-8916BE5FE046}"/>
+                <a16:creationId xmlns:a16="http://schemas.microsoft.com/office/drawing/2014/main" id="{33E80B8C-435B-4978-B337-146A63F7823D}"/>
               </a:ext>
             </a:extLst>
           </p:cNvPr>
@@ -9625,7 +9650,7 @@
           <p:cNvPr id="23" name="sensitivity-disclaimer">
             <a:extLst xmlns:a="http://schemas.openxmlformats.org/drawingml/2006/main">
               <a:ext uri="{FF2B5EF4-FFF2-40B4-BE49-F238E27FC236}">
-                <a16:creationId xmlns:a16="http://schemas.microsoft.com/office/drawing/2014/main" id="{1FF650C8-3639-4051-BC35-BCCAC3AD0D35}"/>
+                <a16:creationId xmlns:a16="http://schemas.microsoft.com/office/drawing/2014/main" id="{98A4B2E2-F85E-4014-B24B-D955F3C3821E}"/>
               </a:ext>
             </a:extLst>
           </p:cNvPr>
@@ -9681,7 +9706,7 @@
     </p:spTree>
     <p:extLst>
       <p:ext uri="{BB962C8B-B14F-4D97-AF65-F5344CB8AC3E}">
-        <p14:creationId xmlns:p14="http://schemas.microsoft.com/office/powerpoint/2010/main" val="1677375077"/>
+        <p14:creationId xmlns:p14="http://schemas.microsoft.com/office/powerpoint/2010/main" val="108067368"/>
       </p:ext>
     </p:extLst>
   </p:cSld>
@@ -9712,7 +9737,7 @@
           <p:cNvPr id="13" name="brand-9">
             <a:extLst xmlns:a="http://schemas.openxmlformats.org/drawingml/2006/main">
               <a:ext uri="{FF2B5EF4-FFF2-40B4-BE49-F238E27FC236}">
-                <a16:creationId xmlns:a16="http://schemas.microsoft.com/office/drawing/2014/main" id="{C79BC4A6-B01C-466E-82E0-FE5661E39CA7}"/>
+                <a16:creationId xmlns:a16="http://schemas.microsoft.com/office/drawing/2014/main" id="{99E2E483-4FFF-4AB8-BBF3-AA290B55BAF2}"/>
               </a:ext>
             </a:extLst>
           </p:cNvPr>
@@ -9770,7 +9795,7 @@
           <p:cNvPr id="2" name="title-9">
             <a:extLst xmlns:a="http://schemas.openxmlformats.org/drawingml/2006/main">
               <a:ext uri="{FF2B5EF4-FFF2-40B4-BE49-F238E27FC236}">
-                <a16:creationId xmlns:a16="http://schemas.microsoft.com/office/drawing/2014/main" id="{D91E5955-2DB0-4B5C-829B-CABA5837CD7E}"/>
+                <a16:creationId xmlns:a16="http://schemas.microsoft.com/office/drawing/2014/main" id="{8C165E53-07A8-4FF0-B9C9-07E767ED3991}"/>
               </a:ext>
             </a:extLst>
           </p:cNvPr>
@@ -9828,7 +9853,7 @@
           <p:cNvPr id="3" name="footer-rule-9">
             <a:extLst xmlns:a="http://schemas.openxmlformats.org/drawingml/2006/main">
               <a:ext uri="{FF2B5EF4-FFF2-40B4-BE49-F238E27FC236}">
-                <a16:creationId xmlns:a16="http://schemas.microsoft.com/office/drawing/2014/main" id="{A09B3B47-1A1D-4374-9129-E3A4D702713E}"/>
+                <a16:creationId xmlns:a16="http://schemas.microsoft.com/office/drawing/2014/main" id="{FCEB8C1E-187F-4897-8311-665F91195C6D}"/>
               </a:ext>
             </a:extLst>
           </p:cNvPr>
@@ -9859,7 +9884,7 @@
           <p:cNvPr id="4" name="footer-source-9">
             <a:extLst xmlns:a="http://schemas.openxmlformats.org/drawingml/2006/main">
               <a:ext uri="{FF2B5EF4-FFF2-40B4-BE49-F238E27FC236}">
-                <a16:creationId xmlns:a16="http://schemas.microsoft.com/office/drawing/2014/main" id="{00F4602E-3D56-44B8-9E84-E2D87619F04E}"/>
+                <a16:creationId xmlns:a16="http://schemas.microsoft.com/office/drawing/2014/main" id="{35293825-FE09-4B15-A907-FD80F8309FEA}"/>
               </a:ext>
             </a:extLst>
           </p:cNvPr>
@@ -9917,7 +9942,7 @@
           <p:cNvPr id="5" name="footer-page-9">
             <a:extLst xmlns:a="http://schemas.openxmlformats.org/drawingml/2006/main">
               <a:ext uri="{FF2B5EF4-FFF2-40B4-BE49-F238E27FC236}">
-                <a16:creationId xmlns:a16="http://schemas.microsoft.com/office/drawing/2014/main" id="{B3126B7C-34FD-45C6-AE26-F921BAAA59EC}"/>
+                <a16:creationId xmlns:a16="http://schemas.microsoft.com/office/drawing/2014/main" id="{F9F911A3-643E-413F-B8F8-3E73C30848F4}"/>
               </a:ext>
             </a:extLst>
           </p:cNvPr>
@@ -9975,7 +10000,7 @@
           <p:cNvPr id="6" name="ownership-divider">
             <a:extLst xmlns:a="http://schemas.openxmlformats.org/drawingml/2006/main">
               <a:ext uri="{FF2B5EF4-FFF2-40B4-BE49-F238E27FC236}">
-                <a16:creationId xmlns:a16="http://schemas.microsoft.com/office/drawing/2014/main" id="{81F2E6A7-C631-46DD-8CE7-D09A82A41278}"/>
+                <a16:creationId xmlns:a16="http://schemas.microsoft.com/office/drawing/2014/main" id="{CDA20BEC-A5AE-4DAA-A5EA-C590305FBFFF}"/>
               </a:ext>
             </a:extLst>
           </p:cNvPr>
@@ -10006,7 +10031,7 @@
           <p:cNvPr id="7" name="ownership-ayush-label">
             <a:extLst xmlns:a="http://schemas.openxmlformats.org/drawingml/2006/main">
               <a:ext uri="{FF2B5EF4-FFF2-40B4-BE49-F238E27FC236}">
-                <a16:creationId xmlns:a16="http://schemas.microsoft.com/office/drawing/2014/main" id="{3453E2F5-8FF2-4B99-ADBE-5369F4BEA384}"/>
+                <a16:creationId xmlns:a16="http://schemas.microsoft.com/office/drawing/2014/main" id="{D0A83A69-A182-4593-B68E-07AC49FE0FDA}"/>
               </a:ext>
             </a:extLst>
           </p:cNvPr>
@@ -10064,7 +10089,7 @@
           <p:cNvPr id="8" name="ownership-ayush-copy">
             <a:extLst xmlns:a="http://schemas.openxmlformats.org/drawingml/2006/main">
               <a:ext uri="{FF2B5EF4-FFF2-40B4-BE49-F238E27FC236}">
-                <a16:creationId xmlns:a16="http://schemas.microsoft.com/office/drawing/2014/main" id="{9FC51FBC-CE49-4492-8606-82FC269C8B8B}"/>
+                <a16:creationId xmlns:a16="http://schemas.microsoft.com/office/drawing/2014/main" id="{884A22C3-98FF-487F-A598-F76A046B4875}"/>
               </a:ext>
             </a:extLst>
           </p:cNvPr>
@@ -10122,7 +10147,7 @@
           <p:cNvPr id="9" name="ownership-finance-label">
             <a:extLst xmlns:a="http://schemas.openxmlformats.org/drawingml/2006/main">
               <a:ext uri="{FF2B5EF4-FFF2-40B4-BE49-F238E27FC236}">
-                <a16:creationId xmlns:a16="http://schemas.microsoft.com/office/drawing/2014/main" id="{17C7E9AA-6474-4FE9-A900-EC904DBC7B53}"/>
+                <a16:creationId xmlns:a16="http://schemas.microsoft.com/office/drawing/2014/main" id="{7118E86A-A12C-4304-AE19-B0175006977F}"/>
               </a:ext>
             </a:extLst>
           </p:cNvPr>
@@ -10180,7 +10205,7 @@
           <p:cNvPr id="10" name="ownership-finance-copy">
             <a:extLst xmlns:a="http://schemas.openxmlformats.org/drawingml/2006/main">
               <a:ext uri="{FF2B5EF4-FFF2-40B4-BE49-F238E27FC236}">
-                <a16:creationId xmlns:a16="http://schemas.microsoft.com/office/drawing/2014/main" id="{070EDE1C-8BC2-47FC-9FA1-0D5E95B77751}"/>
+                <a16:creationId xmlns:a16="http://schemas.microsoft.com/office/drawing/2014/main" id="{0C4161A3-0816-4E06-AE40-C4E4BD68C62D}"/>
               </a:ext>
             </a:extLst>
           </p:cNvPr>
@@ -10238,7 +10263,7 @@
           <p:cNvPr id="11" name="ownership-gate-band">
             <a:extLst xmlns:a="http://schemas.openxmlformats.org/drawingml/2006/main">
               <a:ext uri="{FF2B5EF4-FFF2-40B4-BE49-F238E27FC236}">
-                <a16:creationId xmlns:a16="http://schemas.microsoft.com/office/drawing/2014/main" id="{B6BA8D10-053B-47CF-B58D-E43B9A02C36F}"/>
+                <a16:creationId xmlns:a16="http://schemas.microsoft.com/office/drawing/2014/main" id="{4460F8E4-CA97-4F64-AC91-FF27329D13C8}"/>
               </a:ext>
             </a:extLst>
           </p:cNvPr>
@@ -10271,7 +10296,7 @@
           <p:cNvPr id="12" name="ownership-gate">
             <a:extLst xmlns:a="http://schemas.openxmlformats.org/drawingml/2006/main">
               <a:ext uri="{FF2B5EF4-FFF2-40B4-BE49-F238E27FC236}">
-                <a16:creationId xmlns:a16="http://schemas.microsoft.com/office/drawing/2014/main" id="{BAB86EFC-21FB-46BE-A103-DF55E77224E8}"/>
+                <a16:creationId xmlns:a16="http://schemas.microsoft.com/office/drawing/2014/main" id="{1A028E25-7E09-4DCA-BBEB-D5C52516B01C}"/>
               </a:ext>
             </a:extLst>
           </p:cNvPr>
@@ -10327,7 +10352,7 @@
     </p:spTree>
     <p:extLst>
       <p:ext uri="{BB962C8B-B14F-4D97-AF65-F5344CB8AC3E}">
-        <p14:creationId xmlns:p14="http://schemas.microsoft.com/office/powerpoint/2010/main" val="1664582312"/>
+        <p14:creationId xmlns:p14="http://schemas.microsoft.com/office/powerpoint/2010/main" val="1094079248"/>
       </p:ext>
     </p:extLst>
   </p:cSld>

</xml_diff>